<commit_message>
Complete V3 runtime governance and submission artifacts
</commit_message>
<xml_diff>
--- a/output/presentation/Corporate-Wallet-Digital-Twin.pptx
+++ b/output/presentation/Corporate-Wallet-Digital-Twin.pptx
@@ -2,22 +2,22 @@
 <file path=ppt/presentation.xml><?xml version="1.0" encoding="utf-8"?>
 <p:presentation xmlns:p="http://schemas.openxmlformats.org/presentationml/2006/main">
   <p:sldMasterIdLst>
-    <p:sldMasterId xmlns:r="http://schemas.openxmlformats.org/officeDocument/2006/relationships" id="2147483648" r:id="R0f988ec777744139"/>
+    <p:sldMasterId xmlns:r="http://schemas.openxmlformats.org/officeDocument/2006/relationships" id="2147483648" r:id="R4c2f306103b24b68"/>
   </p:sldMasterIdLst>
   <p:notesMasterIdLst>
-    <p:notesMasterId xmlns:r="http://schemas.openxmlformats.org/officeDocument/2006/relationships" r:id="Rc1af8cba2dc74657"/>
+    <p:notesMasterId xmlns:r="http://schemas.openxmlformats.org/officeDocument/2006/relationships" r:id="R8321a7052f71432d"/>
   </p:notesMasterIdLst>
   <p:sldIdLst>
-    <p:sldId xmlns:r="http://schemas.openxmlformats.org/officeDocument/2006/relationships" id="256" r:id="R7a01fcedcfa44ea1"/>
-    <p:sldId xmlns:r="http://schemas.openxmlformats.org/officeDocument/2006/relationships" id="257" r:id="R59578da3d2514033"/>
-    <p:sldId xmlns:r="http://schemas.openxmlformats.org/officeDocument/2006/relationships" id="258" r:id="R6ad0d8820df140d1"/>
-    <p:sldId xmlns:r="http://schemas.openxmlformats.org/officeDocument/2006/relationships" id="259" r:id="Rd7026876530f4c03"/>
-    <p:sldId xmlns:r="http://schemas.openxmlformats.org/officeDocument/2006/relationships" id="260" r:id="R106292b3fcc94846"/>
-    <p:sldId xmlns:r="http://schemas.openxmlformats.org/officeDocument/2006/relationships" id="261" r:id="Rf3d340afab72460d"/>
-    <p:sldId xmlns:r="http://schemas.openxmlformats.org/officeDocument/2006/relationships" id="262" r:id="Rb749f9b3a1d3483c"/>
-    <p:sldId xmlns:r="http://schemas.openxmlformats.org/officeDocument/2006/relationships" id="263" r:id="Rbe5931830f6e4d9a"/>
-    <p:sldId xmlns:r="http://schemas.openxmlformats.org/officeDocument/2006/relationships" id="264" r:id="Rd167dbea76944215"/>
-    <p:sldId xmlns:r="http://schemas.openxmlformats.org/officeDocument/2006/relationships" id="265" r:id="Rdce1cc091e964891"/>
+    <p:sldId xmlns:r="http://schemas.openxmlformats.org/officeDocument/2006/relationships" id="256" r:id="Rb2a434d7e9d848c9"/>
+    <p:sldId xmlns:r="http://schemas.openxmlformats.org/officeDocument/2006/relationships" id="257" r:id="R1e78dfd2c02648b7"/>
+    <p:sldId xmlns:r="http://schemas.openxmlformats.org/officeDocument/2006/relationships" id="258" r:id="Rbaea77c1765043d2"/>
+    <p:sldId xmlns:r="http://schemas.openxmlformats.org/officeDocument/2006/relationships" id="259" r:id="R1f3ec88e14f74b6f"/>
+    <p:sldId xmlns:r="http://schemas.openxmlformats.org/officeDocument/2006/relationships" id="260" r:id="Ra5e2aecca5864d9b"/>
+    <p:sldId xmlns:r="http://schemas.openxmlformats.org/officeDocument/2006/relationships" id="261" r:id="R0ba1d283f9ef4cd6"/>
+    <p:sldId xmlns:r="http://schemas.openxmlformats.org/officeDocument/2006/relationships" id="262" r:id="R25f9cb7d1eb84101"/>
+    <p:sldId xmlns:r="http://schemas.openxmlformats.org/officeDocument/2006/relationships" id="263" r:id="Rf45561969f3c4d28"/>
+    <p:sldId xmlns:r="http://schemas.openxmlformats.org/officeDocument/2006/relationships" id="264" r:id="Rea894d3cef1c4090"/>
+    <p:sldId xmlns:r="http://schemas.openxmlformats.org/officeDocument/2006/relationships" id="265" r:id="Re58a4e936fc84cc2"/>
   </p:sldIdLst>
   <p:sldSz cx="12192000" cy="6858000"/>
   <p:notesSz cx="6858000" cy="9144000"/>
@@ -1161,7 +1161,7 @@
           </a:p>
           <a:p xmlns:a="http://schemas.openxmlformats.org/drawingml/2006/main">
             <a:r>
-              <a:t>- outputs/v2_validation/global_sensitivity.json</a:t>
+              <a:t>- dashboard/app/data/shadow-fixture.json — sensitivity.product_summary</a:t>
             </a:r>
           </a:p>
         </p:txBody>
@@ -1346,7 +1346,7 @@
           </a:p>
           <a:p xmlns:a="http://schemas.openxmlformats.org/drawingml/2006/main">
             <a:r>
-              <a:t>- src/wallet_twin_v2/genai.py</a:t>
+              <a:t>- src/wallet_twin_v2/genai_gateway.py</a:t>
             </a:r>
           </a:p>
           <a:p xmlns:a="http://schemas.openxmlformats.org/drawingml/2006/main">
@@ -1424,7 +1424,7 @@
   </p:cSld>
   <p:clrMap bg1="lt1" tx1="dk1" bg2="lt2" tx2="dk2" accent1="accent1" accent2="accent2" accent3="accent3" accent4="accent4" accent5="accent5" accent6="accent6" hlink="hlink" folHlink="folHlink"/>
   <p:sldLayoutIdLst>
-    <p:sldLayoutId xmlns:r="http://schemas.openxmlformats.org/officeDocument/2006/relationships" id="2147483649" r:id="Rf5a5fe7b220c43e4"/>
+    <p:sldLayoutId xmlns:r="http://schemas.openxmlformats.org/officeDocument/2006/relationships" id="2147483649" r:id="R17801c5bdec744f0"/>
   </p:sldLayoutIdLst>
   <p:txStyles>
     <p:titleStyle>
@@ -2150,7 +2150,7 @@
           <p:nvPr/>
         </p:nvPicPr>
         <p:blipFill>
-          <a:blip xmlns:r="http://schemas.openxmlformats.org/officeDocument/2006/relationships" xmlns:a="http://schemas.openxmlformats.org/drawingml/2006/main" r:embed="R2e23780b039f4c6d"/>
+          <a:blip xmlns:r="http://schemas.openxmlformats.org/officeDocument/2006/relationships" xmlns:a="http://schemas.openxmlformats.org/drawingml/2006/main" r:embed="Ra4cd3e28ef4c4a23"/>
           <a:srcRect xmlns:a="http://schemas.openxmlformats.org/drawingml/2006/main" l="0" t="27" r="0" b="27"/>
           <a:stretch xmlns:a="http://schemas.openxmlformats.org/drawingml/2006/main">
             <a:fillRect l="0" t="0" r="0" b="0"/>
@@ -7942,7 +7942,7 @@
         </p:xfrm>
         <a:graphic xmlns:a="http://schemas.openxmlformats.org/drawingml/2006/main">
           <a:graphicData uri="http://schemas.openxmlformats.org/drawingml/2006/chart">
-            <c:chart xmlns:r="http://schemas.openxmlformats.org/officeDocument/2006/relationships" xmlns:c="http://schemas.openxmlformats.org/drawingml/2006/chart" r:id="Rbf54e290060f4665"/>
+            <c:chart xmlns:r="http://schemas.openxmlformats.org/officeDocument/2006/relationships" xmlns:c="http://schemas.openxmlformats.org/drawingml/2006/chart" r:id="R7bfe2cf79063405e"/>
           </a:graphicData>
         </a:graphic>
       </p:graphicFrame>

</xml_diff>

<commit_message>
Implement Corporate Banking Decision Twin V3.1
</commit_message>
<xml_diff>
--- a/output/presentation/Corporate-Wallet-Digital-Twin.pptx
+++ b/output/presentation/Corporate-Wallet-Digital-Twin.pptx
@@ -2,22 +2,22 @@
 <file path=ppt/presentation.xml><?xml version="1.0" encoding="utf-8"?>
 <p:presentation xmlns:p="http://schemas.openxmlformats.org/presentationml/2006/main">
   <p:sldMasterIdLst>
-    <p:sldMasterId xmlns:r="http://schemas.openxmlformats.org/officeDocument/2006/relationships" id="2147483648" r:id="R4c2f306103b24b68"/>
+    <p:sldMasterId xmlns:r="http://schemas.openxmlformats.org/officeDocument/2006/relationships" id="2147483648" r:id="Rd4eea221f6b5409b"/>
   </p:sldMasterIdLst>
   <p:notesMasterIdLst>
-    <p:notesMasterId xmlns:r="http://schemas.openxmlformats.org/officeDocument/2006/relationships" r:id="R8321a7052f71432d"/>
+    <p:notesMasterId xmlns:r="http://schemas.openxmlformats.org/officeDocument/2006/relationships" r:id="Rba62f2c9c11c465e"/>
   </p:notesMasterIdLst>
   <p:sldIdLst>
-    <p:sldId xmlns:r="http://schemas.openxmlformats.org/officeDocument/2006/relationships" id="256" r:id="Rb2a434d7e9d848c9"/>
-    <p:sldId xmlns:r="http://schemas.openxmlformats.org/officeDocument/2006/relationships" id="257" r:id="R1e78dfd2c02648b7"/>
-    <p:sldId xmlns:r="http://schemas.openxmlformats.org/officeDocument/2006/relationships" id="258" r:id="Rbaea77c1765043d2"/>
-    <p:sldId xmlns:r="http://schemas.openxmlformats.org/officeDocument/2006/relationships" id="259" r:id="R1f3ec88e14f74b6f"/>
-    <p:sldId xmlns:r="http://schemas.openxmlformats.org/officeDocument/2006/relationships" id="260" r:id="Ra5e2aecca5864d9b"/>
-    <p:sldId xmlns:r="http://schemas.openxmlformats.org/officeDocument/2006/relationships" id="261" r:id="R0ba1d283f9ef4cd6"/>
-    <p:sldId xmlns:r="http://schemas.openxmlformats.org/officeDocument/2006/relationships" id="262" r:id="R25f9cb7d1eb84101"/>
-    <p:sldId xmlns:r="http://schemas.openxmlformats.org/officeDocument/2006/relationships" id="263" r:id="Rf45561969f3c4d28"/>
-    <p:sldId xmlns:r="http://schemas.openxmlformats.org/officeDocument/2006/relationships" id="264" r:id="Rea894d3cef1c4090"/>
-    <p:sldId xmlns:r="http://schemas.openxmlformats.org/officeDocument/2006/relationships" id="265" r:id="Re58a4e936fc84cc2"/>
+    <p:sldId xmlns:r="http://schemas.openxmlformats.org/officeDocument/2006/relationships" id="256" r:id="Rcf9d295e12c94555"/>
+    <p:sldId xmlns:r="http://schemas.openxmlformats.org/officeDocument/2006/relationships" id="257" r:id="R47b6d95526d24576"/>
+    <p:sldId xmlns:r="http://schemas.openxmlformats.org/officeDocument/2006/relationships" id="258" r:id="R0eb06e0fb6744c46"/>
+    <p:sldId xmlns:r="http://schemas.openxmlformats.org/officeDocument/2006/relationships" id="259" r:id="R85e2fa971cde4561"/>
+    <p:sldId xmlns:r="http://schemas.openxmlformats.org/officeDocument/2006/relationships" id="260" r:id="Re5e7a71543474bd4"/>
+    <p:sldId xmlns:r="http://schemas.openxmlformats.org/officeDocument/2006/relationships" id="261" r:id="R21feced3f3b14666"/>
+    <p:sldId xmlns:r="http://schemas.openxmlformats.org/officeDocument/2006/relationships" id="262" r:id="R0aac90570c26466e"/>
+    <p:sldId xmlns:r="http://schemas.openxmlformats.org/officeDocument/2006/relationships" id="263" r:id="Rfc76c936e80544bf"/>
+    <p:sldId xmlns:r="http://schemas.openxmlformats.org/officeDocument/2006/relationships" id="264" r:id="Rd8cea7a540d7430f"/>
+    <p:sldId xmlns:r="http://schemas.openxmlformats.org/officeDocument/2006/relationships" id="265" r:id="Rade9e585f84c4041"/>
   </p:sldIdLst>
   <p:sldSz cx="12192000" cy="6858000"/>
   <p:notesSz cx="6858000" cy="9144000"/>
@@ -451,7 +451,7 @@
           <a:lstStyle xmlns:a="http://schemas.openxmlformats.org/drawingml/2006/main"/>
           <a:p xmlns:a="http://schemas.openxmlformats.org/drawingml/2006/main">
             <a:r>
-              <a:t>Open with the V3 shift: the system no longer stops at a wallet estimate. It reconstructs an anonymous latent network, detects time-sensitive signals, allocates RM capacity, and requests only decision-relevant evidence.</a:t>
+              <a:t>Open with the V3.1 shift: the final analytical object is a client conversation, not a product row. The twin reconstructs the business, detects a problem, resolves the responsible role, evaluates solution bundles, separates client from bank value and allocates eight weekly conversations.</a:t>
             </a:r>
           </a:p>
           <a:p xmlns:a="http://schemas.openxmlformats.org/drawingml/2006/main">
@@ -466,12 +466,12 @@
           </a:p>
           <a:p xmlns:a="http://schemas.openxmlformats.org/drawingml/2006/main">
             <a:r>
-              <a:t>- docs/v3_methodology.md</a:t>
-            </a:r>
-          </a:p>
-          <a:p xmlns:a="http://schemas.openxmlformats.org/drawingml/2006/main">
-            <a:r>
-              <a:t>- dashboard/app/data/v3-fixture.json</a:t>
+              <a:t>- docs/Corporate_Wallet_Digital_Twin_V3_1_System_Dossier.md</a:t>
+            </a:r>
+          </a:p>
+          <a:p xmlns:a="http://schemas.openxmlformats.org/drawingml/2006/main">
+            <a:r>
+              <a:t>- dashboard/app/data/v31-fixture.json</a:t>
             </a:r>
           </a:p>
           <a:p xmlns:a="http://schemas.openxmlformats.org/drawingml/2006/main">
@@ -546,7 +546,7 @@
           <a:lstStyle xmlns:a="http://schemas.openxmlformats.org/drawingml/2006/main"/>
           <a:p xmlns:a="http://schemas.openxmlformats.org/drawingml/2006/main">
             <a:r>
-              <a:t>Close on the implemented V3 decision loop and the remaining external gates. The client demo is complete and reproducible; production claims remain deliberately fail-closed until bank data, controls and supervised outcomes exist.</a:t>
+              <a:t>Close on the implemented V3.1 decision loop and the remaining external gates. The client demo is complete and reproducible; bank-production claims remain deliberately fail-closed until bank data, controls and supervised outcomes exist.</a:t>
             </a:r>
           </a:p>
           <a:p xmlns:a="http://schemas.openxmlformats.org/drawingml/2006/main">
@@ -561,7 +561,7 @@
           </a:p>
           <a:p xmlns:a="http://schemas.openxmlformats.org/drawingml/2006/main">
             <a:r>
-              <a:t>- docs/v3_implementation_status.md</a:t>
+              <a:t>- docs/v31_implementation_status.md</a:t>
             </a:r>
           </a:p>
           <a:p xmlns:a="http://schemas.openxmlformats.org/drawingml/2006/main">
@@ -646,7 +646,7 @@
           <a:lstStyle xmlns:a="http://schemas.openxmlformats.org/drawingml/2006/main"/>
           <a:p xmlns:a="http://schemas.openxmlformats.org/drawingml/2006/main">
             <a:r>
-              <a:t>Explain A = q × T as an identification problem. Public and accounting anchors constrain T, but they do not observe competitor transactions. The Shadow Wallet is therefore an auditable scenario reconstruction, never measured share.</a:t>
+              <a:t>Explain that V3.1 extends the V3 wallet substrate without changing its interpretation. Public and accounting evidence can constrain a wallet and support a business problem; it cannot reveal competitor transactions or causal RM impact.</a:t>
             </a:r>
           </a:p>
           <a:p xmlns:a="http://schemas.openxmlformats.org/drawingml/2006/main">
@@ -661,22 +661,17 @@
           </a:p>
           <a:p xmlns:a="http://schemas.openxmlformats.org/drawingml/2006/main">
             <a:r>
-              <a:t>- docs/v3_methodology.md</a:t>
-            </a:r>
-          </a:p>
-          <a:p xmlns:a="http://schemas.openxmlformats.org/drawingml/2006/main">
-            <a:r>
-              <a:t>- src/wallet_twin_v3/contracts.py</a:t>
-            </a:r>
-          </a:p>
-          <a:p xmlns:a="http://schemas.openxmlformats.org/drawingml/2006/main">
-            <a:r>
-              <a:t>- src/wallet_twin_v3/shadow_network.py</a:t>
-            </a:r>
-          </a:p>
-          <a:p xmlns:a="http://schemas.openxmlformats.org/drawingml/2006/main">
-            <a:r>
-              <a:t>- Anand, Craig and von Peter, BIS Working Paper 455 (2014)</a:t>
+              <a:t>- src/wallet_twin_v31/contracts.py</a:t>
+            </a:r>
+          </a:p>
+          <a:p xmlns:a="http://schemas.openxmlformats.org/drawingml/2006/main">
+            <a:r>
+              <a:t>- outputs/v31/v31_validation_report.json</a:t>
+            </a:r>
+          </a:p>
+          <a:p xmlns:a="http://schemas.openxmlformats.org/drawingml/2006/main">
+            <a:r>
+              <a:t>- docs/Corporate_Wallet_Digital_Twin_V3_1_Technical_Foundations.md</a:t>
             </a:r>
           </a:p>
         </p:txBody>
@@ -746,7 +741,7 @@
           <a:lstStyle xmlns:a="http://schemas.openxmlformats.org/drawingml/2006/main"/>
           <a:p xmlns:a="http://schemas.openxmlformats.org/drawingml/2006/main">
             <a:r>
-              <a:t>Use Glencore Trade Finance as the worked example. The reconstruction distributes posterior-constrained external mass over five corridor priors and three anonymous provider nodes. Exact reconciliation is a mechanical property, not proof that the individual edges are true.</a:t>
+              <a:t>Every client receives the same twelve Business Twin domains. The register is structurally complete but not public-evidence complete: all clients remain below the target of 15 reviewed E1 claims, and the gap is a release blocker rather than a filled assumption.</a:t>
             </a:r>
           </a:p>
           <a:p xmlns:a="http://schemas.openxmlformats.org/drawingml/2006/main">
@@ -761,22 +756,17 @@
           </a:p>
           <a:p xmlns:a="http://schemas.openxmlformats.org/drawingml/2006/main">
             <a:r>
-              <a:t>- dashboard/app/data/v3-fixture.json — E02-trade-finance</a:t>
-            </a:r>
-          </a:p>
-          <a:p xmlns:a="http://schemas.openxmlformats.org/drawingml/2006/main">
-            <a:r>
-              <a:t>- src/wallet_twin_v3/shadow_network.py</a:t>
-            </a:r>
-          </a:p>
-          <a:p xmlns:a="http://schemas.openxmlformats.org/drawingml/2006/main">
-            <a:r>
-              <a:t>- Cuturi, Sinkhorn Distances, NeurIPS 2013</a:t>
-            </a:r>
-          </a:p>
-          <a:p xmlns:a="http://schemas.openxmlformats.org/drawingml/2006/main">
-            <a:r>
-              <a:t>- docs/v3_methodology.md</a:t>
+              <a:t>- outputs/v31/v31_business_twins.json</a:t>
+            </a:r>
+          </a:p>
+          <a:p xmlns:a="http://schemas.openxmlformats.org/drawingml/2006/main">
+            <a:r>
+              <a:t>- outputs/v31/v31_business_evidence_claims.json</a:t>
+            </a:r>
+          </a:p>
+          <a:p xmlns:a="http://schemas.openxmlformats.org/drawingml/2006/main">
+            <a:r>
+              <a:t>- outputs/v31/v31_validation_report.json</a:t>
             </a:r>
           </a:p>
         </p:txBody>
@@ -846,7 +836,7 @@
           <a:lstStyle xmlns:a="http://schemas.openxmlformats.org/drawingml/2006/main"/>
           <a:p xmlns:a="http://schemas.openxmlformats.org/drawingml/2006/main">
             <a:r>
-              <a:t>Lead with the scarce-capacity decision. V3 optimizes a portfolio rather than ranking 100 independent rows. The robust score combines expected scenario value with lower-tail CVaR and enforces client, product and sector constraints.</a:t>
+              <a:t>Lead with the banker decision: eight discovery conversations, selected after Pareto filtering and mixed-integer CVaR optimization. Unknown bank feasibility prevents product-proposal actions even when a need signal and scenario value are high.</a:t>
             </a:r>
           </a:p>
           <a:p xmlns:a="http://schemas.openxmlformats.org/drawingml/2006/main">
@@ -861,17 +851,17 @@
           </a:p>
           <a:p xmlns:a="http://schemas.openxmlformats.org/drawingml/2006/main">
             <a:r>
-              <a:t>- dashboard/app/data/v3-fixture.json — action_portfolio</a:t>
-            </a:r>
-          </a:p>
-          <a:p xmlns:a="http://schemas.openxmlformats.org/drawingml/2006/main">
-            <a:r>
-              <a:t>- src/wallet_twin_v3/decision_portfolio.py</a:t>
-            </a:r>
-          </a:p>
-          <a:p xmlns:a="http://schemas.openxmlformats.org/drawingml/2006/main">
-            <a:r>
-              <a:t>- docs/v3_methodology.md</a:t>
+              <a:t>- outputs/v31/v31_coverage_plan.json</a:t>
+            </a:r>
+          </a:p>
+          <a:p xmlns:a="http://schemas.openxmlformats.org/drawingml/2006/main">
+            <a:r>
+              <a:t>- src/wallet_twin_v31/portfolio.py</a:t>
+            </a:r>
+          </a:p>
+          <a:p xmlns:a="http://schemas.openxmlformats.org/drawingml/2006/main">
+            <a:r>
+              <a:t>- config/v31_decision_policy.json</a:t>
             </a:r>
           </a:p>
         </p:txBody>
@@ -941,7 +931,7 @@
           <a:lstStyle xmlns:a="http://schemas.openxmlformats.org/drawingml/2006/main"/>
           <a:p xmlns:a="http://schemas.openxmlformats.org/drawingml/2006/main">
             <a:r>
-              <a:t>The leakage alarm multiplies recent change-point evidence, observed decline and reconstructed external-wallet exposure. It is a prioritization signal for verification, not evidence that a competitor captured flow.</a:t>
+              <a:t>Walk the BHP path. The problem is well supported, but the engagement trigger is not. V3.1 therefore surfaces a discovery conversation and the highest-VOI decision-authority question rather than inventing urgency or proposing a product.</a:t>
             </a:r>
           </a:p>
           <a:p xmlns:a="http://schemas.openxmlformats.org/drawingml/2006/main">
@@ -956,17 +946,17 @@
           </a:p>
           <a:p xmlns:a="http://schemas.openxmlformats.org/drawingml/2006/main">
             <a:r>
-              <a:t>- src/wallet_twin_v3/event_dynamics.py</a:t>
-            </a:r>
-          </a:p>
-          <a:p xmlns:a="http://schemas.openxmlformats.org/drawingml/2006/main">
-            <a:r>
-              <a:t>- dashboard/app/data/v3-fixture.json — E02-trade-finance</a:t>
-            </a:r>
-          </a:p>
-          <a:p xmlns:a="http://schemas.openxmlformats.org/drawingml/2006/main">
-            <a:r>
-              <a:t>- Adams and MacKay, Bayesian Online Changepoint Detection (2007)</a:t>
+              <a:t>- dashboard/app/data/v31-fixture.json — conv:686ef2a1e7530b6d84a28714</a:t>
+            </a:r>
+          </a:p>
+          <a:p xmlns:a="http://schemas.openxmlformats.org/drawingml/2006/main">
+            <a:r>
+              <a:t>- src/wallet_twin_v31/business_graph.py</a:t>
+            </a:r>
+          </a:p>
+          <a:p xmlns:a="http://schemas.openxmlformats.org/drawingml/2006/main">
+            <a:r>
+              <a:t>- src/wallet_twin_v31/conversations.py</a:t>
             </a:r>
           </a:p>
         </p:txBody>
@@ -1036,7 +1026,7 @@
           <a:lstStyle xmlns:a="http://schemas.openxmlformats.org/drawingml/2006/main"/>
           <a:p xmlns:a="http://schemas.openxmlformats.org/drawingml/2006/main">
             <a:r>
-              <a:t>This is Decision-Directed RAG. Evidence acquisition is selected only when its expected impact on portfolio utility exceeds cost and delay. Retrieval remains non-autonomous and subject to approval and entitlement controls.</a:t>
+              <a:t>The governing question is not 'what is uncertain?' but 'what answer could change rank, bundle, feasibility or abstention?' The client answer becomes a pending E2 candidate and cannot change the twin until a reviewer approves it.</a:t>
             </a:r>
           </a:p>
           <a:p xmlns:a="http://schemas.openxmlformats.org/drawingml/2006/main">
@@ -1051,22 +1041,17 @@
           </a:p>
           <a:p xmlns:a="http://schemas.openxmlformats.org/drawingml/2006/main">
             <a:r>
-              <a:t>- src/wallet_twin_v3/voi.py</a:t>
-            </a:r>
-          </a:p>
-          <a:p xmlns:a="http://schemas.openxmlformats.org/drawingml/2006/main">
-            <a:r>
-              <a:t>- dashboard/app/data/v3-fixture.json — evidence_acquisition</a:t>
-            </a:r>
-          </a:p>
-          <a:p xmlns:a="http://schemas.openxmlformats.org/drawingml/2006/main">
-            <a:r>
-              <a:t>- Bilgic and Getoor, Value of Information Lattice (2014)</a:t>
-            </a:r>
-          </a:p>
-          <a:p xmlns:a="http://schemas.openxmlformats.org/drawingml/2006/main">
-            <a:r>
-              <a:t>- docs/v3_methodology.md</a:t>
+              <a:t>- src/wallet_twin_v31/questions.py</a:t>
+            </a:r>
+          </a:p>
+          <a:p xmlns:a="http://schemas.openxmlformats.org/drawingml/2006/main">
+            <a:r>
+              <a:t>- outputs/v31/v31_validation_report.json</a:t>
+            </a:r>
+          </a:p>
+          <a:p xmlns:a="http://schemas.openxmlformats.org/drawingml/2006/main">
+            <a:r>
+              <a:t>- Sundin et al., Active Learning for Decision-Making, ICML 2019</a:t>
             </a:r>
           </a:p>
         </p:txBody>
@@ -1136,7 +1121,7 @@
           <a:lstStyle xmlns:a="http://schemas.openxmlformats.org/drawingml/2006/main"/>
           <a:p xmlns:a="http://schemas.openxmlformats.org/drawingml/2006/main">
             <a:r>
-              <a:t>Preserve the V2 continuity benchmark. Trade Finance survives all nine rate/prior cases as the first-ranked product, yet the 10,000-draw global sensitivity and the V3 constrained portfolio both argue against treating it as the entire strategy.</a:t>
+              <a:t>Preserve the V3 continuity benchmark. Trade Finance survives the frozen five-product rate/prior cases, yet the V3.1 conversation plan diversifies because the decision object also contains business problem, stakeholder, feasibility, timing and concentration.</a:t>
             </a:r>
           </a:p>
           <a:p xmlns:a="http://schemas.openxmlformats.org/drawingml/2006/main">
@@ -1151,7 +1136,7 @@
           </a:p>
           <a:p xmlns:a="http://schemas.openxmlformats.org/drawingml/2006/main">
             <a:r>
-              <a:t>- dashboard/app/data/shadow-fixture.json — sensitivity</a:t>
+              <a:t>- dashboard/app/data/shadow-fixture.json â€” sensitivity</a:t>
             </a:r>
           </a:p>
           <a:p xmlns:a="http://schemas.openxmlformats.org/drawingml/2006/main">
@@ -1161,7 +1146,7 @@
           </a:p>
           <a:p xmlns:a="http://schemas.openxmlformats.org/drawingml/2006/main">
             <a:r>
-              <a:t>- dashboard/app/data/shadow-fixture.json — sensitivity.product_summary</a:t>
+              <a:t>- dashboard/app/data/shadow-fixture.json â€” sensitivity.product_summary</a:t>
             </a:r>
           </a:p>
         </p:txBody>
@@ -1231,7 +1216,7 @@
           <a:lstStyle xmlns:a="http://schemas.openxmlformats.org/drawingml/2006/main"/>
           <a:p xmlns:a="http://schemas.openxmlformats.org/drawingml/2006/main">
             <a:r>
-              <a:t>Separate mechanical validation from empirical calibration. V3 proves mass balance, constraints, deterministic replay, provenance and claim suppression. It does not claim representative-bank accuracy without E3 and RM outcomes.</a:t>
+              <a:t>Separate representative validation from bank-production validation. V3.1 proves contracts, point-in-time reconstruction, fail-closed estimators, graph integrity, constraints, deterministic replay and claim suppression; it does not prove a bank's empirical accuracy.</a:t>
             </a:r>
           </a:p>
           <a:p xmlns:a="http://schemas.openxmlformats.org/drawingml/2006/main">
@@ -1246,17 +1231,17 @@
           </a:p>
           <a:p xmlns:a="http://schemas.openxmlformats.org/drawingml/2006/main">
             <a:r>
-              <a:t>- dashboard/app/data/v3-fixture.json — validation</a:t>
-            </a:r>
-          </a:p>
-          <a:p xmlns:a="http://schemas.openxmlformats.org/drawingml/2006/main">
-            <a:r>
-              <a:t>- tests/test_v3_decision_intelligence.py</a:t>
-            </a:r>
-          </a:p>
-          <a:p xmlns:a="http://schemas.openxmlformats.org/drawingml/2006/main">
-            <a:r>
-              <a:t>- docs/v3_implementation_status.md</a:t>
+              <a:t>- outputs/v31/v31_validation_report.json</a:t>
+            </a:r>
+          </a:p>
+          <a:p xmlns:a="http://schemas.openxmlformats.org/drawingml/2006/main">
+            <a:r>
+              <a:t>- tests/test_v31_decision_twin.py</a:t>
+            </a:r>
+          </a:p>
+          <a:p xmlns:a="http://schemas.openxmlformats.org/drawingml/2006/main">
+            <a:r>
+              <a:t>- docs/v31_implementation_status.md</a:t>
             </a:r>
           </a:p>
         </p:txBody>
@@ -1326,7 +1311,7 @@
           <a:lstStyle xmlns:a="http://schemas.openxmlformats.org/drawingml/2006/main"/>
           <a:p xmlns:a="http://schemas.openxmlformats.org/drawingml/2006/main">
             <a:r>
-              <a:t>The LLM is last, not first. V3 selects evidence by value of information, requires approval, compiles a closed claim pack, and permits the model only to narrate approved content. Deterministic fallback remains operational.</a:t>
+              <a:t>The LLM is last, not first. V3.1 compiles a closed Why–How–What pack and permits the provider only to translate approved content. Arithmetic, ranks, graph paths, values, VOI and citations remain deterministic; provider failure returns the deterministic brief.</a:t>
             </a:r>
           </a:p>
           <a:p xmlns:a="http://schemas.openxmlformats.org/drawingml/2006/main">
@@ -1341,7 +1326,7 @@
           </a:p>
           <a:p xmlns:a="http://schemas.openxmlformats.org/drawingml/2006/main">
             <a:r>
-              <a:t>- src/wallet_twin_v3/briefing.py</a:t>
+              <a:t>- src/wallet_twin_v31/briefs.py</a:t>
             </a:r>
           </a:p>
           <a:p xmlns:a="http://schemas.openxmlformats.org/drawingml/2006/main">
@@ -1424,7 +1409,7 @@
   </p:cSld>
   <p:clrMap bg1="lt1" tx1="dk1" bg2="lt2" tx2="dk2" accent1="accent1" accent2="accent2" accent3="accent3" accent4="accent4" accent5="accent5" accent6="accent6" hlink="hlink" folHlink="folHlink"/>
   <p:sldLayoutIdLst>
-    <p:sldLayoutId xmlns:r="http://schemas.openxmlformats.org/officeDocument/2006/relationships" id="2147483649" r:id="R17801c5bdec744f0"/>
+    <p:sldLayoutId xmlns:r="http://schemas.openxmlformats.org/officeDocument/2006/relationships" id="2147483649" r:id="R62f12f00f57a4d1e"/>
   </p:sldLayoutIdLst>
   <p:txStyles>
     <p:titleStyle>
@@ -1974,19 +1959,19 @@
             <c:strLit>
               <c:ptCount val="5"/>
               <c:pt idx="0">
-                <c:v>Glencore – TF</c:v>
+                <c:v>Bid Corp · Liquidity</c:v>
               </c:pt>
               <c:pt idx="1">
-                <c:v>BHP – TF</c:v>
+                <c:v>Sanlam · Payments</c:v>
               </c:pt>
               <c:pt idx="2">
-                <c:v>MTN – FX</c:v>
+                <c:v>Sanlam · Liquidity</c:v>
               </c:pt>
               <c:pt idx="3">
-                <c:v>Bid Corp – FX</c:v>
+                <c:v>BHP · FX</c:v>
               </c:pt>
               <c:pt idx="4">
-                <c:v>Anglo American – Liquidity</c:v>
+                <c:v>Shoprite · FX</c:v>
               </c:pt>
             </c:strLit>
           </c:cat>
@@ -1995,19 +1980,19 @@
               <c:formatCode>General</c:formatCode>
               <c:ptCount val="5"/>
               <c:pt idx="0">
-                <c:v>11.1</c:v>
+                <c:v>13.7</c:v>
               </c:pt>
               <c:pt idx="1">
-                <c:v>4.6</c:v>
+                <c:v>17</c:v>
               </c:pt>
               <c:pt idx="2">
-                <c:v>3.7</c:v>
+                <c:v>17</c:v>
               </c:pt>
               <c:pt idx="3">
-                <c:v>2.6</c:v>
+                <c:v>14.6</c:v>
               </c:pt>
               <c:pt idx="4">
-                <c:v>2.6</c:v>
+                <c:v>5.9</c:v>
               </c:pt>
             </c:numLit>
           </c:val>
@@ -2049,7 +2034,7 @@
               <a:lstStyle xmlns:a="http://schemas.openxmlformats.org/drawingml/2006/main"/>
               <a:p xmlns:a="http://schemas.openxmlformats.org/drawingml/2006/main">
                 <a:r>
-                  <a:t>Median scenario contribution gap (R million)</a:t>
+                  <a:t>Client-value proxy (R million)</a:t>
                 </a:r>
               </a:p>
             </c:rich>
@@ -2150,7 +2135,7 @@
           <p:nvPr/>
         </p:nvPicPr>
         <p:blipFill>
-          <a:blip xmlns:r="http://schemas.openxmlformats.org/officeDocument/2006/relationships" xmlns:a="http://schemas.openxmlformats.org/drawingml/2006/main" r:embed="Ra4cd3e28ef4c4a23"/>
+          <a:blip xmlns:r="http://schemas.openxmlformats.org/officeDocument/2006/relationships" xmlns:a="http://schemas.openxmlformats.org/drawingml/2006/main" r:embed="R23a4de620b784cd3"/>
           <a:srcRect xmlns:a="http://schemas.openxmlformats.org/drawingml/2006/main" l="0" t="27" r="0" b="27"/>
           <a:stretch xmlns:a="http://schemas.openxmlformats.org/drawingml/2006/main">
             <a:fillRect l="0" t="0" r="0" b="0"/>
@@ -2393,7 +2378,7 @@
                 <a:ea typeface="Arial"/>
                 <a:cs typeface="Arial"/>
               </a:rPr>
-              <a:t>Reconstruct the unseen wallet.</a:t>
+              <a:t>Know the business.</a:t>
             </a:r>
           </a:p>
           <a:p xmlns:a="http://schemas.openxmlformats.org/drawingml/2006/main">
@@ -2417,7 +2402,7 @@
                 <a:ea typeface="Arial"/>
                 <a:cs typeface="Arial"/>
               </a:rPr>
-              <a:t>Decide what matters next.</a:t>
+              <a:t>Plan the right conversation.</a:t>
             </a:r>
           </a:p>
         </p:txBody>
@@ -2498,7 +2483,7 @@
                 <a:ea typeface="Arial"/>
                 <a:cs typeface="Arial"/>
               </a:rPr>
-              <a:t>Latent-network reconstruction and decision intelligence for corporate relationship teams</a:t>
+              <a:t>Business-model reconstruction and decision intelligence for corporate relationship teams</a:t>
             </a:r>
           </a:p>
         </p:txBody>
@@ -2675,7 +2660,7 @@
                 <a:ea typeface="Arial"/>
                 <a:cs typeface="Arial"/>
               </a:rPr>
-              <a:t>V3.0 | AS OF 10 AUGUST 2026 | SYN BANK SIMULATION + PUBLIC E1</a:t>
+              <a:t>V3.1.0 | AS OF 30 JUNE 2026 | CLIENT DEMO — PUBLIC E1 + SYN BANK</a:t>
             </a:r>
           </a:p>
         </p:txBody>
@@ -2798,7 +2783,7 @@
         </p:spPr>
         <p:txBody>
           <a:bodyPr xmlns:a="http://schemas.openxmlformats.org/drawingml/2006/main" anchor="t">
-            <a:normAutofit fontScale="81286"/>
+            <a:normAutofit fontScale="92649"/>
           </a:bodyPr>
           <a:lstStyle xmlns:a="http://schemas.openxmlformats.org/drawingml/2006/main"/>
           <a:p xmlns:a="http://schemas.openxmlformats.org/drawingml/2006/main">
@@ -2822,7 +2807,7 @@
                 <a:ea typeface="Arial"/>
                 <a:cs typeface="Arial"/>
               </a:rPr>
-              <a:t>Demonstrate the latent decision lab</a:t>
+              <a:t>Demonstrate the Decision Twin</a:t>
             </a:r>
           </a:p>
           <a:p xmlns:a="http://schemas.openxmlformats.org/drawingml/2006/main">
@@ -2846,7 +2831,7 @@
                 <a:ea typeface="Arial"/>
                 <a:cs typeface="Arial"/>
               </a:rPr>
-              <a:t>then earn production</a:t>
+              <a:t>then earn bank production</a:t>
             </a:r>
           </a:p>
         </p:txBody>
@@ -2905,7 +2890,7 @@
                 <a:ea typeface="Arial"/>
                 <a:cs typeface="Arial"/>
               </a:rPr>
-              <a:t>V3 turns partial observations into reconstructed wallets, temporal signals, constrained actions and a deliberate evidence queue—without overstating what was measured.</a:t>
+              <a:t>V3.1 turns partial evidence into business context, solution bundles, dual value, governed conversations and an active learning loop—without overstating what was measured.</a:t>
             </a:r>
           </a:p>
         </p:txBody>
@@ -3021,7 +3006,7 @@
         </p:spPr>
         <p:txBody>
           <a:bodyPr xmlns:a="http://schemas.openxmlformats.org/drawingml/2006/main" anchor="t">
-            <a:normAutofit fontScale="96707"/>
+            <a:normAutofit fontScale="92057"/>
           </a:bodyPr>
           <a:lstStyle xmlns:a="http://schemas.openxmlformats.org/drawingml/2006/main"/>
           <a:p xmlns:a="http://schemas.openxmlformats.org/drawingml/2006/main">
@@ -3045,7 +3030,7 @@
                 <a:ea typeface="Arial"/>
                 <a:cs typeface="Arial"/>
               </a:rPr>
-              <a:t>Reconstruct the unseen wallet</a:t>
+              <a:t>Reconstruct the client business</a:t>
             </a:r>
           </a:p>
         </p:txBody>
@@ -3104,7 +3089,7 @@
                 <a:ea typeface="Arial"/>
                 <a:cs typeface="Arial"/>
               </a:rPr>
-              <a:t>100 client-product networks, 1,500 anonymous external edges and exact mass balance.</a:t>
+              <a:t>Twenty twelve-domain twins, temporal graphs, problems, stakeholders and sixteen solution families.</a:t>
             </a:r>
           </a:p>
         </p:txBody>
@@ -3244,7 +3229,7 @@
                 <a:ea typeface="Arial"/>
                 <a:cs typeface="Arial"/>
               </a:rPr>
-              <a:t>Allocate scarce attention</a:t>
+              <a:t>Plan eight conversations</a:t>
             </a:r>
           </a:p>
         </p:txBody>
@@ -3303,7 +3288,7 @@
                 <a:ea typeface="Arial"/>
                 <a:cs typeface="Arial"/>
               </a:rPr>
-              <a:t>Twelve CVaR-aware actions plus eight positive-net-value evidence requests.</a:t>
+              <a:t>Pareto-filtered, CVaR-aware discovery actions plus positive-net-VOI client questions.</a:t>
             </a:r>
           </a:p>
         </p:txBody>
@@ -3561,7 +3546,7 @@
                 <a:ea typeface="Arial"/>
                 <a:cs typeface="Arial"/>
               </a:rPr>
-              <a:t>A better decision today. A measurable learning system tomorrow.</a:t>
+              <a:t>A better conversation today. A measurable learning system tomorrow.</a:t>
             </a:r>
           </a:p>
         </p:txBody>
@@ -3620,7 +3605,7 @@
                 <a:ea typeface="Arial"/>
                 <a:cs typeface="Arial"/>
               </a:rPr>
-              <a:t>Corporate Wallet Digital Twin | Christopher Koen | V3.0</a:t>
+              <a:t>Corporate Wallet Digital Twin | Christopher Koen | V3.1.0</a:t>
             </a:r>
           </a:p>
         </p:txBody>
@@ -3760,7 +3745,7 @@
                 <a:ea typeface="Arial"/>
                 <a:cs typeface="Arial"/>
               </a:rPr>
-              <a:t>THE PARTIAL-OBSERVATION PROBLEM</a:t>
+              <a:t>THE DECISION OBJECT</a:t>
             </a:r>
           </a:p>
         </p:txBody>
@@ -3795,7 +3780,7 @@
         </p:spPr>
         <p:txBody>
           <a:bodyPr xmlns:a="http://schemas.openxmlformats.org/drawingml/2006/main" anchor="t">
-            <a:normAutofit fontScale="95930"/>
+            <a:normAutofit fontScale="96032"/>
           </a:bodyPr>
           <a:lstStyle xmlns:a="http://schemas.openxmlformats.org/drawingml/2006/main"/>
           <a:p xmlns:a="http://schemas.openxmlformats.org/drawingml/2006/main">
@@ -3819,7 +3804,7 @@
                 <a:ea typeface="Arial"/>
                 <a:cs typeface="Arial"/>
               </a:rPr>
-              <a:t>Partial observation cannot reveal the full financial system</a:t>
+              <a:t>The decision starts beyond a client–product row</a:t>
             </a:r>
           </a:p>
         </p:txBody>
@@ -3900,7 +3885,7 @@
                 <a:ea typeface="Arial"/>
                 <a:cs typeface="Arial"/>
               </a:rPr>
-              <a:t>TEAM: Corporate Wallet Digital Twin | Christopher Koen | V3.0</a:t>
+              <a:t>TEAM: Corporate Wallet Digital Twin | Christopher Koen | V3.1.0</a:t>
             </a:r>
           </a:p>
         </p:txBody>
@@ -4053,7 +4038,7 @@
         </p:spPr>
         <p:txBody>
           <a:bodyPr xmlns:a="http://schemas.openxmlformats.org/drawingml/2006/main" anchor="t">
-            <a:normAutofit fontScale="90960"/>
+            <a:normAutofit fontScale="92269"/>
           </a:bodyPr>
           <a:lstStyle xmlns:a="http://schemas.openxmlformats.org/drawingml/2006/main"/>
           <a:p xmlns:a="http://schemas.openxmlformats.org/drawingml/2006/main">
@@ -4077,7 +4062,7 @@
                 <a:ea typeface="Arial"/>
                 <a:cs typeface="Arial"/>
               </a:rPr>
-              <a:t>Syn Bank observes its own product activity—not the total client wallet, external allocation or response to an RM action. V3 makes that partial-observation boundary explicit.</a:t>
+              <a:t>Syn Bank observes product activity—not the full business model, total wallet, decision owner or response to an RM action. V3.1 adds the context needed for a governed conversation.</a:t>
             </a:r>
           </a:p>
         </p:txBody>
@@ -4615,7 +4600,7 @@
         </p:spPr>
         <p:txBody>
           <a:bodyPr xmlns:a="http://schemas.openxmlformats.org/drawingml/2006/main" anchor="t">
-            <a:normAutofit fontScale="56024"/>
+            <a:normAutofit fontScale="60094"/>
           </a:bodyPr>
           <a:lstStyle xmlns:a="http://schemas.openxmlformats.org/drawingml/2006/main"/>
           <a:p xmlns:a="http://schemas.openxmlformats.org/drawingml/2006/main">
@@ -4639,7 +4624,7 @@
                 <a:ea typeface="Arial"/>
                 <a:cs typeface="Arial"/>
               </a:rPr>
-              <a:t>V3 preserves the claim ladder—and reconstructs only as scenario</a:t>
+              <a:t>One claim ladder governs every twin, value and conversation</a:t>
             </a:r>
           </a:p>
         </p:txBody>
@@ -5199,7 +5184,7 @@
                 <a:ea typeface="Arial"/>
                 <a:cs typeface="Arial"/>
               </a:rPr>
-              <a:t>Anonymous shadow network</a:t>
+              <a:t>Problem, bundle and value</a:t>
             </a:r>
           </a:p>
         </p:txBody>
@@ -5429,7 +5414,7 @@
                 <a:ea typeface="Arial"/>
                 <a:cs typeface="Arial"/>
               </a:rPr>
-              <a:t>All 1,500 external edges remain SCENARIO, SYNTHETIC_SIMULATION and RECONSTRUCTED_NOT_MEASURED; causal value remains withheld.</a:t>
+              <a:t>85 E1 and 820 E0 claims remain separated; measured competitor share and causal value remain zero; unknown bank feasibility stays UNKNOWN.</a:t>
             </a:r>
           </a:p>
         </p:txBody>
@@ -5510,7 +5495,7 @@
                 <a:ea typeface="Arial"/>
                 <a:cs typeface="Arial"/>
               </a:rPr>
-              <a:t>SHADOW WALLET RECONSTRUCTION</a:t>
+              <a:t>BUSINESS MODEL TWIN</a:t>
             </a:r>
           </a:p>
         </p:txBody>
@@ -5569,7 +5554,7 @@
                 <a:ea typeface="Arial"/>
                 <a:cs typeface="Arial"/>
               </a:rPr>
-              <a:t>The Shadow Wallet balances every reconstructed flow</a:t>
+              <a:t>Twenty clients receive the same twelve-domain twin</a:t>
             </a:r>
           </a:p>
         </p:txBody>
@@ -5650,7 +5635,7 @@
                 <a:ea typeface="Arial"/>
                 <a:cs typeface="Arial"/>
               </a:rPr>
-              <a:t>TEAM: Corporate Wallet Digital Twin | Christopher Koen | V3.0</a:t>
+              <a:t>TEAM: Corporate Wallet Digital Twin | Christopher Koen | V3.1.0</a:t>
             </a:r>
           </a:p>
         </p:txBody>
@@ -5849,7 +5834,7 @@
                 <a:ea typeface="Arial"/>
                 <a:cs typeface="Arial"/>
               </a:rPr>
-              <a:t>R1.1bn</a:t>
+              <a:t>20</a:t>
             </a:r>
           </a:p>
         </p:txBody>
@@ -5908,7 +5893,7 @@
                 <a:ea typeface="Arial"/>
                 <a:cs typeface="Arial"/>
               </a:rPr>
-              <a:t>observed Syn Bank flow</a:t>
+              <a:t>client twins</a:t>
             </a:r>
           </a:p>
         </p:txBody>
@@ -5989,7 +5974,7 @@
                 <a:ea typeface="Arial"/>
                 <a:cs typeface="Arial"/>
               </a:rPr>
-              <a:t>7.2%</a:t>
+              <a:t>240</a:t>
             </a:r>
           </a:p>
         </p:txBody>
@@ -6048,7 +6033,7 @@
                 <a:ea typeface="Arial"/>
                 <a:cs typeface="Arial"/>
               </a:rPr>
-              <a:t>scenario bank-share median</a:t>
+              <a:t>domain components</a:t>
             </a:r>
           </a:p>
         </p:txBody>
@@ -6129,7 +6114,7 @@
                 <a:ea typeface="Arial"/>
                 <a:cs typeface="Arial"/>
               </a:rPr>
-              <a:t>R15.0bn</a:t>
+              <a:t>905</a:t>
             </a:r>
           </a:p>
         </p:txBody>
@@ -6188,7 +6173,7 @@
                 <a:ea typeface="Arial"/>
                 <a:cs typeface="Arial"/>
               </a:rPr>
-              <a:t>total-wallet median</a:t>
+              <a:t>typed evidence claims</a:t>
             </a:r>
           </a:p>
         </p:txBody>
@@ -6269,7 +6254,7 @@
                 <a:ea typeface="Arial"/>
                 <a:cs typeface="Arial"/>
               </a:rPr>
-              <a:t>R13.9bn</a:t>
+              <a:t>71</a:t>
             </a:r>
           </a:p>
         </p:txBody>
@@ -6328,7 +6313,7 @@
                 <a:ea typeface="Arial"/>
                 <a:cs typeface="Arial"/>
               </a:rPr>
-              <a:t>latent external median</a:t>
+              <a:t>explicit evidence gaps</a:t>
             </a:r>
           </a:p>
         </p:txBody>
@@ -6387,7 +6372,7 @@
                 <a:ea typeface="Arial"/>
                 <a:cs typeface="Arial"/>
               </a:rPr>
-              <a:t>External-wallet reconciliation</a:t>
+              <a:t>Evidence and graph projection</a:t>
             </a:r>
           </a:p>
         </p:txBody>
@@ -6446,7 +6431,7 @@
                 <a:ea typeface="Arial"/>
                 <a:cs typeface="Arial"/>
               </a:rPr>
-              <a:t>Posterior total</a:t>
+              <a:t>Approved claims</a:t>
             </a:r>
           </a:p>
         </p:txBody>
@@ -6536,7 +6521,7 @@
                 <a:ea typeface="Arial"/>
                 <a:cs typeface="Arial"/>
               </a:rPr>
-              <a:t>R15.0bn</a:t>
+              <a:t>854</a:t>
             </a:r>
           </a:p>
         </p:txBody>
@@ -6595,7 +6580,7 @@
                 <a:ea typeface="Arial"/>
                 <a:cs typeface="Arial"/>
               </a:rPr>
-              <a:t>Observed + latent</a:t>
+              <a:t>Pending review</a:t>
             </a:r>
           </a:p>
         </p:txBody>
@@ -6617,7 +6602,7 @@
         <p:spPr>
           <a:xfrm xmlns:a="http://schemas.openxmlformats.org/drawingml/2006/main">
             <a:off x="2038350" y="4400550"/>
-            <a:ext cx="4008235" cy="257175"/>
+            <a:ext cx="266700" cy="257175"/>
           </a:xfrm>
           <a:prstGeom xmlns:a="http://schemas.openxmlformats.org/drawingml/2006/main" prst="rect">
             <a:avLst/>
@@ -6685,7 +6670,7 @@
                 <a:ea typeface="Arial"/>
                 <a:cs typeface="Arial"/>
               </a:rPr>
-              <a:t>R15.0bn</a:t>
+              <a:t>51</a:t>
             </a:r>
           </a:p>
         </p:txBody>
@@ -6744,7 +6729,7 @@
                 <a:ea typeface="Arial"/>
                 <a:cs typeface="Arial"/>
               </a:rPr>
-              <a:t>R0 balance error</a:t>
+              <a:t>12/12 domains each</a:t>
             </a:r>
           </a:p>
         </p:txBody>
@@ -6779,7 +6764,7 @@
         </p:spPr>
         <p:txBody>
           <a:bodyPr xmlns:a="http://schemas.openxmlformats.org/drawingml/2006/main" anchor="t">
-            <a:normAutofit fontScale="84375"/>
+            <a:normAutofit fontScale="79158"/>
           </a:bodyPr>
           <a:lstStyle xmlns:a="http://schemas.openxmlformats.org/drawingml/2006/main"/>
           <a:p xmlns:a="http://schemas.openxmlformats.org/drawingml/2006/main">
@@ -6803,7 +6788,7 @@
                 <a:ea typeface="Arial"/>
                 <a:cs typeface="Arial"/>
               </a:rPr>
-              <a:t>256 ensemble draws</a:t>
+              <a:t>993 nodes · 1,154 edges</a:t>
             </a:r>
           </a:p>
         </p:txBody>
@@ -6893,7 +6878,7 @@
                 <a:ea typeface="Arial"/>
                 <a:cs typeface="Arial"/>
               </a:rPr>
-              <a:t>METHOD</a:t>
+              <a:t>BOUNDARY</a:t>
             </a:r>
           </a:p>
         </p:txBody>
@@ -6928,7 +6913,7 @@
         </p:spPr>
         <p:txBody>
           <a:bodyPr xmlns:a="http://schemas.openxmlformats.org/drawingml/2006/main" anchor="t">
-            <a:normAutofit fontScale="86387"/>
+            <a:normAutofit fontScale="92420"/>
           </a:bodyPr>
           <a:lstStyle xmlns:a="http://schemas.openxmlformats.org/drawingml/2006/main"/>
           <a:p xmlns:a="http://schemas.openxmlformats.org/drawingml/2006/main">
@@ -6952,7 +6937,7 @@
                 <a:ea typeface="Arial"/>
                 <a:cs typeface="Arial"/>
               </a:rPr>
-              <a:t>Entropy-regularised transport</a:t>
+              <a:t>Unknown remains unknown</a:t>
             </a:r>
           </a:p>
         </p:txBody>
@@ -7011,7 +6996,7 @@
                 <a:ea typeface="Arial"/>
                 <a:cs typeface="Arial"/>
               </a:rPr>
-              <a:t>5 corridors × 3 anonymous providers</a:t>
+              <a:t>Attribute + event graph</a:t>
             </a:r>
           </a:p>
           <a:p xmlns:a="http://schemas.openxmlformats.org/drawingml/2006/main">
@@ -7035,7 +7020,7 @@
                 <a:ea typeface="Arial"/>
                 <a:cs typeface="Arial"/>
               </a:rPr>
-              <a:t>Posterior supplies total mass</a:t>
+              <a:t>Point-in-time availability</a:t>
             </a:r>
           </a:p>
           <a:p xmlns:a="http://schemas.openxmlformats.org/drawingml/2006/main">
@@ -7059,7 +7044,7 @@
                 <a:ea typeface="Arial"/>
                 <a:cs typeface="Arial"/>
               </a:rPr>
-              <a:t>Sinkhorn preserves marginals</a:t>
+              <a:t>Approved lineage on every path</a:t>
             </a:r>
           </a:p>
           <a:p xmlns:a="http://schemas.openxmlformats.org/drawingml/2006/main">
@@ -7083,7 +7068,7 @@
                 <a:ea typeface="Arial"/>
                 <a:cs typeface="Arial"/>
               </a:rPr>
-              <a:t>No competitor identities inferred</a:t>
+              <a:t>No named people in demo</a:t>
             </a:r>
           </a:p>
         </p:txBody>
@@ -7164,7 +7149,7 @@
                 <a:ea typeface="Arial"/>
                 <a:cs typeface="Arial"/>
               </a:rPr>
-              <a:t>ROBUST RM PORTFOLIO</a:t>
+              <a:t>MONDAY-MORNING COVERAGE PLAN</a:t>
             </a:r>
           </a:p>
         </p:txBody>
@@ -7223,7 +7208,7 @@
                 <a:ea typeface="Arial"/>
                 <a:cs typeface="Arial"/>
               </a:rPr>
-              <a:t>Twelve RM actions survive capacity and downside risk</a:t>
+              <a:t>Eight conversations survive feasibility and downside risk</a:t>
             </a:r>
           </a:p>
         </p:txBody>
@@ -7304,7 +7289,7 @@
                 <a:ea typeface="Arial"/>
                 <a:cs typeface="Arial"/>
               </a:rPr>
-              <a:t>TEAM: Corporate Wallet Digital Twin | Christopher Koen | V3.0</a:t>
+              <a:t>TEAM: Corporate Wallet Digital Twin | Christopher Koen | V3.1.0</a:t>
             </a:r>
           </a:p>
         </p:txBody>
@@ -7571,7 +7556,7 @@
                 <a:ea typeface="Arial"/>
                 <a:cs typeface="Arial"/>
               </a:rPr>
-              <a:t>Glencore</a:t>
+              <a:t>Bid Corporation</a:t>
             </a:r>
           </a:p>
         </p:txBody>
@@ -7630,7 +7615,7 @@
                 <a:ea typeface="Arial"/>
                 <a:cs typeface="Arial"/>
               </a:rPr>
-              <a:t>Trade Finance</a:t>
+              <a:t>Liquidity · Treasurer</a:t>
             </a:r>
           </a:p>
         </p:txBody>
@@ -7689,7 +7674,7 @@
                 <a:ea typeface="Arial"/>
                 <a:cs typeface="Arial"/>
               </a:rPr>
-              <a:t>R11.1m</a:t>
+              <a:t>R13.7m</a:t>
             </a:r>
           </a:p>
         </p:txBody>
@@ -7748,7 +7733,7 @@
                 <a:ea typeface="Arial"/>
                 <a:cs typeface="Arial"/>
               </a:rPr>
-              <a:t>expected scenario value</a:t>
+              <a:t>client-value proxy</a:t>
             </a:r>
           </a:p>
         </p:txBody>
@@ -7807,7 +7792,7 @@
                 <a:ea typeface="Arial"/>
                 <a:cs typeface="Arial"/>
               </a:rPr>
-              <a:t>R5.0m downside CVaR | 100% need</a:t>
+              <a:t>R4.0m bank scenario | 79.2% stability</a:t>
             </a:r>
           </a:p>
         </p:txBody>
@@ -7842,7 +7827,7 @@
         </p:spPr>
         <p:txBody>
           <a:bodyPr xmlns:a="http://schemas.openxmlformats.org/drawingml/2006/main" anchor="t">
-            <a:normAutofit fontScale="83359"/>
+            <a:normAutofit fontScale="88072"/>
           </a:bodyPr>
           <a:lstStyle xmlns:a="http://schemas.openxmlformats.org/drawingml/2006/main"/>
           <a:p xmlns:a="http://schemas.openxmlformats.org/drawingml/2006/main">
@@ -7866,7 +7851,7 @@
                 <a:ea typeface="Arial"/>
                 <a:cs typeface="Arial"/>
               </a:rPr>
-              <a:t>Verify external wallet and instrument mix before contact; causal incremental value is withheld.</a:t>
+              <a:t>Discovery only: validate the liquidity structure and feasibility before any product proposal.</a:t>
             </a:r>
           </a:p>
         </p:txBody>
@@ -7925,7 +7910,7 @@
                 <a:ea typeface="Arial"/>
                 <a:cs typeface="Arial"/>
               </a:rPr>
-              <a:t>Top five CVaR-aware action values</a:t>
+              <a:t>Top five client-value scenarios</a:t>
             </a:r>
           </a:p>
         </p:txBody>
@@ -7942,7 +7927,7 @@
         </p:xfrm>
         <a:graphic xmlns:a="http://schemas.openxmlformats.org/drawingml/2006/main">
           <a:graphicData uri="http://schemas.openxmlformats.org/drawingml/2006/chart">
-            <c:chart xmlns:r="http://schemas.openxmlformats.org/officeDocument/2006/relationships" xmlns:c="http://schemas.openxmlformats.org/drawingml/2006/chart" r:id="R7bfe2cf79063405e"/>
+            <c:chart xmlns:r="http://schemas.openxmlformats.org/officeDocument/2006/relationships" xmlns:c="http://schemas.openxmlformats.org/drawingml/2006/chart" r:id="Rb95400c35ecd4c3f"/>
           </a:graphicData>
         </a:graphic>
       </p:graphicFrame>
@@ -8007,7 +7992,7 @@
         </p:spPr>
         <p:txBody>
           <a:bodyPr xmlns:a="http://schemas.openxmlformats.org/drawingml/2006/main" anchor="t">
-            <a:normAutofit fontScale="54902"/>
+            <a:normAutofit fontScale="57250"/>
           </a:bodyPr>
           <a:lstStyle xmlns:a="http://schemas.openxmlformats.org/drawingml/2006/main"/>
           <a:p xmlns:a="http://schemas.openxmlformats.org/drawingml/2006/main">
@@ -8031,7 +8016,7 @@
                 <a:ea typeface="Arial"/>
                 <a:cs typeface="Arial"/>
               </a:rPr>
-              <a:t>Capacity: 12. At most one action per client, four per product and four per sector. The selected portfolio contains four Trade Finance, four FX and four Liquidity actions.</a:t>
+              <a:t>Capacity: 8. At most two per client; one per client/role; three per solution and sector. Solver status: OPTIMAL over 512 common draws.</a:t>
             </a:r>
           </a:p>
         </p:txBody>
@@ -8112,7 +8097,7 @@
                 <a:ea typeface="Arial"/>
                 <a:cs typeface="Arial"/>
               </a:rPr>
-              <a:t>TEMPORAL DYNAMICS</a:t>
+              <a:t>BHP EXPLANATION PATH</a:t>
             </a:r>
           </a:p>
         </p:txBody>
@@ -8147,7 +8132,7 @@
         </p:spPr>
         <p:txBody>
           <a:bodyPr xmlns:a="http://schemas.openxmlformats.org/drawingml/2006/main" anchor="t">
-            <a:normAutofit fontScale="90596"/>
+            <a:normAutofit fontScale="96032"/>
           </a:bodyPr>
           <a:lstStyle xmlns:a="http://schemas.openxmlformats.org/drawingml/2006/main"/>
           <a:p xmlns:a="http://schemas.openxmlformats.org/drawingml/2006/main">
@@ -8171,7 +8156,7 @@
                 <a:ea typeface="Arial"/>
                 <a:cs typeface="Arial"/>
               </a:rPr>
-              <a:t>Change-points surface leakage risk without claiming leakage</a:t>
+              <a:t>BHP’s FX case is valuable—but not yet urgent</a:t>
             </a:r>
           </a:p>
         </p:txBody>
@@ -8252,7 +8237,7 @@
                 <a:ea typeface="Arial"/>
                 <a:cs typeface="Arial"/>
               </a:rPr>
-              <a:t>TEAM: Corporate Wallet Digital Twin | Christopher Koen | V3.0</a:t>
+              <a:t>TEAM: Corporate Wallet Digital Twin | Christopher Koen | V3.1.0</a:t>
             </a:r>
           </a:p>
         </p:txBody>
@@ -8429,7 +8414,7 @@
                 <a:ea typeface="Arial"/>
                 <a:cs typeface="Arial"/>
               </a:rPr>
-              <a:t>GLENCORE TRADE FINANCE — MODELLED SIGNAL</a:t>
+              <a:t>BHP · TREASURER · FX EXPOSURE · DISCOVERY</a:t>
             </a:r>
           </a:p>
         </p:txBody>
@@ -8510,7 +8495,7 @@
                 <a:ea typeface="Arial"/>
                 <a:cs typeface="Arial"/>
               </a:rPr>
-              <a:t>4.6%</a:t>
+              <a:t>90.3%</a:t>
             </a:r>
           </a:p>
         </p:txBody>
@@ -8569,7 +8554,7 @@
                 <a:ea typeface="Arial"/>
                 <a:cs typeface="Arial"/>
               </a:rPr>
-              <a:t>CURRENT CP</a:t>
+              <a:t>NEED SCENARIO</a:t>
             </a:r>
           </a:p>
         </p:txBody>
@@ -8650,7 +8635,7 @@
                 <a:ea typeface="Arial"/>
                 <a:cs typeface="Arial"/>
               </a:rPr>
-              <a:t>17.6%</a:t>
+              <a:t>R14.6m</a:t>
             </a:r>
           </a:p>
         </p:txBody>
@@ -8709,7 +8694,7 @@
                 <a:ea typeface="Arial"/>
                 <a:cs typeface="Arial"/>
               </a:rPr>
-              <a:t>RECENT PEAK</a:t>
+              <a:t>CLIENT PROXY</a:t>
             </a:r>
           </a:p>
         </p:txBody>
@@ -8790,7 +8775,7 @@
                 <a:ea typeface="Arial"/>
                 <a:cs typeface="Arial"/>
               </a:rPr>
-              <a:t>30.6%</a:t>
+              <a:t>R8.1m</a:t>
             </a:r>
           </a:p>
         </p:txBody>
@@ -8849,7 +8834,7 @@
                 <a:ea typeface="Arial"/>
                 <a:cs typeface="Arial"/>
               </a:rPr>
-              <a:t>90-DAY EVENT</a:t>
+              <a:t>BANK SCENARIO</a:t>
             </a:r>
           </a:p>
         </p:txBody>
@@ -8915,7 +8900,7 @@
         </p:spPr>
         <p:txBody>
           <a:bodyPr xmlns:a="http://schemas.openxmlformats.org/drawingml/2006/main" anchor="t">
-            <a:normAutofit fontScale="79653"/>
+            <a:normAutofit fontScale="46552"/>
           </a:bodyPr>
           <a:lstStyle xmlns:a="http://schemas.openxmlformats.org/drawingml/2006/main"/>
           <a:p xmlns:a="http://schemas.openxmlformats.org/drawingml/2006/main">
@@ -8939,7 +8924,7 @@
                 <a:ea typeface="Arial"/>
                 <a:cs typeface="Arial"/>
               </a:rPr>
-              <a:t>100 Bayesian run-length series</a:t>
+              <a:t>Event → impact → problem → role → bundle → value</a:t>
             </a:r>
           </a:p>
         </p:txBody>
@@ -8974,7 +8959,7 @@
         </p:spPr>
         <p:txBody>
           <a:bodyPr xmlns:a="http://schemas.openxmlformats.org/drawingml/2006/main" anchor="t">
-            <a:normAutofit fontScale="88976"/>
+            <a:normAutofit fontScale="97960"/>
           </a:bodyPr>
           <a:lstStyle xmlns:a="http://schemas.openxmlformats.org/drawingml/2006/main"/>
           <a:p xmlns:a="http://schemas.openxmlformats.org/drawingml/2006/main">
@@ -8998,7 +8983,7 @@
                 <a:ea typeface="Arial"/>
                 <a:cs typeface="Arial"/>
               </a:rPr>
-              <a:t>Each 36-month client-product sequence updates a run-length posterior. Observed decline scales the alarm; no decline means no leakage signal.</a:t>
+              <a:t>Audited FX evidence plus observed cross-border activity supports the problem; no dated trigger supports time-critical urgency.</a:t>
             </a:r>
           </a:p>
         </p:txBody>
@@ -9057,7 +9042,7 @@
                 <a:ea typeface="Arial"/>
                 <a:cs typeface="Arial"/>
               </a:rPr>
-              <a:t>Decision: route the signal to RM verification</a:t>
+              <a:t>Decision: ask who signs off—and abstain from urgency</a:t>
             </a:r>
           </a:p>
         </p:txBody>
@@ -9265,7 +9250,7 @@
                 <a:ea typeface="Arial"/>
                 <a:cs typeface="Arial"/>
               </a:rPr>
-              <a:t>confirmed leakage events</a:t>
+              <a:t>causal value claims</a:t>
             </a:r>
           </a:p>
         </p:txBody>
@@ -9324,7 +9309,7 @@
                 <a:ea typeface="Arial"/>
                 <a:cs typeface="Arial"/>
               </a:rPr>
-              <a:t>MODELLED SIGNAL</a:t>
+              <a:t>DISCOVERY ONLY</a:t>
             </a:r>
           </a:p>
           <a:p xmlns:a="http://schemas.openxmlformats.org/drawingml/2006/main">
@@ -9348,7 +9333,7 @@
                 <a:ea typeface="Arial"/>
                 <a:cs typeface="Arial"/>
               </a:rPr>
-              <a:t>Not confirmed leakage; needs named events and RM outcomes.</a:t>
+              <a:t>Client and bank value are separate; causal value is null.</a:t>
             </a:r>
           </a:p>
         </p:txBody>
@@ -9383,7 +9368,7 @@
         </p:spPr>
         <p:txBody>
           <a:bodyPr xmlns:a="http://schemas.openxmlformats.org/drawingml/2006/main" anchor="t">
-            <a:normAutofit fontScale="86667"/>
+            <a:normAutofit fontScale="76347"/>
           </a:bodyPr>
           <a:lstStyle xmlns:a="http://schemas.openxmlformats.org/drawingml/2006/main"/>
           <a:p xmlns:a="http://schemas.openxmlformats.org/drawingml/2006/main">
@@ -9407,7 +9392,7 @@
                 <a:ea typeface="Arial"/>
                 <a:cs typeface="Arial"/>
               </a:rPr>
-              <a:t>No competitor transfer, churn or causal-loss claim is permitted from the change-point score alone.</a:t>
+              <a:t>Hedge ratio, decision authority and bank feasibility remain unknown; product proposal and guaranteed-saving claims are prohibited.</a:t>
             </a:r>
           </a:p>
         </p:txBody>
@@ -9488,7 +9473,7 @@
                 <a:ea typeface="Arial"/>
                 <a:cs typeface="Arial"/>
               </a:rPr>
-              <a:t>DECISION-DIRECTED EVIDENCE</a:t>
+              <a:t>ACTIVE COVERAGE LEARNING</a:t>
             </a:r>
           </a:p>
         </p:txBody>
@@ -9547,7 +9532,7 @@
                 <a:ea typeface="Arial"/>
                 <a:cs typeface="Arial"/>
               </a:rPr>
-              <a:t>Retrieve evidence only when it can change the portfolio</a:t>
+              <a:t>Ask only when the answer can change the decision</a:t>
             </a:r>
           </a:p>
         </p:txBody>
@@ -9628,7 +9613,7 @@
                 <a:ea typeface="Arial"/>
                 <a:cs typeface="Arial"/>
               </a:rPr>
-              <a:t>TEAM: Corporate Wallet Digital Twin | Christopher Koen | V3.0</a:t>
+              <a:t>TEAM: Corporate Wallet Digital Twin | Christopher Koen | V3.1.0</a:t>
             </a:r>
           </a:p>
         </p:txBody>
@@ -9827,7 +9812,7 @@
                 <a:ea typeface="Arial"/>
                 <a:cs typeface="Arial"/>
               </a:rPr>
-              <a:t>8</a:t>
+              <a:t>308</a:t>
             </a:r>
           </a:p>
         </p:txBody>
@@ -9886,7 +9871,7 @@
                 <a:ea typeface="Arial"/>
                 <a:cs typeface="Arial"/>
               </a:rPr>
-              <a:t>positive-net-VOI requests</a:t>
+              <a:t>positive-net-VOI questions</a:t>
             </a:r>
           </a:p>
         </p:txBody>
@@ -9945,7 +9930,7 @@
                 <a:ea typeface="Arial"/>
                 <a:cs typeface="Arial"/>
               </a:rPr>
-              <a:t>Selected after utility, evidence cost and latency</a:t>
+              <a:t>Selected from 891 evaluations with 512 common draws</a:t>
             </a:r>
           </a:p>
         </p:txBody>
@@ -10026,7 +10011,7 @@
                 <a:ea typeface="Arial"/>
                 <a:cs typeface="Arial"/>
               </a:rPr>
-              <a:t>R43.3m</a:t>
+              <a:t>R10.6k</a:t>
             </a:r>
           </a:p>
         </p:txBody>
@@ -10085,7 +10070,7 @@
                 <a:ea typeface="Arial"/>
                 <a:cs typeface="Arial"/>
               </a:rPr>
-              <a:t>expected net information value</a:t>
+              <a:t>BHP question net VOI</a:t>
             </a:r>
           </a:p>
         </p:txBody>
@@ -10144,7 +10129,7 @@
                 <a:ea typeface="Arial"/>
                 <a:cs typeface="Arial"/>
               </a:rPr>
-              <a:t>Representative decision value—not booked or causal value</a:t>
+              <a:t>Decision value—not booked, client or causal value</a:t>
             </a:r>
           </a:p>
         </p:txBody>
@@ -10284,7 +10269,7 @@
                 <a:ea typeface="Arial"/>
                 <a:cs typeface="Arial"/>
               </a:rPr>
-              <a:t>autonomous retrievals</a:t>
+              <a:t>direct model updates</a:t>
             </a:r>
           </a:p>
         </p:txBody>
@@ -10343,7 +10328,7 @@
                 <a:ea typeface="Arial"/>
                 <a:cs typeface="Arial"/>
               </a:rPr>
-              <a:t>Approval remains mandatory for every acquisition</a:t>
+              <a:t>Every submitted answer remains pending until approval</a:t>
             </a:r>
           </a:p>
         </p:txBody>
@@ -10492,7 +10477,7 @@
                 <a:ea typeface="Arial"/>
                 <a:cs typeface="Arial"/>
               </a:rPr>
-              <a:t>Score rank uncertainty and portfolio sensitivity</a:t>
+              <a:t>Model explicit answer states and decision effects</a:t>
             </a:r>
           </a:p>
         </p:txBody>
@@ -10582,7 +10567,7 @@
                 <a:ea typeface="Arial"/>
                 <a:cs typeface="Arial"/>
               </a:rPr>
-              <a:t>Subtract acquisition cost and latency penalty</a:t>
+              <a:t>Subtract question cost and delay penalty</a:t>
             </a:r>
           </a:p>
         </p:txBody>
@@ -10617,7 +10602,7 @@
         </p:spPr>
         <p:txBody>
           <a:bodyPr xmlns:a="http://schemas.openxmlformats.org/drawingml/2006/main" anchor="t">
-            <a:normAutofit fontScale="43081"/>
+            <a:normAutofit fontScale="50769"/>
           </a:bodyPr>
           <a:lstStyle xmlns:a="http://schemas.openxmlformats.org/drawingml/2006/main"/>
           <a:p xmlns:a="http://schemas.openxmlformats.org/drawingml/2006/main">
@@ -10641,7 +10626,7 @@
                 <a:ea typeface="Arial"/>
                 <a:cs typeface="Arial"/>
               </a:rPr>
-              <a:t>= 8 evidence requests</a:t>
+              <a:t>1 primary question</a:t>
             </a:r>
           </a:p>
         </p:txBody>
@@ -11457,7 +11442,7 @@
         </p:spPr>
         <p:txBody>
           <a:bodyPr xmlns:a="http://schemas.openxmlformats.org/drawingml/2006/main" anchor="t">
-            <a:normAutofit fontScale="96032"/>
+            <a:normAutofit fontScale="93039"/>
           </a:bodyPr>
           <a:lstStyle xmlns:a="http://schemas.openxmlformats.org/drawingml/2006/main"/>
           <a:p xmlns:a="http://schemas.openxmlformats.org/drawingml/2006/main">
@@ -11481,7 +11466,7 @@
                 <a:ea typeface="Arial"/>
                 <a:cs typeface="Arial"/>
               </a:rPr>
-              <a:t>Trade Finance stays first-ranked, not portfolio-dominant</a:t>
+              <a:t>Trade Finance remains robust—but conversations diversify</a:t>
             </a:r>
           </a:p>
         </p:txBody>
@@ -11562,7 +11547,7 @@
                 <a:ea typeface="Arial"/>
                 <a:cs typeface="Arial"/>
               </a:rPr>
-              <a:t>TEAM: Corporate Wallet Digital Twin | Christopher Koen | V3.0</a:t>
+              <a:t>TEAM: Corporate Wallet Digital Twin | Christopher Koen | V3.1.0</a:t>
             </a:r>
           </a:p>
         </p:txBody>
@@ -11888,7 +11873,7 @@
                 <a:ea typeface="Arial"/>
                 <a:cs typeface="Arial"/>
               </a:rPr>
-              <a:t>Trade Finance remains the first-ranked product across all frozen low/base/high rate and prior cases.</a:t>
+              <a:t>The five-product V3 benchmark remains reproducible: Trade Finance is first-ranked in all frozen rate/prior cases.</a:t>
             </a:r>
           </a:p>
         </p:txBody>
@@ -13765,7 +13750,7 @@
         </p:spPr>
         <p:txBody>
           <a:bodyPr xmlns:a="http://schemas.openxmlformats.org/drawingml/2006/main" anchor="t">
-            <a:normAutofit fontScale="84259"/>
+            <a:normAutofit fontScale="74886"/>
           </a:bodyPr>
           <a:lstStyle xmlns:a="http://schemas.openxmlformats.org/drawingml/2006/main"/>
           <a:p xmlns:a="http://schemas.openxmlformats.org/drawingml/2006/main">
@@ -13789,7 +13774,7 @@
                 <a:ea typeface="Arial"/>
                 <a:cs typeface="Arial"/>
               </a:rPr>
-              <a:t>V3 selects four Trade Finance, four FX and four Liquidity actions—diversified under scarce RM capacity.</a:t>
+              <a:t>V3.1 selects two Trade Finance, three FX and three transaction-banking conversations after stakeholder, problem, feasibility and concentration constraints.</a:t>
             </a:r>
           </a:p>
         </p:txBody>
@@ -13870,7 +13855,7 @@
                 <a:ea typeface="Arial"/>
                 <a:cs typeface="Arial"/>
               </a:rPr>
-              <a:t>V3 MECHANICAL VALIDATION</a:t>
+              <a:t>V3.1 REPRESENTATIVE VALIDATION</a:t>
             </a:r>
           </a:p>
         </p:txBody>
@@ -13929,7 +13914,7 @@
                 <a:ea typeface="Arial"/>
                 <a:cs typeface="Arial"/>
               </a:rPr>
-              <a:t>V3 adds structure without inventing empirical truth</a:t>
+              <a:t>Complete mechanics still do not create bank evidence</a:t>
             </a:r>
           </a:p>
         </p:txBody>
@@ -14010,7 +13995,7 @@
                 <a:ea typeface="Arial"/>
                 <a:cs typeface="Arial"/>
               </a:rPr>
-              <a:t>TEAM: Corporate Wallet Digital Twin | Christopher Koen | V3.0</a:t>
+              <a:t>TEAM: Corporate Wallet Digital Twin | Christopher Koen | V3.1.0</a:t>
             </a:r>
           </a:p>
         </p:txBody>
@@ -14209,7 +14194,7 @@
                 <a:ea typeface="Arial"/>
                 <a:cs typeface="Arial"/>
               </a:rPr>
-              <a:t>1,500</a:t>
+              <a:t>320</a:t>
             </a:r>
           </a:p>
         </p:txBody>
@@ -14268,7 +14253,7 @@
                 <a:ea typeface="Arial"/>
                 <a:cs typeface="Arial"/>
               </a:rPr>
-              <a:t>shadow-wallet edges</a:t>
+              <a:t>solution projections</a:t>
             </a:r>
           </a:p>
         </p:txBody>
@@ -14327,7 +14312,7 @@
                 <a:ea typeface="Arial"/>
                 <a:cs typeface="Arial"/>
               </a:rPr>
-              <a:t>Exact flow reconciliation across 100 client-product networks</a:t>
+              <a:t>Sixteen solution families across all twenty clients</a:t>
             </a:r>
           </a:p>
         </p:txBody>
@@ -14408,7 +14393,7 @@
                 <a:ea typeface="Arial"/>
                 <a:cs typeface="Arial"/>
               </a:rPr>
-              <a:t>100</a:t>
+              <a:t>224</a:t>
             </a:r>
           </a:p>
         </p:txBody>
@@ -14467,7 +14452,7 @@
                 <a:ea typeface="Arial"/>
                 <a:cs typeface="Arial"/>
               </a:rPr>
-              <a:t>change-point series</a:t>
+              <a:t>conversation candidates</a:t>
             </a:r>
           </a:p>
         </p:txBody>
@@ -14526,7 +14511,7 @@
                 <a:ea typeface="Arial"/>
                 <a:cs typeface="Arial"/>
               </a:rPr>
-              <a:t>Deterministic temporal replay; not RM-outcome calibrated</a:t>
+              <a:t>All discovery-only under unknown bank feasibility</a:t>
             </a:r>
           </a:p>
         </p:txBody>
@@ -14666,7 +14651,7 @@
                 <a:ea typeface="Arial"/>
                 <a:cs typeface="Arial"/>
               </a:rPr>
-              <a:t>selected VOI positive</a:t>
+              <a:t>plan constraints satisfied</a:t>
             </a:r>
           </a:p>
         </p:txBody>
@@ -14725,7 +14710,7 @@
                 <a:ea typeface="Arial"/>
                 <a:cs typeface="Arial"/>
               </a:rPr>
-              <a:t>All retrieval remains non-autonomous</a:t>
+              <a:t>Mixed-integer solver status: OPTIMAL</a:t>
             </a:r>
           </a:p>
         </p:txBody>
@@ -14907,7 +14892,7 @@
                 <a:ea typeface="Arial"/>
                 <a:cs typeface="Arial"/>
               </a:rPr>
-              <a:t>256-draw entropy transport uses anonymous provider nodes</a:t>
+              <a:t>Twenty twins × twelve components reproduce point-in-time</a:t>
             </a:r>
           </a:p>
         </p:txBody>
@@ -14999,7 +14984,7 @@
                 <a:ea typeface="Arial"/>
                 <a:cs typeface="Arial"/>
               </a:rPr>
-              <a:t>PU probabilities retain their SCAR assumption and selection constant</a:t>
+              <a:t>All 320 solution rows return an interval or fail-closed reason</a:t>
             </a:r>
           </a:p>
         </p:txBody>
@@ -15091,7 +15076,7 @@
                 <a:ea typeface="Arial"/>
                 <a:cs typeface="Arial"/>
               </a:rPr>
-              <a:t>CVaR portfolio enforces client, product and sector capacity caps</a:t>
+              <a:t>Pareto + CVaR enforce role, client, solution and sector limits</a:t>
             </a:r>
           </a:p>
         </p:txBody>
@@ -15183,7 +15168,7 @@
                 <a:ea typeface="Arial"/>
                 <a:cs typeface="Arial"/>
               </a:rPr>
-              <a:t>All /v3 routes inherit deny-by-default ABAC and as-of contracts</a:t>
+              <a:t>Every V3.1 read requires as_of and deny-by-default ABAC</a:t>
             </a:r>
           </a:p>
         </p:txBody>
@@ -15391,7 +15376,7 @@
         </p:spPr>
         <p:txBody>
           <a:bodyPr xmlns:a="http://schemas.openxmlformats.org/drawingml/2006/main" anchor="t">
-            <a:normAutofit fontScale="80215"/>
+            <a:normAutofit fontScale="88889"/>
           </a:bodyPr>
           <a:lstStyle xmlns:a="http://schemas.openxmlformats.org/drawingml/2006/main"/>
           <a:p xmlns:a="http://schemas.openxmlformats.org/drawingml/2006/main">
@@ -15415,7 +15400,7 @@
                 <a:ea typeface="Arial"/>
                 <a:cs typeface="Arial"/>
               </a:rPr>
-              <a:t>No E3 competitor share, bank-approved economics or causal RM outcomes exist. V3 reports zero measured-share and zero causal-value claims.</a:t>
+              <a:t>No E3 share, approved economics or RM outcomes exist. Measured-share and causal-value claims: zero.</a:t>
             </a:r>
           </a:p>
         </p:txBody>
@@ -15496,7 +15481,7 @@
                 <a:ea typeface="Arial"/>
                 <a:cs typeface="Arial"/>
               </a:rPr>
-              <a:t>DECISION-DIRECTED RAG + GENAI</a:t>
+              <a:t>CONTROLLED GENAI</a:t>
             </a:r>
           </a:p>
         </p:txBody>
@@ -15555,7 +15540,7 @@
                 <a:ea typeface="Arial"/>
                 <a:cs typeface="Arial"/>
               </a:rPr>
-              <a:t>Ask for evidence before asking for prose</a:t>
+              <a:t>The narrator translates a closed decision pack</a:t>
             </a:r>
           </a:p>
         </p:txBody>
@@ -15636,7 +15621,7 @@
                 <a:ea typeface="Arial"/>
                 <a:cs typeface="Arial"/>
               </a:rPr>
-              <a:t>TEAM: Corporate Wallet Digital Twin | Christopher Koen | V3.0</a:t>
+              <a:t>TEAM: Corporate Wallet Digital Twin | Christopher Koen | V3.1.0</a:t>
             </a:r>
           </a:p>
         </p:txBody>
@@ -16030,7 +16015,7 @@
         </p:spPr>
         <p:txBody>
           <a:bodyPr xmlns:a="http://schemas.openxmlformats.org/drawingml/2006/main" anchor="t">
-            <a:normAutofit fontScale="100000"/>
+            <a:normAutofit fontScale="86053"/>
           </a:bodyPr>
           <a:lstStyle xmlns:a="http://schemas.openxmlformats.org/drawingml/2006/main"/>
           <a:p xmlns:a="http://schemas.openxmlformats.org/drawingml/2006/main">
@@ -16054,7 +16039,7 @@
                 <a:ea typeface="Arial"/>
                 <a:cs typeface="Arial"/>
               </a:rPr>
-              <a:t>Portfolio sensitivity and uncertainty</a:t>
+              <a:t>Deterministic problem, value and rank</a:t>
             </a:r>
           </a:p>
         </p:txBody>
@@ -16242,7 +16227,7 @@
         </p:spPr>
         <p:txBody>
           <a:bodyPr xmlns:a="http://schemas.openxmlformats.org/drawingml/2006/main" anchor="t">
-            <a:normAutofit fontScale="100000"/>
+            <a:normAutofit fontScale="90884"/>
           </a:bodyPr>
           <a:lstStyle xmlns:a="http://schemas.openxmlformats.org/drawingml/2006/main"/>
           <a:p xmlns:a="http://schemas.openxmlformats.org/drawingml/2006/main">
@@ -16266,7 +16251,7 @@
                 <a:ea typeface="Arial"/>
                 <a:cs typeface="Arial"/>
               </a:rPr>
-              <a:t>Expected utility gain minus cost</a:t>
+              <a:t>Question utility minus cost and delay</a:t>
             </a:r>
           </a:p>
         </p:txBody>
@@ -16478,7 +16463,7 @@
                 <a:ea typeface="Arial"/>
                 <a:cs typeface="Arial"/>
               </a:rPr>
-              <a:t>Approved, entitled evidence only</a:t>
+              <a:t>Approved, entitled claims only</a:t>
             </a:r>
           </a:p>
         </p:txBody>
@@ -16690,7 +16675,7 @@
                 <a:ea typeface="Arial"/>
                 <a:cs typeface="Arial"/>
               </a:rPr>
-              <a:t>Claims, numbers and citations</a:t>
+              <a:t>Why–How–What closed pack</a:t>
             </a:r>
           </a:p>
         </p:txBody>
@@ -16983,7 +16968,7 @@
                 <a:ea typeface="Arial"/>
                 <a:cs typeface="Arial"/>
               </a:rPr>
-              <a:t>8</a:t>
+              <a:t>224</a:t>
             </a:r>
           </a:p>
         </p:txBody>
@@ -17042,7 +17027,7 @@
                 <a:ea typeface="Arial"/>
                 <a:cs typeface="Arial"/>
               </a:rPr>
-              <a:t>VOI requests</a:t>
+              <a:t>deterministic briefs</a:t>
             </a:r>
           </a:p>
         </p:txBody>
@@ -17101,7 +17086,7 @@
                 <a:ea typeface="Arial"/>
                 <a:cs typeface="Arial"/>
               </a:rPr>
-              <a:t>Decision-selected, never autonomous</a:t>
+              <a:t>One closed pack per conversation</a:t>
             </a:r>
           </a:p>
         </p:txBody>
@@ -17182,7 +17167,7 @@
                 <a:ea typeface="Arial"/>
                 <a:cs typeface="Arial"/>
               </a:rPr>
-              <a:t>809</a:t>
+              <a:t>100%</a:t>
             </a:r>
           </a:p>
         </p:txBody>
@@ -17241,7 +17226,7 @@
                 <a:ea typeface="Arial"/>
                 <a:cs typeface="Arial"/>
               </a:rPr>
-              <a:t>governed checks</a:t>
+              <a:t>schema requirement</a:t>
             </a:r>
           </a:p>
         </p:txBody>
@@ -17300,7 +17285,7 @@
                 <a:ea typeface="Arial"/>
                 <a:cs typeface="Arial"/>
               </a:rPr>
-              <a:t>Schema, evidence, page grounding and stress</a:t>
+              <a:t>Numbers and citations must survive exactly</a:t>
             </a:r>
           </a:p>
         </p:txBody>
@@ -17381,7 +17366,7 @@
                 <a:ea typeface="Arial"/>
                 <a:cs typeface="Arial"/>
               </a:rPr>
-              <a:t>640</a:t>
+              <a:t>0</a:t>
             </a:r>
           </a:p>
         </p:txBody>
@@ -17440,7 +17425,7 @@
                 <a:ea typeface="Arial"/>
                 <a:cs typeface="Arial"/>
               </a:rPr>
-              <a:t>stress cases</a:t>
+              <a:t>unsupported paths allowed</a:t>
             </a:r>
           </a:p>
         </p:txBody>
@@ -17499,7 +17484,7 @@
                 <a:ea typeface="Arial"/>
                 <a:cs typeface="Arial"/>
               </a:rPr>
-              <a:t>Exact, future, injection and missing evidence</a:t>
+              <a:t>Unknown urgency and roles force abstention</a:t>
             </a:r>
           </a:p>
         </p:txBody>

</xml_diff>

<commit_message>
Harden V3.1.1 hackathon submission
</commit_message>
<xml_diff>
--- a/output/presentation/Corporate-Wallet-Digital-Twin.pptx
+++ b/output/presentation/Corporate-Wallet-Digital-Twin.pptx
@@ -2,22 +2,22 @@
 <file path=ppt/presentation.xml><?xml version="1.0" encoding="utf-8"?>
 <p:presentation xmlns:p="http://schemas.openxmlformats.org/presentationml/2006/main">
   <p:sldMasterIdLst>
-    <p:sldMasterId xmlns:r="http://schemas.openxmlformats.org/officeDocument/2006/relationships" id="2147483648" r:id="Rd4eea221f6b5409b"/>
+    <p:sldMasterId xmlns:r="http://schemas.openxmlformats.org/officeDocument/2006/relationships" id="2147483648" r:id="R0e6a1ae0dbeb43ec"/>
   </p:sldMasterIdLst>
   <p:notesMasterIdLst>
-    <p:notesMasterId xmlns:r="http://schemas.openxmlformats.org/officeDocument/2006/relationships" r:id="Rba62f2c9c11c465e"/>
+    <p:notesMasterId xmlns:r="http://schemas.openxmlformats.org/officeDocument/2006/relationships" r:id="R7439a0cc94464d79"/>
   </p:notesMasterIdLst>
   <p:sldIdLst>
-    <p:sldId xmlns:r="http://schemas.openxmlformats.org/officeDocument/2006/relationships" id="256" r:id="Rcf9d295e12c94555"/>
-    <p:sldId xmlns:r="http://schemas.openxmlformats.org/officeDocument/2006/relationships" id="257" r:id="R47b6d95526d24576"/>
-    <p:sldId xmlns:r="http://schemas.openxmlformats.org/officeDocument/2006/relationships" id="258" r:id="R0eb06e0fb6744c46"/>
-    <p:sldId xmlns:r="http://schemas.openxmlformats.org/officeDocument/2006/relationships" id="259" r:id="R85e2fa971cde4561"/>
-    <p:sldId xmlns:r="http://schemas.openxmlformats.org/officeDocument/2006/relationships" id="260" r:id="Re5e7a71543474bd4"/>
-    <p:sldId xmlns:r="http://schemas.openxmlformats.org/officeDocument/2006/relationships" id="261" r:id="R21feced3f3b14666"/>
-    <p:sldId xmlns:r="http://schemas.openxmlformats.org/officeDocument/2006/relationships" id="262" r:id="R0aac90570c26466e"/>
-    <p:sldId xmlns:r="http://schemas.openxmlformats.org/officeDocument/2006/relationships" id="263" r:id="Rfc76c936e80544bf"/>
-    <p:sldId xmlns:r="http://schemas.openxmlformats.org/officeDocument/2006/relationships" id="264" r:id="Rd8cea7a540d7430f"/>
-    <p:sldId xmlns:r="http://schemas.openxmlformats.org/officeDocument/2006/relationships" id="265" r:id="Rade9e585f84c4041"/>
+    <p:sldId xmlns:r="http://schemas.openxmlformats.org/officeDocument/2006/relationships" id="256" r:id="R7cd4c181f0c24394"/>
+    <p:sldId xmlns:r="http://schemas.openxmlformats.org/officeDocument/2006/relationships" id="257" r:id="R203f467eca994407"/>
+    <p:sldId xmlns:r="http://schemas.openxmlformats.org/officeDocument/2006/relationships" id="258" r:id="R9af28401cca84ad2"/>
+    <p:sldId xmlns:r="http://schemas.openxmlformats.org/officeDocument/2006/relationships" id="259" r:id="R764231041c9947f8"/>
+    <p:sldId xmlns:r="http://schemas.openxmlformats.org/officeDocument/2006/relationships" id="260" r:id="Rdc3ea98cb75944a2"/>
+    <p:sldId xmlns:r="http://schemas.openxmlformats.org/officeDocument/2006/relationships" id="261" r:id="R9447e146db444dd9"/>
+    <p:sldId xmlns:r="http://schemas.openxmlformats.org/officeDocument/2006/relationships" id="262" r:id="R5891d8c8af0f4e3c"/>
+    <p:sldId xmlns:r="http://schemas.openxmlformats.org/officeDocument/2006/relationships" id="263" r:id="Reefa20804bd74c25"/>
+    <p:sldId xmlns:r="http://schemas.openxmlformats.org/officeDocument/2006/relationships" id="264" r:id="R4e6c6db2e7e24b87"/>
+    <p:sldId xmlns:r="http://schemas.openxmlformats.org/officeDocument/2006/relationships" id="265" r:id="Ra5283b935b634ea7"/>
   </p:sldIdLst>
   <p:sldSz cx="12192000" cy="6858000"/>
   <p:notesSz cx="6858000" cy="9144000"/>
@@ -451,7 +451,7 @@
           <a:lstStyle xmlns:a="http://schemas.openxmlformats.org/drawingml/2006/main"/>
           <a:p xmlns:a="http://schemas.openxmlformats.org/drawingml/2006/main">
             <a:r>
-              <a:t>Open with the V3.1 shift: the final analytical object is a client conversation, not a product row. The twin reconstructs the business, detects a problem, resolves the responsible role, evaluates solution bundles, separates client from bank value and allocates eight weekly conversations.</a:t>
+              <a:t>Lead with the commercial answer: Syn Bank observes only its own activity. The solution estimates an interval for total client wallet and bank share, sizes the contestable gap, then turns it into an evidence-backed relationship-manager conversation.</a:t>
             </a:r>
           </a:p>
           <a:p xmlns:a="http://schemas.openxmlformats.org/drawingml/2006/main">
@@ -466,17 +466,17 @@
           </a:p>
           <a:p xmlns:a="http://schemas.openxmlformats.org/drawingml/2006/main">
             <a:r>
-              <a:t>- docs/Corporate_Wallet_Digital_Twin_V3_1_System_Dossier.md</a:t>
-            </a:r>
-          </a:p>
-          <a:p xmlns:a="http://schemas.openxmlformats.org/drawingml/2006/main">
-            <a:r>
-              <a:t>- dashboard/app/data/v31-fixture.json</a:t>
-            </a:r>
-          </a:p>
-          <a:p xmlns:a="http://schemas.openxmlformats.org/drawingml/2006/main">
-            <a:r>
-              <a:t>- config/submission.json</a:t>
+              <a:t>- dashboard/app/data/wallet-v311-fixture.json</a:t>
+            </a:r>
+          </a:p>
+          <a:p xmlns:a="http://schemas.openxmlformats.org/drawingml/2006/main">
+            <a:r>
+              <a:t>- outputs/v2_validation/measurement_policy_sensitivity.json</a:t>
+            </a:r>
+          </a:p>
+          <a:p xmlns:a="http://schemas.openxmlformats.org/drawingml/2006/main">
+            <a:r>
+              <a:t>- https://github.com/ChristopherJohannesKoen/corporate-wallet-digital-twin-hackathon-2026-public</a:t>
             </a:r>
           </a:p>
         </p:txBody>
@@ -546,7 +546,7 @@
           <a:lstStyle xmlns:a="http://schemas.openxmlformats.org/drawingml/2006/main"/>
           <a:p xmlns:a="http://schemas.openxmlformats.org/drawingml/2006/main">
             <a:r>
-              <a:t>Close on the implemented V3.1 decision loop and the remaining external gates. The client demo is complete and reproducible; bank-production claims remain deliberately fail-closed until bank data, controls and supervised outcomes exist.</a:t>
+              <a:t>Close with the commercial story and honest boundary. V3.1.1 is a reproducible hackathon submission once the artifact and public-access gates pass. Bank production stays NOT_PROMOTABLE until representative external calibration, approved bank economics and controls, live provider adjudication and qualified RM outcomes exist.</a:t>
             </a:r>
           </a:p>
           <a:p xmlns:a="http://schemas.openxmlformats.org/drawingml/2006/main">
@@ -566,7 +566,7 @@
           </a:p>
           <a:p xmlns:a="http://schemas.openxmlformats.org/drawingml/2006/main">
             <a:r>
-              <a:t>- docs/production_deployment_runbook.md</a:t>
+              <a:t>- outputs/v2_validation/production_candidate_scorecard.json</a:t>
             </a:r>
           </a:p>
           <a:p xmlns:a="http://schemas.openxmlformats.org/drawingml/2006/main">
@@ -577,6 +577,11 @@
           <a:p xmlns:a="http://schemas.openxmlformats.org/drawingml/2006/main">
             <a:r>
               <a:t>- output/pdf/Corporate-Wallet-Digital-Twin-One-Pager.pdf</a:t>
+            </a:r>
+          </a:p>
+          <a:p xmlns:a="http://schemas.openxmlformats.org/drawingml/2006/main">
+            <a:r>
+              <a:t>- https://github.com/ChristopherJohannesKoen/corporate-wallet-digital-twin-hackathon-2026-public</a:t>
             </a:r>
           </a:p>
         </p:txBody>
@@ -646,7 +651,7 @@
           <a:lstStyle xmlns:a="http://schemas.openxmlformats.org/drawingml/2006/main"/>
           <a:p xmlns:a="http://schemas.openxmlformats.org/drawingml/2006/main">
             <a:r>
-              <a:t>Explain that V3.1 extends the V3 wallet substrate without changing its interpretation. Public and accounting evidence can constrain a wallet and support a business problem; it cannot reveal competitor transactions or causal RM impact.</a:t>
+              <a:t>Explain the core identification problem using A=qT. A is observed in supplied Syn Bank activity; T and q are not. Approved public anchors can narrow plausible T, while governed priors form a posterior interval. Nothing in this chain directly observes competitor transactions.</a:t>
             </a:r>
           </a:p>
           <a:p xmlns:a="http://schemas.openxmlformats.org/drawingml/2006/main">
@@ -661,17 +666,17 @@
           </a:p>
           <a:p xmlns:a="http://schemas.openxmlformats.org/drawingml/2006/main">
             <a:r>
-              <a:t>- src/wallet_twin_v31/contracts.py</a:t>
-            </a:r>
-          </a:p>
-          <a:p xmlns:a="http://schemas.openxmlformats.org/drawingml/2006/main">
-            <a:r>
-              <a:t>- outputs/v31/v31_validation_report.json</a:t>
-            </a:r>
-          </a:p>
-          <a:p xmlns:a="http://schemas.openxmlformats.org/drawingml/2006/main">
-            <a:r>
-              <a:t>- docs/Corporate_Wallet_Digital_Twin_V3_1_Technical_Foundations.md</a:t>
+              <a:t>- src/wallet_twin_v2/wallet_model.py</a:t>
+            </a:r>
+          </a:p>
+          <a:p xmlns:a="http://schemas.openxmlformats.org/drawingml/2006/main">
+            <a:r>
+              <a:t>- src/wallet_twin_v2/measurement_policy.py</a:t>
+            </a:r>
+          </a:p>
+          <a:p xmlns:a="http://schemas.openxmlformats.org/drawingml/2006/main">
+            <a:r>
+              <a:t>- docs/methodology.md</a:t>
             </a:r>
           </a:p>
         </p:txBody>
@@ -741,7 +746,7 @@
           <a:lstStyle xmlns:a="http://schemas.openxmlformats.org/drawingml/2006/main"/>
           <a:p xmlns:a="http://schemas.openxmlformats.org/drawingml/2006/main">
             <a:r>
-              <a:t>Every client receives the same twelve Business Twin domains. The register is structurally complete but not public-evidence complete: all clients remain below the target of 15 reviewed E1 claims, and the gap is a release blocker rather than a filled assumption.</a:t>
+              <a:t>Show the supplied-data chain. Transaction legs produce Collections, Payments and a liquidity-flow opportunity proxy. Cross-border activity provides an FX exposure proxy; instruments provide Trade Finance activity. The conceptual problem statement mentions fifty clients, while the supplied archive contains twenty relationships; all twenty are modelled.</a:t>
             </a:r>
           </a:p>
           <a:p xmlns:a="http://schemas.openxmlformats.org/drawingml/2006/main">
@@ -756,17 +761,17 @@
           </a:p>
           <a:p xmlns:a="http://schemas.openxmlformats.org/drawingml/2006/main">
             <a:r>
-              <a:t>- outputs/v31/v31_business_twins.json</a:t>
-            </a:r>
-          </a:p>
-          <a:p xmlns:a="http://schemas.openxmlformats.org/drawingml/2006/main">
-            <a:r>
-              <a:t>- outputs/v31/v31_business_evidence_claims.json</a:t>
-            </a:r>
-          </a:p>
-          <a:p xmlns:a="http://schemas.openxmlformats.org/drawingml/2006/main">
-            <a:r>
-              <a:t>- outputs/v31/v31_validation_report.json</a:t>
+              <a:t>- notebooks/01_wallet_twin_demo.ipynb</a:t>
+            </a:r>
+          </a:p>
+          <a:p xmlns:a="http://schemas.openxmlformats.org/drawingml/2006/main">
+            <a:r>
+              <a:t>- output/notebook/01_wallet_twin_demo.html</a:t>
+            </a:r>
+          </a:p>
+          <a:p xmlns:a="http://schemas.openxmlformats.org/drawingml/2006/main">
+            <a:r>
+              <a:t>- dashboard/app/data/wallet-v311-fixture.json</a:t>
             </a:r>
           </a:p>
         </p:txBody>
@@ -836,7 +841,7 @@
           <a:lstStyle xmlns:a="http://schemas.openxmlformats.org/drawingml/2006/main"/>
           <a:p xmlns:a="http://schemas.openxmlformats.org/drawingml/2006/main">
             <a:r>
-              <a:t>Lead with the banker decision: eight discovery conversations, selected after Pareto filtering and mixed-integer CVaR optimization. Unknown bank feasibility prevents product-proposal actions even when a need signal and scenario value are high.</a:t>
+              <a:t>Approval is authoritative. Thirty-one approved facts activate fifteen client–product anchors for BHP, Glencore and Shoprite; fifty-one candidates remain pending and cannot alter estimation. The active E1 pooling weight is 0.35, with 0.20 and 0.50 evaluated as sensitivity arms.</a:t>
             </a:r>
           </a:p>
           <a:p xmlns:a="http://schemas.openxmlformats.org/drawingml/2006/main">
@@ -851,17 +856,17 @@
           </a:p>
           <a:p xmlns:a="http://schemas.openxmlformats.org/drawingml/2006/main">
             <a:r>
-              <a:t>- outputs/v31/v31_coverage_plan.json</a:t>
-            </a:r>
-          </a:p>
-          <a:p xmlns:a="http://schemas.openxmlformats.org/drawingml/2006/main">
-            <a:r>
-              <a:t>- src/wallet_twin_v31/portfolio.py</a:t>
-            </a:r>
-          </a:p>
-          <a:p xmlns:a="http://schemas.openxmlformats.org/drawingml/2006/main">
-            <a:r>
-              <a:t>- config/v31_decision_policy.json</a:t>
+              <a:t>- outputs/v2_validation/public_evidence_qa.json</a:t>
+            </a:r>
+          </a:p>
+          <a:p xmlns:a="http://schemas.openxmlformats.org/drawingml/2006/main">
+            <a:r>
+              <a:t>- outputs/v2_validation/measurement_policy_sensitivity.json</a:t>
+            </a:r>
+          </a:p>
+          <a:p xmlns:a="http://schemas.openxmlformats.org/drawingml/2006/main">
+            <a:r>
+              <a:t>- src/wallet_twin_v2/measurement_policy.py</a:t>
             </a:r>
           </a:p>
         </p:txBody>
@@ -931,7 +936,7 @@
           <a:lstStyle xmlns:a="http://schemas.openxmlformats.org/drawingml/2006/main"/>
           <a:p xmlns:a="http://schemas.openxmlformats.org/drawingml/2006/main">
             <a:r>
-              <a:t>Walk the BHP path. The problem is well supported, but the engagement trigger is not. V3.1 therefore surfaces a discovery conversation and the highest-VOI decision-authority question rather than inventing urgency or proposing a product.</a:t>
+              <a:t>Show the actual rendered Wallet Portfolio view. The default colour encodes contestable scenario contribution. Teal underlines mark the fifteen approved E1 cells; amber marks the eighty-five prior-led cells. Judges can toggle observed activity, posterior wallet, estimated share, contestable gap and evidence status.</a:t>
             </a:r>
           </a:p>
           <a:p xmlns:a="http://schemas.openxmlformats.org/drawingml/2006/main">
@@ -946,17 +951,17 @@
           </a:p>
           <a:p xmlns:a="http://schemas.openxmlformats.org/drawingml/2006/main">
             <a:r>
-              <a:t>- dashboard/app/data/v31-fixture.json — conv:686ef2a1e7530b6d84a28714</a:t>
-            </a:r>
-          </a:p>
-          <a:p xmlns:a="http://schemas.openxmlformats.org/drawingml/2006/main">
-            <a:r>
-              <a:t>- src/wallet_twin_v31/business_graph.py</a:t>
-            </a:r>
-          </a:p>
-          <a:p xmlns:a="http://schemas.openxmlformats.org/drawingml/2006/main">
-            <a:r>
-              <a:t>- src/wallet_twin_v31/conversations.py</a:t>
+              <a:t>- dashboard/app/Dashboard.tsx</a:t>
+            </a:r>
+          </a:p>
+          <a:p xmlns:a="http://schemas.openxmlformats.org/drawingml/2006/main">
+            <a:r>
+              <a:t>- dashboard/app/data/wallet-v311-fixture.json</a:t>
+            </a:r>
+          </a:p>
+          <a:p xmlns:a="http://schemas.openxmlformats.org/drawingml/2006/main">
+            <a:r>
+              <a:t>- src/wallet_twin_v31/wallet_portfolio.py</a:t>
             </a:r>
           </a:p>
         </p:txBody>
@@ -1026,7 +1031,7 @@
           <a:lstStyle xmlns:a="http://schemas.openxmlformats.org/drawingml/2006/main"/>
           <a:p xmlns:a="http://schemas.openxmlformats.org/drawingml/2006/main">
             <a:r>
-              <a:t>The governing question is not 'what is uncertain?' but 'what answer could change rank, bundle, feasibility or abstention?' The client answer becomes a pending E2 candidate and cannot change the twin until a reviewer approves it.</a:t>
+              <a:t>Walk the BHP Trade Finance cell. Syn Bank observes A=R1.445bn. Approved issuer accounting anchors constrain the total-wallet measurement; the posterior T spans R5.15bn–R22.08bn, implying q=6.5%–28.0%. A 40% target-share scenario creates a median contestable activity gap of R2.126bn and R7.367m representative scenario contribution.</a:t>
             </a:r>
           </a:p>
           <a:p xmlns:a="http://schemas.openxmlformats.org/drawingml/2006/main">
@@ -1041,17 +1046,17 @@
           </a:p>
           <a:p xmlns:a="http://schemas.openxmlformats.org/drawingml/2006/main">
             <a:r>
-              <a:t>- src/wallet_twin_v31/questions.py</a:t>
-            </a:r>
-          </a:p>
-          <a:p xmlns:a="http://schemas.openxmlformats.org/drawingml/2006/main">
-            <a:r>
-              <a:t>- outputs/v31/v31_validation_report.json</a:t>
-            </a:r>
-          </a:p>
-          <a:p xmlns:a="http://schemas.openxmlformats.org/drawingml/2006/main">
-            <a:r>
-              <a:t>- Sundin et al., Active Learning for Decision-Making, ICML 2019</a:t>
+              <a:t>- dashboard/app/data/wallet-v311-fixture.json — E01-trade-finance</a:t>
+            </a:r>
+          </a:p>
+          <a:p xmlns:a="http://schemas.openxmlformats.org/drawingml/2006/main">
+            <a:r>
+              <a:t>- BHP Annual Report 2025 — approved facts BHP-2025-COST, INV and AP</a:t>
+            </a:r>
+          </a:p>
+          <a:p xmlns:a="http://schemas.openxmlformats.org/drawingml/2006/main">
+            <a:r>
+              <a:t>- outputs/audit/Public-Facts-Anchor-Register-V3.1.1.xlsx</a:t>
             </a:r>
           </a:p>
         </p:txBody>
@@ -1121,7 +1126,7 @@
           <a:lstStyle xmlns:a="http://schemas.openxmlformats.org/drawingml/2006/main"/>
           <a:p xmlns:a="http://schemas.openxmlformats.org/drawingml/2006/main">
             <a:r>
-              <a:t>Preserve the V3 continuity benchmark. Trade Finance survives the frozen five-product rate/prior cases, yet the V3.1 conversation plan diversifies because the decision object also contains business problem, stakeholder, feasibility, timing and concentration.</a:t>
+              <a:t>The Decision Twin remains the action layer, not a replacement for share-of-wallet estimation. It resolves a role, problem, solution bundle, engagement window and next-best question from the wallet gap. Missing credit, conduct, operational or integration feasibility converts the action into discovery; it never silently passes.</a:t>
             </a:r>
           </a:p>
           <a:p xmlns:a="http://schemas.openxmlformats.org/drawingml/2006/main">
@@ -1136,17 +1141,17 @@
           </a:p>
           <a:p xmlns:a="http://schemas.openxmlformats.org/drawingml/2006/main">
             <a:r>
-              <a:t>- dashboard/app/data/shadow-fixture.json â€” sensitivity</a:t>
-            </a:r>
-          </a:p>
-          <a:p xmlns:a="http://schemas.openxmlformats.org/drawingml/2006/main">
-            <a:r>
-              <a:t>- docs/v3_methodology.md</a:t>
-            </a:r>
-          </a:p>
-          <a:p xmlns:a="http://schemas.openxmlformats.org/drawingml/2006/main">
-            <a:r>
-              <a:t>- dashboard/app/data/shadow-fixture.json â€” sensitivity.product_summary</a:t>
+              <a:t>- outputs/v31/v31_coverage_plan.json</a:t>
+            </a:r>
+          </a:p>
+          <a:p xmlns:a="http://schemas.openxmlformats.org/drawingml/2006/main">
+            <a:r>
+              <a:t>- src/wallet_twin_v31/conversations.py</a:t>
+            </a:r>
+          </a:p>
+          <a:p xmlns:a="http://schemas.openxmlformats.org/drawingml/2006/main">
+            <a:r>
+              <a:t>- src/wallet_twin_v31/questions.py</a:t>
             </a:r>
           </a:p>
         </p:txBody>
@@ -1216,7 +1221,7 @@
           <a:lstStyle xmlns:a="http://schemas.openxmlformats.org/drawingml/2006/main"/>
           <a:p xmlns:a="http://schemas.openxmlformats.org/drawingml/2006/main">
             <a:r>
-              <a:t>Separate representative validation from bank-production validation. V3.1 proves contracts, point-in-time reconstruction, fail-closed estimators, graph integrity, constraints, deterministic replay and claim suppression; it does not prove a bank's empirical accuracy.</a:t>
+              <a:t>GenAI is a bounded narrator. The same sanitized pack is prepared for BHP, Glencore and Shoprite across OpenAI, Anthropic and Google. Because no fresh rotated credential and explicit acknowledgement were supplied, all nine target runs remain NOT_EXECUTED. Deterministic briefs remain visible and accepted; no live claim is fabricated.</a:t>
             </a:r>
           </a:p>
           <a:p xmlns:a="http://schemas.openxmlformats.org/drawingml/2006/main">
@@ -1231,17 +1236,17 @@
           </a:p>
           <a:p xmlns:a="http://schemas.openxmlformats.org/drawingml/2006/main">
             <a:r>
-              <a:t>- outputs/v31/v31_validation_report.json</a:t>
-            </a:r>
-          </a:p>
-          <a:p xmlns:a="http://schemas.openxmlformats.org/drawingml/2006/main">
-            <a:r>
-              <a:t>- tests/test_v31_decision_twin.py</a:t>
-            </a:r>
-          </a:p>
-          <a:p xmlns:a="http://schemas.openxmlformats.org/drawingml/2006/main">
-            <a:r>
-              <a:t>- docs/v31_implementation_status.md</a:t>
+              <a:t>- outputs/v2_validation/live_provider_comparison.json</a:t>
+            </a:r>
+          </a:p>
+          <a:p xmlns:a="http://schemas.openxmlformats.org/drawingml/2006/main">
+            <a:r>
+              <a:t>- outputs/v2_validation/genai_golden_eval.json</a:t>
+            </a:r>
+          </a:p>
+          <a:p xmlns:a="http://schemas.openxmlformats.org/drawingml/2006/main">
+            <a:r>
+              <a:t>- src/wallet_twin_v2/live_provider_eval.py</a:t>
             </a:r>
           </a:p>
         </p:txBody>
@@ -1311,7 +1316,7 @@
           <a:lstStyle xmlns:a="http://schemas.openxmlformats.org/drawingml/2006/main"/>
           <a:p xmlns:a="http://schemas.openxmlformats.org/drawingml/2006/main">
             <a:r>
-              <a:t>The LLM is last, not first. V3.1 compiles a closed Why–How–What pack and permits the provider only to translate approved content. Arithmetic, ranks, graph paths, values, VOI and citations remain deterministic; provider failure returns the deterministic brief.</a:t>
+              <a:t>Separate what the implementation proves. Mechanical checks validate data and equations. A known-truth synthetic panel assesses interval behavior. Posterior and ranking diagnostics are predictive model evidence. E3 observations, approved economics, live-provider adjudication and causal RM outcomes remain external gates.</a:t>
             </a:r>
           </a:p>
           <a:p xmlns:a="http://schemas.openxmlformats.org/drawingml/2006/main">
@@ -1326,22 +1331,17 @@
           </a:p>
           <a:p xmlns:a="http://schemas.openxmlformats.org/drawingml/2006/main">
             <a:r>
-              <a:t>- src/wallet_twin_v31/briefs.py</a:t>
-            </a:r>
-          </a:p>
-          <a:p xmlns:a="http://schemas.openxmlformats.org/drawingml/2006/main">
-            <a:r>
-              <a:t>- src/wallet_twin_v2/genai_gateway.py</a:t>
-            </a:r>
-          </a:p>
-          <a:p xmlns:a="http://schemas.openxmlformats.org/drawingml/2006/main">
-            <a:r>
-              <a:t>- prompts/v3_decision_brief.schema.json</a:t>
-            </a:r>
-          </a:p>
-          <a:p xmlns:a="http://schemas.openxmlformats.org/drawingml/2006/main">
-            <a:r>
-              <a:t>- outputs/v2_validation/genai_golden_eval.json</a:t>
+              <a:t>- outputs/v2_validation/measurement_policy_sensitivity.json</a:t>
+            </a:r>
+          </a:p>
+          <a:p xmlns:a="http://schemas.openxmlformats.org/drawingml/2006/main">
+            <a:r>
+              <a:t>- outputs/v2_validation/offline_validation_report.json</a:t>
+            </a:r>
+          </a:p>
+          <a:p xmlns:a="http://schemas.openxmlformats.org/drawingml/2006/main">
+            <a:r>
+              <a:t>- docs/methodology.md</a:t>
             </a:r>
           </a:p>
         </p:txBody>
@@ -1409,7 +1409,7 @@
   </p:cSld>
   <p:clrMap bg1="lt1" tx1="dk1" bg2="lt2" tx2="dk2" accent1="accent1" accent2="accent2" accent3="accent3" accent4="accent4" accent5="accent5" accent6="accent6" hlink="hlink" folHlink="folHlink"/>
   <p:sldLayoutIdLst>
-    <p:sldLayoutId xmlns:r="http://schemas.openxmlformats.org/officeDocument/2006/relationships" id="2147483649" r:id="R62f12f00f57a4d1e"/>
+    <p:sldLayoutId xmlns:r="http://schemas.openxmlformats.org/officeDocument/2006/relationships" id="2147483649" r:id="R82c7dfec022d475a"/>
   </p:sldLayoutIdLst>
   <p:txStyles>
     <p:titleStyle>
@@ -1957,42 +1957,30 @@
           </c:spPr>
           <c:cat>
             <c:strLit>
-              <c:ptCount val="5"/>
+              <c:ptCount val="3"/>
               <c:pt idx="0">
-                <c:v>Bid Corp · Liquidity</c:v>
+                <c:v>E1 weight 0.20</c:v>
               </c:pt>
               <c:pt idx="1">
-                <c:v>Sanlam · Payments</c:v>
+                <c:v>E1 weight 0.35</c:v>
               </c:pt>
               <c:pt idx="2">
-                <c:v>Sanlam · Liquidity</c:v>
-              </c:pt>
-              <c:pt idx="3">
-                <c:v>BHP · FX</c:v>
-              </c:pt>
-              <c:pt idx="4">
-                <c:v>Shoprite · FX</c:v>
+                <c:v>E1 weight 0.50</c:v>
               </c:pt>
             </c:strLit>
           </c:cat>
           <c:val>
             <c:numLit>
               <c:formatCode>General</c:formatCode>
-              <c:ptCount val="5"/>
+              <c:ptCount val="3"/>
               <c:pt idx="0">
-                <c:v>13.7</c:v>
+                <c:v>5.826</c:v>
               </c:pt>
               <c:pt idx="1">
-                <c:v>17</c:v>
+                <c:v>4.374</c:v>
               </c:pt>
               <c:pt idx="2">
-                <c:v>17</c:v>
-              </c:pt>
-              <c:pt idx="3">
-                <c:v>14.6</c:v>
-              </c:pt>
-              <c:pt idx="4">
-                <c:v>5.9</c:v>
+                <c:v>3.293</c:v>
               </c:pt>
             </c:numLit>
           </c:val>
@@ -2034,14 +2022,14 @@
               <a:lstStyle xmlns:a="http://schemas.openxmlformats.org/drawingml/2006/main"/>
               <a:p xmlns:a="http://schemas.openxmlformats.org/drawingml/2006/main">
                 <a:r>
-                  <a:t>Client-value proxy (R million)</a:t>
+                  <a:t>Known-truth interval width (ZAR bn)</a:t>
                 </a:r>
               </a:p>
             </c:rich>
           </c:tx>
           <c:overlay val="0"/>
         </c:title>
-        <c:numFmt formatCode="0.0&quot;m&quot;"/>
+        <c:numFmt formatCode="0.0&quot;bn&quot;"/>
         <c:majorTickMark val="none"/>
         <c:minorTickMark val="none"/>
         <c:spPr>
@@ -2128,21 +2116,21 @@
       </p:grpSpPr>
       <p:pic>
         <p:nvPicPr>
-          <p:cNvPr id="25" name=""/>
+          <p:cNvPr id="32" name=""/>
           <p:cNvPicPr>
             <a:picLocks xmlns:a="http://schemas.openxmlformats.org/drawingml/2006/main" noChangeAspect="1"/>
           </p:cNvPicPr>
           <p:nvPr/>
         </p:nvPicPr>
         <p:blipFill>
-          <a:blip xmlns:r="http://schemas.openxmlformats.org/officeDocument/2006/relationships" xmlns:a="http://schemas.openxmlformats.org/drawingml/2006/main" r:embed="R23a4de620b784cd3"/>
+          <a:blip xmlns:r="http://schemas.openxmlformats.org/officeDocument/2006/relationships" xmlns:a="http://schemas.openxmlformats.org/drawingml/2006/main" r:embed="Rae945cacb570493c"/>
           <a:srcRect xmlns:a="http://schemas.openxmlformats.org/drawingml/2006/main" l="0" t="27" r="0" b="27"/>
           <a:stretch xmlns:a="http://schemas.openxmlformats.org/drawingml/2006/main">
             <a:fillRect l="0" t="0" r="0" b="0"/>
           </a:stretch>
         </p:blipFill>
         <p:spPr>
-          <a:xfrm xmlns:a="http://schemas.openxmlformats.org/drawingml/2006/main" flipH="0" flipV="0">
+          <a:xfrm xmlns:a="http://schemas.openxmlformats.org/drawingml/2006/main">
             <a:off x="0" y="0"/>
             <a:ext cx="12192000" cy="6858000"/>
           </a:xfrm>
@@ -2378,7 +2366,7 @@
                 <a:ea typeface="Arial"/>
                 <a:cs typeface="Arial"/>
               </a:rPr>
-              <a:t>Know the business.</a:t>
+              <a:t>See the wallet. Size the gap.</a:t>
             </a:r>
           </a:p>
           <a:p xmlns:a="http://schemas.openxmlformats.org/drawingml/2006/main">
@@ -2402,14 +2390,14 @@
                 <a:ea typeface="Arial"/>
                 <a:cs typeface="Arial"/>
               </a:rPr>
-              <a:t>Plan the right conversation.</a:t>
+              <a:t>Choose the conversation.</a:t>
             </a:r>
           </a:p>
         </p:txBody>
       </p:sp>
       <p:cxnSp>
         <p:nvCxnSpPr>
-          <p:cNvPr id="30" name="cover-rule"/>
+          <p:cNvPr id="37" name="cover-rule"/>
           <p:cNvCxnSpPr/>
           <p:nvPr/>
         </p:nvCxnSpPr>
@@ -2483,7 +2471,7 @@
                 <a:ea typeface="Arial"/>
                 <a:cs typeface="Arial"/>
               </a:rPr>
-              <a:t>Business-model reconstruction and decision intelligence for corporate relationship teams</a:t>
+              <a:t>Find the latent wallet. Quantify the gap. Plan the governed conversation.</a:t>
             </a:r>
           </a:p>
         </p:txBody>
@@ -2660,7 +2648,7 @@
                 <a:ea typeface="Arial"/>
                 <a:cs typeface="Arial"/>
               </a:rPr>
-              <a:t>V3.1.0 | AS OF 30 JUNE 2026 | CLIENT DEMO — PUBLIC E1 + SYN BANK</a:t>
+              <a:t>V3.1.1 | AS OF 30 JUNE 2026 | HACKATHON SUBMISSION</a:t>
             </a:r>
           </a:p>
         </p:txBody>
@@ -2783,7 +2771,7 @@
         </p:spPr>
         <p:txBody>
           <a:bodyPr xmlns:a="http://schemas.openxmlformats.org/drawingml/2006/main" anchor="t">
-            <a:normAutofit fontScale="92649"/>
+            <a:normAutofit fontScale="94444"/>
           </a:bodyPr>
           <a:lstStyle xmlns:a="http://schemas.openxmlformats.org/drawingml/2006/main"/>
           <a:p xmlns:a="http://schemas.openxmlformats.org/drawingml/2006/main">
@@ -2807,7 +2795,7 @@
                 <a:ea typeface="Arial"/>
                 <a:cs typeface="Arial"/>
               </a:rPr>
-              <a:t>Demonstrate the Decision Twin</a:t>
+              <a:t>Find the gap.</a:t>
             </a:r>
           </a:p>
           <a:p xmlns:a="http://schemas.openxmlformats.org/drawingml/2006/main">
@@ -2831,7 +2819,7 @@
                 <a:ea typeface="Arial"/>
                 <a:cs typeface="Arial"/>
               </a:rPr>
-              <a:t>then earn bank production</a:t>
+              <a:t>Plan the conversation.</a:t>
             </a:r>
           </a:p>
         </p:txBody>
@@ -2890,14 +2878,14 @@
                 <a:ea typeface="Arial"/>
                 <a:cs typeface="Arial"/>
               </a:rPr>
-              <a:t>V3.1 turns partial evidence into business context, solution bundles, dual value, governed conversations and an active learning loop—without overstating what was measured.</a:t>
+              <a:t>V3.1.1 converts partial bank observation into a governed wallet interval, a commercial scenario and a relationship action—while preserving every evidence boundary.</a:t>
             </a:r>
           </a:p>
         </p:txBody>
       </p:sp>
       <p:cxnSp>
         <p:nvCxnSpPr>
-          <p:cNvPr id="46" name="s10-step-rule-0"/>
+          <p:cNvPr id="58" name="s10-step-rule-0"/>
           <p:cNvCxnSpPr/>
           <p:nvPr/>
         </p:nvCxnSpPr>
@@ -3006,7 +2994,7 @@
         </p:spPr>
         <p:txBody>
           <a:bodyPr xmlns:a="http://schemas.openxmlformats.org/drawingml/2006/main" anchor="t">
-            <a:normAutofit fontScale="92057"/>
+            <a:normAutofit fontScale="100000"/>
           </a:bodyPr>
           <a:lstStyle xmlns:a="http://schemas.openxmlformats.org/drawingml/2006/main"/>
           <a:p xmlns:a="http://schemas.openxmlformats.org/drawingml/2006/main">
@@ -3030,7 +3018,7 @@
                 <a:ea typeface="Arial"/>
                 <a:cs typeface="Arial"/>
               </a:rPr>
-              <a:t>Reconstruct the client business</a:t>
+              <a:t>Demonstrate the wallet</a:t>
             </a:r>
           </a:p>
         </p:txBody>
@@ -3089,14 +3077,14 @@
                 <a:ea typeface="Arial"/>
                 <a:cs typeface="Arial"/>
               </a:rPr>
-              <a:t>Twenty twelve-domain twins, temporal graphs, problems, stakeholders and sixteen solution families.</a:t>
+              <a:t>Twenty relationships × five products, approval-authoritative anchors, intervals and contestable gaps.</a:t>
             </a:r>
           </a:p>
         </p:txBody>
       </p:sp>
       <p:cxnSp>
         <p:nvCxnSpPr>
-          <p:cNvPr id="50" name="s10-step-rule-1"/>
+          <p:cNvPr id="62" name="s10-step-rule-1"/>
           <p:cNvCxnSpPr/>
           <p:nvPr/>
         </p:nvCxnSpPr>
@@ -3205,7 +3193,7 @@
         </p:spPr>
         <p:txBody>
           <a:bodyPr xmlns:a="http://schemas.openxmlformats.org/drawingml/2006/main" anchor="t">
-            <a:normAutofit fontScale="100000"/>
+            <a:normAutofit fontScale="83711"/>
           </a:bodyPr>
           <a:lstStyle xmlns:a="http://schemas.openxmlformats.org/drawingml/2006/main"/>
           <a:p xmlns:a="http://schemas.openxmlformats.org/drawingml/2006/main">
@@ -3229,7 +3217,7 @@
                 <a:ea typeface="Arial"/>
                 <a:cs typeface="Arial"/>
               </a:rPr>
-              <a:t>Plan eight conversations</a:t>
+              <a:t>Run eight discovery conversations</a:t>
             </a:r>
           </a:p>
         </p:txBody>
@@ -3288,14 +3276,14 @@
                 <a:ea typeface="Arial"/>
                 <a:cs typeface="Arial"/>
               </a:rPr>
-              <a:t>Pareto-filtered, CVaR-aware discovery actions plus positive-net-VOI client questions.</a:t>
+              <a:t>Decision Twin adds stakeholder, business issue, bundle, timing, feasibility and the highest-VOI question.</a:t>
             </a:r>
           </a:p>
         </p:txBody>
       </p:sp>
       <p:cxnSp>
         <p:nvCxnSpPr>
-          <p:cNvPr id="54" name="s10-step-rule-2"/>
+          <p:cNvPr id="66" name="s10-step-rule-2"/>
           <p:cNvCxnSpPr/>
           <p:nvPr/>
         </p:nvCxnSpPr>
@@ -3428,7 +3416,7 @@
                 <a:ea typeface="Arial"/>
                 <a:cs typeface="Arial"/>
               </a:rPr>
-              <a:t>Close external gates</a:t>
+              <a:t>Earn production</a:t>
             </a:r>
           </a:p>
         </p:txBody>
@@ -3487,7 +3475,7 @@
                 <a:ea typeface="Arial"/>
                 <a:cs typeface="Arial"/>
               </a:rPr>
-              <a:t>E3 calibration, approved economics, bank identity/infrastructure, live evaluation and RM trial.</a:t>
+              <a:t>E3 panel, bank rates and controls, live provider adjudication, RM pilot and randomized outcomes.</a:t>
             </a:r>
           </a:p>
         </p:txBody>
@@ -3546,7 +3534,7 @@
                 <a:ea typeface="Arial"/>
                 <a:cs typeface="Arial"/>
               </a:rPr>
-              <a:t>A better conversation today. A measurable learning system tomorrow.</a:t>
+              <a:t>Submission mechanics validated; live-provider proof remains an explicit gate. Bank-production claims stay fail-closed.</a:t>
             </a:r>
           </a:p>
         </p:txBody>
@@ -3605,7 +3593,7 @@
                 <a:ea typeface="Arial"/>
                 <a:cs typeface="Arial"/>
               </a:rPr>
-              <a:t>Corporate Wallet Digital Twin | Christopher Koen | V3.1.0</a:t>
+              <a:t>Corporate Wallet Digital Twin | Christopher Koen | V3.1.1</a:t>
             </a:r>
           </a:p>
         </p:txBody>
@@ -3664,7 +3652,7 @@
                 <a:ea typeface="Arial"/>
                 <a:cs typeface="Arial"/>
               </a:rPr>
-              <a:t>CODE: https://github.com/ChristopherJohannesKoen/corporate-wallet-digital-twin-hackathon-2026</a:t>
+              <a:t>CODE: https://github.com/ChristopherJohannesKoen/corporate-wallet-digital-twin-hackathon-2026-public</a:t>
             </a:r>
           </a:p>
         </p:txBody>
@@ -3745,7 +3733,7 @@
                 <a:ea typeface="Arial"/>
                 <a:cs typeface="Arial"/>
               </a:rPr>
-              <a:t>THE DECISION OBJECT</a:t>
+              <a:t>THE LATENT-WALLET PROBLEM</a:t>
             </a:r>
           </a:p>
         </p:txBody>
@@ -3804,14 +3792,14 @@
                 <a:ea typeface="Arial"/>
                 <a:cs typeface="Arial"/>
               </a:rPr>
-              <a:t>The decision starts beyond a client–product row</a:t>
+              <a:t>One observed number cannot identify the full wallet</a:t>
             </a:r>
           </a:p>
         </p:txBody>
       </p:sp>
       <p:cxnSp>
         <p:nvCxnSpPr>
-          <p:cNvPr id="97" name="title-rule-2"/>
+          <p:cNvPr id="127" name="title-rule-2"/>
           <p:cNvCxnSpPr/>
           <p:nvPr/>
         </p:nvCxnSpPr>
@@ -3885,7 +3873,7 @@
                 <a:ea typeface="Arial"/>
                 <a:cs typeface="Arial"/>
               </a:rPr>
-              <a:t>TEAM: Corporate Wallet Digital Twin | Christopher Koen | V3.1.0</a:t>
+              <a:t>TEAM: Corporate Wallet Digital Twin | Christopher Koen | V3.1.1</a:t>
             </a:r>
           </a:p>
         </p:txBody>
@@ -3944,7 +3932,7 @@
                 <a:ea typeface="Arial"/>
                 <a:cs typeface="Arial"/>
               </a:rPr>
-              <a:t>SYN BANK SIMULATION + PUBLIC E1 + REPRESENTATIVE PRIORS</a:t>
+              <a:t>CONFIDENTIAL SYN BANK ACTIVITY + APPROVED PUBLIC E1 + GOVERNED PRIORS</a:t>
             </a:r>
           </a:p>
         </p:txBody>
@@ -4038,7 +4026,7 @@
         </p:spPr>
         <p:txBody>
           <a:bodyPr xmlns:a="http://schemas.openxmlformats.org/drawingml/2006/main" anchor="t">
-            <a:normAutofit fontScale="92269"/>
+            <a:normAutofit fontScale="76260"/>
           </a:bodyPr>
           <a:lstStyle xmlns:a="http://schemas.openxmlformats.org/drawingml/2006/main"/>
           <a:p xmlns:a="http://schemas.openxmlformats.org/drawingml/2006/main">
@@ -4062,7 +4050,7 @@
                 <a:ea typeface="Arial"/>
                 <a:cs typeface="Arial"/>
               </a:rPr>
-              <a:t>Syn Bank observes product activity—not the full business model, total wallet, decision owner or response to an RM action. V3.1 adds the context needed for a governed conversation.</a:t>
+              <a:t>Syn Bank observes A—its own client–product activity. Total wallet T and bank share q remain latent. The identity A=qT admits many answers, so V3.1.1 reports bounds and posterior intervals rather than false precision.</a:t>
             </a:r>
           </a:p>
         </p:txBody>
@@ -4600,7 +4588,7 @@
         </p:spPr>
         <p:txBody>
           <a:bodyPr xmlns:a="http://schemas.openxmlformats.org/drawingml/2006/main" anchor="t">
-            <a:normAutofit fontScale="60094"/>
+            <a:normAutofit fontScale="54494"/>
           </a:bodyPr>
           <a:lstStyle xmlns:a="http://schemas.openxmlformats.org/drawingml/2006/main"/>
           <a:p xmlns:a="http://schemas.openxmlformats.org/drawingml/2006/main">
@@ -4624,14 +4612,14 @@
                 <a:ea typeface="Arial"/>
                 <a:cs typeface="Arial"/>
               </a:rPr>
-              <a:t>One claim ladder governs every twin, value and conversation</a:t>
+              <a:t>The claim ladder keeps evidence, inference and economics distinct</a:t>
             </a:r>
           </a:p>
         </p:txBody>
       </p:sp>
       <p:cxnSp>
         <p:nvCxnSpPr>
-          <p:cNvPr id="112" name="s2-claim-rule-0"/>
+          <p:cNvPr id="142" name="s2-claim-rule-0"/>
           <p:cNvCxnSpPr/>
           <p:nvPr/>
         </p:nvCxnSpPr>
@@ -4771,7 +4759,7 @@
       </p:sp>
       <p:cxnSp>
         <p:nvCxnSpPr>
-          <p:cNvPr id="115" name="s2-claim-rule-1"/>
+          <p:cNvPr id="145" name="s2-claim-rule-1"/>
           <p:cNvCxnSpPr/>
           <p:nvPr/>
         </p:nvCxnSpPr>
@@ -4904,14 +4892,14 @@
                 <a:ea typeface="Arial"/>
                 <a:cs typeface="Arial"/>
               </a:rPr>
-              <a:t>Accounting interval</a:t>
+              <a:t>Identification interval</a:t>
             </a:r>
           </a:p>
         </p:txBody>
       </p:sp>
       <p:cxnSp>
         <p:nvCxnSpPr>
-          <p:cNvPr id="118" name="s2-claim-rule-2"/>
+          <p:cNvPr id="148" name="s2-claim-rule-2"/>
           <p:cNvCxnSpPr/>
           <p:nvPr/>
         </p:nvCxnSpPr>
@@ -5044,14 +5032,14 @@
                 <a:ea typeface="Arial"/>
                 <a:cs typeface="Arial"/>
               </a:rPr>
-              <a:t>Wallet distribution</a:t>
+              <a:t>Wallet + share distribution</a:t>
             </a:r>
           </a:p>
         </p:txBody>
       </p:sp>
       <p:cxnSp>
         <p:nvCxnSpPr>
-          <p:cNvPr id="121" name="s2-claim-rule-3"/>
+          <p:cNvPr id="151" name="s2-claim-rule-3"/>
           <p:cNvCxnSpPr/>
           <p:nvPr/>
         </p:nvCxnSpPr>
@@ -5184,14 +5172,14 @@
                 <a:ea typeface="Arial"/>
                 <a:cs typeface="Arial"/>
               </a:rPr>
-              <a:t>Problem, bundle and value</a:t>
+              <a:t>Target-share economics</a:t>
             </a:r>
           </a:p>
         </p:txBody>
       </p:sp>
       <p:cxnSp>
         <p:nvCxnSpPr>
-          <p:cNvPr id="124" name="s2-claim-rule-4"/>
+          <p:cNvPr id="154" name="s2-claim-rule-4"/>
           <p:cNvCxnSpPr/>
           <p:nvPr/>
         </p:nvCxnSpPr>
@@ -5414,7 +5402,7 @@
                 <a:ea typeface="Arial"/>
                 <a:cs typeface="Arial"/>
               </a:rPr>
-              <a:t>85 E1 and 820 E0 claims remain separated; measured competitor share and causal value remain zero; unknown bank feasibility stays UNKNOWN.</a:t>
+              <a:t>Observed ≠ inferred ≠ scenario ≠ causal. Measured competitor share and causal incremental value remain prohibited without E3 observations and a qualified trial.</a:t>
             </a:r>
           </a:p>
         </p:txBody>
@@ -5495,7 +5483,7 @@
                 <a:ea typeface="Arial"/>
                 <a:cs typeface="Arial"/>
               </a:rPr>
-              <a:t>BUSINESS MODEL TWIN</a:t>
+              <a:t>SUPPLIED DATA → FIVE PRODUCT LENSES</a:t>
             </a:r>
           </a:p>
         </p:txBody>
@@ -5554,14 +5542,14 @@
                 <a:ea typeface="Arial"/>
                 <a:cs typeface="Arial"/>
               </a:rPr>
-              <a:t>Twenty clients receive the same twelve-domain twin</a:t>
+              <a:t>Every supplied relationship is modelled</a:t>
             </a:r>
           </a:p>
         </p:txBody>
       </p:sp>
       <p:cxnSp>
         <p:nvCxnSpPr>
-          <p:cNvPr id="66" name="title-rule-4"/>
+          <p:cNvPr id="82" name="title-rule-4"/>
           <p:cNvCxnSpPr/>
           <p:nvPr/>
         </p:nvCxnSpPr>
@@ -5635,7 +5623,7 @@
                 <a:ea typeface="Arial"/>
                 <a:cs typeface="Arial"/>
               </a:rPr>
-              <a:t>TEAM: Corporate Wallet Digital Twin | Christopher Koen | V3.1.0</a:t>
+              <a:t>TEAM: Corporate Wallet Digital Twin | Christopher Koen | V3.1.1</a:t>
             </a:r>
           </a:p>
         </p:txBody>
@@ -5694,7 +5682,7 @@
                 <a:ea typeface="Arial"/>
                 <a:cs typeface="Arial"/>
               </a:rPr>
-              <a:t>SYN BANK SIMULATION + PUBLIC E1 + REPRESENTATIVE PRIORS</a:t>
+              <a:t>CONFIDENTIAL SYN BANK ACTIVITY + APPROVED PUBLIC E1 + GOVERNED PRIORS</a:t>
             </a:r>
           </a:p>
         </p:txBody>
@@ -5760,7 +5748,7 @@
       </p:sp>
       <p:cxnSp>
         <p:nvCxnSpPr>
-          <p:cNvPr id="70" name="s4-metric-0-rule"/>
+          <p:cNvPr id="86" name="s4-metric-0-rule"/>
           <p:cNvCxnSpPr/>
           <p:nvPr/>
         </p:nvCxnSpPr>
@@ -5834,7 +5822,7 @@
                 <a:ea typeface="Arial"/>
                 <a:cs typeface="Arial"/>
               </a:rPr>
-              <a:t>20</a:t>
+              <a:t>3.064m</a:t>
             </a:r>
           </a:p>
         </p:txBody>
@@ -5893,14 +5881,14 @@
                 <a:ea typeface="Arial"/>
                 <a:cs typeface="Arial"/>
               </a:rPr>
-              <a:t>client twins</a:t>
+              <a:t>supplied rows</a:t>
             </a:r>
           </a:p>
         </p:txBody>
       </p:sp>
       <p:cxnSp>
         <p:nvCxnSpPr>
-          <p:cNvPr id="73" name="s4-metric-1-rule"/>
+          <p:cNvPr id="89" name="s4-metric-1-rule"/>
           <p:cNvCxnSpPr/>
           <p:nvPr/>
         </p:nvCxnSpPr>
@@ -5974,7 +5962,7 @@
                 <a:ea typeface="Arial"/>
                 <a:cs typeface="Arial"/>
               </a:rPr>
-              <a:t>240</a:t>
+              <a:t>20</a:t>
             </a:r>
           </a:p>
         </p:txBody>
@@ -6033,14 +6021,14 @@
                 <a:ea typeface="Arial"/>
                 <a:cs typeface="Arial"/>
               </a:rPr>
-              <a:t>domain components</a:t>
+              <a:t>supplied relationships</a:t>
             </a:r>
           </a:p>
         </p:txBody>
       </p:sp>
       <p:cxnSp>
         <p:nvCxnSpPr>
-          <p:cNvPr id="76" name="s4-metric-2-rule"/>
+          <p:cNvPr id="92" name="s4-metric-2-rule"/>
           <p:cNvCxnSpPr/>
           <p:nvPr/>
         </p:nvCxnSpPr>
@@ -6114,7 +6102,7 @@
                 <a:ea typeface="Arial"/>
                 <a:cs typeface="Arial"/>
               </a:rPr>
-              <a:t>905</a:t>
+              <a:t>5</a:t>
             </a:r>
           </a:p>
         </p:txBody>
@@ -6173,14 +6161,14 @@
                 <a:ea typeface="Arial"/>
                 <a:cs typeface="Arial"/>
               </a:rPr>
-              <a:t>typed evidence claims</a:t>
+              <a:t>product mappings</a:t>
             </a:r>
           </a:p>
         </p:txBody>
       </p:sp>
       <p:cxnSp>
         <p:nvCxnSpPr>
-          <p:cNvPr id="79" name="s4-metric-3-rule"/>
+          <p:cNvPr id="95" name="s4-metric-3-rule"/>
           <p:cNvCxnSpPr/>
           <p:nvPr/>
         </p:nvCxnSpPr>
@@ -6254,7 +6242,7 @@
                 <a:ea typeface="Arial"/>
                 <a:cs typeface="Arial"/>
               </a:rPr>
-              <a:t>71</a:t>
+              <a:t>100</a:t>
             </a:r>
           </a:p>
         </p:txBody>
@@ -6313,7 +6301,7 @@
                 <a:ea typeface="Arial"/>
                 <a:cs typeface="Arial"/>
               </a:rPr>
-              <a:t>explicit evidence gaps</a:t>
+              <a:t>client × product cells</a:t>
             </a:r>
           </a:p>
         </p:txBody>
@@ -6372,7 +6360,7 @@
                 <a:ea typeface="Arial"/>
                 <a:cs typeface="Arial"/>
               </a:rPr>
-              <a:t>Evidence and graph projection</a:t>
+              <a:t>Private evaluator transformation</a:t>
             </a:r>
           </a:p>
         </p:txBody>
@@ -6431,7 +6419,7 @@
                 <a:ea typeface="Arial"/>
                 <a:cs typeface="Arial"/>
               </a:rPr>
-              <a:t>Approved claims</a:t>
+              <a:t>Transaction legs</a:t>
             </a:r>
           </a:p>
         </p:txBody>
@@ -6521,7 +6509,7 @@
                 <a:ea typeface="Arial"/>
                 <a:cs typeface="Arial"/>
               </a:rPr>
-              <a:t>854</a:t>
+              <a:t>C / P / L</a:t>
             </a:r>
           </a:p>
         </p:txBody>
@@ -6580,7 +6568,7 @@
                 <a:ea typeface="Arial"/>
                 <a:cs typeface="Arial"/>
               </a:rPr>
-              <a:t>Pending review</a:t>
+              <a:t>Specialist feeds</a:t>
             </a:r>
           </a:p>
         </p:txBody>
@@ -6602,7 +6590,7 @@
         <p:spPr>
           <a:xfrm xmlns:a="http://schemas.openxmlformats.org/drawingml/2006/main">
             <a:off x="2038350" y="4400550"/>
-            <a:ext cx="266700" cy="257175"/>
+            <a:ext cx="2485106" cy="257175"/>
           </a:xfrm>
           <a:prstGeom xmlns:a="http://schemas.openxmlformats.org/drawingml/2006/main" prst="rect">
             <a:avLst/>
@@ -6670,7 +6658,7 @@
                 <a:ea typeface="Arial"/>
                 <a:cs typeface="Arial"/>
               </a:rPr>
-              <a:t>51</a:t>
+              <a:t>FX / TF</a:t>
             </a:r>
           </a:p>
         </p:txBody>
@@ -6729,7 +6717,7 @@
                 <a:ea typeface="Arial"/>
                 <a:cs typeface="Arial"/>
               </a:rPr>
-              <a:t>12/12 domains each</a:t>
+              <a:t>PIT aggregated</a:t>
             </a:r>
           </a:p>
         </p:txBody>
@@ -6764,7 +6752,7 @@
         </p:spPr>
         <p:txBody>
           <a:bodyPr xmlns:a="http://schemas.openxmlformats.org/drawingml/2006/main" anchor="t">
-            <a:normAutofit fontScale="79158"/>
+            <a:normAutofit fontScale="79923"/>
           </a:bodyPr>
           <a:lstStyle xmlns:a="http://schemas.openxmlformats.org/drawingml/2006/main"/>
           <a:p xmlns:a="http://schemas.openxmlformats.org/drawingml/2006/main">
@@ -6788,7 +6776,7 @@
                 <a:ea typeface="Arial"/>
                 <a:cs typeface="Arial"/>
               </a:rPr>
-              <a:t>993 nodes · 1,154 edges</a:t>
+              <a:t>hash + schema retained</a:t>
             </a:r>
           </a:p>
         </p:txBody>
@@ -6878,7 +6866,7 @@
                 <a:ea typeface="Arial"/>
                 <a:cs typeface="Arial"/>
               </a:rPr>
-              <a:t>BOUNDARY</a:t>
+              <a:t>SCOPE NOTE</a:t>
             </a:r>
           </a:p>
         </p:txBody>
@@ -6913,7 +6901,7 @@
         </p:spPr>
         <p:txBody>
           <a:bodyPr xmlns:a="http://schemas.openxmlformats.org/drawingml/2006/main" anchor="t">
-            <a:normAutofit fontScale="92420"/>
+            <a:normAutofit fontScale="77294"/>
           </a:bodyPr>
           <a:lstStyle xmlns:a="http://schemas.openxmlformats.org/drawingml/2006/main"/>
           <a:p xmlns:a="http://schemas.openxmlformats.org/drawingml/2006/main">
@@ -6937,7 +6925,7 @@
                 <a:ea typeface="Arial"/>
                 <a:cs typeface="Arial"/>
               </a:rPr>
-              <a:t>Unknown remains unknown</a:t>
+              <a:t>Brief says 50; supply contains 20</a:t>
             </a:r>
           </a:p>
         </p:txBody>
@@ -6996,7 +6984,7 @@
                 <a:ea typeface="Arial"/>
                 <a:cs typeface="Arial"/>
               </a:rPr>
-              <a:t>Attribute + event graph</a:t>
+              <a:t>Collections + Payments</a:t>
             </a:r>
           </a:p>
           <a:p xmlns:a="http://schemas.openxmlformats.org/drawingml/2006/main">
@@ -7020,7 +7008,7 @@
                 <a:ea typeface="Arial"/>
                 <a:cs typeface="Arial"/>
               </a:rPr>
-              <a:t>Point-in-time availability</a:t>
+              <a:t>Liquidity-flow proxy</a:t>
             </a:r>
           </a:p>
           <a:p xmlns:a="http://schemas.openxmlformats.org/drawingml/2006/main">
@@ -7044,7 +7032,7 @@
                 <a:ea typeface="Arial"/>
                 <a:cs typeface="Arial"/>
               </a:rPr>
-              <a:t>Approved lineage on every path</a:t>
+              <a:t>Cross-border FX exposure</a:t>
             </a:r>
           </a:p>
           <a:p xmlns:a="http://schemas.openxmlformats.org/drawingml/2006/main">
@@ -7068,7 +7056,7 @@
                 <a:ea typeface="Arial"/>
                 <a:cs typeface="Arial"/>
               </a:rPr>
-              <a:t>No named people in demo</a:t>
+              <a:t>Trade Finance instruments</a:t>
             </a:r>
           </a:p>
         </p:txBody>
@@ -7149,7 +7137,7 @@
                 <a:ea typeface="Arial"/>
                 <a:cs typeface="Arial"/>
               </a:rPr>
-              <a:t>MONDAY-MORNING COVERAGE PLAN</a:t>
+              <a:t>GOVERNED MEASUREMENT</a:t>
             </a:r>
           </a:p>
         </p:txBody>
@@ -7208,14 +7196,14 @@
                 <a:ea typeface="Arial"/>
                 <a:cs typeface="Arial"/>
               </a:rPr>
-              <a:t>Eight conversations survive feasibility and downside risk</a:t>
+              <a:t>Only approved evidence is allowed to narrow the wallet</a:t>
             </a:r>
           </a:p>
         </p:txBody>
       </p:sp>
       <p:cxnSp>
         <p:nvCxnSpPr>
-          <p:cNvPr id="29" name="title-rule-3"/>
+          <p:cNvPr id="33" name="title-rule-3"/>
           <p:cNvCxnSpPr/>
           <p:nvPr/>
         </p:nvCxnSpPr>
@@ -7289,7 +7277,7 @@
                 <a:ea typeface="Arial"/>
                 <a:cs typeface="Arial"/>
               </a:rPr>
-              <a:t>TEAM: Corporate Wallet Digital Twin | Christopher Koen | V3.1.0</a:t>
+              <a:t>TEAM: Corporate Wallet Digital Twin | Christopher Koen | V3.1.1</a:t>
             </a:r>
           </a:p>
         </p:txBody>
@@ -7348,7 +7336,7 @@
                 <a:ea typeface="Arial"/>
                 <a:cs typeface="Arial"/>
               </a:rPr>
-              <a:t>SYN BANK SIMULATION + PUBLIC E1 + REPRESENTATIVE PRIORS</a:t>
+              <a:t>CONFIDENTIAL SYN BANK ACTIVITY + APPROVED PUBLIC E1 + GOVERNED PRIORS</a:t>
             </a:r>
           </a:p>
         </p:txBody>
@@ -7497,7 +7485,7 @@
                 <a:ea typeface="Arial"/>
                 <a:cs typeface="Arial"/>
               </a:rPr>
-              <a:t>NEXT ACTION</a:t>
+              <a:t>AUTHORITATIVE SOURCE ESTATE</a:t>
             </a:r>
           </a:p>
         </p:txBody>
@@ -7556,7 +7544,7 @@
                 <a:ea typeface="Arial"/>
                 <a:cs typeface="Arial"/>
               </a:rPr>
-              <a:t>Bid Corporation</a:t>
+              <a:t>82 public facts</a:t>
             </a:r>
           </a:p>
         </p:txBody>
@@ -7591,7 +7579,7 @@
         </p:spPr>
         <p:txBody>
           <a:bodyPr xmlns:a="http://schemas.openxmlformats.org/drawingml/2006/main" anchor="t">
-            <a:normAutofit fontScale="87097"/>
+            <a:normAutofit fontScale="80495"/>
           </a:bodyPr>
           <a:lstStyle xmlns:a="http://schemas.openxmlformats.org/drawingml/2006/main"/>
           <a:p xmlns:a="http://schemas.openxmlformats.org/drawingml/2006/main">
@@ -7615,7 +7603,7 @@
                 <a:ea typeface="Arial"/>
                 <a:cs typeface="Arial"/>
               </a:rPr>
-              <a:t>Liquidity · Treasurer</a:t>
+              <a:t>31 approved · 51 pending</a:t>
             </a:r>
           </a:p>
         </p:txBody>
@@ -7674,7 +7662,7 @@
                 <a:ea typeface="Arial"/>
                 <a:cs typeface="Arial"/>
               </a:rPr>
-              <a:t>R13.7m</a:t>
+              <a:t>15</a:t>
             </a:r>
           </a:p>
         </p:txBody>
@@ -7733,7 +7721,7 @@
                 <a:ea typeface="Arial"/>
                 <a:cs typeface="Arial"/>
               </a:rPr>
-              <a:t>client-value proxy</a:t>
+              <a:t>active anchored cells</a:t>
             </a:r>
           </a:p>
         </p:txBody>
@@ -7768,7 +7756,7 @@
         </p:spPr>
         <p:txBody>
           <a:bodyPr xmlns:a="http://schemas.openxmlformats.org/drawingml/2006/main" anchor="t">
-            <a:normAutofit fontScale="80392"/>
+            <a:normAutofit fontScale="66615"/>
           </a:bodyPr>
           <a:lstStyle xmlns:a="http://schemas.openxmlformats.org/drawingml/2006/main"/>
           <a:p xmlns:a="http://schemas.openxmlformats.org/drawingml/2006/main">
@@ -7792,7 +7780,7 @@
                 <a:ea typeface="Arial"/>
                 <a:cs typeface="Arial"/>
               </a:rPr>
-              <a:t>R4.0m bank scenario | 79.2% stability</a:t>
+              <a:t>85 E0 prior-led cells · three approved-anchor clients</a:t>
             </a:r>
           </a:p>
         </p:txBody>
@@ -7827,7 +7815,7 @@
         </p:spPr>
         <p:txBody>
           <a:bodyPr xmlns:a="http://schemas.openxmlformats.org/drawingml/2006/main" anchor="t">
-            <a:normAutofit fontScale="88072"/>
+            <a:normAutofit fontScale="66667"/>
           </a:bodyPr>
           <a:lstStyle xmlns:a="http://schemas.openxmlformats.org/drawingml/2006/main"/>
           <a:p xmlns:a="http://schemas.openxmlformats.org/drawingml/2006/main">
@@ -7851,7 +7839,7 @@
                 <a:ea typeface="Arial"/>
                 <a:cs typeface="Arial"/>
               </a:rPr>
-              <a:t>Discovery only: validate the liquidity structure and feasibility before any product proposal.</a:t>
+              <a:t>Pending candidates may pass deterministic QA, but cannot activate anchors, change ranks or enter banker-facing claim paths.</a:t>
             </a:r>
           </a:p>
         </p:txBody>
@@ -7910,14 +7898,14 @@
                 <a:ea typeface="Arial"/>
                 <a:cs typeface="Arial"/>
               </a:rPr>
-              <a:t>Top five client-value scenarios</a:t>
+              <a:t>E1 pooling-weight sensitivity</a:t>
             </a:r>
           </a:p>
         </p:txBody>
       </p:sp>
       <p:graphicFrame>
         <p:nvGraphicFramePr>
-          <p:cNvPr id="42" name="Chart"/>
+          <p:cNvPr id="46" name="Chart"/>
           <p:cNvGraphicFramePr/>
           <p:nvPr/>
         </p:nvGraphicFramePr>
@@ -7927,7 +7915,7 @@
         </p:xfrm>
         <a:graphic xmlns:a="http://schemas.openxmlformats.org/drawingml/2006/main">
           <a:graphicData uri="http://schemas.openxmlformats.org/drawingml/2006/chart">
-            <c:chart xmlns:r="http://schemas.openxmlformats.org/officeDocument/2006/relationships" xmlns:c="http://schemas.openxmlformats.org/drawingml/2006/chart" r:id="Rb95400c35ecd4c3f"/>
+            <c:chart xmlns:r="http://schemas.openxmlformats.org/officeDocument/2006/relationships" xmlns:c="http://schemas.openxmlformats.org/drawingml/2006/chart" r:id="R0fbd3b2c23b74aa2"/>
           </a:graphicData>
         </a:graphic>
       </p:graphicFrame>
@@ -7992,7 +7980,7 @@
         </p:spPr>
         <p:txBody>
           <a:bodyPr xmlns:a="http://schemas.openxmlformats.org/drawingml/2006/main" anchor="t">
-            <a:normAutofit fontScale="57250"/>
+            <a:normAutofit fontScale="54902"/>
           </a:bodyPr>
           <a:lstStyle xmlns:a="http://schemas.openxmlformats.org/drawingml/2006/main"/>
           <a:p xmlns:a="http://schemas.openxmlformats.org/drawingml/2006/main">
@@ -8016,7 +8004,7 @@
                 <a:ea typeface="Arial"/>
                 <a:cs typeface="Arial"/>
               </a:rPr>
-              <a:t>Capacity: 8. At most two per client; one per client/role; three per solution and sector. Solver status: OPTIMAL over 512 common draws.</a:t>
+              <a:t>Measurement policy v2-wallet-measurement-policy-1.1.0 fixes E1 at 0.35. The 0.20 / 0.35 / 0.50 sweep reports coverage, CRPS, width and rank effects.</a:t>
             </a:r>
           </a:p>
         </p:txBody>
@@ -8097,7 +8085,7 @@
                 <a:ea typeface="Arial"/>
                 <a:cs typeface="Arial"/>
               </a:rPr>
-              <a:t>BHP EXPLANATION PATH</a:t>
+              <a:t>THE 20 × 5 COMMERCIAL SURFACE</a:t>
             </a:r>
           </a:p>
         </p:txBody>
@@ -8156,14 +8144,14 @@
                 <a:ea typeface="Arial"/>
                 <a:cs typeface="Arial"/>
               </a:rPr>
-              <a:t>BHP’s FX case is valuable—but not yet urgent</a:t>
+              <a:t>One heatmap makes the latent opportunity actionable</a:t>
             </a:r>
           </a:p>
         </p:txBody>
       </p:sp>
       <p:cxnSp>
         <p:nvCxnSpPr>
-          <p:cNvPr id="57" name="title-rule-9"/>
+          <p:cNvPr id="73" name="title-rule-9"/>
           <p:cNvCxnSpPr/>
           <p:nvPr/>
         </p:nvCxnSpPr>
@@ -8237,7 +8225,7 @@
                 <a:ea typeface="Arial"/>
                 <a:cs typeface="Arial"/>
               </a:rPr>
-              <a:t>TEAM: Corporate Wallet Digital Twin | Christopher Koen | V3.1.0</a:t>
+              <a:t>TEAM: Corporate Wallet Digital Twin | Christopher Koen | V3.1.1</a:t>
             </a:r>
           </a:p>
         </p:txBody>
@@ -8296,7 +8284,7 @@
                 <a:ea typeface="Arial"/>
                 <a:cs typeface="Arial"/>
               </a:rPr>
-              <a:t>SYN BANK SIMULATION + PUBLIC E1 + REPRESENTATIVE PRIORS</a:t>
+              <a:t>CONFIDENTIAL SYN BANK ACTIVITY + APPROVED PUBLIC E1 + GOVERNED PRIORS</a:t>
             </a:r>
           </a:p>
         </p:txBody>
@@ -8414,14 +8402,14 @@
                 <a:ea typeface="Arial"/>
                 <a:cs typeface="Arial"/>
               </a:rPr>
-              <a:t>BHP · TREASURER · FX EXPOSURE · DISCOVERY</a:t>
+              <a:t>DEFAULT COLOUR: CONTESTABLE SCENARIO CONTRIBUTION</a:t>
             </a:r>
           </a:p>
         </p:txBody>
       </p:sp>
       <p:cxnSp>
         <p:nvCxnSpPr>
-          <p:cNvPr id="62" name="s9-h-rule-0"/>
+          <p:cNvPr id="78" name="s9-h-rule-0"/>
           <p:cNvCxnSpPr/>
           <p:nvPr/>
         </p:nvCxnSpPr>
@@ -8495,7 +8483,7 @@
                 <a:ea typeface="Arial"/>
                 <a:cs typeface="Arial"/>
               </a:rPr>
-              <a:t>90.3%</a:t>
+              <a:t>100</a:t>
             </a:r>
           </a:p>
         </p:txBody>
@@ -8554,14 +8542,14 @@
                 <a:ea typeface="Arial"/>
                 <a:cs typeface="Arial"/>
               </a:rPr>
-              <a:t>NEED SCENARIO</a:t>
+              <a:t>INTERACTIVE CELLS</a:t>
             </a:r>
           </a:p>
         </p:txBody>
       </p:sp>
       <p:cxnSp>
         <p:nvCxnSpPr>
-          <p:cNvPr id="65" name="s9-h-rule-1"/>
+          <p:cNvPr id="81" name="s9-h-rule-1"/>
           <p:cNvCxnSpPr/>
           <p:nvPr/>
         </p:nvCxnSpPr>
@@ -8635,7 +8623,7 @@
                 <a:ea typeface="Arial"/>
                 <a:cs typeface="Arial"/>
               </a:rPr>
-              <a:t>R14.6m</a:t>
+              <a:t>15</a:t>
             </a:r>
           </a:p>
         </p:txBody>
@@ -8694,14 +8682,14 @@
                 <a:ea typeface="Arial"/>
                 <a:cs typeface="Arial"/>
               </a:rPr>
-              <a:t>CLIENT PROXY</a:t>
+              <a:t>E1 APPROVED</a:t>
             </a:r>
           </a:p>
         </p:txBody>
       </p:sp>
       <p:cxnSp>
         <p:nvCxnSpPr>
-          <p:cNvPr id="68" name="s9-h-rule-2"/>
+          <p:cNvPr id="84" name="s9-h-rule-2"/>
           <p:cNvCxnSpPr/>
           <p:nvPr/>
         </p:nvCxnSpPr>
@@ -8775,7 +8763,7 @@
                 <a:ea typeface="Arial"/>
                 <a:cs typeface="Arial"/>
               </a:rPr>
-              <a:t>R8.1m</a:t>
+              <a:t>85</a:t>
             </a:r>
           </a:p>
         </p:txBody>
@@ -8834,7 +8822,7 @@
                 <a:ea typeface="Arial"/>
                 <a:cs typeface="Arial"/>
               </a:rPr>
-              <a:t>BANK SCENARIO</a:t>
+              <a:t>E0 PRIOR-LED</a:t>
             </a:r>
           </a:p>
         </p:txBody>
@@ -8900,7 +8888,7 @@
         </p:spPr>
         <p:txBody>
           <a:bodyPr xmlns:a="http://schemas.openxmlformats.org/drawingml/2006/main" anchor="t">
-            <a:normAutofit fontScale="46552"/>
+            <a:normAutofit fontScale="51126"/>
           </a:bodyPr>
           <a:lstStyle xmlns:a="http://schemas.openxmlformats.org/drawingml/2006/main"/>
           <a:p xmlns:a="http://schemas.openxmlformats.org/drawingml/2006/main">
@@ -8924,7 +8912,7 @@
                 <a:ea typeface="Arial"/>
                 <a:cs typeface="Arial"/>
               </a:rPr>
-              <a:t>Event → impact → problem → role → bundle → value</a:t>
+              <a:t>Five product lenses · one explicit evidence state</a:t>
             </a:r>
           </a:p>
         </p:txBody>
@@ -8959,7 +8947,7 @@
         </p:spPr>
         <p:txBody>
           <a:bodyPr xmlns:a="http://schemas.openxmlformats.org/drawingml/2006/main" anchor="t">
-            <a:normAutofit fontScale="97960"/>
+            <a:normAutofit fontScale="100000"/>
           </a:bodyPr>
           <a:lstStyle xmlns:a="http://schemas.openxmlformats.org/drawingml/2006/main"/>
           <a:p xmlns:a="http://schemas.openxmlformats.org/drawingml/2006/main">
@@ -8983,7 +8971,7 @@
                 <a:ea typeface="Arial"/>
                 <a:cs typeface="Arial"/>
               </a:rPr>
-              <a:t>Audited FX evidence plus observed cross-border activity supports the problem; no dated trigger supports time-critical urgency.</a:t>
+              <a:t>Toggle A, posterior T, estimated q, contestable G or approval status. FX and Liquidity remain labelled proxies.</a:t>
             </a:r>
           </a:p>
         </p:txBody>
@@ -9042,7 +9030,7 @@
                 <a:ea typeface="Arial"/>
                 <a:cs typeface="Arial"/>
               </a:rPr>
-              <a:t>Decision: ask who signs off—and abstain from urgency</a:t>
+              <a:t>Click a cell to open A / T / q / q* / G</a:t>
             </a:r>
           </a:p>
         </p:txBody>
@@ -9132,7 +9120,7 @@
                 <a:ea typeface="Arial"/>
                 <a:cs typeface="Arial"/>
               </a:rPr>
-              <a:t>CLAIM BOUNDARY</a:t>
+              <a:t>AGGREGATION RULE</a:t>
             </a:r>
           </a:p>
         </p:txBody>
@@ -9250,7 +9238,7 @@
                 <a:ea typeface="Arial"/>
                 <a:cs typeface="Arial"/>
               </a:rPr>
-              <a:t>causal value claims</a:t>
+              <a:t>heterogeneous spend totals</a:t>
             </a:r>
           </a:p>
         </p:txBody>
@@ -9309,7 +9297,7 @@
                 <a:ea typeface="Arial"/>
                 <a:cs typeface="Arial"/>
               </a:rPr>
-              <a:t>DISCOVERY ONLY</a:t>
+              <a:t>WALLET FIRST</a:t>
             </a:r>
           </a:p>
           <a:p xmlns:a="http://schemas.openxmlformats.org/drawingml/2006/main">
@@ -9333,7 +9321,7 @@
                 <a:ea typeface="Arial"/>
                 <a:cs typeface="Arial"/>
               </a:rPr>
-              <a:t>Client and bank value are separate; causal value is null.</a:t>
+              <a:t>Coverage Plan is the governed action layer below this evidence.</a:t>
             </a:r>
           </a:p>
         </p:txBody>
@@ -9368,7 +9356,7 @@
         </p:spPr>
         <p:txBody>
           <a:bodyPr xmlns:a="http://schemas.openxmlformats.org/drawingml/2006/main" anchor="t">
-            <a:normAutofit fontScale="76347"/>
+            <a:normAutofit fontScale="86667"/>
           </a:bodyPr>
           <a:lstStyle xmlns:a="http://schemas.openxmlformats.org/drawingml/2006/main"/>
           <a:p xmlns:a="http://schemas.openxmlformats.org/drawingml/2006/main">
@@ -9392,11 +9380,66 @@
                 <a:ea typeface="Arial"/>
                 <a:cs typeface="Arial"/>
               </a:rPr>
-              <a:t>Hedge ratio, decision authority and bank feasibility remain unknown; product proposal and guaranteed-saving claims are prohibited.</a:t>
-            </a:r>
-          </a:p>
-        </p:txBody>
-      </p:sp>
+              <a:t>Product activities are never summed as a single banking-spend number. Only scenario contribution is aggregated.</a:t>
+            </a:r>
+          </a:p>
+        </p:txBody>
+      </p:sp>
+      <p:sp>
+        <p:nvSpPr>
+          <p:cNvPr id="69" name="">
+            <a:extLst xmlns:a="http://schemas.openxmlformats.org/drawingml/2006/main">
+              <a:ext uri="{FF2B5EF4-FFF2-40B4-BE49-F238E27FC236}">
+                <a16:creationId xmlns:a16="http://schemas.microsoft.com/office/drawing/2014/main" id="{71D95F7E-7CB4-4974-9A17-1C177BB5F6EA}"/>
+              </a:ext>
+            </a:extLst>
+          </p:cNvPr>
+          <p:cNvSpPr>
+            <a:spLocks xmlns:a="http://schemas.openxmlformats.org/drawingml/2006/main" noGrp="1"/>
+          </p:cNvSpPr>
+          <p:nvPr/>
+        </p:nvSpPr>
+        <p:spPr>
+          <a:xfrm xmlns:a="http://schemas.openxmlformats.org/drawingml/2006/main">
+            <a:off x="514350" y="1447800"/>
+            <a:ext cx="11239500" cy="4914900"/>
+          </a:xfrm>
+          <a:prstGeom xmlns:a="http://schemas.openxmlformats.org/drawingml/2006/main" prst="rect">
+            <a:avLst/>
+          </a:prstGeom>
+          <a:solidFill xmlns:a="http://schemas.openxmlformats.org/drawingml/2006/main">
+            <a:srgbClr val="FFFFFF"/>
+          </a:solidFill>
+          <a:ln xmlns:a="http://schemas.openxmlformats.org/drawingml/2006/main" w="9525">
+            <a:solidFill>
+              <a:srgbClr val="D7DEE8"/>
+            </a:solidFill>
+            <a:prstDash val="solid"/>
+          </a:ln>
+        </p:spPr>
+      </p:sp>
+      <p:pic>
+        <p:nvPicPr>
+          <p:cNvPr id="98" name=""/>
+          <p:cNvPicPr>
+            <a:picLocks xmlns:a="http://schemas.openxmlformats.org/drawingml/2006/main" noChangeAspect="1"/>
+          </p:cNvPicPr>
+          <p:nvPr/>
+        </p:nvPicPr>
+        <p:blipFill>
+          <a:blip xmlns:r="http://schemas.openxmlformats.org/officeDocument/2006/relationships" xmlns:a="http://schemas.openxmlformats.org/drawingml/2006/main" r:embed="Rf80bbded097e405f"/>
+          <a:stretch xmlns:a="http://schemas.openxmlformats.org/drawingml/2006/main"/>
+        </p:blipFill>
+        <p:spPr>
+          <a:xfrm xmlns:a="http://schemas.openxmlformats.org/drawingml/2006/main">
+            <a:off x="1991798" y="1524000"/>
+            <a:ext cx="8208404" cy="4762500"/>
+          </a:xfrm>
+          <a:prstGeom xmlns:a="http://schemas.openxmlformats.org/drawingml/2006/main" prst="rect">
+            <a:avLst/>
+          </a:prstGeom>
+        </p:spPr>
+      </p:pic>
     </p:spTree>
     <p:extLst>
       <p:ext uri="{BB962C8B-B14F-4D97-AF65-F5344CB8AC3E}">
@@ -9473,7 +9516,7 @@
                 <a:ea typeface="Arial"/>
                 <a:cs typeface="Arial"/>
               </a:rPr>
-              <a:t>ACTIVE COVERAGE LEARNING</a:t>
+              <a:t>BHP FORENSIC DRILL-DOWN</a:t>
             </a:r>
           </a:p>
         </p:txBody>
@@ -9532,14 +9575,14 @@
                 <a:ea typeface="Arial"/>
                 <a:cs typeface="Arial"/>
               </a:rPr>
-              <a:t>Ask only when the answer can change the decision</a:t>
+              <a:t>Trade Finance: A → T → q → q* → G</a:t>
             </a:r>
           </a:p>
         </p:txBody>
       </p:sp>
       <p:cxnSp>
         <p:nvCxnSpPr>
-          <p:cNvPr id="116" name="title-rule-5"/>
+          <p:cNvPr id="153" name="title-rule-5"/>
           <p:cNvCxnSpPr/>
           <p:nvPr/>
         </p:nvCxnSpPr>
@@ -9613,7 +9656,7 @@
                 <a:ea typeface="Arial"/>
                 <a:cs typeface="Arial"/>
               </a:rPr>
-              <a:t>TEAM: Corporate Wallet Digital Twin | Christopher Koen | V3.1.0</a:t>
+              <a:t>TEAM: Corporate Wallet Digital Twin | Christopher Koen | V3.1.1</a:t>
             </a:r>
           </a:p>
         </p:txBody>
@@ -9672,7 +9715,7 @@
                 <a:ea typeface="Arial"/>
                 <a:cs typeface="Arial"/>
               </a:rPr>
-              <a:t>SYN BANK SIMULATION + PUBLIC E1 + REPRESENTATIVE PRIORS</a:t>
+              <a:t>CONFIDENTIAL SYN BANK ACTIVITY + APPROVED PUBLIC E1 + GOVERNED PRIORS</a:t>
             </a:r>
           </a:p>
         </p:txBody>
@@ -9738,7 +9781,7 @@
       </p:sp>
       <p:cxnSp>
         <p:nvCxnSpPr>
-          <p:cNvPr id="120" name="s5-facts-rule"/>
+          <p:cNvPr id="157" name="s5-facts-rule"/>
           <p:cNvCxnSpPr/>
           <p:nvPr/>
         </p:nvCxnSpPr>
@@ -9812,7 +9855,7 @@
                 <a:ea typeface="Arial"/>
                 <a:cs typeface="Arial"/>
               </a:rPr>
-              <a:t>308</a:t>
+              <a:t>R1.445bn</a:t>
             </a:r>
           </a:p>
         </p:txBody>
@@ -9871,7 +9914,7 @@
                 <a:ea typeface="Arial"/>
                 <a:cs typeface="Arial"/>
               </a:rPr>
-              <a:t>positive-net-VOI questions</a:t>
+              <a:t>A · observed activity</a:t>
             </a:r>
           </a:p>
         </p:txBody>
@@ -9930,14 +9973,14 @@
                 <a:ea typeface="Arial"/>
                 <a:cs typeface="Arial"/>
               </a:rPr>
-              <a:t>Selected from 891 evaluations with 512 common draws</a:t>
+              <a:t>Syn Bank supplied annual trade-flow activity</a:t>
             </a:r>
           </a:p>
         </p:txBody>
       </p:sp>
       <p:cxnSp>
         <p:nvCxnSpPr>
-          <p:cNvPr id="124" name="s5-clients-rule"/>
+          <p:cNvPr id="161" name="s5-clients-rule"/>
           <p:cNvCxnSpPr/>
           <p:nvPr/>
         </p:nvCxnSpPr>
@@ -10011,7 +10054,7 @@
                 <a:ea typeface="Arial"/>
                 <a:cs typeface="Arial"/>
               </a:rPr>
-              <a:t>R10.6k</a:t>
+              <a:t>R5.15–22.08bn</a:t>
             </a:r>
           </a:p>
         </p:txBody>
@@ -10070,7 +10113,7 @@
                 <a:ea typeface="Arial"/>
                 <a:cs typeface="Arial"/>
               </a:rPr>
-              <a:t>BHP question net VOI</a:t>
+              <a:t>T · posterior wallet</a:t>
             </a:r>
           </a:p>
         </p:txBody>
@@ -10129,14 +10172,14 @@
                 <a:ea typeface="Arial"/>
                 <a:cs typeface="Arial"/>
               </a:rPr>
-              <a:t>Decision value—not booked, client or causal value</a:t>
+              <a:t>P10–P90; P50 R8.93bn</a:t>
             </a:r>
           </a:p>
         </p:txBody>
       </p:sp>
       <p:cxnSp>
         <p:nvCxnSpPr>
-          <p:cNvPr id="128" name="s5-review-rule"/>
+          <p:cNvPr id="165" name="s5-review-rule"/>
           <p:cNvCxnSpPr/>
           <p:nvPr/>
         </p:nvCxnSpPr>
@@ -10210,7 +10253,7 @@
                 <a:ea typeface="Arial"/>
                 <a:cs typeface="Arial"/>
               </a:rPr>
-              <a:t>0</a:t>
+              <a:t>6.5–28.0%</a:t>
             </a:r>
           </a:p>
         </p:txBody>
@@ -10269,7 +10312,7 @@
                 <a:ea typeface="Arial"/>
                 <a:cs typeface="Arial"/>
               </a:rPr>
-              <a:t>direct model updates</a:t>
+              <a:t>q · estimated share</a:t>
             </a:r>
           </a:p>
         </p:txBody>
@@ -10328,7 +10371,7 @@
                 <a:ea typeface="Arial"/>
                 <a:cs typeface="Arial"/>
               </a:rPr>
-              <a:t>Every submitted answer remains pending until approval</a:t>
+              <a:t>P50 16.2%; POSTERIOR, not measured competitor share</a:t>
             </a:r>
           </a:p>
         </p:txBody>
@@ -10387,7 +10430,7 @@
                 <a:ea typeface="Arial"/>
                 <a:cs typeface="Arial"/>
               </a:rPr>
-              <a:t>Value comes from decision change—not semantic relevance</a:t>
+              <a:t>q* = 40% governed target-share scenario</a:t>
             </a:r>
           </a:p>
         </p:txBody>
@@ -10477,7 +10520,7 @@
                 <a:ea typeface="Arial"/>
                 <a:cs typeface="Arial"/>
               </a:rPr>
-              <a:t>Model explicit answer states and decision effects</a:t>
+              <a:t>G P50 = R2.126bn contestable activity</a:t>
             </a:r>
           </a:p>
         </p:txBody>
@@ -10567,7 +10610,7 @@
                 <a:ea typeface="Arial"/>
                 <a:cs typeface="Arial"/>
               </a:rPr>
-              <a:t>Subtract question cost and delay penalty</a:t>
+              <a:t>Scenario contribution P50 = R7.367m</a:t>
             </a:r>
           </a:p>
         </p:txBody>
@@ -10602,7 +10645,7 @@
         </p:spPr>
         <p:txBody>
           <a:bodyPr xmlns:a="http://schemas.openxmlformats.org/drawingml/2006/main" anchor="t">
-            <a:normAutofit fontScale="50769"/>
+            <a:normAutofit fontScale="42593"/>
           </a:bodyPr>
           <a:lstStyle xmlns:a="http://schemas.openxmlformats.org/drawingml/2006/main"/>
           <a:p xmlns:a="http://schemas.openxmlformats.org/drawingml/2006/main">
@@ -10626,14 +10669,14 @@
                 <a:ea typeface="Arial"/>
                 <a:cs typeface="Arial"/>
               </a:rPr>
-              <a:t>1 primary question</a:t>
+              <a:t>Rank #2 · E1 approved</a:t>
             </a:r>
           </a:p>
         </p:txBody>
       </p:sp>
       <p:cxnSp>
         <p:nvCxnSpPr>
-          <p:cNvPr id="138" name="s5-tier-rule-0"/>
+          <p:cNvPr id="175" name="s5-tier-rule-0"/>
           <p:cNvCxnSpPr/>
           <p:nvPr/>
         </p:nvCxnSpPr>
@@ -10707,7 +10750,7 @@
                 <a:ea typeface="Arial"/>
                 <a:cs typeface="Arial"/>
               </a:rPr>
-              <a:t>E3</a:t>
+              <a:t>A</a:t>
             </a:r>
           </a:p>
         </p:txBody>
@@ -10742,7 +10785,7 @@
         </p:spPr>
         <p:txBody>
           <a:bodyPr xmlns:a="http://schemas.openxmlformats.org/drawingml/2006/main" anchor="t">
-            <a:normAutofit fontScale="75809"/>
+            <a:normAutofit fontScale="98303"/>
           </a:bodyPr>
           <a:lstStyle xmlns:a="http://schemas.openxmlformats.org/drawingml/2006/main"/>
           <a:p xmlns:a="http://schemas.openxmlformats.org/drawingml/2006/main">
@@ -10766,14 +10809,14 @@
                 <a:ea typeface="Arial"/>
                 <a:cs typeface="Arial"/>
               </a:rPr>
-              <a:t>multibank observation</a:t>
+              <a:t>observed activity</a:t>
             </a:r>
           </a:p>
         </p:txBody>
       </p:sp>
       <p:cxnSp>
         <p:nvCxnSpPr>
-          <p:cNvPr id="141" name="s5-tier-rule-1"/>
+          <p:cNvPr id="178" name="s5-tier-rule-1"/>
           <p:cNvCxnSpPr/>
           <p:nvPr/>
         </p:nvCxnSpPr>
@@ -10823,7 +10866,7 @@
         </p:spPr>
         <p:txBody>
           <a:bodyPr xmlns:a="http://schemas.openxmlformats.org/drawingml/2006/main" anchor="t">
-            <a:normAutofit fontScale="55073"/>
+            <a:normAutofit fontScale="80392"/>
           </a:bodyPr>
           <a:lstStyle xmlns:a="http://schemas.openxmlformats.org/drawingml/2006/main"/>
           <a:p xmlns:a="http://schemas.openxmlformats.org/drawingml/2006/main">
@@ -10847,7 +10890,7 @@
                 <a:ea typeface="Arial"/>
                 <a:cs typeface="Arial"/>
               </a:rPr>
-              <a:t>RATE</a:t>
+              <a:t>T</a:t>
             </a:r>
           </a:p>
         </p:txBody>
@@ -10882,7 +10925,7 @@
         </p:spPr>
         <p:txBody>
           <a:bodyPr xmlns:a="http://schemas.openxmlformats.org/drawingml/2006/main" anchor="t">
-            <a:normAutofit fontScale="80647"/>
+            <a:normAutofit fontScale="100000"/>
           </a:bodyPr>
           <a:lstStyle xmlns:a="http://schemas.openxmlformats.org/drawingml/2006/main"/>
           <a:p xmlns:a="http://schemas.openxmlformats.org/drawingml/2006/main">
@@ -10906,14 +10949,14 @@
                 <a:ea typeface="Arial"/>
                 <a:cs typeface="Arial"/>
               </a:rPr>
-              <a:t>approved economics</a:t>
+              <a:t>wallet posterior</a:t>
             </a:r>
           </a:p>
         </p:txBody>
       </p:sp>
       <p:cxnSp>
         <p:nvCxnSpPr>
-          <p:cNvPr id="144" name="s5-tier-rule-2"/>
+          <p:cNvPr id="181" name="s5-tier-rule-2"/>
           <p:cNvCxnSpPr/>
           <p:nvPr/>
         </p:nvCxnSpPr>
@@ -10987,7 +11030,7 @@
                 <a:ea typeface="Arial"/>
                 <a:cs typeface="Arial"/>
               </a:rPr>
-              <a:t>E2</a:t>
+              <a:t>q</a:t>
             </a:r>
           </a:p>
         </p:txBody>
@@ -11022,7 +11065,7 @@
         </p:spPr>
         <p:txBody>
           <a:bodyPr xmlns:a="http://schemas.openxmlformats.org/drawingml/2006/main" anchor="t">
-            <a:normAutofit fontScale="77684"/>
+            <a:normAutofit fontScale="100000"/>
           </a:bodyPr>
           <a:lstStyle xmlns:a="http://schemas.openxmlformats.org/drawingml/2006/main"/>
           <a:p xmlns:a="http://schemas.openxmlformats.org/drawingml/2006/main">
@@ -11046,14 +11089,14 @@
                 <a:ea typeface="Arial"/>
                 <a:cs typeface="Arial"/>
               </a:rPr>
-              <a:t>client / RM attestation</a:t>
+              <a:t>A ÷ T</a:t>
             </a:r>
           </a:p>
         </p:txBody>
       </p:sp>
       <p:cxnSp>
         <p:nvCxnSpPr>
-          <p:cNvPr id="147" name="s5-tier-rule-3"/>
+          <p:cNvPr id="184" name="s5-tier-rule-3"/>
           <p:cNvCxnSpPr/>
           <p:nvPr/>
         </p:nvCxnSpPr>
@@ -11127,7 +11170,7 @@
                 <a:ea typeface="Arial"/>
                 <a:cs typeface="Arial"/>
               </a:rPr>
-              <a:t>PIT</a:t>
+              <a:t>q*</a:t>
             </a:r>
           </a:p>
         </p:txBody>
@@ -11162,7 +11205,7 @@
         </p:spPr>
         <p:txBody>
           <a:bodyPr xmlns:a="http://schemas.openxmlformats.org/drawingml/2006/main" anchor="t">
-            <a:normAutofit fontScale="83741"/>
+            <a:normAutofit fontScale="100000"/>
           </a:bodyPr>
           <a:lstStyle xmlns:a="http://schemas.openxmlformats.org/drawingml/2006/main"/>
           <a:p xmlns:a="http://schemas.openxmlformats.org/drawingml/2006/main">
@@ -11186,14 +11229,14 @@
                 <a:ea typeface="Arial"/>
                 <a:cs typeface="Arial"/>
               </a:rPr>
-              <a:t>point-in-time source</a:t>
+              <a:t>40% scenario</a:t>
             </a:r>
           </a:p>
         </p:txBody>
       </p:sp>
       <p:cxnSp>
         <p:nvCxnSpPr>
-          <p:cNvPr id="150" name="s5-tier-rule-4"/>
+          <p:cNvPr id="187" name="s5-tier-rule-4"/>
           <p:cNvCxnSpPr/>
           <p:nvPr/>
         </p:nvCxnSpPr>
@@ -11243,7 +11286,7 @@
         </p:spPr>
         <p:txBody>
           <a:bodyPr xmlns:a="http://schemas.openxmlformats.org/drawingml/2006/main" anchor="t">
-            <a:normAutofit fontScale="56597"/>
+            <a:normAutofit fontScale="80392"/>
           </a:bodyPr>
           <a:lstStyle xmlns:a="http://schemas.openxmlformats.org/drawingml/2006/main"/>
           <a:p xmlns:a="http://schemas.openxmlformats.org/drawingml/2006/main">
@@ -11267,7 +11310,7 @@
                 <a:ea typeface="Arial"/>
                 <a:cs typeface="Arial"/>
               </a:rPr>
-              <a:t>4EYE</a:t>
+              <a:t>G</a:t>
             </a:r>
           </a:p>
         </p:txBody>
@@ -11326,7 +11369,7 @@
                 <a:ea typeface="Arial"/>
                 <a:cs typeface="Arial"/>
               </a:rPr>
-              <a:t>human approval</a:t>
+              <a:t>max(q*T−A,0)</a:t>
             </a:r>
           </a:p>
         </p:txBody>
@@ -11407,7 +11450,7 @@
                 <a:ea typeface="Arial"/>
                 <a:cs typeface="Arial"/>
               </a:rPr>
-              <a:t>RATE AND PRIOR SENSITIVITY</a:t>
+              <a:t>DECISION TWIN ACTION LAYER</a:t>
             </a:r>
           </a:p>
         </p:txBody>
@@ -11442,7 +11485,7 @@
         </p:spPr>
         <p:txBody>
           <a:bodyPr xmlns:a="http://schemas.openxmlformats.org/drawingml/2006/main" anchor="t">
-            <a:normAutofit fontScale="93039"/>
+            <a:normAutofit fontScale="94994"/>
           </a:bodyPr>
           <a:lstStyle xmlns:a="http://schemas.openxmlformats.org/drawingml/2006/main"/>
           <a:p xmlns:a="http://schemas.openxmlformats.org/drawingml/2006/main">
@@ -11466,14 +11509,14 @@
                 <a:ea typeface="Arial"/>
                 <a:cs typeface="Arial"/>
               </a:rPr>
-              <a:t>Trade Finance remains robust—but conversations diversify</a:t>
+              <a:t>Wallet gap → stakeholder → problem → solution → timing</a:t>
             </a:r>
           </a:p>
         </p:txBody>
       </p:sp>
       <p:cxnSp>
         <p:nvCxnSpPr>
-          <p:cNvPr id="142" name="title-rule-7"/>
+          <p:cNvPr id="187" name="title-rule-7"/>
           <p:cNvCxnSpPr/>
           <p:nvPr/>
         </p:nvCxnSpPr>
@@ -11547,7 +11590,7 @@
                 <a:ea typeface="Arial"/>
                 <a:cs typeface="Arial"/>
               </a:rPr>
-              <a:t>TEAM: Corporate Wallet Digital Twin | Christopher Koen | V3.1.0</a:t>
+              <a:t>TEAM: Corporate Wallet Digital Twin | Christopher Koen | V3.1.1</a:t>
             </a:r>
           </a:p>
         </p:txBody>
@@ -11606,7 +11649,7 @@
                 <a:ea typeface="Arial"/>
                 <a:cs typeface="Arial"/>
               </a:rPr>
-              <a:t>SYN BANK SIMULATION + PUBLIC E1 + REPRESENTATIVE PRIORS</a:t>
+              <a:t>CONFIDENTIAL SYN BANK ACTIVITY + APPROVED PUBLIC E1 + GOVERNED PRIORS</a:t>
             </a:r>
           </a:p>
         </p:txBody>
@@ -11755,7 +11798,7 @@
                 <a:ea typeface="Arial"/>
                 <a:cs typeface="Arial"/>
               </a:rPr>
-              <a:t>FROZEN 3 x 3 BENCHMARK</a:t>
+              <a:t>BHP TRADE FINANCE CELL</a:t>
             </a:r>
           </a:p>
         </p:txBody>
@@ -11814,7 +11857,7 @@
                 <a:ea typeface="Arial"/>
                 <a:cs typeface="Arial"/>
               </a:rPr>
-              <a:t>#1 in 9 / 9</a:t>
+              <a:t>#2 in wallet</a:t>
             </a:r>
           </a:p>
         </p:txBody>
@@ -11873,7 +11916,7 @@
                 <a:ea typeface="Arial"/>
                 <a:cs typeface="Arial"/>
               </a:rPr>
-              <a:t>The five-product V3 benchmark remains reproducible: Trade Finance is first-ranked in all frozen rate/prior cases.</a:t>
+              <a:t>The wallet interval starts the investigation; it does not automatically become a product pitch.</a:t>
             </a:r>
           </a:p>
         </p:txBody>
@@ -11932,7 +11975,7 @@
                 <a:ea typeface="Arial"/>
                 <a:cs typeface="Arial"/>
               </a:rPr>
-              <a:t>LOW RATE</a:t>
+              <a:t>STAKEHOLDER</a:t>
             </a:r>
           </a:p>
         </p:txBody>
@@ -11991,7 +12034,7 @@
                 <a:ea typeface="Arial"/>
                 <a:cs typeface="Arial"/>
               </a:rPr>
-              <a:t>BASE</a:t>
+              <a:t>PROBLEM</a:t>
             </a:r>
           </a:p>
         </p:txBody>
@@ -12050,7 +12093,7 @@
                 <a:ea typeface="Arial"/>
                 <a:cs typeface="Arial"/>
               </a:rPr>
-              <a:t>HIGH RATE</a:t>
+              <a:t>SOLUTION</a:t>
             </a:r>
           </a:p>
         </p:txBody>
@@ -12140,7 +12183,7 @@
                 <a:ea typeface="Arial"/>
                 <a:cs typeface="Arial"/>
               </a:rPr>
-              <a:t>LOW P | TF #1</a:t>
+              <a:t>TREASURER</a:t>
             </a:r>
           </a:p>
         </p:txBody>
@@ -12230,7 +12273,7 @@
                 <a:ea typeface="Arial"/>
                 <a:cs typeface="Arial"/>
               </a:rPr>
-              <a:t>TF #1</a:t>
+              <a:t>WC PRESSURE</a:t>
             </a:r>
           </a:p>
         </p:txBody>
@@ -12320,7 +12363,7 @@
                 <a:ea typeface="Arial"/>
                 <a:cs typeface="Arial"/>
               </a:rPr>
-              <a:t>TF #1</a:t>
+              <a:t>TRADE FINANCE</a:t>
             </a:r>
           </a:p>
         </p:txBody>
@@ -12410,7 +12453,7 @@
                 <a:ea typeface="Arial"/>
                 <a:cs typeface="Arial"/>
               </a:rPr>
-              <a:t>BASE P | TF #1</a:t>
+              <a:t>CFO</a:t>
             </a:r>
           </a:p>
         </p:txBody>
@@ -12500,7 +12543,7 @@
                 <a:ea typeface="Arial"/>
                 <a:cs typeface="Arial"/>
               </a:rPr>
-              <a:t>TF #1</a:t>
+              <a:t>SUPPLY RISK</a:t>
             </a:r>
           </a:p>
         </p:txBody>
@@ -12590,7 +12633,7 @@
                 <a:ea typeface="Arial"/>
                 <a:cs typeface="Arial"/>
               </a:rPr>
-              <a:t>TF #1</a:t>
+              <a:t>+ SCF</a:t>
             </a:r>
           </a:p>
         </p:txBody>
@@ -12680,7 +12723,7 @@
                 <a:ea typeface="Arial"/>
                 <a:cs typeface="Arial"/>
               </a:rPr>
-              <a:t>HIGH P | TF #1</a:t>
+              <a:t>FIN OPS</a:t>
             </a:r>
           </a:p>
         </p:txBody>
@@ -12770,7 +12813,7 @@
                 <a:ea typeface="Arial"/>
                 <a:cs typeface="Arial"/>
               </a:rPr>
-              <a:t>TF #1</a:t>
+              <a:t>CONFIRM</a:t>
             </a:r>
           </a:p>
         </p:txBody>
@@ -12860,7 +12903,7 @@
                 <a:ea typeface="Arial"/>
                 <a:cs typeface="Arial"/>
               </a:rPr>
-              <a:t>TF #1</a:t>
+              <a:t>DISCOVERY</a:t>
             </a:r>
           </a:p>
         </p:txBody>
@@ -12919,14 +12962,14 @@
                 <a:ea typeface="Arial"/>
                 <a:cs typeface="Arial"/>
               </a:rPr>
-              <a:t>10,000-DRAW GLOBAL SENSITIVITY</a:t>
+              <a:t>WHY NOW + WHAT TO ASK</a:t>
             </a:r>
           </a:p>
         </p:txBody>
       </p:sp>
       <p:cxnSp>
         <p:nvCxnSpPr>
-          <p:cNvPr id="172" name="s7-first-rule"/>
+          <p:cNvPr id="217" name="s7-first-rule"/>
           <p:cNvCxnSpPr/>
           <p:nvPr/>
         </p:nvCxnSpPr>
@@ -13000,7 +13043,7 @@
                 <a:ea typeface="Arial"/>
                 <a:cs typeface="Arial"/>
               </a:rPr>
-              <a:t>100%</a:t>
+              <a:t>36.0%</a:t>
             </a:r>
           </a:p>
         </p:txBody>
@@ -13059,7 +13102,7 @@
                 <a:ea typeface="Arial"/>
                 <a:cs typeface="Arial"/>
               </a:rPr>
-              <a:t>TF first-rank frequency</a:t>
+              <a:t>90-day baseline</a:t>
             </a:r>
           </a:p>
         </p:txBody>
@@ -13118,14 +13161,14 @@
                 <a:ea typeface="Arial"/>
                 <a:cs typeface="Arial"/>
               </a:rPr>
-              <a:t>Stable single highest-ranked product</a:t>
+              <a:t>Transparent—not calibrated hazard</a:t>
             </a:r>
           </a:p>
         </p:txBody>
       </p:sp>
       <p:cxnSp>
         <p:nvCxnSpPr>
-          <p:cNvPr id="176" name="s7-top10-rule"/>
+          <p:cNvPr id="221" name="s7-top10-rule"/>
           <p:cNvCxnSpPr/>
           <p:nvPr/>
         </p:nvCxnSpPr>
@@ -13199,7 +13242,7 @@
                 <a:ea typeface="Arial"/>
                 <a:cs typeface="Arial"/>
               </a:rPr>
-              <a:t>25.2%</a:t>
+              <a:t>1</a:t>
             </a:r>
           </a:p>
         </p:txBody>
@@ -13258,7 +13301,7 @@
                 <a:ea typeface="Arial"/>
                 <a:cs typeface="Arial"/>
               </a:rPr>
-              <a:t>TF mean top-10 share</a:t>
+              <a:t>primary VOI question</a:t>
             </a:r>
           </a:p>
         </p:txBody>
@@ -13317,14 +13360,14 @@
                 <a:ea typeface="Arial"/>
                 <a:cs typeface="Arial"/>
               </a:rPr>
-              <a:t>Important, but not a portfolio majority</a:t>
+              <a:t>Only if it can change the decision</a:t>
             </a:r>
           </a:p>
         </p:txBody>
       </p:sp>
       <p:cxnSp>
         <p:nvCxnSpPr>
-          <p:cNvPr id="180" name="s7-fx-rule"/>
+          <p:cNvPr id="225" name="s7-fx-rule"/>
           <p:cNvCxnSpPr/>
           <p:nvPr/>
         </p:nvCxnSpPr>
@@ -13398,7 +13441,7 @@
                 <a:ea typeface="Arial"/>
                 <a:cs typeface="Arial"/>
               </a:rPr>
-              <a:t>79.7%</a:t>
+              <a:t>8</a:t>
             </a:r>
           </a:p>
         </p:txBody>
@@ -13457,7 +13500,7 @@
                 <a:ea typeface="Arial"/>
                 <a:cs typeface="Arial"/>
               </a:rPr>
-              <a:t>FX majority frequency</a:t>
+              <a:t>weekly conversations</a:t>
             </a:r>
           </a:p>
         </p:txBody>
@@ -13516,14 +13559,14 @@
                 <a:ea typeface="Arial"/>
                 <a:cs typeface="Arial"/>
               </a:rPr>
-              <a:t>The wider top 10 concentrates in FX</a:t>
+              <a:t>All discovery under unknown bank gates</a:t>
             </a:r>
           </a:p>
         </p:txBody>
       </p:sp>
       <p:cxnSp>
         <p:nvCxnSpPr>
-          <p:cNvPr id="184" name="s7-econ-rule"/>
+          <p:cNvPr id="229" name="s7-econ-rule"/>
           <p:cNvCxnSpPr/>
           <p:nvPr/>
         </p:nvCxnSpPr>
@@ -13597,7 +13640,7 @@
                 <a:ea typeface="Arial"/>
                 <a:cs typeface="Arial"/>
               </a:rPr>
-              <a:t>R53.4m</a:t>
+              <a:t>NULL</a:t>
             </a:r>
           </a:p>
         </p:txBody>
@@ -13656,7 +13699,7 @@
                 <a:ea typeface="Arial"/>
                 <a:cs typeface="Arial"/>
               </a:rPr>
-              <a:t>TF absolute economics</a:t>
+              <a:t>causal value</a:t>
             </a:r>
           </a:p>
         </p:txBody>
@@ -13715,7 +13758,7 @@
                 <a:ea typeface="Arial"/>
                 <a:cs typeface="Arial"/>
               </a:rPr>
-              <a:t>Median across approved-shape scenario distributions</a:t>
+              <a:t>No qualified RM trial history</a:t>
             </a:r>
           </a:p>
         </p:txBody>
@@ -13750,7 +13793,7 @@
         </p:spPr>
         <p:txBody>
           <a:bodyPr xmlns:a="http://schemas.openxmlformats.org/drawingml/2006/main" anchor="t">
-            <a:normAutofit fontScale="74886"/>
+            <a:normAutofit fontScale="70758"/>
           </a:bodyPr>
           <a:lstStyle xmlns:a="http://schemas.openxmlformats.org/drawingml/2006/main"/>
           <a:p xmlns:a="http://schemas.openxmlformats.org/drawingml/2006/main">
@@ -13774,7 +13817,7 @@
                 <a:ea typeface="Arial"/>
                 <a:cs typeface="Arial"/>
               </a:rPr>
-              <a:t>V3.1 selects two Trade Finance, three FX and three transaction-banking conversations after stakeholder, problem, feasibility and concentration constraints.</a:t>
+              <a:t>Permitted action now: validate wallet, stakeholder and feasibility. Conditional commercial action begins only after the missing facts and required gates are confirmed.</a:t>
             </a:r>
           </a:p>
         </p:txBody>
@@ -13855,7 +13898,7 @@
                 <a:ea typeface="Arial"/>
                 <a:cs typeface="Arial"/>
               </a:rPr>
-              <a:t>V3.1 REPRESENTATIVE VALIDATION</a:t>
+              <a:t>GROUNDED GENAI BRIEFING</a:t>
             </a:r>
           </a:p>
         </p:txBody>
@@ -13914,14 +13957,14 @@
                 <a:ea typeface="Arial"/>
                 <a:cs typeface="Arial"/>
               </a:rPr>
-              <a:t>Complete mechanics still do not create bank evidence</a:t>
+              <a:t>A closed evidence pack controls every published word</a:t>
             </a:r>
           </a:p>
         </p:txBody>
       </p:sp>
       <p:cxnSp>
         <p:nvCxnSpPr>
-          <p:cNvPr id="65" name="title-rule-6"/>
+          <p:cNvPr id="80" name="title-rule-6"/>
           <p:cNvCxnSpPr/>
           <p:nvPr/>
         </p:nvCxnSpPr>
@@ -13995,7 +14038,7 @@
                 <a:ea typeface="Arial"/>
                 <a:cs typeface="Arial"/>
               </a:rPr>
-              <a:t>TEAM: Corporate Wallet Digital Twin | Christopher Koen | V3.1.0</a:t>
+              <a:t>TEAM: Corporate Wallet Digital Twin | Christopher Koen | V3.1.1</a:t>
             </a:r>
           </a:p>
         </p:txBody>
@@ -14054,7 +14097,7 @@
                 <a:ea typeface="Arial"/>
                 <a:cs typeface="Arial"/>
               </a:rPr>
-              <a:t>SYN BANK SIMULATION + PUBLIC E1 + REPRESENTATIVE PRIORS</a:t>
+              <a:t>CONFIDENTIAL SYN BANK ACTIVITY + APPROVED PUBLIC E1 + GOVERNED PRIORS</a:t>
             </a:r>
           </a:p>
         </p:txBody>
@@ -14120,7 +14163,7 @@
       </p:sp>
       <p:cxnSp>
         <p:nvCxnSpPr>
-          <p:cNvPr id="69" name="s6-wallet-rule"/>
+          <p:cNvPr id="84" name="s6-wallet-rule"/>
           <p:cNvCxnSpPr/>
           <p:nvPr/>
         </p:nvCxnSpPr>
@@ -14194,7 +14237,7 @@
                 <a:ea typeface="Arial"/>
                 <a:cs typeface="Arial"/>
               </a:rPr>
-              <a:t>320</a:t>
+              <a:t>3 / 3</a:t>
             </a:r>
           </a:p>
         </p:txBody>
@@ -14253,7 +14296,7 @@
                 <a:ea typeface="Arial"/>
                 <a:cs typeface="Arial"/>
               </a:rPr>
-              <a:t>solution projections</a:t>
+              <a:t>showcase fallback briefs</a:t>
             </a:r>
           </a:p>
         </p:txBody>
@@ -14312,14 +14355,14 @@
                 <a:ea typeface="Arial"/>
                 <a:cs typeface="Arial"/>
               </a:rPr>
-              <a:t>Sixteen solution families across all twenty clients</a:t>
+              <a:t>BHP · Glencore · Shoprite; deterministic and validated</a:t>
             </a:r>
           </a:p>
         </p:txBody>
       </p:sp>
       <p:cxnSp>
         <p:nvCxnSpPr>
-          <p:cNvPr id="73" name="s6-share-rule"/>
+          <p:cNvPr id="88" name="s6-share-rule"/>
           <p:cNvCxnSpPr/>
           <p:nvPr/>
         </p:nvCxnSpPr>
@@ -14393,7 +14436,7 @@
                 <a:ea typeface="Arial"/>
                 <a:cs typeface="Arial"/>
               </a:rPr>
-              <a:t>224</a:t>
+              <a:t>9</a:t>
             </a:r>
           </a:p>
         </p:txBody>
@@ -14452,7 +14495,7 @@
                 <a:ea typeface="Arial"/>
                 <a:cs typeface="Arial"/>
               </a:rPr>
-              <a:t>conversation candidates</a:t>
+              <a:t>comparative target runs</a:t>
             </a:r>
           </a:p>
         </p:txBody>
@@ -14511,14 +14554,14 @@
                 <a:ea typeface="Arial"/>
                 <a:cs typeface="Arial"/>
               </a:rPr>
-              <a:t>All discovery-only under unknown bank feasibility</a:t>
+              <a:t>OpenAI · Anthropic · Google × three clients</a:t>
             </a:r>
           </a:p>
         </p:txBody>
       </p:sp>
       <p:cxnSp>
         <p:nvCxnSpPr>
-          <p:cNvPr id="77" name="s6-narrow-rule"/>
+          <p:cNvPr id="92" name="s6-narrow-rule"/>
           <p:cNvCxnSpPr/>
           <p:nvPr/>
         </p:nvCxnSpPr>
@@ -14592,7 +14635,7 @@
                 <a:ea typeface="Arial"/>
                 <a:cs typeface="Arial"/>
               </a:rPr>
-              <a:t>8 / 8</a:t>
+              <a:t>0</a:t>
             </a:r>
           </a:p>
         </p:txBody>
@@ -14651,7 +14694,7 @@
                 <a:ea typeface="Arial"/>
                 <a:cs typeface="Arial"/>
               </a:rPr>
-              <a:t>plan constraints satisfied</a:t>
+              <a:t>live runs executed</a:t>
             </a:r>
           </a:p>
         </p:txBody>
@@ -14710,7 +14753,7 @@
                 <a:ea typeface="Arial"/>
                 <a:cs typeface="Arial"/>
               </a:rPr>
-              <a:t>Mixed-integer solver status: OPTIMAL</a:t>
+              <a:t>Fresh rotated credentials and acknowledgement absent</a:t>
             </a:r>
           </a:p>
         </p:txBody>
@@ -14800,7 +14843,7 @@
                 <a:ea typeface="Arial"/>
                 <a:cs typeface="Arial"/>
               </a:rPr>
-              <a:t>CONTROLLED DESIGN</a:t>
+              <a:t>CONTROLLED WORKFLOW</a:t>
             </a:r>
           </a:p>
         </p:txBody>
@@ -14892,7 +14935,7 @@
                 <a:ea typeface="Arial"/>
                 <a:cs typeface="Arial"/>
               </a:rPr>
-              <a:t>Twenty twins × twelve components reproduce point-in-time</a:t>
+              <a:t>Resolve exact provider model; no silent substitution</a:t>
             </a:r>
           </a:p>
         </p:txBody>
@@ -14984,7 +15027,7 @@
                 <a:ea typeface="Arial"/>
                 <a:cs typeface="Arial"/>
               </a:rPr>
-              <a:t>All 320 solution rows return an interval or fail-closed reason</a:t>
+              <a:t>Send approved public evidence + minimal synthetic aggregates only</a:t>
             </a:r>
           </a:p>
         </p:txBody>
@@ -15076,7 +15119,7 @@
                 <a:ea typeface="Arial"/>
                 <a:cs typeface="Arial"/>
               </a:rPr>
-              <a:t>Pareto + CVaR enforce role, client, solution and sector limits</a:t>
+              <a:t>Validate schema, every number, sign, currency and citation</a:t>
             </a:r>
           </a:p>
         </p:txBody>
@@ -15168,7 +15211,7 @@
                 <a:ea typeface="Arial"/>
                 <a:cs typeface="Arial"/>
               </a:rPr>
-              <a:t>Every V3.1 read requires as_of and deny-by-default ABAC</a:t>
+              <a:t>Provider failure returns the deterministic brief</a:t>
             </a:r>
           </a:p>
         </p:txBody>
@@ -15400,7 +15443,7 @@
                 <a:ea typeface="Arial"/>
                 <a:cs typeface="Arial"/>
               </a:rPr>
-              <a:t>No E3 share, approved economics or RM outcomes exist. Measured-share and causal-value claims: zero.</a:t>
+              <a:t>The report records all nine runs as NOT_EXECUTED. It will not present provider access failure as successful evaluation.</a:t>
             </a:r>
           </a:p>
         </p:txBody>
@@ -15481,7 +15524,7 @@
                 <a:ea typeface="Arial"/>
                 <a:cs typeface="Arial"/>
               </a:rPr>
-              <a:t>CONTROLLED GENAI</a:t>
+              <a:t>VALIDATION HIERARCHY</a:t>
             </a:r>
           </a:p>
         </p:txBody>
@@ -15540,14 +15583,14 @@
                 <a:ea typeface="Arial"/>
                 <a:cs typeface="Arial"/>
               </a:rPr>
-              <a:t>The narrator translates a closed decision pack</a:t>
+              <a:t>Each claim earns the strongest label its evidence permits</a:t>
             </a:r>
           </a:p>
         </p:txBody>
       </p:sp>
       <p:cxnSp>
         <p:nvCxnSpPr>
-          <p:cNvPr id="135" name="title-rule-8"/>
+          <p:cNvPr id="178" name="title-rule-8"/>
           <p:cNvCxnSpPr/>
           <p:nvPr/>
         </p:nvCxnSpPr>
@@ -15621,7 +15664,7 @@
                 <a:ea typeface="Arial"/>
                 <a:cs typeface="Arial"/>
               </a:rPr>
-              <a:t>TEAM: Corporate Wallet Digital Twin | Christopher Koen | V3.1.0</a:t>
+              <a:t>TEAM: Corporate Wallet Digital Twin | Christopher Koen | V3.1.1</a:t>
             </a:r>
           </a:p>
         </p:txBody>
@@ -15680,7 +15723,7 @@
                 <a:ea typeface="Arial"/>
                 <a:cs typeface="Arial"/>
               </a:rPr>
-              <a:t>SYN BANK SIMULATION + PUBLIC E1 + REPRESENTATIVE PRIORS</a:t>
+              <a:t>CONFIDENTIAL SYN BANK ACTIVITY + APPROVED PUBLIC E1 + GOVERNED PRIORS</a:t>
             </a:r>
           </a:p>
         </p:txBody>
@@ -15746,7 +15789,7 @@
       </p:sp>
       <p:cxnSp>
         <p:nvCxnSpPr>
-          <p:cNvPr id="139" name="s8-link-0"/>
+          <p:cNvPr id="182" name="s8-link-0"/>
           <p:cNvCxnSpPr/>
           <p:nvPr/>
         </p:nvCxnSpPr>
@@ -15768,7 +15811,7 @@
       </p:cxnSp>
       <p:cxnSp>
         <p:nvCxnSpPr>
-          <p:cNvPr id="140" name="s8-link-1"/>
+          <p:cNvPr id="183" name="s8-link-1"/>
           <p:cNvCxnSpPr/>
           <p:nvPr/>
         </p:nvCxnSpPr>
@@ -15790,7 +15833,7 @@
       </p:cxnSp>
       <p:cxnSp>
         <p:nvCxnSpPr>
-          <p:cNvPr id="141" name="s8-link-2"/>
+          <p:cNvPr id="184" name="s8-link-2"/>
           <p:cNvCxnSpPr/>
           <p:nvPr/>
         </p:nvCxnSpPr>
@@ -15812,7 +15855,7 @@
       </p:cxnSp>
       <p:cxnSp>
         <p:nvCxnSpPr>
-          <p:cNvPr id="142" name="s8-link-3"/>
+          <p:cNvPr id="185" name="s8-link-3"/>
           <p:cNvCxnSpPr/>
           <p:nvPr/>
         </p:nvCxnSpPr>
@@ -15980,7 +16023,7 @@
                 <a:ea typeface="Arial"/>
                 <a:cs typeface="Arial"/>
               </a:rPr>
-              <a:t>Score</a:t>
+              <a:t>Mechanical</a:t>
             </a:r>
           </a:p>
         </p:txBody>
@@ -16015,7 +16058,7 @@
         </p:spPr>
         <p:txBody>
           <a:bodyPr xmlns:a="http://schemas.openxmlformats.org/drawingml/2006/main" anchor="t">
-            <a:normAutofit fontScale="86053"/>
+            <a:normAutofit fontScale="86066"/>
           </a:bodyPr>
           <a:lstStyle xmlns:a="http://schemas.openxmlformats.org/drawingml/2006/main"/>
           <a:p xmlns:a="http://schemas.openxmlformats.org/drawingml/2006/main">
@@ -16039,7 +16082,7 @@
                 <a:ea typeface="Arial"/>
                 <a:cs typeface="Arial"/>
               </a:rPr>
-              <a:t>Deterministic problem, value and rank</a:t>
+              <a:t>Contracts, identities, arithmetic, PIT lineage</a:t>
             </a:r>
           </a:p>
         </p:txBody>
@@ -16192,7 +16235,7 @@
                 <a:ea typeface="Arial"/>
                 <a:cs typeface="Arial"/>
               </a:rPr>
-              <a:t>Value</a:t>
+              <a:t>Known truth</a:t>
             </a:r>
           </a:p>
         </p:txBody>
@@ -16227,7 +16270,7 @@
         </p:spPr>
         <p:txBody>
           <a:bodyPr xmlns:a="http://schemas.openxmlformats.org/drawingml/2006/main" anchor="t">
-            <a:normAutofit fontScale="90884"/>
+            <a:normAutofit fontScale="73978"/>
           </a:bodyPr>
           <a:lstStyle xmlns:a="http://schemas.openxmlformats.org/drawingml/2006/main"/>
           <a:p xmlns:a="http://schemas.openxmlformats.org/drawingml/2006/main">
@@ -16251,7 +16294,7 @@
                 <a:ea typeface="Arial"/>
                 <a:cs typeface="Arial"/>
               </a:rPr>
-              <a:t>Question utility minus cost and delay</a:t>
+              <a:t>Synthetic panel coverage, width and CRPS</a:t>
             </a:r>
           </a:p>
         </p:txBody>
@@ -16404,7 +16447,7 @@
                 <a:ea typeface="Arial"/>
                 <a:cs typeface="Arial"/>
               </a:rPr>
-              <a:t>Acquire</a:t>
+              <a:t>Predictive</a:t>
             </a:r>
           </a:p>
         </p:txBody>
@@ -16439,7 +16482,7 @@
         </p:spPr>
         <p:txBody>
           <a:bodyPr xmlns:a="http://schemas.openxmlformats.org/drawingml/2006/main" anchor="t">
-            <a:normAutofit fontScale="100000"/>
+            <a:normAutofit fontScale="96503"/>
           </a:bodyPr>
           <a:lstStyle xmlns:a="http://schemas.openxmlformats.org/drawingml/2006/main"/>
           <a:p xmlns:a="http://schemas.openxmlformats.org/drawingml/2006/main">
@@ -16463,7 +16506,7 @@
                 <a:ea typeface="Arial"/>
                 <a:cs typeface="Arial"/>
               </a:rPr>
-              <a:t>Approved, entitled claims only</a:t>
+              <a:t>Posterior intervals and ranking stability</a:t>
             </a:r>
           </a:p>
         </p:txBody>
@@ -16616,7 +16659,7 @@
                 <a:ea typeface="Arial"/>
                 <a:cs typeface="Arial"/>
               </a:rPr>
-              <a:t>Compile</a:t>
+              <a:t>External</a:t>
             </a:r>
           </a:p>
         </p:txBody>
@@ -16651,7 +16694,7 @@
         </p:spPr>
         <p:txBody>
           <a:bodyPr xmlns:a="http://schemas.openxmlformats.org/drawingml/2006/main" anchor="t">
-            <a:normAutofit fontScale="100000"/>
+            <a:normAutofit fontScale="79609"/>
           </a:bodyPr>
           <a:lstStyle xmlns:a="http://schemas.openxmlformats.org/drawingml/2006/main"/>
           <a:p xmlns:a="http://schemas.openxmlformats.org/drawingml/2006/main">
@@ -16675,7 +16718,7 @@
                 <a:ea typeface="Arial"/>
                 <a:cs typeface="Arial"/>
               </a:rPr>
-              <a:t>Why–How–What closed pack</a:t>
+              <a:t>E3 calibration, approved rates and live eval</a:t>
             </a:r>
           </a:p>
         </p:txBody>
@@ -16828,7 +16871,7 @@
                 <a:ea typeface="Arial"/>
                 <a:cs typeface="Arial"/>
               </a:rPr>
-              <a:t>Brief</a:t>
+              <a:t>Causal</a:t>
             </a:r>
           </a:p>
         </p:txBody>
@@ -16863,7 +16906,7 @@
         </p:spPr>
         <p:txBody>
           <a:bodyPr xmlns:a="http://schemas.openxmlformats.org/drawingml/2006/main" anchor="t">
-            <a:normAutofit fontScale="91916"/>
+            <a:normAutofit fontScale="90828"/>
           </a:bodyPr>
           <a:lstStyle xmlns:a="http://schemas.openxmlformats.org/drawingml/2006/main"/>
           <a:p xmlns:a="http://schemas.openxmlformats.org/drawingml/2006/main">
@@ -16887,14 +16930,14 @@
                 <a:ea typeface="Arial"/>
                 <a:cs typeface="Arial"/>
               </a:rPr>
-              <a:t>LLM gateway or deterministic fallback</a:t>
+              <a:t>Qualified randomized RM outcome history</a:t>
             </a:r>
           </a:p>
         </p:txBody>
       </p:sp>
       <p:cxnSp>
         <p:nvCxnSpPr>
-          <p:cNvPr id="163" name="s8-checks-rule"/>
+          <p:cNvPr id="206" name="s8-checks-rule"/>
           <p:cNvCxnSpPr/>
           <p:nvPr/>
         </p:nvCxnSpPr>
@@ -16968,7 +17011,7 @@
                 <a:ea typeface="Arial"/>
                 <a:cs typeface="Arial"/>
               </a:rPr>
-              <a:t>224</a:t>
+              <a:t>100</a:t>
             </a:r>
           </a:p>
         </p:txBody>
@@ -17027,7 +17070,7 @@
                 <a:ea typeface="Arial"/>
                 <a:cs typeface="Arial"/>
               </a:rPr>
-              <a:t>deterministic briefs</a:t>
+              <a:t>wallet identities</a:t>
             </a:r>
           </a:p>
         </p:txBody>
@@ -17086,14 +17129,14 @@
                 <a:ea typeface="Arial"/>
                 <a:cs typeface="Arial"/>
               </a:rPr>
-              <a:t>One closed pack per conversation</a:t>
+              <a:t>T ≥ A; q=A/T; G=max(q*T−A,0)</a:t>
             </a:r>
           </a:p>
         </p:txBody>
       </p:sp>
       <p:cxnSp>
         <p:nvCxnSpPr>
-          <p:cNvPr id="167" name="s8-cases-rule"/>
+          <p:cNvPr id="210" name="s8-cases-rule"/>
           <p:cNvCxnSpPr/>
           <p:nvPr/>
         </p:nvCxnSpPr>
@@ -17167,7 +17210,7 @@
                 <a:ea typeface="Arial"/>
                 <a:cs typeface="Arial"/>
               </a:rPr>
-              <a:t>100%</a:t>
+              <a:t>88.0%</a:t>
             </a:r>
           </a:p>
         </p:txBody>
@@ -17226,7 +17269,7 @@
                 <a:ea typeface="Arial"/>
                 <a:cs typeface="Arial"/>
               </a:rPr>
-              <a:t>schema requirement</a:t>
+              <a:t>base 90% coverage</a:t>
             </a:r>
           </a:p>
         </p:txBody>
@@ -17285,14 +17328,14 @@
                 <a:ea typeface="Arial"/>
                 <a:cs typeface="Arial"/>
               </a:rPr>
-              <a:t>Numbers and citations must survive exactly</a:t>
+              <a:t>Known-truth E1 weight 0.35 arm</a:t>
             </a:r>
           </a:p>
         </p:txBody>
       </p:sp>
       <p:cxnSp>
         <p:nvCxnSpPr>
-          <p:cNvPr id="171" name="s8-stress-rule"/>
+          <p:cNvPr id="214" name="s8-stress-rule"/>
           <p:cNvCxnSpPr/>
           <p:nvPr/>
         </p:nvCxnSpPr>
@@ -17366,7 +17409,7 @@
                 <a:ea typeface="Arial"/>
                 <a:cs typeface="Arial"/>
               </a:rPr>
-              <a:t>0</a:t>
+              <a:t>100%</a:t>
             </a:r>
           </a:p>
         </p:txBody>
@@ -17425,7 +17468,7 @@
                 <a:ea typeface="Arial"/>
                 <a:cs typeface="Arial"/>
               </a:rPr>
-              <a:t>unsupported paths allowed</a:t>
+              <a:t>TF first-rank frequency</a:t>
             </a:r>
           </a:p>
         </p:txBody>
@@ -17484,14 +17527,14 @@
                 <a:ea typeface="Arial"/>
                 <a:cs typeface="Arial"/>
               </a:rPr>
-              <a:t>Unknown urgency and roles force abstention</a:t>
+              <a:t>10,000-draw global benchmark</a:t>
             </a:r>
           </a:p>
         </p:txBody>
       </p:sp>
       <p:cxnSp>
         <p:nvCxnSpPr>
-          <p:cNvPr id="175" name="s8-fail-rule"/>
+          <p:cNvPr id="218" name="s8-fail-rule"/>
           <p:cNvCxnSpPr/>
           <p:nvPr/>
         </p:nvCxnSpPr>
@@ -17624,7 +17667,7 @@
                 <a:ea typeface="Arial"/>
                 <a:cs typeface="Arial"/>
               </a:rPr>
-              <a:t>autonomous actions</a:t>
+              <a:t>measured-share claims</a:t>
             </a:r>
           </a:p>
         </p:txBody>
@@ -17683,7 +17726,7 @@
                 <a:ea typeface="Arial"/>
                 <a:cs typeface="Arial"/>
               </a:rPr>
-              <a:t>No CRM, client, pricing or retrieval action is delegated</a:t>
+              <a:t>No E3 multibank observation exists</a:t>
             </a:r>
           </a:p>
         </p:txBody>

</xml_diff>

<commit_message>
Bind V3.1.1 artifacts to release source
</commit_message>
<xml_diff>
--- a/output/presentation/Corporate-Wallet-Digital-Twin.pptx
+++ b/output/presentation/Corporate-Wallet-Digital-Twin.pptx
@@ -2,22 +2,22 @@
 <file path=ppt/presentation.xml><?xml version="1.0" encoding="utf-8"?>
 <p:presentation xmlns:p="http://schemas.openxmlformats.org/presentationml/2006/main">
   <p:sldMasterIdLst>
-    <p:sldMasterId xmlns:r="http://schemas.openxmlformats.org/officeDocument/2006/relationships" id="2147483648" r:id="R0e6a1ae0dbeb43ec"/>
+    <p:sldMasterId xmlns:r="http://schemas.openxmlformats.org/officeDocument/2006/relationships" id="2147483648" r:id="Rffcca287085d4139"/>
   </p:sldMasterIdLst>
   <p:notesMasterIdLst>
-    <p:notesMasterId xmlns:r="http://schemas.openxmlformats.org/officeDocument/2006/relationships" r:id="R7439a0cc94464d79"/>
+    <p:notesMasterId xmlns:r="http://schemas.openxmlformats.org/officeDocument/2006/relationships" r:id="R79ef9da246854236"/>
   </p:notesMasterIdLst>
   <p:sldIdLst>
-    <p:sldId xmlns:r="http://schemas.openxmlformats.org/officeDocument/2006/relationships" id="256" r:id="R7cd4c181f0c24394"/>
-    <p:sldId xmlns:r="http://schemas.openxmlformats.org/officeDocument/2006/relationships" id="257" r:id="R203f467eca994407"/>
-    <p:sldId xmlns:r="http://schemas.openxmlformats.org/officeDocument/2006/relationships" id="258" r:id="R9af28401cca84ad2"/>
-    <p:sldId xmlns:r="http://schemas.openxmlformats.org/officeDocument/2006/relationships" id="259" r:id="R764231041c9947f8"/>
-    <p:sldId xmlns:r="http://schemas.openxmlformats.org/officeDocument/2006/relationships" id="260" r:id="Rdc3ea98cb75944a2"/>
-    <p:sldId xmlns:r="http://schemas.openxmlformats.org/officeDocument/2006/relationships" id="261" r:id="R9447e146db444dd9"/>
-    <p:sldId xmlns:r="http://schemas.openxmlformats.org/officeDocument/2006/relationships" id="262" r:id="R5891d8c8af0f4e3c"/>
-    <p:sldId xmlns:r="http://schemas.openxmlformats.org/officeDocument/2006/relationships" id="263" r:id="Reefa20804bd74c25"/>
-    <p:sldId xmlns:r="http://schemas.openxmlformats.org/officeDocument/2006/relationships" id="264" r:id="R4e6c6db2e7e24b87"/>
-    <p:sldId xmlns:r="http://schemas.openxmlformats.org/officeDocument/2006/relationships" id="265" r:id="Ra5283b935b634ea7"/>
+    <p:sldId xmlns:r="http://schemas.openxmlformats.org/officeDocument/2006/relationships" id="256" r:id="R3657af9430b747ff"/>
+    <p:sldId xmlns:r="http://schemas.openxmlformats.org/officeDocument/2006/relationships" id="257" r:id="R2a2109ec6dc148cd"/>
+    <p:sldId xmlns:r="http://schemas.openxmlformats.org/officeDocument/2006/relationships" id="258" r:id="Rbed700bd25a74db5"/>
+    <p:sldId xmlns:r="http://schemas.openxmlformats.org/officeDocument/2006/relationships" id="259" r:id="Rfe3bc3b01f624fcd"/>
+    <p:sldId xmlns:r="http://schemas.openxmlformats.org/officeDocument/2006/relationships" id="260" r:id="R4553d0923e954c24"/>
+    <p:sldId xmlns:r="http://schemas.openxmlformats.org/officeDocument/2006/relationships" id="261" r:id="Raed3731be113459f"/>
+    <p:sldId xmlns:r="http://schemas.openxmlformats.org/officeDocument/2006/relationships" id="262" r:id="R1a8da4eeda39409c"/>
+    <p:sldId xmlns:r="http://schemas.openxmlformats.org/officeDocument/2006/relationships" id="263" r:id="R8d6c6c35849d41fa"/>
+    <p:sldId xmlns:r="http://schemas.openxmlformats.org/officeDocument/2006/relationships" id="264" r:id="R68b0d187e84947c3"/>
+    <p:sldId xmlns:r="http://schemas.openxmlformats.org/officeDocument/2006/relationships" id="265" r:id="Rd50817a052804f6f"/>
   </p:sldIdLst>
   <p:sldSz cx="12192000" cy="6858000"/>
   <p:notesSz cx="6858000" cy="9144000"/>
@@ -1409,7 +1409,7 @@
   </p:cSld>
   <p:clrMap bg1="lt1" tx1="dk1" bg2="lt2" tx2="dk2" accent1="accent1" accent2="accent2" accent3="accent3" accent4="accent4" accent5="accent5" accent6="accent6" hlink="hlink" folHlink="folHlink"/>
   <p:sldLayoutIdLst>
-    <p:sldLayoutId xmlns:r="http://schemas.openxmlformats.org/officeDocument/2006/relationships" id="2147483649" r:id="R82c7dfec022d475a"/>
+    <p:sldLayoutId xmlns:r="http://schemas.openxmlformats.org/officeDocument/2006/relationships" id="2147483649" r:id="R593aae21da3a4858"/>
   </p:sldLayoutIdLst>
   <p:txStyles>
     <p:titleStyle>
@@ -2123,7 +2123,7 @@
           <p:nvPr/>
         </p:nvPicPr>
         <p:blipFill>
-          <a:blip xmlns:r="http://schemas.openxmlformats.org/officeDocument/2006/relationships" xmlns:a="http://schemas.openxmlformats.org/drawingml/2006/main" r:embed="Rae945cacb570493c"/>
+          <a:blip xmlns:r="http://schemas.openxmlformats.org/officeDocument/2006/relationships" xmlns:a="http://schemas.openxmlformats.org/drawingml/2006/main" r:embed="R69d5a2e0f78144bc"/>
           <a:srcRect xmlns:a="http://schemas.openxmlformats.org/drawingml/2006/main" l="0" t="27" r="0" b="27"/>
           <a:stretch xmlns:a="http://schemas.openxmlformats.org/drawingml/2006/main">
             <a:fillRect l="0" t="0" r="0" b="0"/>
@@ -7915,7 +7915,7 @@
         </p:xfrm>
         <a:graphic xmlns:a="http://schemas.openxmlformats.org/drawingml/2006/main">
           <a:graphicData uri="http://schemas.openxmlformats.org/drawingml/2006/chart">
-            <c:chart xmlns:r="http://schemas.openxmlformats.org/officeDocument/2006/relationships" xmlns:c="http://schemas.openxmlformats.org/drawingml/2006/chart" r:id="R0fbd3b2c23b74aa2"/>
+            <c:chart xmlns:r="http://schemas.openxmlformats.org/officeDocument/2006/relationships" xmlns:c="http://schemas.openxmlformats.org/drawingml/2006/chart" r:id="R2fb90adb07eb48ab"/>
           </a:graphicData>
         </a:graphic>
       </p:graphicFrame>
@@ -9390,7 +9390,7 @@
           <p:cNvPr id="69" name="">
             <a:extLst xmlns:a="http://schemas.openxmlformats.org/drawingml/2006/main">
               <a:ext uri="{FF2B5EF4-FFF2-40B4-BE49-F238E27FC236}">
-                <a16:creationId xmlns:a16="http://schemas.microsoft.com/office/drawing/2014/main" id="{71D95F7E-7CB4-4974-9A17-1C177BB5F6EA}"/>
+                <a16:creationId xmlns:a16="http://schemas.microsoft.com/office/drawing/2014/main" id="{0CE9475B-AEAB-4047-9C75-371ECF6CD115}"/>
               </a:ext>
             </a:extLst>
           </p:cNvPr>
@@ -9427,7 +9427,7 @@
           <p:nvPr/>
         </p:nvPicPr>
         <p:blipFill>
-          <a:blip xmlns:r="http://schemas.openxmlformats.org/officeDocument/2006/relationships" xmlns:a="http://schemas.openxmlformats.org/drawingml/2006/main" r:embed="Rf80bbded097e405f"/>
+          <a:blip xmlns:r="http://schemas.openxmlformats.org/officeDocument/2006/relationships" xmlns:a="http://schemas.openxmlformats.org/drawingml/2006/main" r:embed="R8cc46dcb36824af5"/>
           <a:stretch xmlns:a="http://schemas.openxmlformats.org/drawingml/2006/main"/>
         </p:blipFill>
         <p:spPr>

</xml_diff>

<commit_message>
Bind canonical V3.1.1 submission release
</commit_message>
<xml_diff>
--- a/output/presentation/Corporate-Wallet-Digital-Twin.pptx
+++ b/output/presentation/Corporate-Wallet-Digital-Twin.pptx
@@ -2,22 +2,22 @@
 <file path=ppt/presentation.xml><?xml version="1.0" encoding="utf-8"?>
 <p:presentation xmlns:p="http://schemas.openxmlformats.org/presentationml/2006/main">
   <p:sldMasterIdLst>
-    <p:sldMasterId xmlns:r="http://schemas.openxmlformats.org/officeDocument/2006/relationships" id="2147483648" r:id="Rffcca287085d4139"/>
+    <p:sldMasterId xmlns:r="http://schemas.openxmlformats.org/officeDocument/2006/relationships" id="2147483648" r:id="R2855e412c5894f43"/>
   </p:sldMasterIdLst>
   <p:notesMasterIdLst>
-    <p:notesMasterId xmlns:r="http://schemas.openxmlformats.org/officeDocument/2006/relationships" r:id="R79ef9da246854236"/>
+    <p:notesMasterId xmlns:r="http://schemas.openxmlformats.org/officeDocument/2006/relationships" r:id="R6cff5d92e9ed4ffd"/>
   </p:notesMasterIdLst>
   <p:sldIdLst>
-    <p:sldId xmlns:r="http://schemas.openxmlformats.org/officeDocument/2006/relationships" id="256" r:id="R3657af9430b747ff"/>
-    <p:sldId xmlns:r="http://schemas.openxmlformats.org/officeDocument/2006/relationships" id="257" r:id="R2a2109ec6dc148cd"/>
-    <p:sldId xmlns:r="http://schemas.openxmlformats.org/officeDocument/2006/relationships" id="258" r:id="Rbed700bd25a74db5"/>
-    <p:sldId xmlns:r="http://schemas.openxmlformats.org/officeDocument/2006/relationships" id="259" r:id="Rfe3bc3b01f624fcd"/>
-    <p:sldId xmlns:r="http://schemas.openxmlformats.org/officeDocument/2006/relationships" id="260" r:id="R4553d0923e954c24"/>
-    <p:sldId xmlns:r="http://schemas.openxmlformats.org/officeDocument/2006/relationships" id="261" r:id="Raed3731be113459f"/>
-    <p:sldId xmlns:r="http://schemas.openxmlformats.org/officeDocument/2006/relationships" id="262" r:id="R1a8da4eeda39409c"/>
-    <p:sldId xmlns:r="http://schemas.openxmlformats.org/officeDocument/2006/relationships" id="263" r:id="R8d6c6c35849d41fa"/>
-    <p:sldId xmlns:r="http://schemas.openxmlformats.org/officeDocument/2006/relationships" id="264" r:id="R68b0d187e84947c3"/>
-    <p:sldId xmlns:r="http://schemas.openxmlformats.org/officeDocument/2006/relationships" id="265" r:id="Rd50817a052804f6f"/>
+    <p:sldId xmlns:r="http://schemas.openxmlformats.org/officeDocument/2006/relationships" id="256" r:id="R014b119264844b4e"/>
+    <p:sldId xmlns:r="http://schemas.openxmlformats.org/officeDocument/2006/relationships" id="257" r:id="R22ed6c7cad7d446e"/>
+    <p:sldId xmlns:r="http://schemas.openxmlformats.org/officeDocument/2006/relationships" id="258" r:id="Raa74390b3fda4ea4"/>
+    <p:sldId xmlns:r="http://schemas.openxmlformats.org/officeDocument/2006/relationships" id="259" r:id="R910ed40aa2e34f33"/>
+    <p:sldId xmlns:r="http://schemas.openxmlformats.org/officeDocument/2006/relationships" id="260" r:id="R458ff2966ec34f85"/>
+    <p:sldId xmlns:r="http://schemas.openxmlformats.org/officeDocument/2006/relationships" id="261" r:id="R9a067d6c02554588"/>
+    <p:sldId xmlns:r="http://schemas.openxmlformats.org/officeDocument/2006/relationships" id="262" r:id="Rd9d0e102b97d43af"/>
+    <p:sldId xmlns:r="http://schemas.openxmlformats.org/officeDocument/2006/relationships" id="263" r:id="R5df4e6d4c4414341"/>
+    <p:sldId xmlns:r="http://schemas.openxmlformats.org/officeDocument/2006/relationships" id="264" r:id="Rdff748d66fe744f5"/>
+    <p:sldId xmlns:r="http://schemas.openxmlformats.org/officeDocument/2006/relationships" id="265" r:id="R791a72aef2d44efa"/>
   </p:sldIdLst>
   <p:sldSz cx="12192000" cy="6858000"/>
   <p:notesSz cx="6858000" cy="9144000"/>
@@ -1409,7 +1409,7 @@
   </p:cSld>
   <p:clrMap bg1="lt1" tx1="dk1" bg2="lt2" tx2="dk2" accent1="accent1" accent2="accent2" accent3="accent3" accent4="accent4" accent5="accent5" accent6="accent6" hlink="hlink" folHlink="folHlink"/>
   <p:sldLayoutIdLst>
-    <p:sldLayoutId xmlns:r="http://schemas.openxmlformats.org/officeDocument/2006/relationships" id="2147483649" r:id="R593aae21da3a4858"/>
+    <p:sldLayoutId xmlns:r="http://schemas.openxmlformats.org/officeDocument/2006/relationships" id="2147483649" r:id="R8e595b76c8714082"/>
   </p:sldLayoutIdLst>
   <p:txStyles>
     <p:titleStyle>
@@ -2123,7 +2123,7 @@
           <p:nvPr/>
         </p:nvPicPr>
         <p:blipFill>
-          <a:blip xmlns:r="http://schemas.openxmlformats.org/officeDocument/2006/relationships" xmlns:a="http://schemas.openxmlformats.org/drawingml/2006/main" r:embed="R69d5a2e0f78144bc"/>
+          <a:blip xmlns:r="http://schemas.openxmlformats.org/officeDocument/2006/relationships" xmlns:a="http://schemas.openxmlformats.org/drawingml/2006/main" r:embed="R06e3ca4de93d4785"/>
           <a:srcRect xmlns:a="http://schemas.openxmlformats.org/drawingml/2006/main" l="0" t="27" r="0" b="27"/>
           <a:stretch xmlns:a="http://schemas.openxmlformats.org/drawingml/2006/main">
             <a:fillRect l="0" t="0" r="0" b="0"/>
@@ -7915,7 +7915,7 @@
         </p:xfrm>
         <a:graphic xmlns:a="http://schemas.openxmlformats.org/drawingml/2006/main">
           <a:graphicData uri="http://schemas.openxmlformats.org/drawingml/2006/chart">
-            <c:chart xmlns:r="http://schemas.openxmlformats.org/officeDocument/2006/relationships" xmlns:c="http://schemas.openxmlformats.org/drawingml/2006/chart" r:id="R2fb90adb07eb48ab"/>
+            <c:chart xmlns:r="http://schemas.openxmlformats.org/officeDocument/2006/relationships" xmlns:c="http://schemas.openxmlformats.org/drawingml/2006/chart" r:id="R3cf8e311923b45ba"/>
           </a:graphicData>
         </a:graphic>
       </p:graphicFrame>
@@ -9390,7 +9390,7 @@
           <p:cNvPr id="69" name="">
             <a:extLst xmlns:a="http://schemas.openxmlformats.org/drawingml/2006/main">
               <a:ext uri="{FF2B5EF4-FFF2-40B4-BE49-F238E27FC236}">
-                <a16:creationId xmlns:a16="http://schemas.microsoft.com/office/drawing/2014/main" id="{0CE9475B-AEAB-4047-9C75-371ECF6CD115}"/>
+                <a16:creationId xmlns:a16="http://schemas.microsoft.com/office/drawing/2014/main" id="{371169C1-46E7-49FB-AA63-F673F623BEDF}"/>
               </a:ext>
             </a:extLst>
           </p:cNvPr>
@@ -9427,7 +9427,7 @@
           <p:nvPr/>
         </p:nvPicPr>
         <p:blipFill>
-          <a:blip xmlns:r="http://schemas.openxmlformats.org/officeDocument/2006/relationships" xmlns:a="http://schemas.openxmlformats.org/drawingml/2006/main" r:embed="R8cc46dcb36824af5"/>
+          <a:blip xmlns:r="http://schemas.openxmlformats.org/officeDocument/2006/relationships" xmlns:a="http://schemas.openxmlformats.org/drawingml/2006/main" r:embed="R2ca543061391458b"/>
           <a:stretch xmlns:a="http://schemas.openxmlformats.org/drawingml/2006/main"/>
         </p:blipFill>
         <p:spPr>

</xml_diff>

<commit_message>
Bind final canonical V3.1.1 judging artifacts
</commit_message>
<xml_diff>
--- a/output/presentation/Corporate-Wallet-Digital-Twin.pptx
+++ b/output/presentation/Corporate-Wallet-Digital-Twin.pptx
@@ -2,22 +2,22 @@
 <file path=ppt/presentation.xml><?xml version="1.0" encoding="utf-8"?>
 <p:presentation xmlns:p="http://schemas.openxmlformats.org/presentationml/2006/main">
   <p:sldMasterIdLst>
-    <p:sldMasterId xmlns:r="http://schemas.openxmlformats.org/officeDocument/2006/relationships" id="2147483648" r:id="R2855e412c5894f43"/>
+    <p:sldMasterId xmlns:r="http://schemas.openxmlformats.org/officeDocument/2006/relationships" id="2147483648" r:id="R118cd93421834555"/>
   </p:sldMasterIdLst>
   <p:notesMasterIdLst>
-    <p:notesMasterId xmlns:r="http://schemas.openxmlformats.org/officeDocument/2006/relationships" r:id="R6cff5d92e9ed4ffd"/>
+    <p:notesMasterId xmlns:r="http://schemas.openxmlformats.org/officeDocument/2006/relationships" r:id="R497b7d2046b848dd"/>
   </p:notesMasterIdLst>
   <p:sldIdLst>
-    <p:sldId xmlns:r="http://schemas.openxmlformats.org/officeDocument/2006/relationships" id="256" r:id="R014b119264844b4e"/>
-    <p:sldId xmlns:r="http://schemas.openxmlformats.org/officeDocument/2006/relationships" id="257" r:id="R22ed6c7cad7d446e"/>
-    <p:sldId xmlns:r="http://schemas.openxmlformats.org/officeDocument/2006/relationships" id="258" r:id="Raa74390b3fda4ea4"/>
-    <p:sldId xmlns:r="http://schemas.openxmlformats.org/officeDocument/2006/relationships" id="259" r:id="R910ed40aa2e34f33"/>
-    <p:sldId xmlns:r="http://schemas.openxmlformats.org/officeDocument/2006/relationships" id="260" r:id="R458ff2966ec34f85"/>
-    <p:sldId xmlns:r="http://schemas.openxmlformats.org/officeDocument/2006/relationships" id="261" r:id="R9a067d6c02554588"/>
-    <p:sldId xmlns:r="http://schemas.openxmlformats.org/officeDocument/2006/relationships" id="262" r:id="Rd9d0e102b97d43af"/>
-    <p:sldId xmlns:r="http://schemas.openxmlformats.org/officeDocument/2006/relationships" id="263" r:id="R5df4e6d4c4414341"/>
-    <p:sldId xmlns:r="http://schemas.openxmlformats.org/officeDocument/2006/relationships" id="264" r:id="Rdff748d66fe744f5"/>
-    <p:sldId xmlns:r="http://schemas.openxmlformats.org/officeDocument/2006/relationships" id="265" r:id="R791a72aef2d44efa"/>
+    <p:sldId xmlns:r="http://schemas.openxmlformats.org/officeDocument/2006/relationships" id="256" r:id="R077f2e1d531a4812"/>
+    <p:sldId xmlns:r="http://schemas.openxmlformats.org/officeDocument/2006/relationships" id="257" r:id="Rf385228f0eb74f0a"/>
+    <p:sldId xmlns:r="http://schemas.openxmlformats.org/officeDocument/2006/relationships" id="258" r:id="Rd9ddc54e6a71408c"/>
+    <p:sldId xmlns:r="http://schemas.openxmlformats.org/officeDocument/2006/relationships" id="259" r:id="Rbe899e917fc84d36"/>
+    <p:sldId xmlns:r="http://schemas.openxmlformats.org/officeDocument/2006/relationships" id="260" r:id="R09af695e7e7a45d3"/>
+    <p:sldId xmlns:r="http://schemas.openxmlformats.org/officeDocument/2006/relationships" id="261" r:id="R163e07f628ac4ca9"/>
+    <p:sldId xmlns:r="http://schemas.openxmlformats.org/officeDocument/2006/relationships" id="262" r:id="R23d847fb0eb34128"/>
+    <p:sldId xmlns:r="http://schemas.openxmlformats.org/officeDocument/2006/relationships" id="263" r:id="Rbe5b16e66a3b483d"/>
+    <p:sldId xmlns:r="http://schemas.openxmlformats.org/officeDocument/2006/relationships" id="264" r:id="R291c88f8fc124459"/>
+    <p:sldId xmlns:r="http://schemas.openxmlformats.org/officeDocument/2006/relationships" id="265" r:id="Rb7788b5e96fd4ef1"/>
   </p:sldIdLst>
   <p:sldSz cx="12192000" cy="6858000"/>
   <p:notesSz cx="6858000" cy="9144000"/>
@@ -1409,7 +1409,7 @@
   </p:cSld>
   <p:clrMap bg1="lt1" tx1="dk1" bg2="lt2" tx2="dk2" accent1="accent1" accent2="accent2" accent3="accent3" accent4="accent4" accent5="accent5" accent6="accent6" hlink="hlink" folHlink="folHlink"/>
   <p:sldLayoutIdLst>
-    <p:sldLayoutId xmlns:r="http://schemas.openxmlformats.org/officeDocument/2006/relationships" id="2147483649" r:id="R8e595b76c8714082"/>
+    <p:sldLayoutId xmlns:r="http://schemas.openxmlformats.org/officeDocument/2006/relationships" id="2147483649" r:id="Rd18ae1e823c94f2c"/>
   </p:sldLayoutIdLst>
   <p:txStyles>
     <p:titleStyle>
@@ -2123,7 +2123,7 @@
           <p:nvPr/>
         </p:nvPicPr>
         <p:blipFill>
-          <a:blip xmlns:r="http://schemas.openxmlformats.org/officeDocument/2006/relationships" xmlns:a="http://schemas.openxmlformats.org/drawingml/2006/main" r:embed="R06e3ca4de93d4785"/>
+          <a:blip xmlns:r="http://schemas.openxmlformats.org/officeDocument/2006/relationships" xmlns:a="http://schemas.openxmlformats.org/drawingml/2006/main" r:embed="Rc78d06003bb7484a"/>
           <a:srcRect xmlns:a="http://schemas.openxmlformats.org/drawingml/2006/main" l="0" t="27" r="0" b="27"/>
           <a:stretch xmlns:a="http://schemas.openxmlformats.org/drawingml/2006/main">
             <a:fillRect l="0" t="0" r="0" b="0"/>
@@ -7915,7 +7915,7 @@
         </p:xfrm>
         <a:graphic xmlns:a="http://schemas.openxmlformats.org/drawingml/2006/main">
           <a:graphicData uri="http://schemas.openxmlformats.org/drawingml/2006/chart">
-            <c:chart xmlns:r="http://schemas.openxmlformats.org/officeDocument/2006/relationships" xmlns:c="http://schemas.openxmlformats.org/drawingml/2006/chart" r:id="R3cf8e311923b45ba"/>
+            <c:chart xmlns:r="http://schemas.openxmlformats.org/officeDocument/2006/relationships" xmlns:c="http://schemas.openxmlformats.org/drawingml/2006/chart" r:id="Rdc8db5bde6744a62"/>
           </a:graphicData>
         </a:graphic>
       </p:graphicFrame>
@@ -9390,7 +9390,7 @@
           <p:cNvPr id="69" name="">
             <a:extLst xmlns:a="http://schemas.openxmlformats.org/drawingml/2006/main">
               <a:ext uri="{FF2B5EF4-FFF2-40B4-BE49-F238E27FC236}">
-                <a16:creationId xmlns:a16="http://schemas.microsoft.com/office/drawing/2014/main" id="{371169C1-46E7-49FB-AA63-F673F623BEDF}"/>
+                <a16:creationId xmlns:a16="http://schemas.microsoft.com/office/drawing/2014/main" id="{3F163888-F4D2-4002-A2DA-EECCB15757FE}"/>
               </a:ext>
             </a:extLst>
           </p:cNvPr>
@@ -9427,7 +9427,7 @@
           <p:nvPr/>
         </p:nvPicPr>
         <p:blipFill>
-          <a:blip xmlns:r="http://schemas.openxmlformats.org/officeDocument/2006/relationships" xmlns:a="http://schemas.openxmlformats.org/drawingml/2006/main" r:embed="R2ca543061391458b"/>
+          <a:blip xmlns:r="http://schemas.openxmlformats.org/officeDocument/2006/relationships" xmlns:a="http://schemas.openxmlformats.org/drawingml/2006/main" r:embed="R0a546e13d7274116"/>
           <a:stretch xmlns:a="http://schemas.openxmlformats.org/drawingml/2006/main"/>
         </p:blipFill>
         <p:spPr>

</xml_diff>

<commit_message>
Regenerate V3.1.1 deliverables from the clean commit
First build in which clean_worktree is both true and meaningful: source
and all 74 reproducibility-gated artifacts match commit f5015d8, and the
eight deliverables that stamp their own creation time are reported
separately rather than counted as drift. 16/16 checks PASS.

Co-Authored-By: Claude Opus 5 <noreply@anthropic.com>
</commit_message>
<xml_diff>
--- a/output/presentation/Corporate-Wallet-Digital-Twin.pptx
+++ b/output/presentation/Corporate-Wallet-Digital-Twin.pptx
@@ -2,22 +2,22 @@
 <file path=ppt/presentation.xml><?xml version="1.0" encoding="utf-8"?>
 <p:presentation xmlns:p="http://schemas.openxmlformats.org/presentationml/2006/main">
   <p:sldMasterIdLst>
-    <p:sldMasterId xmlns:r="http://schemas.openxmlformats.org/officeDocument/2006/relationships" id="2147483648" r:id="R8daa969c1e7e49ac"/>
+    <p:sldMasterId xmlns:r="http://schemas.openxmlformats.org/officeDocument/2006/relationships" id="2147483648" r:id="R42d524b2f5a2401c"/>
   </p:sldMasterIdLst>
   <p:notesMasterIdLst>
-    <p:notesMasterId xmlns:r="http://schemas.openxmlformats.org/officeDocument/2006/relationships" r:id="Rdccb669c3c2e4ee7"/>
+    <p:notesMasterId xmlns:r="http://schemas.openxmlformats.org/officeDocument/2006/relationships" r:id="R72ee2a7b8f274198"/>
   </p:notesMasterIdLst>
   <p:sldIdLst>
-    <p:sldId xmlns:r="http://schemas.openxmlformats.org/officeDocument/2006/relationships" id="256" r:id="R8211039cc12c425f"/>
-    <p:sldId xmlns:r="http://schemas.openxmlformats.org/officeDocument/2006/relationships" id="257" r:id="Rbb5315d7e4f64ef6"/>
-    <p:sldId xmlns:r="http://schemas.openxmlformats.org/officeDocument/2006/relationships" id="258" r:id="Rde9daf82df5a465f"/>
-    <p:sldId xmlns:r="http://schemas.openxmlformats.org/officeDocument/2006/relationships" id="259" r:id="R78e34e27d4a44ade"/>
-    <p:sldId xmlns:r="http://schemas.openxmlformats.org/officeDocument/2006/relationships" id="260" r:id="R4022ec93010d4e53"/>
-    <p:sldId xmlns:r="http://schemas.openxmlformats.org/officeDocument/2006/relationships" id="261" r:id="R3bdac356dbcf4fed"/>
-    <p:sldId xmlns:r="http://schemas.openxmlformats.org/officeDocument/2006/relationships" id="262" r:id="R0d18da680fec4ef0"/>
-    <p:sldId xmlns:r="http://schemas.openxmlformats.org/officeDocument/2006/relationships" id="263" r:id="Rb0e958ef32364b61"/>
-    <p:sldId xmlns:r="http://schemas.openxmlformats.org/officeDocument/2006/relationships" id="264" r:id="Re1a517219cef4b17"/>
-    <p:sldId xmlns:r="http://schemas.openxmlformats.org/officeDocument/2006/relationships" id="265" r:id="Rad77c17a55864758"/>
+    <p:sldId xmlns:r="http://schemas.openxmlformats.org/officeDocument/2006/relationships" id="256" r:id="R9b73cf49d4884c89"/>
+    <p:sldId xmlns:r="http://schemas.openxmlformats.org/officeDocument/2006/relationships" id="257" r:id="Rdf8de8c7e1b74ab9"/>
+    <p:sldId xmlns:r="http://schemas.openxmlformats.org/officeDocument/2006/relationships" id="258" r:id="Rc62a54f9d2e3402d"/>
+    <p:sldId xmlns:r="http://schemas.openxmlformats.org/officeDocument/2006/relationships" id="259" r:id="R87055ca73f5e42d7"/>
+    <p:sldId xmlns:r="http://schemas.openxmlformats.org/officeDocument/2006/relationships" id="260" r:id="Rde31bf2dfab14d39"/>
+    <p:sldId xmlns:r="http://schemas.openxmlformats.org/officeDocument/2006/relationships" id="261" r:id="R6abdfeb17f9344f8"/>
+    <p:sldId xmlns:r="http://schemas.openxmlformats.org/officeDocument/2006/relationships" id="262" r:id="Re415d384b014465e"/>
+    <p:sldId xmlns:r="http://schemas.openxmlformats.org/officeDocument/2006/relationships" id="263" r:id="R58d657bb9a4f4b7b"/>
+    <p:sldId xmlns:r="http://schemas.openxmlformats.org/officeDocument/2006/relationships" id="264" r:id="R0952db5989e348bd"/>
+    <p:sldId xmlns:r="http://schemas.openxmlformats.org/officeDocument/2006/relationships" id="265" r:id="R56be44bc9c714aa4"/>
   </p:sldIdLst>
   <p:sldSz cx="12192000" cy="6858000"/>
   <p:notesSz cx="6858000" cy="9144000"/>
@@ -1409,7 +1409,7 @@
   </p:cSld>
   <p:clrMap bg1="lt1" tx1="dk1" bg2="lt2" tx2="dk2" accent1="accent1" accent2="accent2" accent3="accent3" accent4="accent4" accent5="accent5" accent6="accent6" hlink="hlink" folHlink="folHlink"/>
   <p:sldLayoutIdLst>
-    <p:sldLayoutId xmlns:r="http://schemas.openxmlformats.org/officeDocument/2006/relationships" id="2147483649" r:id="Re2e797c22eef4045"/>
+    <p:sldLayoutId xmlns:r="http://schemas.openxmlformats.org/officeDocument/2006/relationships" id="2147483649" r:id="Ra57c9e5c6d024cf8"/>
   </p:sldLayoutIdLst>
   <p:txStyles>
     <p:titleStyle>
@@ -2123,7 +2123,7 @@
           <p:nvPr/>
         </p:nvPicPr>
         <p:blipFill>
-          <a:blip xmlns:r="http://schemas.openxmlformats.org/officeDocument/2006/relationships" xmlns:a="http://schemas.openxmlformats.org/drawingml/2006/main" r:embed="R5d0abb3cb7964c0e"/>
+          <a:blip xmlns:r="http://schemas.openxmlformats.org/officeDocument/2006/relationships" xmlns:a="http://schemas.openxmlformats.org/drawingml/2006/main" r:embed="Rbf7234dac5db44f6"/>
           <a:srcRect xmlns:a="http://schemas.openxmlformats.org/drawingml/2006/main" l="0" t="27" r="0" b="27"/>
           <a:stretch xmlns:a="http://schemas.openxmlformats.org/drawingml/2006/main">
             <a:fillRect l="0" t="0" r="0" b="0"/>
@@ -7915,7 +7915,7 @@
         </p:xfrm>
         <a:graphic xmlns:a="http://schemas.openxmlformats.org/drawingml/2006/main">
           <a:graphicData uri="http://schemas.openxmlformats.org/drawingml/2006/chart">
-            <c:chart xmlns:r="http://schemas.openxmlformats.org/officeDocument/2006/relationships" xmlns:c="http://schemas.openxmlformats.org/drawingml/2006/chart" r:id="R5fa2628a8d7d4bb0"/>
+            <c:chart xmlns:r="http://schemas.openxmlformats.org/officeDocument/2006/relationships" xmlns:c="http://schemas.openxmlformats.org/drawingml/2006/chart" r:id="Rbefdf0a29b6c4f7f"/>
           </a:graphicData>
         </a:graphic>
       </p:graphicFrame>
@@ -9390,7 +9390,7 @@
           <p:cNvPr id="69" name="">
             <a:extLst xmlns:a="http://schemas.openxmlformats.org/drawingml/2006/main">
               <a:ext uri="{FF2B5EF4-FFF2-40B4-BE49-F238E27FC236}">
-                <a16:creationId xmlns:a16="http://schemas.microsoft.com/office/drawing/2014/main" id="{852CE1C4-86BD-46B6-81C5-2B3DA529B9FF}"/>
+                <a16:creationId xmlns:a16="http://schemas.microsoft.com/office/drawing/2014/main" id="{BD58BE48-0CB9-4A20-A066-9DCFD8033971}"/>
               </a:ext>
             </a:extLst>
           </p:cNvPr>
@@ -9427,7 +9427,7 @@
           <p:nvPr/>
         </p:nvPicPr>
         <p:blipFill>
-          <a:blip xmlns:r="http://schemas.openxmlformats.org/officeDocument/2006/relationships" xmlns:a="http://schemas.openxmlformats.org/drawingml/2006/main" r:embed="R9848f9c9fcba40e5"/>
+          <a:blip xmlns:r="http://schemas.openxmlformats.org/officeDocument/2006/relationships" xmlns:a="http://schemas.openxmlformats.org/drawingml/2006/main" r:embed="R658d0b91d79f4fed"/>
           <a:stretch xmlns:a="http://schemas.openxmlformats.org/drawingml/2006/main"/>
         </p:blipFill>
         <p:spPr>

</xml_diff>

<commit_message>
Regenerate V3.2 deliverables from the clean commit
Second consecutive build produced an identical gated artifact set:
clean_worktree true, dirty_paths empty, and only the seven self-timestamping
deliverables plus the self-referential manifest rewritten. 18/18 checks.

Co-Authored-By: Claude Opus 5 <noreply@anthropic.com>
</commit_message>
<xml_diff>
--- a/output/presentation/Corporate-Wallet-Digital-Twin.pptx
+++ b/output/presentation/Corporate-Wallet-Digital-Twin.pptx
@@ -2,22 +2,22 @@
 <file path=ppt/presentation.xml><?xml version="1.0" encoding="utf-8"?>
 <p:presentation xmlns:p="http://schemas.openxmlformats.org/presentationml/2006/main">
   <p:sldMasterIdLst>
-    <p:sldMasterId xmlns:r="http://schemas.openxmlformats.org/officeDocument/2006/relationships" id="2147483648" r:id="R19c8273e595f4031"/>
+    <p:sldMasterId xmlns:r="http://schemas.openxmlformats.org/officeDocument/2006/relationships" id="2147483648" r:id="R23ed0e9f678b4820"/>
   </p:sldMasterIdLst>
   <p:notesMasterIdLst>
-    <p:notesMasterId xmlns:r="http://schemas.openxmlformats.org/officeDocument/2006/relationships" r:id="R13050f9667dc49a0"/>
+    <p:notesMasterId xmlns:r="http://schemas.openxmlformats.org/officeDocument/2006/relationships" r:id="Racf075decefd4e38"/>
   </p:notesMasterIdLst>
   <p:sldIdLst>
-    <p:sldId xmlns:r="http://schemas.openxmlformats.org/officeDocument/2006/relationships" id="256" r:id="Re16b9c7c1b1849c9"/>
-    <p:sldId xmlns:r="http://schemas.openxmlformats.org/officeDocument/2006/relationships" id="257" r:id="R6045c30188544efa"/>
-    <p:sldId xmlns:r="http://schemas.openxmlformats.org/officeDocument/2006/relationships" id="258" r:id="R1712b713277a40f3"/>
-    <p:sldId xmlns:r="http://schemas.openxmlformats.org/officeDocument/2006/relationships" id="259" r:id="R3a476f2308704752"/>
-    <p:sldId xmlns:r="http://schemas.openxmlformats.org/officeDocument/2006/relationships" id="260" r:id="R8bfcf3f6fdfe4493"/>
-    <p:sldId xmlns:r="http://schemas.openxmlformats.org/officeDocument/2006/relationships" id="261" r:id="Rd975bb1e0c114361"/>
-    <p:sldId xmlns:r="http://schemas.openxmlformats.org/officeDocument/2006/relationships" id="262" r:id="R52ebc438a7e84715"/>
-    <p:sldId xmlns:r="http://schemas.openxmlformats.org/officeDocument/2006/relationships" id="263" r:id="Rd21e2e6992034506"/>
-    <p:sldId xmlns:r="http://schemas.openxmlformats.org/officeDocument/2006/relationships" id="264" r:id="R55f597e1bfef43bd"/>
-    <p:sldId xmlns:r="http://schemas.openxmlformats.org/officeDocument/2006/relationships" id="265" r:id="R8e9f993ef7ec4de8"/>
+    <p:sldId xmlns:r="http://schemas.openxmlformats.org/officeDocument/2006/relationships" id="256" r:id="R170e89467b144996"/>
+    <p:sldId xmlns:r="http://schemas.openxmlformats.org/officeDocument/2006/relationships" id="257" r:id="R905be719558747b8"/>
+    <p:sldId xmlns:r="http://schemas.openxmlformats.org/officeDocument/2006/relationships" id="258" r:id="Rf3ddf45c924549db"/>
+    <p:sldId xmlns:r="http://schemas.openxmlformats.org/officeDocument/2006/relationships" id="259" r:id="Rd71dc67de056455a"/>
+    <p:sldId xmlns:r="http://schemas.openxmlformats.org/officeDocument/2006/relationships" id="260" r:id="R14aedc4b6e764a50"/>
+    <p:sldId xmlns:r="http://schemas.openxmlformats.org/officeDocument/2006/relationships" id="261" r:id="R2373291c2d2c48d5"/>
+    <p:sldId xmlns:r="http://schemas.openxmlformats.org/officeDocument/2006/relationships" id="262" r:id="Ra9f7df87ddfa4d28"/>
+    <p:sldId xmlns:r="http://schemas.openxmlformats.org/officeDocument/2006/relationships" id="263" r:id="R04ebeabc81af4a85"/>
+    <p:sldId xmlns:r="http://schemas.openxmlformats.org/officeDocument/2006/relationships" id="264" r:id="Rd0d046fa55064033"/>
+    <p:sldId xmlns:r="http://schemas.openxmlformats.org/officeDocument/2006/relationships" id="265" r:id="R877ad3c0b19b47ab"/>
   </p:sldIdLst>
   <p:sldSz cx="12192000" cy="6858000"/>
   <p:notesSz cx="6858000" cy="9144000"/>
@@ -1409,7 +1409,7 @@
   </p:cSld>
   <p:clrMap bg1="lt1" tx1="dk1" bg2="lt2" tx2="dk2" accent1="accent1" accent2="accent2" accent3="accent3" accent4="accent4" accent5="accent5" accent6="accent6" hlink="hlink" folHlink="folHlink"/>
   <p:sldLayoutIdLst>
-    <p:sldLayoutId xmlns:r="http://schemas.openxmlformats.org/officeDocument/2006/relationships" id="2147483649" r:id="R13496971198b4ae9"/>
+    <p:sldLayoutId xmlns:r="http://schemas.openxmlformats.org/officeDocument/2006/relationships" id="2147483649" r:id="R5cf33f2fbd2f4538"/>
   </p:sldLayoutIdLst>
   <p:txStyles>
     <p:titleStyle>
@@ -2123,7 +2123,7 @@
           <p:nvPr/>
         </p:nvPicPr>
         <p:blipFill>
-          <a:blip xmlns:r="http://schemas.openxmlformats.org/officeDocument/2006/relationships" xmlns:a="http://schemas.openxmlformats.org/drawingml/2006/main" r:embed="R46e19dc799264b27"/>
+          <a:blip xmlns:r="http://schemas.openxmlformats.org/officeDocument/2006/relationships" xmlns:a="http://schemas.openxmlformats.org/drawingml/2006/main" r:embed="R7a29c289cb0c4688"/>
           <a:srcRect xmlns:a="http://schemas.openxmlformats.org/drawingml/2006/main" l="0" t="27" r="0" b="27"/>
           <a:stretch xmlns:a="http://schemas.openxmlformats.org/drawingml/2006/main">
             <a:fillRect l="0" t="0" r="0" b="0"/>
@@ -7915,7 +7915,7 @@
         </p:xfrm>
         <a:graphic xmlns:a="http://schemas.openxmlformats.org/drawingml/2006/main">
           <a:graphicData uri="http://schemas.openxmlformats.org/drawingml/2006/chart">
-            <c:chart xmlns:r="http://schemas.openxmlformats.org/officeDocument/2006/relationships" xmlns:c="http://schemas.openxmlformats.org/drawingml/2006/chart" r:id="R2115878244d34b30"/>
+            <c:chart xmlns:r="http://schemas.openxmlformats.org/officeDocument/2006/relationships" xmlns:c="http://schemas.openxmlformats.org/drawingml/2006/chart" r:id="Rdf74b224e3c14b7a"/>
           </a:graphicData>
         </a:graphic>
       </p:graphicFrame>
@@ -9390,7 +9390,7 @@
           <p:cNvPr id="69" name="">
             <a:extLst xmlns:a="http://schemas.openxmlformats.org/drawingml/2006/main">
               <a:ext uri="{FF2B5EF4-FFF2-40B4-BE49-F238E27FC236}">
-                <a16:creationId xmlns:a16="http://schemas.microsoft.com/office/drawing/2014/main" id="{ACB7BAD4-41F8-45DC-96A1-2BAA74A6E708}"/>
+                <a16:creationId xmlns:a16="http://schemas.microsoft.com/office/drawing/2014/main" id="{DCD2B45A-8DBC-4DB0-93B8-BF0990CECB8F}"/>
               </a:ext>
             </a:extLst>
           </p:cNvPr>
@@ -9427,7 +9427,7 @@
           <p:nvPr/>
         </p:nvPicPr>
         <p:blipFill>
-          <a:blip xmlns:r="http://schemas.openxmlformats.org/officeDocument/2006/relationships" xmlns:a="http://schemas.openxmlformats.org/drawingml/2006/main" r:embed="R68c17e9a49aa4d97"/>
+          <a:blip xmlns:r="http://schemas.openxmlformats.org/officeDocument/2006/relationships" xmlns:a="http://schemas.openxmlformats.org/drawingml/2006/main" r:embed="R9cd0c9cdaa054668"/>
           <a:stretch xmlns:a="http://schemas.openxmlformats.org/drawingml/2006/main"/>
         </p:blipFill>
         <p:spPr>

</xml_diff>

<commit_message>
Close V3.2.0 promotion readiness release
</commit_message>
<xml_diff>
--- a/output/presentation/Corporate-Wallet-Digital-Twin.pptx
+++ b/output/presentation/Corporate-Wallet-Digital-Twin.pptx
@@ -2,22 +2,22 @@
 <file path=ppt/presentation.xml><?xml version="1.0" encoding="utf-8"?>
 <p:presentation xmlns:p="http://schemas.openxmlformats.org/presentationml/2006/main">
   <p:sldMasterIdLst>
-    <p:sldMasterId xmlns:r="http://schemas.openxmlformats.org/officeDocument/2006/relationships" id="2147483648" r:id="R23ed0e9f678b4820"/>
+    <p:sldMasterId xmlns:r="http://schemas.openxmlformats.org/officeDocument/2006/relationships" id="2147483648" r:id="R256803986f8c4118"/>
   </p:sldMasterIdLst>
   <p:notesMasterIdLst>
-    <p:notesMasterId xmlns:r="http://schemas.openxmlformats.org/officeDocument/2006/relationships" r:id="Racf075decefd4e38"/>
+    <p:notesMasterId xmlns:r="http://schemas.openxmlformats.org/officeDocument/2006/relationships" r:id="R7e6537f70eeb4abc"/>
   </p:notesMasterIdLst>
   <p:sldIdLst>
-    <p:sldId xmlns:r="http://schemas.openxmlformats.org/officeDocument/2006/relationships" id="256" r:id="R170e89467b144996"/>
-    <p:sldId xmlns:r="http://schemas.openxmlformats.org/officeDocument/2006/relationships" id="257" r:id="R905be719558747b8"/>
-    <p:sldId xmlns:r="http://schemas.openxmlformats.org/officeDocument/2006/relationships" id="258" r:id="Rf3ddf45c924549db"/>
-    <p:sldId xmlns:r="http://schemas.openxmlformats.org/officeDocument/2006/relationships" id="259" r:id="Rd71dc67de056455a"/>
-    <p:sldId xmlns:r="http://schemas.openxmlformats.org/officeDocument/2006/relationships" id="260" r:id="R14aedc4b6e764a50"/>
-    <p:sldId xmlns:r="http://schemas.openxmlformats.org/officeDocument/2006/relationships" id="261" r:id="R2373291c2d2c48d5"/>
-    <p:sldId xmlns:r="http://schemas.openxmlformats.org/officeDocument/2006/relationships" id="262" r:id="Ra9f7df87ddfa4d28"/>
-    <p:sldId xmlns:r="http://schemas.openxmlformats.org/officeDocument/2006/relationships" id="263" r:id="R04ebeabc81af4a85"/>
-    <p:sldId xmlns:r="http://schemas.openxmlformats.org/officeDocument/2006/relationships" id="264" r:id="Rd0d046fa55064033"/>
-    <p:sldId xmlns:r="http://schemas.openxmlformats.org/officeDocument/2006/relationships" id="265" r:id="R877ad3c0b19b47ab"/>
+    <p:sldId xmlns:r="http://schemas.openxmlformats.org/officeDocument/2006/relationships" id="256" r:id="R72e1ed7cfe6f4928"/>
+    <p:sldId xmlns:r="http://schemas.openxmlformats.org/officeDocument/2006/relationships" id="257" r:id="Re5e4cbd87c4e428e"/>
+    <p:sldId xmlns:r="http://schemas.openxmlformats.org/officeDocument/2006/relationships" id="258" r:id="R9852561b03494437"/>
+    <p:sldId xmlns:r="http://schemas.openxmlformats.org/officeDocument/2006/relationships" id="259" r:id="R8a04db5d8270434e"/>
+    <p:sldId xmlns:r="http://schemas.openxmlformats.org/officeDocument/2006/relationships" id="260" r:id="Rd818d8842c8e4a87"/>
+    <p:sldId xmlns:r="http://schemas.openxmlformats.org/officeDocument/2006/relationships" id="261" r:id="R912314af9ad24315"/>
+    <p:sldId xmlns:r="http://schemas.openxmlformats.org/officeDocument/2006/relationships" id="262" r:id="R3caedd03bc734e38"/>
+    <p:sldId xmlns:r="http://schemas.openxmlformats.org/officeDocument/2006/relationships" id="263" r:id="Rac017e8412334554"/>
+    <p:sldId xmlns:r="http://schemas.openxmlformats.org/officeDocument/2006/relationships" id="264" r:id="R9a7d04d147284d98"/>
+    <p:sldId xmlns:r="http://schemas.openxmlformats.org/officeDocument/2006/relationships" id="265" r:id="Re6b82ff32ccd4a0c"/>
   </p:sldIdLst>
   <p:sldSz cx="12192000" cy="6858000"/>
   <p:notesSz cx="6858000" cy="9144000"/>
@@ -546,7 +546,7 @@
           <a:lstStyle xmlns:a="http://schemas.openxmlformats.org/drawingml/2006/main"/>
           <a:p xmlns:a="http://schemas.openxmlformats.org/drawingml/2006/main">
             <a:r>
-              <a:t>Close with the commercial story and honest boundary. V3.1.1 is a reproducible hackathon submission once the artifact and public-access gates pass. Bank production stays NOT_PROMOTABLE until representative external calibration, approved bank economics and controls, live provider adjudication and qualified RM outcomes exist.</a:t>
+              <a:t>Close with the commercial and governance story. V3.2 is a reproducible offline candidate and a shadow-deployment package with a passed promotion rehearsal. Bank production stays NOT_PROMOTABLE until the real bank evidence, control-owner approvals, elapsed operation and qualified outcomes exist.</a:t>
             </a:r>
           </a:p>
           <a:p xmlns:a="http://schemas.openxmlformats.org/drawingml/2006/main">
@@ -577,6 +577,11 @@
           <a:p xmlns:a="http://schemas.openxmlformats.org/drawingml/2006/main">
             <a:r>
               <a:t>- output/pdf/Corporate-Wallet-Digital-Twin-One-Pager.pdf</a:t>
+            </a:r>
+          </a:p>
+          <a:p xmlns:a="http://schemas.openxmlformats.org/drawingml/2006/main">
+            <a:r>
+              <a:t>- outputs/judging_manifest_v3.2.0.json</a:t>
             </a:r>
           </a:p>
           <a:p xmlns:a="http://schemas.openxmlformats.org/drawingml/2006/main">
@@ -1056,7 +1061,7 @@
           </a:p>
           <a:p xmlns:a="http://schemas.openxmlformats.org/drawingml/2006/main">
             <a:r>
-              <a:t>- outputs/audit/Public-Facts-Anchor-Register-V3.1.1.xlsx</a:t>
+              <a:t>- outputs/audit/Public-Facts-Anchor-Register-V3.2.0.xlsx</a:t>
             </a:r>
           </a:p>
         </p:txBody>
@@ -1316,7 +1321,7 @@
           <a:lstStyle xmlns:a="http://schemas.openxmlformats.org/drawingml/2006/main"/>
           <a:p xmlns:a="http://schemas.openxmlformats.org/drawingml/2006/main">
             <a:r>
-              <a:t>Separate what the implementation proves. Mechanical checks validate data and equations. A known-truth synthetic panel assesses interval behavior. Posterior and ranking diagnostics are predictive model evidence. E3 observations, approved economics, live-provider adjudication and causal RM outcomes remain external gates.</a:t>
+              <a:t>The Promotion Twin evaluates thirty cumulative gates twice. Blue rehearsal evidence proves the mechanism and its refusal behavior work; only real, bank-attested evidence can authorize actual use. The accelerated rehearsal resets on day 17 and then reaches thirty clean virtual days. The real bank-day count remains zero.</a:t>
             </a:r>
           </a:p>
           <a:p xmlns:a="http://schemas.openxmlformats.org/drawingml/2006/main">
@@ -1331,17 +1336,22 @@
           </a:p>
           <a:p xmlns:a="http://schemas.openxmlformats.org/drawingml/2006/main">
             <a:r>
-              <a:t>- outputs/v2_validation/measurement_policy_sensitivity.json</a:t>
-            </a:r>
-          </a:p>
-          <a:p xmlns:a="http://schemas.openxmlformats.org/drawingml/2006/main">
-            <a:r>
-              <a:t>- outputs/v2_validation/offline_validation_report.json</a:t>
-            </a:r>
-          </a:p>
-          <a:p xmlns:a="http://schemas.openxmlformats.org/drawingml/2006/main">
-            <a:r>
-              <a:t>- docs/methodology.md</a:t>
+              <a:t>- dashboard/app/data/promotion-fixture.json</a:t>
+            </a:r>
+          </a:p>
+          <a:p xmlns:a="http://schemas.openxmlformats.org/drawingml/2006/main">
+            <a:r>
+              <a:t>- contracts/promotion-gate-catalogue.json</a:t>
+            </a:r>
+          </a:p>
+          <a:p xmlns:a="http://schemas.openxmlformats.org/drawingml/2006/main">
+            <a:r>
+              <a:t>- outputs/v32/v32_shadow_rehearsal.json</a:t>
+            </a:r>
+          </a:p>
+          <a:p xmlns:a="http://schemas.openxmlformats.org/drawingml/2006/main">
+            <a:r>
+              <a:t>- docs/Corporate_Wallet_Digital_Twin_V3_2_Promotion_Twin.md</a:t>
             </a:r>
           </a:p>
         </p:txBody>
@@ -1409,7 +1419,7 @@
   </p:cSld>
   <p:clrMap bg1="lt1" tx1="dk1" bg2="lt2" tx2="dk2" accent1="accent1" accent2="accent2" accent3="accent3" accent4="accent4" accent5="accent5" accent6="accent6" hlink="hlink" folHlink="folHlink"/>
   <p:sldLayoutIdLst>
-    <p:sldLayoutId xmlns:r="http://schemas.openxmlformats.org/officeDocument/2006/relationships" id="2147483649" r:id="R5cf33f2fbd2f4538"/>
+    <p:sldLayoutId xmlns:r="http://schemas.openxmlformats.org/officeDocument/2006/relationships" id="2147483649" r:id="R52d412685c1e4b8c"/>
   </p:sldLayoutIdLst>
   <p:txStyles>
     <p:titleStyle>
@@ -2123,7 +2133,7 @@
           <p:nvPr/>
         </p:nvPicPr>
         <p:blipFill>
-          <a:blip xmlns:r="http://schemas.openxmlformats.org/officeDocument/2006/relationships" xmlns:a="http://schemas.openxmlformats.org/drawingml/2006/main" r:embed="R7a29c289cb0c4688"/>
+          <a:blip xmlns:r="http://schemas.openxmlformats.org/officeDocument/2006/relationships" xmlns:a="http://schemas.openxmlformats.org/drawingml/2006/main" r:embed="Re4c4e35e49a3415f"/>
           <a:srcRect xmlns:a="http://schemas.openxmlformats.org/drawingml/2006/main" l="0" t="27" r="0" b="27"/>
           <a:stretch xmlns:a="http://schemas.openxmlformats.org/drawingml/2006/main">
             <a:fillRect l="0" t="0" r="0" b="0"/>
@@ -2648,7 +2658,7 @@
                 <a:ea typeface="Arial"/>
                 <a:cs typeface="Arial"/>
               </a:rPr>
-              <a:t>V3.1.1 | AS OF 30 JUNE 2026 | HACKATHON SUBMISSION</a:t>
+              <a:t>V3.2.0 | AS OF 30 JUNE 2026 | HACKATHON SUBMISSION</a:t>
             </a:r>
           </a:p>
         </p:txBody>
@@ -2819,7 +2829,7 @@
                 <a:ea typeface="Arial"/>
                 <a:cs typeface="Arial"/>
               </a:rPr>
-              <a:t>Plan the conversation.</a:t>
+              <a:t>Earn the right to act.</a:t>
             </a:r>
           </a:p>
         </p:txBody>
@@ -2854,7 +2864,7 @@
         </p:spPr>
         <p:txBody>
           <a:bodyPr xmlns:a="http://schemas.openxmlformats.org/drawingml/2006/main" anchor="t">
-            <a:normAutofit fontScale="95370"/>
+            <a:normAutofit fontScale="100000"/>
           </a:bodyPr>
           <a:lstStyle xmlns:a="http://schemas.openxmlformats.org/drawingml/2006/main"/>
           <a:p xmlns:a="http://schemas.openxmlformats.org/drawingml/2006/main">
@@ -2878,7 +2888,7 @@
                 <a:ea typeface="Arial"/>
                 <a:cs typeface="Arial"/>
               </a:rPr>
-              <a:t>V3.1.1 converts partial bank observation into a governed wallet interval, a commercial scenario and a relationship action—while preserving every evidence boundary.</a:t>
+              <a:t>V3.2 combines a governed wallet interval, a relationship action and an executable proof of what may—and may not—be used.</a:t>
             </a:r>
           </a:p>
         </p:txBody>
@@ -3416,7 +3426,7 @@
                 <a:ea typeface="Arial"/>
                 <a:cs typeface="Arial"/>
               </a:rPr>
-              <a:t>Earn production</a:t>
+              <a:t>Earn the right to use it</a:t>
             </a:r>
           </a:p>
         </p:txBody>
@@ -3475,7 +3485,7 @@
                 <a:ea typeface="Arial"/>
                 <a:cs typeface="Arial"/>
               </a:rPr>
-              <a:t>E3 panel, bank rates and controls, live provider adjudication, RM pilot and randomized outcomes.</a:t>
+              <a:t>Promotion Twin keeps signed rehearsal evidence separate from real bank authorization at every transition.</a:t>
             </a:r>
           </a:p>
         </p:txBody>
@@ -3534,7 +3544,7 @@
                 <a:ea typeface="Arial"/>
                 <a:cs typeface="Arial"/>
               </a:rPr>
-              <a:t>Submission mechanics validated; live-provider proof remains an explicit gate. Bank-production claims stay fail-closed.</a:t>
+              <a:t>Offline candidate validated; shadow promotion rehearsed. BANK_SHADOW_AUTHORIZED remains FALSE.</a:t>
             </a:r>
           </a:p>
         </p:txBody>
@@ -3593,7 +3603,7 @@
                 <a:ea typeface="Arial"/>
                 <a:cs typeface="Arial"/>
               </a:rPr>
-              <a:t>Corporate Wallet Digital Twin | Christopher Koen | V3.1.1</a:t>
+              <a:t>Corporate Wallet Digital Twin | Christopher Koen | V3.2.0</a:t>
             </a:r>
           </a:p>
         </p:txBody>
@@ -3873,7 +3883,7 @@
                 <a:ea typeface="Arial"/>
                 <a:cs typeface="Arial"/>
               </a:rPr>
-              <a:t>TEAM: Corporate Wallet Digital Twin | Christopher Koen | V3.1.1</a:t>
+              <a:t>TEAM: Corporate Wallet Digital Twin | Christopher Koen | V3.2.0</a:t>
             </a:r>
           </a:p>
         </p:txBody>
@@ -4050,7 +4060,7 @@
                 <a:ea typeface="Arial"/>
                 <a:cs typeface="Arial"/>
               </a:rPr>
-              <a:t>Syn Bank observes A—its own client–product activity. Total wallet T and bank share q remain latent. The identity A=qT admits many answers, so V3.1.1 reports bounds and posterior intervals rather than false precision.</a:t>
+              <a:t>Syn Bank observes A—its own client–product activity. Total wallet T and bank share q remain latent. The identity A=qT admits many answers, so V3.2 reports bounds and posterior intervals rather than false precision.</a:t>
             </a:r>
           </a:p>
         </p:txBody>
@@ -5623,7 +5633,7 @@
                 <a:ea typeface="Arial"/>
                 <a:cs typeface="Arial"/>
               </a:rPr>
-              <a:t>TEAM: Corporate Wallet Digital Twin | Christopher Koen | V3.1.1</a:t>
+              <a:t>TEAM: Corporate Wallet Digital Twin | Christopher Koen | V3.2.0</a:t>
             </a:r>
           </a:p>
         </p:txBody>
@@ -7277,7 +7287,7 @@
                 <a:ea typeface="Arial"/>
                 <a:cs typeface="Arial"/>
               </a:rPr>
-              <a:t>TEAM: Corporate Wallet Digital Twin | Christopher Koen | V3.1.1</a:t>
+              <a:t>TEAM: Corporate Wallet Digital Twin | Christopher Koen | V3.2.0</a:t>
             </a:r>
           </a:p>
         </p:txBody>
@@ -7915,7 +7925,7 @@
         </p:xfrm>
         <a:graphic xmlns:a="http://schemas.openxmlformats.org/drawingml/2006/main">
           <a:graphicData uri="http://schemas.openxmlformats.org/drawingml/2006/chart">
-            <c:chart xmlns:r="http://schemas.openxmlformats.org/officeDocument/2006/relationships" xmlns:c="http://schemas.openxmlformats.org/drawingml/2006/chart" r:id="Rdf74b224e3c14b7a"/>
+            <c:chart xmlns:r="http://schemas.openxmlformats.org/officeDocument/2006/relationships" xmlns:c="http://schemas.openxmlformats.org/drawingml/2006/chart" r:id="R872f30441f4c41fb"/>
           </a:graphicData>
         </a:graphic>
       </p:graphicFrame>
@@ -8225,7 +8235,7 @@
                 <a:ea typeface="Arial"/>
                 <a:cs typeface="Arial"/>
               </a:rPr>
-              <a:t>TEAM: Corporate Wallet Digital Twin | Christopher Koen | V3.1.1</a:t>
+              <a:t>TEAM: Corporate Wallet Digital Twin | Christopher Koen | V3.2.0</a:t>
             </a:r>
           </a:p>
         </p:txBody>
@@ -9390,7 +9400,7 @@
           <p:cNvPr id="69" name="">
             <a:extLst xmlns:a="http://schemas.openxmlformats.org/drawingml/2006/main">
               <a:ext uri="{FF2B5EF4-FFF2-40B4-BE49-F238E27FC236}">
-                <a16:creationId xmlns:a16="http://schemas.microsoft.com/office/drawing/2014/main" id="{DCD2B45A-8DBC-4DB0-93B8-BF0990CECB8F}"/>
+                <a16:creationId xmlns:a16="http://schemas.microsoft.com/office/drawing/2014/main" id="{4F42E015-E644-4945-AC45-1B81AFC51582}"/>
               </a:ext>
             </a:extLst>
           </p:cNvPr>
@@ -9427,7 +9437,7 @@
           <p:nvPr/>
         </p:nvPicPr>
         <p:blipFill>
-          <a:blip xmlns:r="http://schemas.openxmlformats.org/officeDocument/2006/relationships" xmlns:a="http://schemas.openxmlformats.org/drawingml/2006/main" r:embed="R9cd0c9cdaa054668"/>
+          <a:blip xmlns:r="http://schemas.openxmlformats.org/officeDocument/2006/relationships" xmlns:a="http://schemas.openxmlformats.org/drawingml/2006/main" r:embed="Rb82c39fb4b3c469c"/>
           <a:stretch xmlns:a="http://schemas.openxmlformats.org/drawingml/2006/main"/>
         </p:blipFill>
         <p:spPr>
@@ -9656,7 +9666,7 @@
                 <a:ea typeface="Arial"/>
                 <a:cs typeface="Arial"/>
               </a:rPr>
-              <a:t>TEAM: Corporate Wallet Digital Twin | Christopher Koen | V3.1.1</a:t>
+              <a:t>TEAM: Corporate Wallet Digital Twin | Christopher Koen | V3.2.0</a:t>
             </a:r>
           </a:p>
         </p:txBody>
@@ -11590,7 +11600,7 @@
                 <a:ea typeface="Arial"/>
                 <a:cs typeface="Arial"/>
               </a:rPr>
-              <a:t>TEAM: Corporate Wallet Digital Twin | Christopher Koen | V3.1.1</a:t>
+              <a:t>TEAM: Corporate Wallet Digital Twin | Christopher Koen | V3.2.0</a:t>
             </a:r>
           </a:p>
         </p:txBody>
@@ -14038,7 +14048,7 @@
                 <a:ea typeface="Arial"/>
                 <a:cs typeface="Arial"/>
               </a:rPr>
-              <a:t>TEAM: Corporate Wallet Digital Twin | Christopher Koen | V3.1.1</a:t>
+              <a:t>TEAM: Corporate Wallet Digital Twin | Christopher Koen | V3.2.0</a:t>
             </a:r>
           </a:p>
         </p:txBody>
@@ -15524,7 +15534,7 @@
                 <a:ea typeface="Arial"/>
                 <a:cs typeface="Arial"/>
               </a:rPr>
-              <a:t>VALIDATION HIERARCHY</a:t>
+              <a:t>PROMOTION READINESS TWIN</a:t>
             </a:r>
           </a:p>
         </p:txBody>
@@ -15583,7 +15593,7 @@
                 <a:ea typeface="Arial"/>
                 <a:cs typeface="Arial"/>
               </a:rPr>
-              <a:t>Each claim earns the strongest label its evidence permits</a:t>
+              <a:t>The machinery is ready; bank authority is not</a:t>
             </a:r>
           </a:p>
         </p:txBody>
@@ -15664,7 +15674,7 @@
                 <a:ea typeface="Arial"/>
                 <a:cs typeface="Arial"/>
               </a:rPr>
-              <a:t>TEAM: Corporate Wallet Digital Twin | Christopher Koen | V3.1.1</a:t>
+              <a:t>TEAM: Corporate Wallet Digital Twin | Christopher Koen | V3.2.0</a:t>
             </a:r>
           </a:p>
         </p:txBody>
@@ -16023,7 +16033,7 @@
                 <a:ea typeface="Arial"/>
                 <a:cs typeface="Arial"/>
               </a:rPr>
-              <a:t>Mechanical</a:t>
+              <a:t>Offline</a:t>
             </a:r>
           </a:p>
         </p:txBody>
@@ -16058,7 +16068,7 @@
         </p:spPr>
         <p:txBody>
           <a:bodyPr xmlns:a="http://schemas.openxmlformats.org/drawingml/2006/main" anchor="t">
-            <a:normAutofit fontScale="86066"/>
+            <a:normAutofit fontScale="81391"/>
           </a:bodyPr>
           <a:lstStyle xmlns:a="http://schemas.openxmlformats.org/drawingml/2006/main"/>
           <a:p xmlns:a="http://schemas.openxmlformats.org/drawingml/2006/main">
@@ -16082,7 +16092,7 @@
                 <a:ea typeface="Arial"/>
                 <a:cs typeface="Arial"/>
               </a:rPr>
-              <a:t>Contracts, identities, arithmetic, PIT lineage</a:t>
+              <a:t>Reproducible candidate and claim boundaries</a:t>
             </a:r>
           </a:p>
         </p:txBody>
@@ -16235,7 +16245,7 @@
                 <a:ea typeface="Arial"/>
                 <a:cs typeface="Arial"/>
               </a:rPr>
-              <a:t>Known truth</a:t>
+              <a:t>Shadow</a:t>
             </a:r>
           </a:p>
         </p:txBody>
@@ -16270,7 +16280,7 @@
         </p:spPr>
         <p:txBody>
           <a:bodyPr xmlns:a="http://schemas.openxmlformats.org/drawingml/2006/main" anchor="t">
-            <a:normAutofit fontScale="73978"/>
+            <a:normAutofit fontScale="75772"/>
           </a:bodyPr>
           <a:lstStyle xmlns:a="http://schemas.openxmlformats.org/drawingml/2006/main"/>
           <a:p xmlns:a="http://schemas.openxmlformats.org/drawingml/2006/main">
@@ -16294,7 +16304,7 @@
                 <a:ea typeface="Arial"/>
                 <a:cs typeface="Arial"/>
               </a:rPr>
-              <a:t>Synthetic panel coverage, width and CRPS</a:t>
+              <a:t>Hidden bank run; missing capabilities fail closed</a:t>
             </a:r>
           </a:p>
         </p:txBody>
@@ -16447,7 +16457,7 @@
                 <a:ea typeface="Arial"/>
                 <a:cs typeface="Arial"/>
               </a:rPr>
-              <a:t>Predictive</a:t>
+              <a:t>Pilot</a:t>
             </a:r>
           </a:p>
         </p:txBody>
@@ -16482,7 +16492,7 @@
         </p:spPr>
         <p:txBody>
           <a:bodyPr xmlns:a="http://schemas.openxmlformats.org/drawingml/2006/main" anchor="t">
-            <a:normAutofit fontScale="96503"/>
+            <a:normAutofit fontScale="73611"/>
           </a:bodyPr>
           <a:lstStyle xmlns:a="http://schemas.openxmlformats.org/drawingml/2006/main"/>
           <a:p xmlns:a="http://schemas.openxmlformats.org/drawingml/2006/main">
@@ -16506,7 +16516,7 @@
                 <a:ea typeface="Arial"/>
                 <a:cs typeface="Arial"/>
               </a:rPr>
-              <a:t>Posterior intervals and ranking stability</a:t>
+              <a:t>Thirty real days + approved evidence and cohort</a:t>
             </a:r>
           </a:p>
         </p:txBody>
@@ -16659,7 +16669,7 @@
                 <a:ea typeface="Arial"/>
                 <a:cs typeface="Arial"/>
               </a:rPr>
-              <a:t>External</a:t>
+              <a:t>Scale</a:t>
             </a:r>
           </a:p>
         </p:txBody>
@@ -16694,7 +16704,7 @@
         </p:spPr>
         <p:txBody>
           <a:bodyPr xmlns:a="http://schemas.openxmlformats.org/drawingml/2006/main" anchor="t">
-            <a:normAutofit fontScale="79609"/>
+            <a:normAutofit fontScale="75828"/>
           </a:bodyPr>
           <a:lstStyle xmlns:a="http://schemas.openxmlformats.org/drawingml/2006/main"/>
           <a:p xmlns:a="http://schemas.openxmlformats.org/drawingml/2006/main">
@@ -16718,7 +16728,7 @@
                 <a:ea typeface="Arial"/>
                 <a:cs typeface="Arial"/>
               </a:rPr>
-              <a:t>E3 calibration, approved rates and live eval</a:t>
+              <a:t>Bank-attested pilot, operations and approvals</a:t>
             </a:r>
           </a:p>
         </p:txBody>
@@ -16906,7 +16916,7 @@
         </p:spPr>
         <p:txBody>
           <a:bodyPr xmlns:a="http://schemas.openxmlformats.org/drawingml/2006/main" anchor="t">
-            <a:normAutofit fontScale="90828"/>
+            <a:normAutofit fontScale="73611"/>
           </a:bodyPr>
           <a:lstStyle xmlns:a="http://schemas.openxmlformats.org/drawingml/2006/main"/>
           <a:p xmlns:a="http://schemas.openxmlformats.org/drawingml/2006/main">
@@ -16930,7 +16940,7 @@
                 <a:ea typeface="Arial"/>
                 <a:cs typeface="Arial"/>
               </a:rPr>
-              <a:t>Qualified randomized RM outcome history</a:t>
+              <a:t>Positive independently validated randomized evidence</a:t>
             </a:r>
           </a:p>
         </p:txBody>
@@ -17011,7 +17021,7 @@
                 <a:ea typeface="Arial"/>
                 <a:cs typeface="Arial"/>
               </a:rPr>
-              <a:t>100</a:t>
+              <a:t>30</a:t>
             </a:r>
           </a:p>
         </p:txBody>
@@ -17070,7 +17080,7 @@
                 <a:ea typeface="Arial"/>
                 <a:cs typeface="Arial"/>
               </a:rPr>
-              <a:t>wallet identities</a:t>
+              <a:t>governed gates</a:t>
             </a:r>
           </a:p>
         </p:txBody>
@@ -17129,7 +17139,7 @@
                 <a:ea typeface="Arial"/>
                 <a:cs typeface="Arial"/>
               </a:rPr>
-              <a:t>T ≥ A; q=A/T; G=max(q*T−A,0)</a:t>
+              <a:t>Every gate has REAL + REHEARSAL outcomes</a:t>
             </a:r>
           </a:p>
         </p:txBody>
@@ -17210,7 +17220,7 @@
                 <a:ea typeface="Arial"/>
                 <a:cs typeface="Arial"/>
               </a:rPr>
-              <a:t>88.0%</a:t>
+              <a:t>100%</a:t>
             </a:r>
           </a:p>
         </p:txBody>
@@ -17269,7 +17279,7 @@
                 <a:ea typeface="Arial"/>
                 <a:cs typeface="Arial"/>
               </a:rPr>
-              <a:t>base 90% coverage</a:t>
+              <a:t>PMR</a:t>
             </a:r>
           </a:p>
         </p:txBody>
@@ -17328,7 +17338,7 @@
                 <a:ea typeface="Arial"/>
                 <a:cs typeface="Arial"/>
               </a:rPr>
-              <a:t>Known-truth E1 weight 0.35 arm</a:t>
+              <a:t>Signed positive and failure-path rehearsal</a:t>
             </a:r>
           </a:p>
         </p:txBody>
@@ -17409,7 +17419,7 @@
                 <a:ea typeface="Arial"/>
                 <a:cs typeface="Arial"/>
               </a:rPr>
-              <a:t>100%</a:t>
+              <a:t>0%</a:t>
             </a:r>
           </a:p>
         </p:txBody>
@@ -17468,7 +17478,7 @@
                 <a:ea typeface="Arial"/>
                 <a:cs typeface="Arial"/>
               </a:rPr>
-              <a:t>TF first-rank frequency</a:t>
+              <a:t>BER</a:t>
             </a:r>
           </a:p>
         </p:txBody>
@@ -17527,7 +17537,7 @@
                 <a:ea typeface="Arial"/>
                 <a:cs typeface="Arial"/>
               </a:rPr>
-              <a:t>10,000-draw global benchmark</a:t>
+              <a:t>Synthetic evidence contributes zero</a:t>
             </a:r>
           </a:p>
         </p:txBody>
@@ -17667,7 +17677,7 @@
                 <a:ea typeface="Arial"/>
                 <a:cs typeface="Arial"/>
               </a:rPr>
-              <a:t>measured-share claims</a:t>
+              <a:t>elapsed bank days</a:t>
             </a:r>
           </a:p>
         </p:txBody>
@@ -17726,7 +17736,7 @@
                 <a:ea typeface="Arial"/>
                 <a:cs typeface="Arial"/>
               </a:rPr>
-              <a:t>No E3 multibank observation exists</a:t>
+              <a:t>30 clean virtual days are kept separate</a:t>
             </a:r>
           </a:p>
         </p:txBody>

</xml_diff>

<commit_message>
Seed V3.2.0 reproducible release artifacts
</commit_message>
<xml_diff>
--- a/output/presentation/Corporate-Wallet-Digital-Twin.pptx
+++ b/output/presentation/Corporate-Wallet-Digital-Twin.pptx
@@ -2,22 +2,22 @@
 <file path=ppt/presentation.xml><?xml version="1.0" encoding="utf-8"?>
 <p:presentation xmlns:p="http://schemas.openxmlformats.org/presentationml/2006/main">
   <p:sldMasterIdLst>
-    <p:sldMasterId xmlns:r="http://schemas.openxmlformats.org/officeDocument/2006/relationships" id="2147483648" r:id="R256803986f8c4118"/>
+    <p:sldMasterId xmlns:r="http://schemas.openxmlformats.org/officeDocument/2006/relationships" id="2147483648" r:id="R32a5c608ecb444cb"/>
   </p:sldMasterIdLst>
   <p:notesMasterIdLst>
-    <p:notesMasterId xmlns:r="http://schemas.openxmlformats.org/officeDocument/2006/relationships" r:id="R7e6537f70eeb4abc"/>
+    <p:notesMasterId xmlns:r="http://schemas.openxmlformats.org/officeDocument/2006/relationships" r:id="Rcffceab9e08f484f"/>
   </p:notesMasterIdLst>
   <p:sldIdLst>
-    <p:sldId xmlns:r="http://schemas.openxmlformats.org/officeDocument/2006/relationships" id="256" r:id="R72e1ed7cfe6f4928"/>
-    <p:sldId xmlns:r="http://schemas.openxmlformats.org/officeDocument/2006/relationships" id="257" r:id="Re5e4cbd87c4e428e"/>
-    <p:sldId xmlns:r="http://schemas.openxmlformats.org/officeDocument/2006/relationships" id="258" r:id="R9852561b03494437"/>
-    <p:sldId xmlns:r="http://schemas.openxmlformats.org/officeDocument/2006/relationships" id="259" r:id="R8a04db5d8270434e"/>
-    <p:sldId xmlns:r="http://schemas.openxmlformats.org/officeDocument/2006/relationships" id="260" r:id="Rd818d8842c8e4a87"/>
-    <p:sldId xmlns:r="http://schemas.openxmlformats.org/officeDocument/2006/relationships" id="261" r:id="R912314af9ad24315"/>
-    <p:sldId xmlns:r="http://schemas.openxmlformats.org/officeDocument/2006/relationships" id="262" r:id="R3caedd03bc734e38"/>
-    <p:sldId xmlns:r="http://schemas.openxmlformats.org/officeDocument/2006/relationships" id="263" r:id="Rac017e8412334554"/>
-    <p:sldId xmlns:r="http://schemas.openxmlformats.org/officeDocument/2006/relationships" id="264" r:id="R9a7d04d147284d98"/>
-    <p:sldId xmlns:r="http://schemas.openxmlformats.org/officeDocument/2006/relationships" id="265" r:id="Re6b82ff32ccd4a0c"/>
+    <p:sldId xmlns:r="http://schemas.openxmlformats.org/officeDocument/2006/relationships" id="256" r:id="R0f1b3e600730454e"/>
+    <p:sldId xmlns:r="http://schemas.openxmlformats.org/officeDocument/2006/relationships" id="257" r:id="Re966a9b8ff7a4978"/>
+    <p:sldId xmlns:r="http://schemas.openxmlformats.org/officeDocument/2006/relationships" id="258" r:id="Rf1da5726884f4ecb"/>
+    <p:sldId xmlns:r="http://schemas.openxmlformats.org/officeDocument/2006/relationships" id="259" r:id="R30779fd1d605461b"/>
+    <p:sldId xmlns:r="http://schemas.openxmlformats.org/officeDocument/2006/relationships" id="260" r:id="Rcf3bf034ad3d45b9"/>
+    <p:sldId xmlns:r="http://schemas.openxmlformats.org/officeDocument/2006/relationships" id="261" r:id="R56c70cbfada044bb"/>
+    <p:sldId xmlns:r="http://schemas.openxmlformats.org/officeDocument/2006/relationships" id="262" r:id="R1217e210f47041b8"/>
+    <p:sldId xmlns:r="http://schemas.openxmlformats.org/officeDocument/2006/relationships" id="263" r:id="R3d96efafb16c4b58"/>
+    <p:sldId xmlns:r="http://schemas.openxmlformats.org/officeDocument/2006/relationships" id="264" r:id="Raf75d85076744cb4"/>
+    <p:sldId xmlns:r="http://schemas.openxmlformats.org/officeDocument/2006/relationships" id="265" r:id="Ra714e08db0a44a00"/>
   </p:sldIdLst>
   <p:sldSz cx="12192000" cy="6858000"/>
   <p:notesSz cx="6858000" cy="9144000"/>
@@ -1419,7 +1419,7 @@
   </p:cSld>
   <p:clrMap bg1="lt1" tx1="dk1" bg2="lt2" tx2="dk2" accent1="accent1" accent2="accent2" accent3="accent3" accent4="accent4" accent5="accent5" accent6="accent6" hlink="hlink" folHlink="folHlink"/>
   <p:sldLayoutIdLst>
-    <p:sldLayoutId xmlns:r="http://schemas.openxmlformats.org/officeDocument/2006/relationships" id="2147483649" r:id="R52d412685c1e4b8c"/>
+    <p:sldLayoutId xmlns:r="http://schemas.openxmlformats.org/officeDocument/2006/relationships" id="2147483649" r:id="Rcae67a755430446f"/>
   </p:sldLayoutIdLst>
   <p:txStyles>
     <p:titleStyle>
@@ -2133,7 +2133,7 @@
           <p:nvPr/>
         </p:nvPicPr>
         <p:blipFill>
-          <a:blip xmlns:r="http://schemas.openxmlformats.org/officeDocument/2006/relationships" xmlns:a="http://schemas.openxmlformats.org/drawingml/2006/main" r:embed="Re4c4e35e49a3415f"/>
+          <a:blip xmlns:r="http://schemas.openxmlformats.org/officeDocument/2006/relationships" xmlns:a="http://schemas.openxmlformats.org/drawingml/2006/main" r:embed="Rb81d7789d66f46fc"/>
           <a:srcRect xmlns:a="http://schemas.openxmlformats.org/drawingml/2006/main" l="0" t="27" r="0" b="27"/>
           <a:stretch xmlns:a="http://schemas.openxmlformats.org/drawingml/2006/main">
             <a:fillRect l="0" t="0" r="0" b="0"/>
@@ -7925,7 +7925,7 @@
         </p:xfrm>
         <a:graphic xmlns:a="http://schemas.openxmlformats.org/drawingml/2006/main">
           <a:graphicData uri="http://schemas.openxmlformats.org/drawingml/2006/chart">
-            <c:chart xmlns:r="http://schemas.openxmlformats.org/officeDocument/2006/relationships" xmlns:c="http://schemas.openxmlformats.org/drawingml/2006/chart" r:id="R872f30441f4c41fb"/>
+            <c:chart xmlns:r="http://schemas.openxmlformats.org/officeDocument/2006/relationships" xmlns:c="http://schemas.openxmlformats.org/drawingml/2006/chart" r:id="R6749d44a01c449bf"/>
           </a:graphicData>
         </a:graphic>
       </p:graphicFrame>
@@ -9400,7 +9400,7 @@
           <p:cNvPr id="69" name="">
             <a:extLst xmlns:a="http://schemas.openxmlformats.org/drawingml/2006/main">
               <a:ext uri="{FF2B5EF4-FFF2-40B4-BE49-F238E27FC236}">
-                <a16:creationId xmlns:a16="http://schemas.microsoft.com/office/drawing/2014/main" id="{4F42E015-E644-4945-AC45-1B81AFC51582}"/>
+                <a16:creationId xmlns:a16="http://schemas.microsoft.com/office/drawing/2014/main" id="{FDFDEEEC-4460-4CC9-A2C4-1C3F33C63633}"/>
               </a:ext>
             </a:extLst>
           </p:cNvPr>
@@ -9437,7 +9437,7 @@
           <p:nvPr/>
         </p:nvPicPr>
         <p:blipFill>
-          <a:blip xmlns:r="http://schemas.openxmlformats.org/officeDocument/2006/relationships" xmlns:a="http://schemas.openxmlformats.org/drawingml/2006/main" r:embed="Rb82c39fb4b3c469c"/>
+          <a:blip xmlns:r="http://schemas.openxmlformats.org/officeDocument/2006/relationships" xmlns:a="http://schemas.openxmlformats.org/drawingml/2006/main" r:embed="R072930a5fc624ae5"/>
           <a:stretch xmlns:a="http://schemas.openxmlformats.org/drawingml/2006/main"/>
         </p:blipFill>
         <p:spPr>

</xml_diff>

<commit_message>
Finalize V3.2.0 release artifacts
</commit_message>
<xml_diff>
--- a/output/presentation/Corporate-Wallet-Digital-Twin.pptx
+++ b/output/presentation/Corporate-Wallet-Digital-Twin.pptx
@@ -2,22 +2,22 @@
 <file path=ppt/presentation.xml><?xml version="1.0" encoding="utf-8"?>
 <p:presentation xmlns:p="http://schemas.openxmlformats.org/presentationml/2006/main">
   <p:sldMasterIdLst>
-    <p:sldMasterId xmlns:r="http://schemas.openxmlformats.org/officeDocument/2006/relationships" id="2147483648" r:id="R32a5c608ecb444cb"/>
+    <p:sldMasterId xmlns:r="http://schemas.openxmlformats.org/officeDocument/2006/relationships" id="2147483648" r:id="R1859f3ea25c7445a"/>
   </p:sldMasterIdLst>
   <p:notesMasterIdLst>
-    <p:notesMasterId xmlns:r="http://schemas.openxmlformats.org/officeDocument/2006/relationships" r:id="Rcffceab9e08f484f"/>
+    <p:notesMasterId xmlns:r="http://schemas.openxmlformats.org/officeDocument/2006/relationships" r:id="Rcb5528e3867b428a"/>
   </p:notesMasterIdLst>
   <p:sldIdLst>
-    <p:sldId xmlns:r="http://schemas.openxmlformats.org/officeDocument/2006/relationships" id="256" r:id="R0f1b3e600730454e"/>
-    <p:sldId xmlns:r="http://schemas.openxmlformats.org/officeDocument/2006/relationships" id="257" r:id="Re966a9b8ff7a4978"/>
-    <p:sldId xmlns:r="http://schemas.openxmlformats.org/officeDocument/2006/relationships" id="258" r:id="Rf1da5726884f4ecb"/>
-    <p:sldId xmlns:r="http://schemas.openxmlformats.org/officeDocument/2006/relationships" id="259" r:id="R30779fd1d605461b"/>
-    <p:sldId xmlns:r="http://schemas.openxmlformats.org/officeDocument/2006/relationships" id="260" r:id="Rcf3bf034ad3d45b9"/>
-    <p:sldId xmlns:r="http://schemas.openxmlformats.org/officeDocument/2006/relationships" id="261" r:id="R56c70cbfada044bb"/>
-    <p:sldId xmlns:r="http://schemas.openxmlformats.org/officeDocument/2006/relationships" id="262" r:id="R1217e210f47041b8"/>
-    <p:sldId xmlns:r="http://schemas.openxmlformats.org/officeDocument/2006/relationships" id="263" r:id="R3d96efafb16c4b58"/>
-    <p:sldId xmlns:r="http://schemas.openxmlformats.org/officeDocument/2006/relationships" id="264" r:id="Raf75d85076744cb4"/>
-    <p:sldId xmlns:r="http://schemas.openxmlformats.org/officeDocument/2006/relationships" id="265" r:id="Ra714e08db0a44a00"/>
+    <p:sldId xmlns:r="http://schemas.openxmlformats.org/officeDocument/2006/relationships" id="256" r:id="R6fe2619069fb4748"/>
+    <p:sldId xmlns:r="http://schemas.openxmlformats.org/officeDocument/2006/relationships" id="257" r:id="Ra1bee90dc5ae4f64"/>
+    <p:sldId xmlns:r="http://schemas.openxmlformats.org/officeDocument/2006/relationships" id="258" r:id="Rb4974a8288764a09"/>
+    <p:sldId xmlns:r="http://schemas.openxmlformats.org/officeDocument/2006/relationships" id="259" r:id="R3ef24c5121564139"/>
+    <p:sldId xmlns:r="http://schemas.openxmlformats.org/officeDocument/2006/relationships" id="260" r:id="Rc43f5894d1724c55"/>
+    <p:sldId xmlns:r="http://schemas.openxmlformats.org/officeDocument/2006/relationships" id="261" r:id="R41aa0a0ee9594471"/>
+    <p:sldId xmlns:r="http://schemas.openxmlformats.org/officeDocument/2006/relationships" id="262" r:id="Rdc5014666ff74938"/>
+    <p:sldId xmlns:r="http://schemas.openxmlformats.org/officeDocument/2006/relationships" id="263" r:id="R8771adda713047a7"/>
+    <p:sldId xmlns:r="http://schemas.openxmlformats.org/officeDocument/2006/relationships" id="264" r:id="R5451c8237c19403e"/>
+    <p:sldId xmlns:r="http://schemas.openxmlformats.org/officeDocument/2006/relationships" id="265" r:id="Rebe6ef0f6a2f465c"/>
   </p:sldIdLst>
   <p:sldSz cx="12192000" cy="6858000"/>
   <p:notesSz cx="6858000" cy="9144000"/>
@@ -1419,7 +1419,7 @@
   </p:cSld>
   <p:clrMap bg1="lt1" tx1="dk1" bg2="lt2" tx2="dk2" accent1="accent1" accent2="accent2" accent3="accent3" accent4="accent4" accent5="accent5" accent6="accent6" hlink="hlink" folHlink="folHlink"/>
   <p:sldLayoutIdLst>
-    <p:sldLayoutId xmlns:r="http://schemas.openxmlformats.org/officeDocument/2006/relationships" id="2147483649" r:id="Rcae67a755430446f"/>
+    <p:sldLayoutId xmlns:r="http://schemas.openxmlformats.org/officeDocument/2006/relationships" id="2147483649" r:id="R2adcd3391af8411a"/>
   </p:sldLayoutIdLst>
   <p:txStyles>
     <p:titleStyle>
@@ -2133,7 +2133,7 @@
           <p:nvPr/>
         </p:nvPicPr>
         <p:blipFill>
-          <a:blip xmlns:r="http://schemas.openxmlformats.org/officeDocument/2006/relationships" xmlns:a="http://schemas.openxmlformats.org/drawingml/2006/main" r:embed="Rb81d7789d66f46fc"/>
+          <a:blip xmlns:r="http://schemas.openxmlformats.org/officeDocument/2006/relationships" xmlns:a="http://schemas.openxmlformats.org/drawingml/2006/main" r:embed="R114c046f1a3a4679"/>
           <a:srcRect xmlns:a="http://schemas.openxmlformats.org/drawingml/2006/main" l="0" t="27" r="0" b="27"/>
           <a:stretch xmlns:a="http://schemas.openxmlformats.org/drawingml/2006/main">
             <a:fillRect l="0" t="0" r="0" b="0"/>
@@ -7925,7 +7925,7 @@
         </p:xfrm>
         <a:graphic xmlns:a="http://schemas.openxmlformats.org/drawingml/2006/main">
           <a:graphicData uri="http://schemas.openxmlformats.org/drawingml/2006/chart">
-            <c:chart xmlns:r="http://schemas.openxmlformats.org/officeDocument/2006/relationships" xmlns:c="http://schemas.openxmlformats.org/drawingml/2006/chart" r:id="R6749d44a01c449bf"/>
+            <c:chart xmlns:r="http://schemas.openxmlformats.org/officeDocument/2006/relationships" xmlns:c="http://schemas.openxmlformats.org/drawingml/2006/chart" r:id="R78e6faa132074b5c"/>
           </a:graphicData>
         </a:graphic>
       </p:graphicFrame>
@@ -9400,7 +9400,7 @@
           <p:cNvPr id="69" name="">
             <a:extLst xmlns:a="http://schemas.openxmlformats.org/drawingml/2006/main">
               <a:ext uri="{FF2B5EF4-FFF2-40B4-BE49-F238E27FC236}">
-                <a16:creationId xmlns:a16="http://schemas.microsoft.com/office/drawing/2014/main" id="{FDFDEEEC-4460-4CC9-A2C4-1C3F33C63633}"/>
+                <a16:creationId xmlns:a16="http://schemas.microsoft.com/office/drawing/2014/main" id="{75296C02-A961-4089-9C99-CEE3E99AC37E}"/>
               </a:ext>
             </a:extLst>
           </p:cNvPr>
@@ -9437,7 +9437,7 @@
           <p:nvPr/>
         </p:nvPicPr>
         <p:blipFill>
-          <a:blip xmlns:r="http://schemas.openxmlformats.org/officeDocument/2006/relationships" xmlns:a="http://schemas.openxmlformats.org/drawingml/2006/main" r:embed="R072930a5fc624ae5"/>
+          <a:blip xmlns:r="http://schemas.openxmlformats.org/officeDocument/2006/relationships" xmlns:a="http://schemas.openxmlformats.org/drawingml/2006/main" r:embed="R9e8bcd9831fb4436"/>
           <a:stretch xmlns:a="http://schemas.openxmlformats.org/drawingml/2006/main"/>
         </p:blipFill>
         <p:spPr>

</xml_diff>

<commit_message>
Harden V3.2 submission coherence
</commit_message>
<xml_diff>
--- a/output/presentation/Corporate-Wallet-Digital-Twin.pptx
+++ b/output/presentation/Corporate-Wallet-Digital-Twin.pptx
@@ -2,22 +2,22 @@
 <file path=ppt/presentation.xml><?xml version="1.0" encoding="utf-8"?>
 <p:presentation xmlns:p="http://schemas.openxmlformats.org/presentationml/2006/main">
   <p:sldMasterIdLst>
-    <p:sldMasterId xmlns:r="http://schemas.openxmlformats.org/officeDocument/2006/relationships" id="2147483648" r:id="R1859f3ea25c7445a"/>
+    <p:sldMasterId xmlns:r="http://schemas.openxmlformats.org/officeDocument/2006/relationships" id="2147483648" r:id="Rfba6974e4c4c4fa4"/>
   </p:sldMasterIdLst>
   <p:notesMasterIdLst>
-    <p:notesMasterId xmlns:r="http://schemas.openxmlformats.org/officeDocument/2006/relationships" r:id="Rcb5528e3867b428a"/>
+    <p:notesMasterId xmlns:r="http://schemas.openxmlformats.org/officeDocument/2006/relationships" r:id="Rbf9eb69e0a834496"/>
   </p:notesMasterIdLst>
   <p:sldIdLst>
-    <p:sldId xmlns:r="http://schemas.openxmlformats.org/officeDocument/2006/relationships" id="256" r:id="R6fe2619069fb4748"/>
-    <p:sldId xmlns:r="http://schemas.openxmlformats.org/officeDocument/2006/relationships" id="257" r:id="Ra1bee90dc5ae4f64"/>
-    <p:sldId xmlns:r="http://schemas.openxmlformats.org/officeDocument/2006/relationships" id="258" r:id="Rb4974a8288764a09"/>
-    <p:sldId xmlns:r="http://schemas.openxmlformats.org/officeDocument/2006/relationships" id="259" r:id="R3ef24c5121564139"/>
-    <p:sldId xmlns:r="http://schemas.openxmlformats.org/officeDocument/2006/relationships" id="260" r:id="Rc43f5894d1724c55"/>
-    <p:sldId xmlns:r="http://schemas.openxmlformats.org/officeDocument/2006/relationships" id="261" r:id="R41aa0a0ee9594471"/>
-    <p:sldId xmlns:r="http://schemas.openxmlformats.org/officeDocument/2006/relationships" id="262" r:id="Rdc5014666ff74938"/>
-    <p:sldId xmlns:r="http://schemas.openxmlformats.org/officeDocument/2006/relationships" id="263" r:id="R8771adda713047a7"/>
-    <p:sldId xmlns:r="http://schemas.openxmlformats.org/officeDocument/2006/relationships" id="264" r:id="R5451c8237c19403e"/>
-    <p:sldId xmlns:r="http://schemas.openxmlformats.org/officeDocument/2006/relationships" id="265" r:id="Rebe6ef0f6a2f465c"/>
+    <p:sldId xmlns:r="http://schemas.openxmlformats.org/officeDocument/2006/relationships" id="256" r:id="R3f1580f4819b452a"/>
+    <p:sldId xmlns:r="http://schemas.openxmlformats.org/officeDocument/2006/relationships" id="257" r:id="R55cdc9389674471e"/>
+    <p:sldId xmlns:r="http://schemas.openxmlformats.org/officeDocument/2006/relationships" id="258" r:id="Rb36e15e577374d5a"/>
+    <p:sldId xmlns:r="http://schemas.openxmlformats.org/officeDocument/2006/relationships" id="259" r:id="R7610d25a9bf64339"/>
+    <p:sldId xmlns:r="http://schemas.openxmlformats.org/officeDocument/2006/relationships" id="260" r:id="R670cd8c516514b41"/>
+    <p:sldId xmlns:r="http://schemas.openxmlformats.org/officeDocument/2006/relationships" id="261" r:id="Re487e91c44f04069"/>
+    <p:sldId xmlns:r="http://schemas.openxmlformats.org/officeDocument/2006/relationships" id="262" r:id="Rc88afbe28bf4489c"/>
+    <p:sldId xmlns:r="http://schemas.openxmlformats.org/officeDocument/2006/relationships" id="263" r:id="R8b40d1a1c6ef4a3e"/>
+    <p:sldId xmlns:r="http://schemas.openxmlformats.org/officeDocument/2006/relationships" id="264" r:id="Ra3073549928f4262"/>
+    <p:sldId xmlns:r="http://schemas.openxmlformats.org/officeDocument/2006/relationships" id="265" r:id="R42bcae98151b446b"/>
   </p:sldIdLst>
   <p:sldSz cx="12192000" cy="6858000"/>
   <p:notesSz cx="6858000" cy="9144000"/>
@@ -546,7 +546,7 @@
           <a:lstStyle xmlns:a="http://schemas.openxmlformats.org/drawingml/2006/main"/>
           <a:p xmlns:a="http://schemas.openxmlformats.org/drawingml/2006/main">
             <a:r>
-              <a:t>Close with the commercial and governance story. V3.2 is a reproducible offline candidate and a shadow-deployment package with a passed promotion rehearsal. Bank production stays NOT_PROMOTABLE until the real bank evidence, control-owner approvals, elapsed operation and qualified outcomes exist.</a:t>
+              <a:t>Close on the commercial decision. The ranked surface begins with Glencore Trade Finance at R17.0m representative scenario contribution, followed by BHP Trade Finance at R7.37m. The relationship manager receives eight priority discovery conversations, not a generic model score. Governance is the final boundary, not the central pitch: hackathon ready; bank production NOT_PROMOTABLE.</a:t>
             </a:r>
           </a:p>
           <a:p xmlns:a="http://schemas.openxmlformats.org/drawingml/2006/main">
@@ -561,7 +561,7 @@
           </a:p>
           <a:p xmlns:a="http://schemas.openxmlformats.org/drawingml/2006/main">
             <a:r>
-              <a:t>- docs/v31_implementation_status.md</a:t>
+              <a:t>- data/v2/submission_truth_v3.2.0.json</a:t>
             </a:r>
           </a:p>
           <a:p xmlns:a="http://schemas.openxmlformats.org/drawingml/2006/main">
@@ -941,7 +941,7 @@
           <a:lstStyle xmlns:a="http://schemas.openxmlformats.org/drawingml/2006/main"/>
           <a:p xmlns:a="http://schemas.openxmlformats.org/drawingml/2006/main">
             <a:r>
-              <a:t>Show the actual rendered Wallet Portfolio view. The default colour encodes contestable scenario contribution. Teal underlines mark the fifteen approved E1 cells; amber marks the eighty-five prior-led cells. Judges can toggle observed activity, posterior wallet, estimated share, contestable gap and evidence status.</a:t>
+              <a:t>Show the actual rendered Wallet Portfolio view. The default colour encodes portfolio-wide contestable scenario contribution. A, T, q and G views use relative intensity within each product column. The leading opportunities are Glencore Trade finance R17.02m; BHP Group Trade finance R7.37m; Glencore Cross-border FX R6.45m; BHP Group Cross-border FX R5.18m; Glencore Liquidity R4.26m.</a:t>
             </a:r>
           </a:p>
           <a:p xmlns:a="http://schemas.openxmlformats.org/drawingml/2006/main">
@@ -1131,7 +1131,7 @@
           <a:lstStyle xmlns:a="http://schemas.openxmlformats.org/drawingml/2006/main"/>
           <a:p xmlns:a="http://schemas.openxmlformats.org/drawingml/2006/main">
             <a:r>
-              <a:t>The Decision Twin remains the action layer, not a replacement for share-of-wallet estimation. It resolves a role, problem, solution bundle, engagement window and next-best question from the wallet gap. Missing credit, conduct, operational or integration feasibility converts the action into discovery; it never silently passes.</a:t>
+              <a:t>The Decision Twin remains the action layer, not a replacement for share-of-wallet estimation. For BHP, 106 bank-observed trade events include a dated 14 August event. With a 45-day preparation lead, the engagement window opens on 30 June. The 36% 90-day seasonal baseline stays visible as an uncalibrated challenger, not the sole urgency claim. Missing feasibility converts the action into discovery.</a:t>
             </a:r>
           </a:p>
           <a:p xmlns:a="http://schemas.openxmlformats.org/drawingml/2006/main">
@@ -1226,7 +1226,7 @@
           <a:lstStyle xmlns:a="http://schemas.openxmlformats.org/drawingml/2006/main"/>
           <a:p xmlns:a="http://schemas.openxmlformats.org/drawingml/2006/main">
             <a:r>
-              <a:t>GenAI is a bounded narrator. The same sanitized pack is prepared for BHP, Glencore and Shoprite across OpenAI, Anthropic and Google. Because no fresh rotated credential and explicit acknowledgement were supplied, all nine target runs remain NOT_EXECUTED. Deterministic briefs remain visible and accepted; no live claim is fabricated.</a:t>
+              <a:t>GenAI is a bounded narrator. Eight of nine genuine provider outputs passed every critical validator, covering OpenAI, Anthropic, Google and all three showcase clients. The ninth output was generated but rejected by the claim compiler before publication, which demonstrates fail-closed control rather than a hidden failure. Deterministic fallback remains beside every accepted brief. This is hackathon evaluation, not bank provider approval.</a:t>
             </a:r>
           </a:p>
           <a:p xmlns:a="http://schemas.openxmlformats.org/drawingml/2006/main">
@@ -1242,6 +1242,11 @@
           <a:p xmlns:a="http://schemas.openxmlformats.org/drawingml/2006/main">
             <a:r>
               <a:t>- outputs/v2_validation/live_provider_comparison.json</a:t>
+            </a:r>
+          </a:p>
+          <a:p xmlns:a="http://schemas.openxmlformats.org/drawingml/2006/main">
+            <a:r>
+              <a:t>- data/v2/submission_truth_v3.2.0.json</a:t>
             </a:r>
           </a:p>
           <a:p xmlns:a="http://schemas.openxmlformats.org/drawingml/2006/main">
@@ -1321,7 +1326,7 @@
           <a:lstStyle xmlns:a="http://schemas.openxmlformats.org/drawingml/2006/main"/>
           <a:p xmlns:a="http://schemas.openxmlformats.org/drawingml/2006/main">
             <a:r>
-              <a:t>The Promotion Twin evaluates thirty cumulative gates twice. Blue rehearsal evidence proves the mechanism and its refusal behavior work; only real, bank-attested evidence can authorize actual use. The accelerated rehearsal resets on day 17 and then reaches thirty clean virtual days. The real bank-day count remains zero.</a:t>
+              <a:t>Trade Finance is first-ranked in all 10,000 global sensitivity draws and majority-dominant in 87.8%, but its absolute economics vary and the top-eight portfolio is not invariant across E1 pooling weights. Coverage and CRPS are known-truth rehearsal metrics only. The compact permission boundary is equally explicit: real state OFFLINE_CANDIDATE; rehearsal only to SHADOW_READY; PMR 100%, BER 0%, and zero elapsed bank shadow days.</a:t>
             </a:r>
           </a:p>
           <a:p xmlns:a="http://schemas.openxmlformats.org/drawingml/2006/main">
@@ -1336,22 +1341,17 @@
           </a:p>
           <a:p xmlns:a="http://schemas.openxmlformats.org/drawingml/2006/main">
             <a:r>
-              <a:t>- dashboard/app/data/promotion-fixture.json</a:t>
-            </a:r>
-          </a:p>
-          <a:p xmlns:a="http://schemas.openxmlformats.org/drawingml/2006/main">
-            <a:r>
-              <a:t>- contracts/promotion-gate-catalogue.json</a:t>
-            </a:r>
-          </a:p>
-          <a:p xmlns:a="http://schemas.openxmlformats.org/drawingml/2006/main">
-            <a:r>
-              <a:t>- outputs/v32/v32_shadow_rehearsal.json</a:t>
-            </a:r>
-          </a:p>
-          <a:p xmlns:a="http://schemas.openxmlformats.org/drawingml/2006/main">
-            <a:r>
-              <a:t>- docs/Corporate_Wallet_Digital_Twin_V3_2_Promotion_Twin.md</a:t>
+              <a:t>- dashboard/app/data/shadow-fixture.json — sensitivity.product_summary.Trade finance</a:t>
+            </a:r>
+          </a:p>
+          <a:p xmlns:a="http://schemas.openxmlformats.org/drawingml/2006/main">
+            <a:r>
+              <a:t>- outputs/v2_validation/measurement_policy_sensitivity.json</a:t>
+            </a:r>
+          </a:p>
+          <a:p xmlns:a="http://schemas.openxmlformats.org/drawingml/2006/main">
+            <a:r>
+              <a:t>- data/v2/submission_truth_v3.2.0.json</a:t>
             </a:r>
           </a:p>
         </p:txBody>
@@ -1419,7 +1419,7 @@
   </p:cSld>
   <p:clrMap bg1="lt1" tx1="dk1" bg2="lt2" tx2="dk2" accent1="accent1" accent2="accent2" accent3="accent3" accent4="accent4" accent5="accent5" accent6="accent6" hlink="hlink" folHlink="folHlink"/>
   <p:sldLayoutIdLst>
-    <p:sldLayoutId xmlns:r="http://schemas.openxmlformats.org/officeDocument/2006/relationships" id="2147483649" r:id="R2adcd3391af8411a"/>
+    <p:sldLayoutId xmlns:r="http://schemas.openxmlformats.org/officeDocument/2006/relationships" id="2147483649" r:id="R74baee2083ca418f"/>
   </p:sldLayoutIdLst>
   <p:txStyles>
     <p:titleStyle>
@@ -2133,7 +2133,7 @@
           <p:nvPr/>
         </p:nvPicPr>
         <p:blipFill>
-          <a:blip xmlns:r="http://schemas.openxmlformats.org/officeDocument/2006/relationships" xmlns:a="http://schemas.openxmlformats.org/drawingml/2006/main" r:embed="R114c046f1a3a4679"/>
+          <a:blip xmlns:r="http://schemas.openxmlformats.org/officeDocument/2006/relationships" xmlns:a="http://schemas.openxmlformats.org/drawingml/2006/main" r:embed="Rb17b50a56e7e4e6b"/>
           <a:srcRect xmlns:a="http://schemas.openxmlformats.org/drawingml/2006/main" l="0" t="27" r="0" b="27"/>
           <a:stretch xmlns:a="http://schemas.openxmlformats.org/drawingml/2006/main">
             <a:fillRect l="0" t="0" r="0" b="0"/>
@@ -2781,13 +2781,13 @@
         </p:spPr>
         <p:txBody>
           <a:bodyPr xmlns:a="http://schemas.openxmlformats.org/drawingml/2006/main" anchor="t">
-            <a:normAutofit fontScale="94444"/>
-          </a:bodyPr>
-          <a:lstStyle xmlns:a="http://schemas.openxmlformats.org/drawingml/2006/main"/>
-          <a:p xmlns:a="http://schemas.openxmlformats.org/drawingml/2006/main">
-            <a:pPr algn="l">
-              <a:buNone/>
-              <a:defRPr sz="4050" b="1">
+            <a:normAutofit fontScale="69388"/>
+          </a:bodyPr>
+          <a:lstStyle xmlns:a="http://schemas.openxmlformats.org/drawingml/2006/main"/>
+          <a:p xmlns:a="http://schemas.openxmlformats.org/drawingml/2006/main">
+            <a:pPr algn="l">
+              <a:buNone/>
+              <a:defRPr sz="3675" b="1">
                 <a:solidFill>
                   <a:srgbClr val="FFFFFF"/>
                 </a:solidFill>
@@ -2797,7 +2797,7 @@
               </a:defRPr>
             </a:pPr>
             <a:r>
-              <a:rPr sz="4050" b="1">
+              <a:rPr sz="3675" b="1">
                 <a:solidFill>
                   <a:srgbClr val="FFFFFF"/>
                 </a:solidFill>
@@ -2805,13 +2805,13 @@
                 <a:ea typeface="Arial"/>
                 <a:cs typeface="Arial"/>
               </a:rPr>
-              <a:t>Find the gap.</a:t>
-            </a:r>
-          </a:p>
-          <a:p xmlns:a="http://schemas.openxmlformats.org/drawingml/2006/main">
-            <a:pPr algn="l">
-              <a:buNone/>
-              <a:defRPr sz="4050" b="1">
+              <a:t>See the wallet.</a:t>
+            </a:r>
+          </a:p>
+          <a:p xmlns:a="http://schemas.openxmlformats.org/drawingml/2006/main">
+            <a:pPr algn="l">
+              <a:buNone/>
+              <a:defRPr sz="3675" b="1">
                 <a:solidFill>
                   <a:srgbClr val="FFFFFF"/>
                 </a:solidFill>
@@ -2821,7 +2821,7 @@
               </a:defRPr>
             </a:pPr>
             <a:r>
-              <a:rPr sz="4050" b="1">
+              <a:rPr sz="3675" b="1">
                 <a:solidFill>
                   <a:srgbClr val="FFFFFF"/>
                 </a:solidFill>
@@ -2829,7 +2829,31 @@
                 <a:ea typeface="Arial"/>
                 <a:cs typeface="Arial"/>
               </a:rPr>
-              <a:t>Earn the right to act.</a:t>
+              <a:t>Size the gap.</a:t>
+            </a:r>
+          </a:p>
+          <a:p xmlns:a="http://schemas.openxmlformats.org/drawingml/2006/main">
+            <a:pPr algn="l">
+              <a:buNone/>
+              <a:defRPr sz="3675" b="1">
+                <a:solidFill>
+                  <a:srgbClr val="FFFFFF"/>
+                </a:solidFill>
+                <a:latin typeface="Arial"/>
+                <a:ea typeface="Arial"/>
+                <a:cs typeface="Arial"/>
+              </a:defRPr>
+            </a:pPr>
+            <a:r>
+              <a:rPr sz="3675" b="1">
+                <a:solidFill>
+                  <a:srgbClr val="FFFFFF"/>
+                </a:solidFill>
+                <a:latin typeface="Arial"/>
+                <a:ea typeface="Arial"/>
+                <a:cs typeface="Arial"/>
+              </a:rPr>
+              <a:t>Choose the conversation.</a:t>
             </a:r>
           </a:p>
         </p:txBody>
@@ -2864,13 +2888,13 @@
         </p:spPr>
         <p:txBody>
           <a:bodyPr xmlns:a="http://schemas.openxmlformats.org/drawingml/2006/main" anchor="t">
-            <a:normAutofit fontScale="100000"/>
-          </a:bodyPr>
-          <a:lstStyle xmlns:a="http://schemas.openxmlformats.org/drawingml/2006/main"/>
-          <a:p xmlns:a="http://schemas.openxmlformats.org/drawingml/2006/main">
-            <a:pPr algn="l">
-              <a:buNone/>
-              <a:defRPr sz="1800" b="0">
+            <a:normAutofit fontScale="99517"/>
+          </a:bodyPr>
+          <a:lstStyle xmlns:a="http://schemas.openxmlformats.org/drawingml/2006/main"/>
+          <a:p xmlns:a="http://schemas.openxmlformats.org/drawingml/2006/main">
+            <a:pPr algn="l">
+              <a:buNone/>
+              <a:defRPr sz="1725" b="0">
                 <a:solidFill>
                   <a:srgbClr val="C7D5E8"/>
                 </a:solidFill>
@@ -2880,7 +2904,7 @@
               </a:defRPr>
             </a:pPr>
             <a:r>
-              <a:rPr sz="1800" b="0">
+              <a:rPr sz="1725" b="0">
                 <a:solidFill>
                   <a:srgbClr val="C7D5E8"/>
                 </a:solidFill>
@@ -2888,7 +2912,7 @@
                 <a:ea typeface="Arial"/>
                 <a:cs typeface="Arial"/>
               </a:rPr>
-              <a:t>V3.2 combines a governed wallet interval, a relationship action and an executable proof of what may—and may not—be used.</a:t>
+              <a:t>The highest-value discovery starts with Glencore Trade Finance, then BHP. Eight priority conversations turn governed wallet intervals into a focused coverage plan.</a:t>
             </a:r>
           </a:p>
         </p:txBody>
@@ -3028,7 +3052,7 @@
                 <a:ea typeface="Arial"/>
                 <a:cs typeface="Arial"/>
               </a:rPr>
-              <a:t>Demonstrate the wallet</a:t>
+              <a:t>See the wallet</a:t>
             </a:r>
           </a:p>
         </p:txBody>
@@ -3087,7 +3111,7 @@
                 <a:ea typeface="Arial"/>
                 <a:cs typeface="Arial"/>
               </a:rPr>
-              <a:t>Twenty relationships × five products, approval-authoritative anchors, intervals and contestable gaps.</a:t>
+              <a:t>Twenty relationships × five products reveal where observed activity sits below a governed total-wallet interval.</a:t>
             </a:r>
           </a:p>
         </p:txBody>
@@ -3203,7 +3227,7 @@
         </p:spPr>
         <p:txBody>
           <a:bodyPr xmlns:a="http://schemas.openxmlformats.org/drawingml/2006/main" anchor="t">
-            <a:normAutofit fontScale="83711"/>
+            <a:normAutofit fontScale="100000"/>
           </a:bodyPr>
           <a:lstStyle xmlns:a="http://schemas.openxmlformats.org/drawingml/2006/main"/>
           <a:p xmlns:a="http://schemas.openxmlformats.org/drawingml/2006/main">
@@ -3227,7 +3251,7 @@
                 <a:ea typeface="Arial"/>
                 <a:cs typeface="Arial"/>
               </a:rPr>
-              <a:t>Run eight discovery conversations</a:t>
+              <a:t>Size the gap</a:t>
             </a:r>
           </a:p>
         </p:txBody>
@@ -3286,7 +3310,7 @@
                 <a:ea typeface="Arial"/>
                 <a:cs typeface="Arial"/>
               </a:rPr>
-              <a:t>Decision Twin adds stakeholder, business issue, bundle, timing, feasibility and the highest-VOI question.</a:t>
+              <a:t>Target-share scenarios convert the interval into contestable activity and transparent commercial value.</a:t>
             </a:r>
           </a:p>
         </p:txBody>
@@ -3426,7 +3450,7 @@
                 <a:ea typeface="Arial"/>
                 <a:cs typeface="Arial"/>
               </a:rPr>
-              <a:t>Earn the right to use it</a:t>
+              <a:t>Choose the conversation</a:t>
             </a:r>
           </a:p>
         </p:txBody>
@@ -3485,7 +3509,7 @@
                 <a:ea typeface="Arial"/>
                 <a:cs typeface="Arial"/>
               </a:rPr>
-              <a:t>Promotion Twin keeps signed rehearsal evidence separate from real bank authorization at every transition.</a:t>
+              <a:t>Stakeholder, issue, bundle, dated trigger, feasibility and the next-best question make the gap actionable.</a:t>
             </a:r>
           </a:p>
         </p:txBody>
@@ -3544,7 +3568,7 @@
                 <a:ea typeface="Arial"/>
                 <a:cs typeface="Arial"/>
               </a:rPr>
-              <a:t>Offline candidate validated; shadow promotion rehearsed. BANK_SHADOW_AUTHORIZED remains FALSE.</a:t>
+              <a:t>Hackathon ready. Real state OFFLINE_CANDIDATE; rehearsal SHADOW_READY; bank production NOT_PROMOTABLE.</a:t>
             </a:r>
           </a:p>
         </p:txBody>
@@ -7925,7 +7949,7 @@
         </p:xfrm>
         <a:graphic xmlns:a="http://schemas.openxmlformats.org/drawingml/2006/main">
           <a:graphicData uri="http://schemas.openxmlformats.org/drawingml/2006/chart">
-            <c:chart xmlns:r="http://schemas.openxmlformats.org/officeDocument/2006/relationships" xmlns:c="http://schemas.openxmlformats.org/drawingml/2006/chart" r:id="R78e6faa132074b5c"/>
+            <c:chart xmlns:r="http://schemas.openxmlformats.org/officeDocument/2006/relationships" xmlns:c="http://schemas.openxmlformats.org/drawingml/2006/chart" r:id="R3088939d94ae417c"/>
           </a:graphicData>
         </a:graphic>
       </p:graphicFrame>
@@ -8095,7 +8119,7 @@
                 <a:ea typeface="Arial"/>
                 <a:cs typeface="Arial"/>
               </a:rPr>
-              <a:t>THE 20 × 5 COMMERCIAL SURFACE</a:t>
+              <a:t>THE 20 × 5 COMMERCIAL SURFACE · TOP FIVE R 40,3M</a:t>
             </a:r>
           </a:p>
         </p:txBody>
@@ -8154,7 +8178,7 @@
                 <a:ea typeface="Arial"/>
                 <a:cs typeface="Arial"/>
               </a:rPr>
-              <a:t>One heatmap makes the latent opportunity actionable</a:t>
+              <a:t>Start with Glencore Trade Finance—then BHP</a:t>
             </a:r>
           </a:p>
         </p:txBody>
@@ -9400,7 +9424,7 @@
           <p:cNvPr id="69" name="">
             <a:extLst xmlns:a="http://schemas.openxmlformats.org/drawingml/2006/main">
               <a:ext uri="{FF2B5EF4-FFF2-40B4-BE49-F238E27FC236}">
-                <a16:creationId xmlns:a16="http://schemas.microsoft.com/office/drawing/2014/main" id="{75296C02-A961-4089-9C99-CEE3E99AC37E}"/>
+                <a16:creationId xmlns:a16="http://schemas.microsoft.com/office/drawing/2014/main" id="{94E996FD-5AB7-486E-A330-CBE6DB73B77E}"/>
               </a:ext>
             </a:extLst>
           </p:cNvPr>
@@ -9437,13 +9461,13 @@
           <p:nvPr/>
         </p:nvPicPr>
         <p:blipFill>
-          <a:blip xmlns:r="http://schemas.openxmlformats.org/officeDocument/2006/relationships" xmlns:a="http://schemas.openxmlformats.org/drawingml/2006/main" r:embed="R9e8bcd9831fb4436"/>
+          <a:blip xmlns:r="http://schemas.openxmlformats.org/officeDocument/2006/relationships" xmlns:a="http://schemas.openxmlformats.org/drawingml/2006/main" r:embed="Rcf9140ade0984810"/>
           <a:stretch xmlns:a="http://schemas.openxmlformats.org/drawingml/2006/main"/>
         </p:blipFill>
         <p:spPr>
           <a:xfrm xmlns:a="http://schemas.openxmlformats.org/drawingml/2006/main">
-            <a:off x="1991798" y="1524000"/>
-            <a:ext cx="8208404" cy="4762500"/>
+            <a:off x="2832472" y="1524000"/>
+            <a:ext cx="6527056" cy="4762500"/>
           </a:xfrm>
           <a:prstGeom xmlns:a="http://schemas.openxmlformats.org/drawingml/2006/main" prst="rect">
             <a:avLst/>
@@ -12972,7 +12996,7 @@
                 <a:ea typeface="Arial"/>
                 <a:cs typeface="Arial"/>
               </a:rPr>
-              <a:t>WHY NOW + WHAT TO ASK</a:t>
+              <a:t>WHY NOW: DATED EVENT + PREPARATION WINDOW</a:t>
             </a:r>
           </a:p>
         </p:txBody>
@@ -13053,7 +13077,7 @@
                 <a:ea typeface="Arial"/>
                 <a:cs typeface="Arial"/>
               </a:rPr>
-              <a:t>36.0%</a:t>
+              <a:t>14 AUG</a:t>
             </a:r>
           </a:p>
         </p:txBody>
@@ -13112,7 +13136,7 @@
                 <a:ea typeface="Arial"/>
                 <a:cs typeface="Arial"/>
               </a:rPr>
-              <a:t>90-day baseline</a:t>
+              <a:t>dated trade event</a:t>
             </a:r>
           </a:p>
         </p:txBody>
@@ -13171,7 +13195,7 @@
                 <a:ea typeface="Arial"/>
                 <a:cs typeface="Arial"/>
               </a:rPr>
-              <a:t>Transparent—not calibrated hazard</a:t>
+              <a:t>106 bank-observed trade events inside 90 days</a:t>
             </a:r>
           </a:p>
         </p:txBody>
@@ -13252,7 +13276,7 @@
                 <a:ea typeface="Arial"/>
                 <a:cs typeface="Arial"/>
               </a:rPr>
-              <a:t>1</a:t>
+              <a:t>45d</a:t>
             </a:r>
           </a:p>
         </p:txBody>
@@ -13311,7 +13335,7 @@
                 <a:ea typeface="Arial"/>
                 <a:cs typeface="Arial"/>
               </a:rPr>
-              <a:t>primary VOI question</a:t>
+              <a:t>preparation lead</a:t>
             </a:r>
           </a:p>
         </p:txBody>
@@ -13370,7 +13394,7 @@
                 <a:ea typeface="Arial"/>
                 <a:cs typeface="Arial"/>
               </a:rPr>
-              <a:t>Only if it can change the decision</a:t>
+              <a:t>Engagement window opens 30 June</a:t>
             </a:r>
           </a:p>
         </p:txBody>
@@ -14247,7 +14271,7 @@
                 <a:ea typeface="Arial"/>
                 <a:cs typeface="Arial"/>
               </a:rPr>
-              <a:t>3 / 3</a:t>
+              <a:t>8</a:t>
             </a:r>
           </a:p>
         </p:txBody>
@@ -14306,7 +14330,7 @@
                 <a:ea typeface="Arial"/>
                 <a:cs typeface="Arial"/>
               </a:rPr>
-              <a:t>showcase fallback briefs</a:t>
+              <a:t>accepted outputs</a:t>
             </a:r>
           </a:p>
         </p:txBody>
@@ -14365,7 +14389,7 @@
                 <a:ea typeface="Arial"/>
                 <a:cs typeface="Arial"/>
               </a:rPr>
-              <a:t>BHP · Glencore · Shoprite; deterministic and validated</a:t>
+              <a:t>9 targets · all three showcase clients covered</a:t>
             </a:r>
           </a:p>
         </p:txBody>
@@ -14446,7 +14470,7 @@
                 <a:ea typeface="Arial"/>
                 <a:cs typeface="Arial"/>
               </a:rPr>
-              <a:t>9</a:t>
+              <a:t>3</a:t>
             </a:r>
           </a:p>
         </p:txBody>
@@ -14505,7 +14529,7 @@
                 <a:ea typeface="Arial"/>
                 <a:cs typeface="Arial"/>
               </a:rPr>
-              <a:t>comparative target runs</a:t>
+              <a:t>providers accepted</a:t>
             </a:r>
           </a:p>
         </p:txBody>
@@ -14564,7 +14588,7 @@
                 <a:ea typeface="Arial"/>
                 <a:cs typeface="Arial"/>
               </a:rPr>
-              <a:t>OpenAI · Anthropic · Google × three clients</a:t>
+              <a:t>OpenAI · Anthropic · Google; exact pinned models</a:t>
             </a:r>
           </a:p>
         </p:txBody>
@@ -14645,7 +14669,7 @@
                 <a:ea typeface="Arial"/>
                 <a:cs typeface="Arial"/>
               </a:rPr>
-              <a:t>0</a:t>
+              <a:t>1</a:t>
             </a:r>
           </a:p>
         </p:txBody>
@@ -14704,7 +14728,7 @@
                 <a:ea typeface="Arial"/>
                 <a:cs typeface="Arial"/>
               </a:rPr>
-              <a:t>live runs executed</a:t>
+              <a:t>unsafe output blocked</a:t>
             </a:r>
           </a:p>
         </p:txBody>
@@ -14763,7 +14787,7 @@
                 <a:ea typeface="Arial"/>
                 <a:cs typeface="Arial"/>
               </a:rPr>
-              <a:t>Fresh rotated credentials and acknowledgement absent</a:t>
+              <a:t>Claim compiler rejected before publication; fallback retained</a:t>
             </a:r>
           </a:p>
         </p:txBody>
@@ -14945,7 +14969,7 @@
                 <a:ea typeface="Arial"/>
                 <a:cs typeface="Arial"/>
               </a:rPr>
-              <a:t>Resolve exact provider model; no silent substitution</a:t>
+              <a:t>BHP · OpenAI gpt-5.6-sol · accepted</a:t>
             </a:r>
           </a:p>
         </p:txBody>
@@ -15037,7 +15061,7 @@
                 <a:ea typeface="Arial"/>
                 <a:cs typeface="Arial"/>
               </a:rPr>
-              <a:t>Send approved public evidence + minimal synthetic aggregates only</a:t>
+              <a:t>Glencore · Anthropic claude-sonnet-5 · accepted</a:t>
             </a:r>
           </a:p>
         </p:txBody>
@@ -15129,7 +15153,7 @@
                 <a:ea typeface="Arial"/>
                 <a:cs typeface="Arial"/>
               </a:rPr>
-              <a:t>Validate schema, every number, sign, currency and citation</a:t>
+              <a:t>Shoprite · Google gemini-3.6-flash · accepted</a:t>
             </a:r>
           </a:p>
         </p:txBody>
@@ -15221,7 +15245,7 @@
                 <a:ea typeface="Arial"/>
                 <a:cs typeface="Arial"/>
               </a:rPr>
-              <a:t>Provider failure returns the deterministic brief</a:t>
+              <a:t>One Anthropic/BHP output blocked; deterministic fallback retained</a:t>
             </a:r>
           </a:p>
         </p:txBody>
@@ -15346,55 +15370,55 @@
         </p:spPr>
         <p:txBody>
           <a:bodyPr xmlns:a="http://schemas.openxmlformats.org/drawingml/2006/main" anchor="t">
-            <a:normAutofit fontScale="90112"/>
-          </a:bodyPr>
-          <a:lstStyle xmlns:a="http://schemas.openxmlformats.org/drawingml/2006/main"/>
-          <a:p xmlns:a="http://schemas.openxmlformats.org/drawingml/2006/main">
-            <a:pPr algn="l">
-              <a:buNone/>
-              <a:defRPr sz="2100" b="1">
-                <a:solidFill>
-                  <a:srgbClr val="0C1728"/>
-                </a:solidFill>
-                <a:latin typeface="Arial"/>
-                <a:ea typeface="Arial"/>
-                <a:cs typeface="Arial"/>
-              </a:defRPr>
-            </a:pPr>
-            <a:r>
-              <a:rPr sz="2100" b="1">
-                <a:solidFill>
-                  <a:srgbClr val="0C1728"/>
-                </a:solidFill>
-                <a:latin typeface="Arial"/>
-                <a:ea typeface="Arial"/>
-                <a:cs typeface="Arial"/>
-              </a:rPr>
-              <a:t>Strong mechanics,</a:t>
-            </a:r>
-          </a:p>
-          <a:p xmlns:a="http://schemas.openxmlformats.org/drawingml/2006/main">
-            <a:pPr algn="l">
-              <a:buNone/>
-              <a:defRPr sz="2100" b="1">
-                <a:solidFill>
-                  <a:srgbClr val="0C1728"/>
-                </a:solidFill>
-                <a:latin typeface="Arial"/>
-                <a:ea typeface="Arial"/>
-                <a:cs typeface="Arial"/>
-              </a:defRPr>
-            </a:pPr>
-            <a:r>
-              <a:rPr sz="2100" b="1">
-                <a:solidFill>
-                  <a:srgbClr val="0C1728"/>
-                </a:solidFill>
-                <a:latin typeface="Arial"/>
-                <a:ea typeface="Arial"/>
-                <a:cs typeface="Arial"/>
-              </a:rPr>
-              <a:t>not empirical E3 accuracy</a:t>
+            <a:normAutofit fontScale="100000"/>
+          </a:bodyPr>
+          <a:lstStyle xmlns:a="http://schemas.openxmlformats.org/drawingml/2006/main"/>
+          <a:p xmlns:a="http://schemas.openxmlformats.org/drawingml/2006/main">
+            <a:pPr algn="l">
+              <a:buNone/>
+              <a:defRPr sz="1950" b="1">
+                <a:solidFill>
+                  <a:srgbClr val="0F1F33"/>
+                </a:solidFill>
+                <a:latin typeface="Arial"/>
+                <a:ea typeface="Arial"/>
+                <a:cs typeface="Arial"/>
+              </a:defRPr>
+            </a:pPr>
+            <a:r>
+              <a:rPr sz="1950" b="1">
+                <a:solidFill>
+                  <a:srgbClr val="0F1F33"/>
+                </a:solidFill>
+                <a:latin typeface="Arial"/>
+                <a:ea typeface="Arial"/>
+                <a:cs typeface="Arial"/>
+              </a:rPr>
+              <a:t>8 accepted;</a:t>
+            </a:r>
+          </a:p>
+          <a:p xmlns:a="http://schemas.openxmlformats.org/drawingml/2006/main">
+            <a:pPr algn="l">
+              <a:buNone/>
+              <a:defRPr sz="1950" b="1">
+                <a:solidFill>
+                  <a:srgbClr val="0F1F33"/>
+                </a:solidFill>
+                <a:latin typeface="Arial"/>
+                <a:ea typeface="Arial"/>
+                <a:cs typeface="Arial"/>
+              </a:defRPr>
+            </a:pPr>
+            <a:r>
+              <a:rPr sz="1950" b="1">
+                <a:solidFill>
+                  <a:srgbClr val="0F1F33"/>
+                </a:solidFill>
+                <a:latin typeface="Arial"/>
+                <a:ea typeface="Arial"/>
+                <a:cs typeface="Arial"/>
+              </a:rPr>
+              <a:t>one blocked safely</a:t>
             </a:r>
           </a:p>
         </p:txBody>
@@ -15429,7 +15453,7 @@
         </p:spPr>
         <p:txBody>
           <a:bodyPr xmlns:a="http://schemas.openxmlformats.org/drawingml/2006/main" anchor="t">
-            <a:normAutofit fontScale="88889"/>
+            <a:normAutofit fontScale="66667"/>
           </a:bodyPr>
           <a:lstStyle xmlns:a="http://schemas.openxmlformats.org/drawingml/2006/main"/>
           <a:p xmlns:a="http://schemas.openxmlformats.org/drawingml/2006/main">
@@ -15453,7 +15477,7 @@
                 <a:ea typeface="Arial"/>
                 <a:cs typeface="Arial"/>
               </a:rPr>
-              <a:t>The report records all nine runs as NOT_EXECUTED. It will not present provider access failure as successful evaluation.</a:t>
+              <a:t>Every accepted output passed schema, number, sign, currency, citation, abstention and unsupported-claim checks. This is hackathon external-provider evaluation—not bank-authorized LIVE_GENAI.</a:t>
             </a:r>
           </a:p>
         </p:txBody>
@@ -15534,7 +15558,7 @@
                 <a:ea typeface="Arial"/>
                 <a:cs typeface="Arial"/>
               </a:rPr>
-              <a:t>PROMOTION READINESS TWIN</a:t>
+              <a:t>ANALYTICAL TRUST + PROMOTION BOUNDARY</a:t>
             </a:r>
           </a:p>
         </p:txBody>
@@ -15593,7 +15617,7 @@
                 <a:ea typeface="Arial"/>
                 <a:cs typeface="Arial"/>
               </a:rPr>
-              <a:t>The machinery is ready; bank authority is not</a:t>
+              <a:t>Trade Finance stays first; the portfolio mix still moves</a:t>
             </a:r>
           </a:p>
         </p:txBody>
@@ -16033,7 +16057,7 @@
                 <a:ea typeface="Arial"/>
                 <a:cs typeface="Arial"/>
               </a:rPr>
-              <a:t>Offline</a:t>
+              <a:t>Stress</a:t>
             </a:r>
           </a:p>
         </p:txBody>
@@ -16068,7 +16092,7 @@
         </p:spPr>
         <p:txBody>
           <a:bodyPr xmlns:a="http://schemas.openxmlformats.org/drawingml/2006/main" anchor="t">
-            <a:normAutofit fontScale="81391"/>
+            <a:normAutofit fontScale="100000"/>
           </a:bodyPr>
           <a:lstStyle xmlns:a="http://schemas.openxmlformats.org/drawingml/2006/main"/>
           <a:p xmlns:a="http://schemas.openxmlformats.org/drawingml/2006/main">
@@ -16092,7 +16116,7 @@
                 <a:ea typeface="Arial"/>
                 <a:cs typeface="Arial"/>
               </a:rPr>
-              <a:t>Reproducible candidate and claim boundaries</a:t>
+              <a:t>10,000 correlated scenario draws</a:t>
             </a:r>
           </a:p>
         </p:txBody>
@@ -16245,7 +16269,7 @@
                 <a:ea typeface="Arial"/>
                 <a:cs typeface="Arial"/>
               </a:rPr>
-              <a:t>Shadow</a:t>
+              <a:t>Prior</a:t>
             </a:r>
           </a:p>
         </p:txBody>
@@ -16280,7 +16304,7 @@
         </p:spPr>
         <p:txBody>
           <a:bodyPr xmlns:a="http://schemas.openxmlformats.org/drawingml/2006/main" anchor="t">
-            <a:normAutofit fontScale="75772"/>
+            <a:normAutofit fontScale="100000"/>
           </a:bodyPr>
           <a:lstStyle xmlns:a="http://schemas.openxmlformats.org/drawingml/2006/main"/>
           <a:p xmlns:a="http://schemas.openxmlformats.org/drawingml/2006/main">
@@ -16304,7 +16328,7 @@
                 <a:ea typeface="Arial"/>
                 <a:cs typeface="Arial"/>
               </a:rPr>
-              <a:t>Hidden bank run; missing capabilities fail closed</a:t>
+              <a:t>E1 weight 0.20 / 0.35 / 0.50</a:t>
             </a:r>
           </a:p>
         </p:txBody>
@@ -16457,7 +16481,7 @@
                 <a:ea typeface="Arial"/>
                 <a:cs typeface="Arial"/>
               </a:rPr>
-              <a:t>Pilot</a:t>
+              <a:t>Coverage</a:t>
             </a:r>
           </a:p>
         </p:txBody>
@@ -16492,7 +16516,7 @@
         </p:spPr>
         <p:txBody>
           <a:bodyPr xmlns:a="http://schemas.openxmlformats.org/drawingml/2006/main" anchor="t">
-            <a:normAutofit fontScale="73611"/>
+            <a:normAutofit fontScale="100000"/>
           </a:bodyPr>
           <a:lstStyle xmlns:a="http://schemas.openxmlformats.org/drawingml/2006/main"/>
           <a:p xmlns:a="http://schemas.openxmlformats.org/drawingml/2006/main">
@@ -16516,7 +16540,7 @@
                 <a:ea typeface="Arial"/>
                 <a:cs typeface="Arial"/>
               </a:rPr>
-              <a:t>Thirty real days + approved evidence and cohort</a:t>
+              <a:t>Known-truth only; no E3 claim</a:t>
             </a:r>
           </a:p>
         </p:txBody>
@@ -16669,7 +16693,7 @@
                 <a:ea typeface="Arial"/>
                 <a:cs typeface="Arial"/>
               </a:rPr>
-              <a:t>Scale</a:t>
+              <a:t>Selection</a:t>
             </a:r>
           </a:p>
         </p:txBody>
@@ -16704,7 +16728,7 @@
         </p:spPr>
         <p:txBody>
           <a:bodyPr xmlns:a="http://schemas.openxmlformats.org/drawingml/2006/main" anchor="t">
-            <a:normAutofit fontScale="75828"/>
+            <a:normAutofit fontScale="88072"/>
           </a:bodyPr>
           <a:lstStyle xmlns:a="http://schemas.openxmlformats.org/drawingml/2006/main"/>
           <a:p xmlns:a="http://schemas.openxmlformats.org/drawingml/2006/main">
@@ -16728,7 +16752,7 @@
                 <a:ea typeface="Arial"/>
                 <a:cs typeface="Arial"/>
               </a:rPr>
-              <a:t>Bank-attested pilot, operations and approvals</a:t>
+              <a:t>Top-eight composition is not invariant</a:t>
             </a:r>
           </a:p>
         </p:txBody>
@@ -16881,7 +16905,7 @@
                 <a:ea typeface="Arial"/>
                 <a:cs typeface="Arial"/>
               </a:rPr>
-              <a:t>Causal</a:t>
+              <a:t>Permission</a:t>
             </a:r>
           </a:p>
         </p:txBody>
@@ -16916,7 +16940,7 @@
         </p:spPr>
         <p:txBody>
           <a:bodyPr xmlns:a="http://schemas.openxmlformats.org/drawingml/2006/main" anchor="t">
-            <a:normAutofit fontScale="73611"/>
+            <a:normAutofit fontScale="88916"/>
           </a:bodyPr>
           <a:lstStyle xmlns:a="http://schemas.openxmlformats.org/drawingml/2006/main"/>
           <a:p xmlns:a="http://schemas.openxmlformats.org/drawingml/2006/main">
@@ -16940,7 +16964,8 @@
                 <a:ea typeface="Arial"/>
                 <a:cs typeface="Arial"/>
               </a:rPr>
-              <a:t>Positive independently validated randomized evidence</a:t>
+              <a:t>Real: OFFLINE
+Rehearsal: SHADOW</a:t>
             </a:r>
           </a:p>
         </p:txBody>
@@ -17021,7 +17046,7 @@
                 <a:ea typeface="Arial"/>
                 <a:cs typeface="Arial"/>
               </a:rPr>
-              <a:t>30</a:t>
+              <a:t>10k</a:t>
             </a:r>
           </a:p>
         </p:txBody>
@@ -17080,7 +17105,7 @@
                 <a:ea typeface="Arial"/>
                 <a:cs typeface="Arial"/>
               </a:rPr>
-              <a:t>governed gates</a:t>
+              <a:t>scenario draws</a:t>
             </a:r>
           </a:p>
         </p:txBody>
@@ -17139,7 +17164,7 @@
                 <a:ea typeface="Arial"/>
                 <a:cs typeface="Arial"/>
               </a:rPr>
-              <a:t>Every gate has REAL + REHEARSAL outcomes</a:t>
+              <a:t>Rates, wallet, share and commercial inputs</a:t>
             </a:r>
           </a:p>
         </p:txBody>
@@ -17279,7 +17304,7 @@
                 <a:ea typeface="Arial"/>
                 <a:cs typeface="Arial"/>
               </a:rPr>
-              <a:t>PMR</a:t>
+              <a:t>TF first-ranked</a:t>
             </a:r>
           </a:p>
         </p:txBody>
@@ -17338,7 +17363,7 @@
                 <a:ea typeface="Arial"/>
                 <a:cs typeface="Arial"/>
               </a:rPr>
-              <a:t>Signed positive and failure-path rehearsal</a:t>
+              <a:t>Global sensitivity—not a hard-coded winner</a:t>
             </a:r>
           </a:p>
         </p:txBody>
@@ -17419,7 +17444,7 @@
                 <a:ea typeface="Arial"/>
                 <a:cs typeface="Arial"/>
               </a:rPr>
-              <a:t>0%</a:t>
+              <a:t>87.8%</a:t>
             </a:r>
           </a:p>
         </p:txBody>
@@ -17478,7 +17503,7 @@
                 <a:ea typeface="Arial"/>
                 <a:cs typeface="Arial"/>
               </a:rPr>
-              <a:t>BER</a:t>
+              <a:t>TF majority dominance</a:t>
             </a:r>
           </a:p>
         </p:txBody>
@@ -17537,7 +17562,7 @@
                 <a:ea typeface="Arial"/>
                 <a:cs typeface="Arial"/>
               </a:rPr>
-              <a:t>Synthetic evidence contributes zero</a:t>
+              <a:t>Absolute economics still varies materially</a:t>
             </a:r>
           </a:p>
         </p:txBody>
@@ -17736,7 +17761,7 @@
                 <a:ea typeface="Arial"/>
                 <a:cs typeface="Arial"/>
               </a:rPr>
-              <a:t>30 clean virtual days are kept separate</a:t>
+              <a:t>PMR 100% · BER 0% · rehearsed only to SHADOW_READY</a:t>
             </a:r>
           </a:p>
         </p:txBody>

</xml_diff>

<commit_message>
Refresh V3.2 judging artifacts
</commit_message>
<xml_diff>
--- a/output/presentation/Corporate-Wallet-Digital-Twin.pptx
+++ b/output/presentation/Corporate-Wallet-Digital-Twin.pptx
@@ -2,22 +2,22 @@
 <file path=ppt/presentation.xml><?xml version="1.0" encoding="utf-8"?>
 <p:presentation xmlns:p="http://schemas.openxmlformats.org/presentationml/2006/main">
   <p:sldMasterIdLst>
-    <p:sldMasterId xmlns:r="http://schemas.openxmlformats.org/officeDocument/2006/relationships" id="2147483648" r:id="Rfba6974e4c4c4fa4"/>
+    <p:sldMasterId xmlns:r="http://schemas.openxmlformats.org/officeDocument/2006/relationships" id="2147483648" r:id="R41e176d33f9a44dc"/>
   </p:sldMasterIdLst>
   <p:notesMasterIdLst>
-    <p:notesMasterId xmlns:r="http://schemas.openxmlformats.org/officeDocument/2006/relationships" r:id="Rbf9eb69e0a834496"/>
+    <p:notesMasterId xmlns:r="http://schemas.openxmlformats.org/officeDocument/2006/relationships" r:id="Rf68d8c0233114849"/>
   </p:notesMasterIdLst>
   <p:sldIdLst>
-    <p:sldId xmlns:r="http://schemas.openxmlformats.org/officeDocument/2006/relationships" id="256" r:id="R3f1580f4819b452a"/>
-    <p:sldId xmlns:r="http://schemas.openxmlformats.org/officeDocument/2006/relationships" id="257" r:id="R55cdc9389674471e"/>
-    <p:sldId xmlns:r="http://schemas.openxmlformats.org/officeDocument/2006/relationships" id="258" r:id="Rb36e15e577374d5a"/>
-    <p:sldId xmlns:r="http://schemas.openxmlformats.org/officeDocument/2006/relationships" id="259" r:id="R7610d25a9bf64339"/>
-    <p:sldId xmlns:r="http://schemas.openxmlformats.org/officeDocument/2006/relationships" id="260" r:id="R670cd8c516514b41"/>
-    <p:sldId xmlns:r="http://schemas.openxmlformats.org/officeDocument/2006/relationships" id="261" r:id="Re487e91c44f04069"/>
-    <p:sldId xmlns:r="http://schemas.openxmlformats.org/officeDocument/2006/relationships" id="262" r:id="Rc88afbe28bf4489c"/>
-    <p:sldId xmlns:r="http://schemas.openxmlformats.org/officeDocument/2006/relationships" id="263" r:id="R8b40d1a1c6ef4a3e"/>
-    <p:sldId xmlns:r="http://schemas.openxmlformats.org/officeDocument/2006/relationships" id="264" r:id="Ra3073549928f4262"/>
-    <p:sldId xmlns:r="http://schemas.openxmlformats.org/officeDocument/2006/relationships" id="265" r:id="R42bcae98151b446b"/>
+    <p:sldId xmlns:r="http://schemas.openxmlformats.org/officeDocument/2006/relationships" id="256" r:id="R8f19caa7701f485c"/>
+    <p:sldId xmlns:r="http://schemas.openxmlformats.org/officeDocument/2006/relationships" id="257" r:id="R5b80215faac84646"/>
+    <p:sldId xmlns:r="http://schemas.openxmlformats.org/officeDocument/2006/relationships" id="258" r:id="R00aabe1328104090"/>
+    <p:sldId xmlns:r="http://schemas.openxmlformats.org/officeDocument/2006/relationships" id="259" r:id="Rfb0038dbd3254154"/>
+    <p:sldId xmlns:r="http://schemas.openxmlformats.org/officeDocument/2006/relationships" id="260" r:id="R57e7bbb672524d4c"/>
+    <p:sldId xmlns:r="http://schemas.openxmlformats.org/officeDocument/2006/relationships" id="261" r:id="R91b3fab0f866425d"/>
+    <p:sldId xmlns:r="http://schemas.openxmlformats.org/officeDocument/2006/relationships" id="262" r:id="Rb7f68c577d16481f"/>
+    <p:sldId xmlns:r="http://schemas.openxmlformats.org/officeDocument/2006/relationships" id="263" r:id="Rda964d7abb084bd3"/>
+    <p:sldId xmlns:r="http://schemas.openxmlformats.org/officeDocument/2006/relationships" id="264" r:id="R4eb42a67b1e24e79"/>
+    <p:sldId xmlns:r="http://schemas.openxmlformats.org/officeDocument/2006/relationships" id="265" r:id="R843b5f20c06049fa"/>
   </p:sldIdLst>
   <p:sldSz cx="12192000" cy="6858000"/>
   <p:notesSz cx="6858000" cy="9144000"/>
@@ -1419,7 +1419,7 @@
   </p:cSld>
   <p:clrMap bg1="lt1" tx1="dk1" bg2="lt2" tx2="dk2" accent1="accent1" accent2="accent2" accent3="accent3" accent4="accent4" accent5="accent5" accent6="accent6" hlink="hlink" folHlink="folHlink"/>
   <p:sldLayoutIdLst>
-    <p:sldLayoutId xmlns:r="http://schemas.openxmlformats.org/officeDocument/2006/relationships" id="2147483649" r:id="R74baee2083ca418f"/>
+    <p:sldLayoutId xmlns:r="http://schemas.openxmlformats.org/officeDocument/2006/relationships" id="2147483649" r:id="R94c17a59446c487f"/>
   </p:sldLayoutIdLst>
   <p:txStyles>
     <p:titleStyle>
@@ -2133,7 +2133,7 @@
           <p:nvPr/>
         </p:nvPicPr>
         <p:blipFill>
-          <a:blip xmlns:r="http://schemas.openxmlformats.org/officeDocument/2006/relationships" xmlns:a="http://schemas.openxmlformats.org/drawingml/2006/main" r:embed="Rb17b50a56e7e4e6b"/>
+          <a:blip xmlns:r="http://schemas.openxmlformats.org/officeDocument/2006/relationships" xmlns:a="http://schemas.openxmlformats.org/drawingml/2006/main" r:embed="R6cac87ac61984576"/>
           <a:srcRect xmlns:a="http://schemas.openxmlformats.org/drawingml/2006/main" l="0" t="27" r="0" b="27"/>
           <a:stretch xmlns:a="http://schemas.openxmlformats.org/drawingml/2006/main">
             <a:fillRect l="0" t="0" r="0" b="0"/>
@@ -7949,7 +7949,7 @@
         </p:xfrm>
         <a:graphic xmlns:a="http://schemas.openxmlformats.org/drawingml/2006/main">
           <a:graphicData uri="http://schemas.openxmlformats.org/drawingml/2006/chart">
-            <c:chart xmlns:r="http://schemas.openxmlformats.org/officeDocument/2006/relationships" xmlns:c="http://schemas.openxmlformats.org/drawingml/2006/chart" r:id="R3088939d94ae417c"/>
+            <c:chart xmlns:r="http://schemas.openxmlformats.org/officeDocument/2006/relationships" xmlns:c="http://schemas.openxmlformats.org/drawingml/2006/chart" r:id="Rcb925b2aaca24109"/>
           </a:graphicData>
         </a:graphic>
       </p:graphicFrame>
@@ -9424,7 +9424,7 @@
           <p:cNvPr id="69" name="">
             <a:extLst xmlns:a="http://schemas.openxmlformats.org/drawingml/2006/main">
               <a:ext uri="{FF2B5EF4-FFF2-40B4-BE49-F238E27FC236}">
-                <a16:creationId xmlns:a16="http://schemas.microsoft.com/office/drawing/2014/main" id="{94E996FD-5AB7-486E-A330-CBE6DB73B77E}"/>
+                <a16:creationId xmlns:a16="http://schemas.microsoft.com/office/drawing/2014/main" id="{0D80A9EB-5F43-4B15-997D-8FDC2BD7E920}"/>
               </a:ext>
             </a:extLst>
           </p:cNvPr>
@@ -9461,7 +9461,7 @@
           <p:nvPr/>
         </p:nvPicPr>
         <p:blipFill>
-          <a:blip xmlns:r="http://schemas.openxmlformats.org/officeDocument/2006/relationships" xmlns:a="http://schemas.openxmlformats.org/drawingml/2006/main" r:embed="Rcf9140ade0984810"/>
+          <a:blip xmlns:r="http://schemas.openxmlformats.org/officeDocument/2006/relationships" xmlns:a="http://schemas.openxmlformats.org/drawingml/2006/main" r:embed="Rcea370989460492f"/>
           <a:stretch xmlns:a="http://schemas.openxmlformats.org/drawingml/2006/main"/>
         </p:blipFill>
         <p:spPr>

</xml_diff>

<commit_message>
Bind V3.2 artifacts to final status authority
</commit_message>
<xml_diff>
--- a/output/presentation/Corporate-Wallet-Digital-Twin.pptx
+++ b/output/presentation/Corporate-Wallet-Digital-Twin.pptx
@@ -2,22 +2,22 @@
 <file path=ppt/presentation.xml><?xml version="1.0" encoding="utf-8"?>
 <p:presentation xmlns:p="http://schemas.openxmlformats.org/presentationml/2006/main">
   <p:sldMasterIdLst>
-    <p:sldMasterId xmlns:r="http://schemas.openxmlformats.org/officeDocument/2006/relationships" id="2147483648" r:id="R41e176d33f9a44dc"/>
+    <p:sldMasterId xmlns:r="http://schemas.openxmlformats.org/officeDocument/2006/relationships" id="2147483648" r:id="R82732dccf6424cda"/>
   </p:sldMasterIdLst>
   <p:notesMasterIdLst>
-    <p:notesMasterId xmlns:r="http://schemas.openxmlformats.org/officeDocument/2006/relationships" r:id="Rf68d8c0233114849"/>
+    <p:notesMasterId xmlns:r="http://schemas.openxmlformats.org/officeDocument/2006/relationships" r:id="Rd0b20c0051544ab5"/>
   </p:notesMasterIdLst>
   <p:sldIdLst>
-    <p:sldId xmlns:r="http://schemas.openxmlformats.org/officeDocument/2006/relationships" id="256" r:id="R8f19caa7701f485c"/>
-    <p:sldId xmlns:r="http://schemas.openxmlformats.org/officeDocument/2006/relationships" id="257" r:id="R5b80215faac84646"/>
-    <p:sldId xmlns:r="http://schemas.openxmlformats.org/officeDocument/2006/relationships" id="258" r:id="R00aabe1328104090"/>
-    <p:sldId xmlns:r="http://schemas.openxmlformats.org/officeDocument/2006/relationships" id="259" r:id="Rfb0038dbd3254154"/>
-    <p:sldId xmlns:r="http://schemas.openxmlformats.org/officeDocument/2006/relationships" id="260" r:id="R57e7bbb672524d4c"/>
-    <p:sldId xmlns:r="http://schemas.openxmlformats.org/officeDocument/2006/relationships" id="261" r:id="R91b3fab0f866425d"/>
-    <p:sldId xmlns:r="http://schemas.openxmlformats.org/officeDocument/2006/relationships" id="262" r:id="Rb7f68c577d16481f"/>
-    <p:sldId xmlns:r="http://schemas.openxmlformats.org/officeDocument/2006/relationships" id="263" r:id="Rda964d7abb084bd3"/>
-    <p:sldId xmlns:r="http://schemas.openxmlformats.org/officeDocument/2006/relationships" id="264" r:id="R4eb42a67b1e24e79"/>
-    <p:sldId xmlns:r="http://schemas.openxmlformats.org/officeDocument/2006/relationships" id="265" r:id="R843b5f20c06049fa"/>
+    <p:sldId xmlns:r="http://schemas.openxmlformats.org/officeDocument/2006/relationships" id="256" r:id="Ra577374cd3a74aff"/>
+    <p:sldId xmlns:r="http://schemas.openxmlformats.org/officeDocument/2006/relationships" id="257" r:id="Ra4d140331edd420a"/>
+    <p:sldId xmlns:r="http://schemas.openxmlformats.org/officeDocument/2006/relationships" id="258" r:id="Rf16ed209dae64cb0"/>
+    <p:sldId xmlns:r="http://schemas.openxmlformats.org/officeDocument/2006/relationships" id="259" r:id="Raf3d489d64454e8e"/>
+    <p:sldId xmlns:r="http://schemas.openxmlformats.org/officeDocument/2006/relationships" id="260" r:id="Rd28acddfc6a241de"/>
+    <p:sldId xmlns:r="http://schemas.openxmlformats.org/officeDocument/2006/relationships" id="261" r:id="R216f3802d09449af"/>
+    <p:sldId xmlns:r="http://schemas.openxmlformats.org/officeDocument/2006/relationships" id="262" r:id="R48c5ecbf9ee1434e"/>
+    <p:sldId xmlns:r="http://schemas.openxmlformats.org/officeDocument/2006/relationships" id="263" r:id="R764cd42fda91495a"/>
+    <p:sldId xmlns:r="http://schemas.openxmlformats.org/officeDocument/2006/relationships" id="264" r:id="Rea4b518840e246a7"/>
+    <p:sldId xmlns:r="http://schemas.openxmlformats.org/officeDocument/2006/relationships" id="265" r:id="R481498fba67a4289"/>
   </p:sldIdLst>
   <p:sldSz cx="12192000" cy="6858000"/>
   <p:notesSz cx="6858000" cy="9144000"/>
@@ -1419,7 +1419,7 @@
   </p:cSld>
   <p:clrMap bg1="lt1" tx1="dk1" bg2="lt2" tx2="dk2" accent1="accent1" accent2="accent2" accent3="accent3" accent4="accent4" accent5="accent5" accent6="accent6" hlink="hlink" folHlink="folHlink"/>
   <p:sldLayoutIdLst>
-    <p:sldLayoutId xmlns:r="http://schemas.openxmlformats.org/officeDocument/2006/relationships" id="2147483649" r:id="R94c17a59446c487f"/>
+    <p:sldLayoutId xmlns:r="http://schemas.openxmlformats.org/officeDocument/2006/relationships" id="2147483649" r:id="Rb3a8422ea58248c6"/>
   </p:sldLayoutIdLst>
   <p:txStyles>
     <p:titleStyle>
@@ -2133,7 +2133,7 @@
           <p:nvPr/>
         </p:nvPicPr>
         <p:blipFill>
-          <a:blip xmlns:r="http://schemas.openxmlformats.org/officeDocument/2006/relationships" xmlns:a="http://schemas.openxmlformats.org/drawingml/2006/main" r:embed="R6cac87ac61984576"/>
+          <a:blip xmlns:r="http://schemas.openxmlformats.org/officeDocument/2006/relationships" xmlns:a="http://schemas.openxmlformats.org/drawingml/2006/main" r:embed="R8de8d40740a94c6e"/>
           <a:srcRect xmlns:a="http://schemas.openxmlformats.org/drawingml/2006/main" l="0" t="27" r="0" b="27"/>
           <a:stretch xmlns:a="http://schemas.openxmlformats.org/drawingml/2006/main">
             <a:fillRect l="0" t="0" r="0" b="0"/>
@@ -7949,7 +7949,7 @@
         </p:xfrm>
         <a:graphic xmlns:a="http://schemas.openxmlformats.org/drawingml/2006/main">
           <a:graphicData uri="http://schemas.openxmlformats.org/drawingml/2006/chart">
-            <c:chart xmlns:r="http://schemas.openxmlformats.org/officeDocument/2006/relationships" xmlns:c="http://schemas.openxmlformats.org/drawingml/2006/chart" r:id="Rcb925b2aaca24109"/>
+            <c:chart xmlns:r="http://schemas.openxmlformats.org/officeDocument/2006/relationships" xmlns:c="http://schemas.openxmlformats.org/drawingml/2006/chart" r:id="R04187bd6f24b4cd4"/>
           </a:graphicData>
         </a:graphic>
       </p:graphicFrame>
@@ -9424,7 +9424,7 @@
           <p:cNvPr id="69" name="">
             <a:extLst xmlns:a="http://schemas.openxmlformats.org/drawingml/2006/main">
               <a:ext uri="{FF2B5EF4-FFF2-40B4-BE49-F238E27FC236}">
-                <a16:creationId xmlns:a16="http://schemas.microsoft.com/office/drawing/2014/main" id="{0D80A9EB-5F43-4B15-997D-8FDC2BD7E920}"/>
+                <a16:creationId xmlns:a16="http://schemas.microsoft.com/office/drawing/2014/main" id="{8F529834-8FB2-4B28-859C-EA76E90858B0}"/>
               </a:ext>
             </a:extLst>
           </p:cNvPr>
@@ -9461,7 +9461,7 @@
           <p:nvPr/>
         </p:nvPicPr>
         <p:blipFill>
-          <a:blip xmlns:r="http://schemas.openxmlformats.org/officeDocument/2006/relationships" xmlns:a="http://schemas.openxmlformats.org/drawingml/2006/main" r:embed="Rcea370989460492f"/>
+          <a:blip xmlns:r="http://schemas.openxmlformats.org/officeDocument/2006/relationships" xmlns:a="http://schemas.openxmlformats.org/drawingml/2006/main" r:embed="R42dd32943a8e47c5"/>
           <a:stretch xmlns:a="http://schemas.openxmlformats.org/drawingml/2006/main"/>
         </p:blipFill>
         <p:spPr>

</xml_diff>

<commit_message>
Normalize cross-platform presentation provenance
</commit_message>
<xml_diff>
--- a/output/presentation/Corporate-Wallet-Digital-Twin.pptx
+++ b/output/presentation/Corporate-Wallet-Digital-Twin.pptx
@@ -2,22 +2,22 @@
 <file path=ppt/presentation.xml><?xml version="1.0" encoding="utf-8"?>
 <p:presentation xmlns:p="http://schemas.openxmlformats.org/presentationml/2006/main">
   <p:sldMasterIdLst>
-    <p:sldMasterId xmlns:r="http://schemas.openxmlformats.org/officeDocument/2006/relationships" id="2147483648" r:id="R82732dccf6424cda"/>
+    <p:sldMasterId xmlns:r="http://schemas.openxmlformats.org/officeDocument/2006/relationships" id="2147483648" r:id="R2732b56d7e174f1f"/>
   </p:sldMasterIdLst>
   <p:notesMasterIdLst>
-    <p:notesMasterId xmlns:r="http://schemas.openxmlformats.org/officeDocument/2006/relationships" r:id="Rd0b20c0051544ab5"/>
+    <p:notesMasterId xmlns:r="http://schemas.openxmlformats.org/officeDocument/2006/relationships" r:id="Rc3cfd1f0d7b642d5"/>
   </p:notesMasterIdLst>
   <p:sldIdLst>
-    <p:sldId xmlns:r="http://schemas.openxmlformats.org/officeDocument/2006/relationships" id="256" r:id="Ra577374cd3a74aff"/>
-    <p:sldId xmlns:r="http://schemas.openxmlformats.org/officeDocument/2006/relationships" id="257" r:id="Ra4d140331edd420a"/>
-    <p:sldId xmlns:r="http://schemas.openxmlformats.org/officeDocument/2006/relationships" id="258" r:id="Rf16ed209dae64cb0"/>
-    <p:sldId xmlns:r="http://schemas.openxmlformats.org/officeDocument/2006/relationships" id="259" r:id="Raf3d489d64454e8e"/>
-    <p:sldId xmlns:r="http://schemas.openxmlformats.org/officeDocument/2006/relationships" id="260" r:id="Rd28acddfc6a241de"/>
-    <p:sldId xmlns:r="http://schemas.openxmlformats.org/officeDocument/2006/relationships" id="261" r:id="R216f3802d09449af"/>
-    <p:sldId xmlns:r="http://schemas.openxmlformats.org/officeDocument/2006/relationships" id="262" r:id="R48c5ecbf9ee1434e"/>
-    <p:sldId xmlns:r="http://schemas.openxmlformats.org/officeDocument/2006/relationships" id="263" r:id="R764cd42fda91495a"/>
-    <p:sldId xmlns:r="http://schemas.openxmlformats.org/officeDocument/2006/relationships" id="264" r:id="Rea4b518840e246a7"/>
-    <p:sldId xmlns:r="http://schemas.openxmlformats.org/officeDocument/2006/relationships" id="265" r:id="R481498fba67a4289"/>
+    <p:sldId xmlns:r="http://schemas.openxmlformats.org/officeDocument/2006/relationships" id="256" r:id="R9d310e23b57d48a4"/>
+    <p:sldId xmlns:r="http://schemas.openxmlformats.org/officeDocument/2006/relationships" id="257" r:id="R7a64f5e3b4694398"/>
+    <p:sldId xmlns:r="http://schemas.openxmlformats.org/officeDocument/2006/relationships" id="258" r:id="R4b5c16639236478d"/>
+    <p:sldId xmlns:r="http://schemas.openxmlformats.org/officeDocument/2006/relationships" id="259" r:id="R517369dc6e344a61"/>
+    <p:sldId xmlns:r="http://schemas.openxmlformats.org/officeDocument/2006/relationships" id="260" r:id="Rbc123c3008d4400e"/>
+    <p:sldId xmlns:r="http://schemas.openxmlformats.org/officeDocument/2006/relationships" id="261" r:id="Rea94aa0fdc1b497d"/>
+    <p:sldId xmlns:r="http://schemas.openxmlformats.org/officeDocument/2006/relationships" id="262" r:id="Rd967056322cc4a3a"/>
+    <p:sldId xmlns:r="http://schemas.openxmlformats.org/officeDocument/2006/relationships" id="263" r:id="Ra46716ab9c4b4189"/>
+    <p:sldId xmlns:r="http://schemas.openxmlformats.org/officeDocument/2006/relationships" id="264" r:id="R727b741d30564d16"/>
+    <p:sldId xmlns:r="http://schemas.openxmlformats.org/officeDocument/2006/relationships" id="265" r:id="R7fb7cde15c6e4d08"/>
   </p:sldIdLst>
   <p:sldSz cx="12192000" cy="6858000"/>
   <p:notesSz cx="6858000" cy="9144000"/>
@@ -1419,7 +1419,7 @@
   </p:cSld>
   <p:clrMap bg1="lt1" tx1="dk1" bg2="lt2" tx2="dk2" accent1="accent1" accent2="accent2" accent3="accent3" accent4="accent4" accent5="accent5" accent6="accent6" hlink="hlink" folHlink="folHlink"/>
   <p:sldLayoutIdLst>
-    <p:sldLayoutId xmlns:r="http://schemas.openxmlformats.org/officeDocument/2006/relationships" id="2147483649" r:id="Rb3a8422ea58248c6"/>
+    <p:sldLayoutId xmlns:r="http://schemas.openxmlformats.org/officeDocument/2006/relationships" id="2147483649" r:id="R2a6b951aa9d248f6"/>
   </p:sldLayoutIdLst>
   <p:txStyles>
     <p:titleStyle>
@@ -2133,7 +2133,7 @@
           <p:nvPr/>
         </p:nvPicPr>
         <p:blipFill>
-          <a:blip xmlns:r="http://schemas.openxmlformats.org/officeDocument/2006/relationships" xmlns:a="http://schemas.openxmlformats.org/drawingml/2006/main" r:embed="R8de8d40740a94c6e"/>
+          <a:blip xmlns:r="http://schemas.openxmlformats.org/officeDocument/2006/relationships" xmlns:a="http://schemas.openxmlformats.org/drawingml/2006/main" r:embed="Rbc57d30c142147d8"/>
           <a:srcRect xmlns:a="http://schemas.openxmlformats.org/drawingml/2006/main" l="0" t="27" r="0" b="27"/>
           <a:stretch xmlns:a="http://schemas.openxmlformats.org/drawingml/2006/main">
             <a:fillRect l="0" t="0" r="0" b="0"/>
@@ -7949,7 +7949,7 @@
         </p:xfrm>
         <a:graphic xmlns:a="http://schemas.openxmlformats.org/drawingml/2006/main">
           <a:graphicData uri="http://schemas.openxmlformats.org/drawingml/2006/chart">
-            <c:chart xmlns:r="http://schemas.openxmlformats.org/officeDocument/2006/relationships" xmlns:c="http://schemas.openxmlformats.org/drawingml/2006/chart" r:id="R04187bd6f24b4cd4"/>
+            <c:chart xmlns:r="http://schemas.openxmlformats.org/officeDocument/2006/relationships" xmlns:c="http://schemas.openxmlformats.org/drawingml/2006/chart" r:id="R2fe3bf8f71564999"/>
           </a:graphicData>
         </a:graphic>
       </p:graphicFrame>
@@ -9424,7 +9424,7 @@
           <p:cNvPr id="69" name="">
             <a:extLst xmlns:a="http://schemas.openxmlformats.org/drawingml/2006/main">
               <a:ext uri="{FF2B5EF4-FFF2-40B4-BE49-F238E27FC236}">
-                <a16:creationId xmlns:a16="http://schemas.microsoft.com/office/drawing/2014/main" id="{8F529834-8FB2-4B28-859C-EA76E90858B0}"/>
+                <a16:creationId xmlns:a16="http://schemas.microsoft.com/office/drawing/2014/main" id="{784BDFD1-6AE5-494F-A70E-20CE160C823F}"/>
               </a:ext>
             </a:extLst>
           </p:cNvPr>
@@ -9461,7 +9461,7 @@
           <p:nvPr/>
         </p:nvPicPr>
         <p:blipFill>
-          <a:blip xmlns:r="http://schemas.openxmlformats.org/officeDocument/2006/relationships" xmlns:a="http://schemas.openxmlformats.org/drawingml/2006/main" r:embed="R42dd32943a8e47c5"/>
+          <a:blip xmlns:r="http://schemas.openxmlformats.org/officeDocument/2006/relationships" xmlns:a="http://schemas.openxmlformats.org/drawingml/2006/main" r:embed="R5a16ed8695e64d63"/>
           <a:stretch xmlns:a="http://schemas.openxmlformats.org/drawingml/2006/main"/>
         </p:blipFill>
         <p:spPr>

</xml_diff>

<commit_message>
Harden V3.2 hackathon submission coherence (#3)
* Harden V3.2 submission coherence

* Refresh V3.2 judging artifacts

* Make canonical artifact build convergent

* Bind V3.2 artifacts to final status authority

* Normalize cross-platform presentation provenance

* Use content-based submission drift checks

* Stamp final V3.2 submission artifacts

* Normalize golden-set hashes across platforms

* Restamp V3.2 artifacts after portable hash fix

* Preserve frozen digest and V3.2 status authority

* Restamp final V3.2 portable release
</commit_message>
<xml_diff>
--- a/output/presentation/Corporate-Wallet-Digital-Twin.pptx
+++ b/output/presentation/Corporate-Wallet-Digital-Twin.pptx
@@ -2,22 +2,22 @@
 <file path=ppt/presentation.xml><?xml version="1.0" encoding="utf-8"?>
 <p:presentation xmlns:p="http://schemas.openxmlformats.org/presentationml/2006/main">
   <p:sldMasterIdLst>
-    <p:sldMasterId xmlns:r="http://schemas.openxmlformats.org/officeDocument/2006/relationships" id="2147483648" r:id="R1859f3ea25c7445a"/>
+    <p:sldMasterId xmlns:r="http://schemas.openxmlformats.org/officeDocument/2006/relationships" id="2147483648" r:id="R2732b56d7e174f1f"/>
   </p:sldMasterIdLst>
   <p:notesMasterIdLst>
-    <p:notesMasterId xmlns:r="http://schemas.openxmlformats.org/officeDocument/2006/relationships" r:id="Rcb5528e3867b428a"/>
+    <p:notesMasterId xmlns:r="http://schemas.openxmlformats.org/officeDocument/2006/relationships" r:id="Rc3cfd1f0d7b642d5"/>
   </p:notesMasterIdLst>
   <p:sldIdLst>
-    <p:sldId xmlns:r="http://schemas.openxmlformats.org/officeDocument/2006/relationships" id="256" r:id="R6fe2619069fb4748"/>
-    <p:sldId xmlns:r="http://schemas.openxmlformats.org/officeDocument/2006/relationships" id="257" r:id="Ra1bee90dc5ae4f64"/>
-    <p:sldId xmlns:r="http://schemas.openxmlformats.org/officeDocument/2006/relationships" id="258" r:id="Rb4974a8288764a09"/>
-    <p:sldId xmlns:r="http://schemas.openxmlformats.org/officeDocument/2006/relationships" id="259" r:id="R3ef24c5121564139"/>
-    <p:sldId xmlns:r="http://schemas.openxmlformats.org/officeDocument/2006/relationships" id="260" r:id="Rc43f5894d1724c55"/>
-    <p:sldId xmlns:r="http://schemas.openxmlformats.org/officeDocument/2006/relationships" id="261" r:id="R41aa0a0ee9594471"/>
-    <p:sldId xmlns:r="http://schemas.openxmlformats.org/officeDocument/2006/relationships" id="262" r:id="Rdc5014666ff74938"/>
-    <p:sldId xmlns:r="http://schemas.openxmlformats.org/officeDocument/2006/relationships" id="263" r:id="R8771adda713047a7"/>
-    <p:sldId xmlns:r="http://schemas.openxmlformats.org/officeDocument/2006/relationships" id="264" r:id="R5451c8237c19403e"/>
-    <p:sldId xmlns:r="http://schemas.openxmlformats.org/officeDocument/2006/relationships" id="265" r:id="Rebe6ef0f6a2f465c"/>
+    <p:sldId xmlns:r="http://schemas.openxmlformats.org/officeDocument/2006/relationships" id="256" r:id="R9d310e23b57d48a4"/>
+    <p:sldId xmlns:r="http://schemas.openxmlformats.org/officeDocument/2006/relationships" id="257" r:id="R7a64f5e3b4694398"/>
+    <p:sldId xmlns:r="http://schemas.openxmlformats.org/officeDocument/2006/relationships" id="258" r:id="R4b5c16639236478d"/>
+    <p:sldId xmlns:r="http://schemas.openxmlformats.org/officeDocument/2006/relationships" id="259" r:id="R517369dc6e344a61"/>
+    <p:sldId xmlns:r="http://schemas.openxmlformats.org/officeDocument/2006/relationships" id="260" r:id="Rbc123c3008d4400e"/>
+    <p:sldId xmlns:r="http://schemas.openxmlformats.org/officeDocument/2006/relationships" id="261" r:id="Rea94aa0fdc1b497d"/>
+    <p:sldId xmlns:r="http://schemas.openxmlformats.org/officeDocument/2006/relationships" id="262" r:id="Rd967056322cc4a3a"/>
+    <p:sldId xmlns:r="http://schemas.openxmlformats.org/officeDocument/2006/relationships" id="263" r:id="Ra46716ab9c4b4189"/>
+    <p:sldId xmlns:r="http://schemas.openxmlformats.org/officeDocument/2006/relationships" id="264" r:id="R727b741d30564d16"/>
+    <p:sldId xmlns:r="http://schemas.openxmlformats.org/officeDocument/2006/relationships" id="265" r:id="R7fb7cde15c6e4d08"/>
   </p:sldIdLst>
   <p:sldSz cx="12192000" cy="6858000"/>
   <p:notesSz cx="6858000" cy="9144000"/>
@@ -546,7 +546,7 @@
           <a:lstStyle xmlns:a="http://schemas.openxmlformats.org/drawingml/2006/main"/>
           <a:p xmlns:a="http://schemas.openxmlformats.org/drawingml/2006/main">
             <a:r>
-              <a:t>Close with the commercial and governance story. V3.2 is a reproducible offline candidate and a shadow-deployment package with a passed promotion rehearsal. Bank production stays NOT_PROMOTABLE until the real bank evidence, control-owner approvals, elapsed operation and qualified outcomes exist.</a:t>
+              <a:t>Close on the commercial decision. The ranked surface begins with Glencore Trade Finance at R17.0m representative scenario contribution, followed by BHP Trade Finance at R7.37m. The relationship manager receives eight priority discovery conversations, not a generic model score. Governance is the final boundary, not the central pitch: hackathon ready; bank production NOT_PROMOTABLE.</a:t>
             </a:r>
           </a:p>
           <a:p xmlns:a="http://schemas.openxmlformats.org/drawingml/2006/main">
@@ -561,7 +561,7 @@
           </a:p>
           <a:p xmlns:a="http://schemas.openxmlformats.org/drawingml/2006/main">
             <a:r>
-              <a:t>- docs/v31_implementation_status.md</a:t>
+              <a:t>- data/v2/submission_truth_v3.2.0.json</a:t>
             </a:r>
           </a:p>
           <a:p xmlns:a="http://schemas.openxmlformats.org/drawingml/2006/main">
@@ -941,7 +941,7 @@
           <a:lstStyle xmlns:a="http://schemas.openxmlformats.org/drawingml/2006/main"/>
           <a:p xmlns:a="http://schemas.openxmlformats.org/drawingml/2006/main">
             <a:r>
-              <a:t>Show the actual rendered Wallet Portfolio view. The default colour encodes contestable scenario contribution. Teal underlines mark the fifteen approved E1 cells; amber marks the eighty-five prior-led cells. Judges can toggle observed activity, posterior wallet, estimated share, contestable gap and evidence status.</a:t>
+              <a:t>Show the actual rendered Wallet Portfolio view. The default colour encodes portfolio-wide contestable scenario contribution. A, T, q and G views use relative intensity within each product column. The leading opportunities are Glencore Trade finance R17.02m; BHP Group Trade finance R7.37m; Glencore Cross-border FX R6.45m; BHP Group Cross-border FX R5.18m; Glencore Liquidity R4.26m.</a:t>
             </a:r>
           </a:p>
           <a:p xmlns:a="http://schemas.openxmlformats.org/drawingml/2006/main">
@@ -1131,7 +1131,7 @@
           <a:lstStyle xmlns:a="http://schemas.openxmlformats.org/drawingml/2006/main"/>
           <a:p xmlns:a="http://schemas.openxmlformats.org/drawingml/2006/main">
             <a:r>
-              <a:t>The Decision Twin remains the action layer, not a replacement for share-of-wallet estimation. It resolves a role, problem, solution bundle, engagement window and next-best question from the wallet gap. Missing credit, conduct, operational or integration feasibility converts the action into discovery; it never silently passes.</a:t>
+              <a:t>The Decision Twin remains the action layer, not a replacement for share-of-wallet estimation. For BHP, 106 bank-observed trade events include a dated 14 August event. With a 45-day preparation lead, the engagement window opens on 30 June. The 36% 90-day seasonal baseline stays visible as an uncalibrated challenger, not the sole urgency claim. Missing feasibility converts the action into discovery.</a:t>
             </a:r>
           </a:p>
           <a:p xmlns:a="http://schemas.openxmlformats.org/drawingml/2006/main">
@@ -1226,7 +1226,7 @@
           <a:lstStyle xmlns:a="http://schemas.openxmlformats.org/drawingml/2006/main"/>
           <a:p xmlns:a="http://schemas.openxmlformats.org/drawingml/2006/main">
             <a:r>
-              <a:t>GenAI is a bounded narrator. The same sanitized pack is prepared for BHP, Glencore and Shoprite across OpenAI, Anthropic and Google. Because no fresh rotated credential and explicit acknowledgement were supplied, all nine target runs remain NOT_EXECUTED. Deterministic briefs remain visible and accepted; no live claim is fabricated.</a:t>
+              <a:t>GenAI is a bounded narrator. Eight of nine genuine provider outputs passed every critical validator, covering OpenAI, Anthropic, Google and all three showcase clients. The ninth output was generated but rejected by the claim compiler before publication, which demonstrates fail-closed control rather than a hidden failure. Deterministic fallback remains beside every accepted brief. This is hackathon evaluation, not bank provider approval.</a:t>
             </a:r>
           </a:p>
           <a:p xmlns:a="http://schemas.openxmlformats.org/drawingml/2006/main">
@@ -1242,6 +1242,11 @@
           <a:p xmlns:a="http://schemas.openxmlformats.org/drawingml/2006/main">
             <a:r>
               <a:t>- outputs/v2_validation/live_provider_comparison.json</a:t>
+            </a:r>
+          </a:p>
+          <a:p xmlns:a="http://schemas.openxmlformats.org/drawingml/2006/main">
+            <a:r>
+              <a:t>- data/v2/submission_truth_v3.2.0.json</a:t>
             </a:r>
           </a:p>
           <a:p xmlns:a="http://schemas.openxmlformats.org/drawingml/2006/main">
@@ -1321,7 +1326,7 @@
           <a:lstStyle xmlns:a="http://schemas.openxmlformats.org/drawingml/2006/main"/>
           <a:p xmlns:a="http://schemas.openxmlformats.org/drawingml/2006/main">
             <a:r>
-              <a:t>The Promotion Twin evaluates thirty cumulative gates twice. Blue rehearsal evidence proves the mechanism and its refusal behavior work; only real, bank-attested evidence can authorize actual use. The accelerated rehearsal resets on day 17 and then reaches thirty clean virtual days. The real bank-day count remains zero.</a:t>
+              <a:t>Trade Finance is first-ranked in all 10,000 global sensitivity draws and majority-dominant in 87.8%, but its absolute economics vary and the top-eight portfolio is not invariant across E1 pooling weights. Coverage and CRPS are known-truth rehearsal metrics only. The compact permission boundary is equally explicit: real state OFFLINE_CANDIDATE; rehearsal only to SHADOW_READY; PMR 100%, BER 0%, and zero elapsed bank shadow days.</a:t>
             </a:r>
           </a:p>
           <a:p xmlns:a="http://schemas.openxmlformats.org/drawingml/2006/main">
@@ -1336,22 +1341,17 @@
           </a:p>
           <a:p xmlns:a="http://schemas.openxmlformats.org/drawingml/2006/main">
             <a:r>
-              <a:t>- dashboard/app/data/promotion-fixture.json</a:t>
-            </a:r>
-          </a:p>
-          <a:p xmlns:a="http://schemas.openxmlformats.org/drawingml/2006/main">
-            <a:r>
-              <a:t>- contracts/promotion-gate-catalogue.json</a:t>
-            </a:r>
-          </a:p>
-          <a:p xmlns:a="http://schemas.openxmlformats.org/drawingml/2006/main">
-            <a:r>
-              <a:t>- outputs/v32/v32_shadow_rehearsal.json</a:t>
-            </a:r>
-          </a:p>
-          <a:p xmlns:a="http://schemas.openxmlformats.org/drawingml/2006/main">
-            <a:r>
-              <a:t>- docs/Corporate_Wallet_Digital_Twin_V3_2_Promotion_Twin.md</a:t>
+              <a:t>- dashboard/app/data/shadow-fixture.json — sensitivity.product_summary.Trade finance</a:t>
+            </a:r>
+          </a:p>
+          <a:p xmlns:a="http://schemas.openxmlformats.org/drawingml/2006/main">
+            <a:r>
+              <a:t>- outputs/v2_validation/measurement_policy_sensitivity.json</a:t>
+            </a:r>
+          </a:p>
+          <a:p xmlns:a="http://schemas.openxmlformats.org/drawingml/2006/main">
+            <a:r>
+              <a:t>- data/v2/submission_truth_v3.2.0.json</a:t>
             </a:r>
           </a:p>
         </p:txBody>
@@ -1419,7 +1419,7 @@
   </p:cSld>
   <p:clrMap bg1="lt1" tx1="dk1" bg2="lt2" tx2="dk2" accent1="accent1" accent2="accent2" accent3="accent3" accent4="accent4" accent5="accent5" accent6="accent6" hlink="hlink" folHlink="folHlink"/>
   <p:sldLayoutIdLst>
-    <p:sldLayoutId xmlns:r="http://schemas.openxmlformats.org/officeDocument/2006/relationships" id="2147483649" r:id="R2adcd3391af8411a"/>
+    <p:sldLayoutId xmlns:r="http://schemas.openxmlformats.org/officeDocument/2006/relationships" id="2147483649" r:id="R2a6b951aa9d248f6"/>
   </p:sldLayoutIdLst>
   <p:txStyles>
     <p:titleStyle>
@@ -2133,7 +2133,7 @@
           <p:nvPr/>
         </p:nvPicPr>
         <p:blipFill>
-          <a:blip xmlns:r="http://schemas.openxmlformats.org/officeDocument/2006/relationships" xmlns:a="http://schemas.openxmlformats.org/drawingml/2006/main" r:embed="R114c046f1a3a4679"/>
+          <a:blip xmlns:r="http://schemas.openxmlformats.org/officeDocument/2006/relationships" xmlns:a="http://schemas.openxmlformats.org/drawingml/2006/main" r:embed="Rbc57d30c142147d8"/>
           <a:srcRect xmlns:a="http://schemas.openxmlformats.org/drawingml/2006/main" l="0" t="27" r="0" b="27"/>
           <a:stretch xmlns:a="http://schemas.openxmlformats.org/drawingml/2006/main">
             <a:fillRect l="0" t="0" r="0" b="0"/>
@@ -2781,13 +2781,13 @@
         </p:spPr>
         <p:txBody>
           <a:bodyPr xmlns:a="http://schemas.openxmlformats.org/drawingml/2006/main" anchor="t">
-            <a:normAutofit fontScale="94444"/>
-          </a:bodyPr>
-          <a:lstStyle xmlns:a="http://schemas.openxmlformats.org/drawingml/2006/main"/>
-          <a:p xmlns:a="http://schemas.openxmlformats.org/drawingml/2006/main">
-            <a:pPr algn="l">
-              <a:buNone/>
-              <a:defRPr sz="4050" b="1">
+            <a:normAutofit fontScale="69388"/>
+          </a:bodyPr>
+          <a:lstStyle xmlns:a="http://schemas.openxmlformats.org/drawingml/2006/main"/>
+          <a:p xmlns:a="http://schemas.openxmlformats.org/drawingml/2006/main">
+            <a:pPr algn="l">
+              <a:buNone/>
+              <a:defRPr sz="3675" b="1">
                 <a:solidFill>
                   <a:srgbClr val="FFFFFF"/>
                 </a:solidFill>
@@ -2797,7 +2797,7 @@
               </a:defRPr>
             </a:pPr>
             <a:r>
-              <a:rPr sz="4050" b="1">
+              <a:rPr sz="3675" b="1">
                 <a:solidFill>
                   <a:srgbClr val="FFFFFF"/>
                 </a:solidFill>
@@ -2805,13 +2805,13 @@
                 <a:ea typeface="Arial"/>
                 <a:cs typeface="Arial"/>
               </a:rPr>
-              <a:t>Find the gap.</a:t>
-            </a:r>
-          </a:p>
-          <a:p xmlns:a="http://schemas.openxmlformats.org/drawingml/2006/main">
-            <a:pPr algn="l">
-              <a:buNone/>
-              <a:defRPr sz="4050" b="1">
+              <a:t>See the wallet.</a:t>
+            </a:r>
+          </a:p>
+          <a:p xmlns:a="http://schemas.openxmlformats.org/drawingml/2006/main">
+            <a:pPr algn="l">
+              <a:buNone/>
+              <a:defRPr sz="3675" b="1">
                 <a:solidFill>
                   <a:srgbClr val="FFFFFF"/>
                 </a:solidFill>
@@ -2821,7 +2821,7 @@
               </a:defRPr>
             </a:pPr>
             <a:r>
-              <a:rPr sz="4050" b="1">
+              <a:rPr sz="3675" b="1">
                 <a:solidFill>
                   <a:srgbClr val="FFFFFF"/>
                 </a:solidFill>
@@ -2829,7 +2829,31 @@
                 <a:ea typeface="Arial"/>
                 <a:cs typeface="Arial"/>
               </a:rPr>
-              <a:t>Earn the right to act.</a:t>
+              <a:t>Size the gap.</a:t>
+            </a:r>
+          </a:p>
+          <a:p xmlns:a="http://schemas.openxmlformats.org/drawingml/2006/main">
+            <a:pPr algn="l">
+              <a:buNone/>
+              <a:defRPr sz="3675" b="1">
+                <a:solidFill>
+                  <a:srgbClr val="FFFFFF"/>
+                </a:solidFill>
+                <a:latin typeface="Arial"/>
+                <a:ea typeface="Arial"/>
+                <a:cs typeface="Arial"/>
+              </a:defRPr>
+            </a:pPr>
+            <a:r>
+              <a:rPr sz="3675" b="1">
+                <a:solidFill>
+                  <a:srgbClr val="FFFFFF"/>
+                </a:solidFill>
+                <a:latin typeface="Arial"/>
+                <a:ea typeface="Arial"/>
+                <a:cs typeface="Arial"/>
+              </a:rPr>
+              <a:t>Choose the conversation.</a:t>
             </a:r>
           </a:p>
         </p:txBody>
@@ -2864,13 +2888,13 @@
         </p:spPr>
         <p:txBody>
           <a:bodyPr xmlns:a="http://schemas.openxmlformats.org/drawingml/2006/main" anchor="t">
-            <a:normAutofit fontScale="100000"/>
-          </a:bodyPr>
-          <a:lstStyle xmlns:a="http://schemas.openxmlformats.org/drawingml/2006/main"/>
-          <a:p xmlns:a="http://schemas.openxmlformats.org/drawingml/2006/main">
-            <a:pPr algn="l">
-              <a:buNone/>
-              <a:defRPr sz="1800" b="0">
+            <a:normAutofit fontScale="99517"/>
+          </a:bodyPr>
+          <a:lstStyle xmlns:a="http://schemas.openxmlformats.org/drawingml/2006/main"/>
+          <a:p xmlns:a="http://schemas.openxmlformats.org/drawingml/2006/main">
+            <a:pPr algn="l">
+              <a:buNone/>
+              <a:defRPr sz="1725" b="0">
                 <a:solidFill>
                   <a:srgbClr val="C7D5E8"/>
                 </a:solidFill>
@@ -2880,7 +2904,7 @@
               </a:defRPr>
             </a:pPr>
             <a:r>
-              <a:rPr sz="1800" b="0">
+              <a:rPr sz="1725" b="0">
                 <a:solidFill>
                   <a:srgbClr val="C7D5E8"/>
                 </a:solidFill>
@@ -2888,7 +2912,7 @@
                 <a:ea typeface="Arial"/>
                 <a:cs typeface="Arial"/>
               </a:rPr>
-              <a:t>V3.2 combines a governed wallet interval, a relationship action and an executable proof of what may—and may not—be used.</a:t>
+              <a:t>The highest-value discovery starts with Glencore Trade Finance, then BHP. Eight priority conversations turn governed wallet intervals into a focused coverage plan.</a:t>
             </a:r>
           </a:p>
         </p:txBody>
@@ -3028,7 +3052,7 @@
                 <a:ea typeface="Arial"/>
                 <a:cs typeface="Arial"/>
               </a:rPr>
-              <a:t>Demonstrate the wallet</a:t>
+              <a:t>See the wallet</a:t>
             </a:r>
           </a:p>
         </p:txBody>
@@ -3087,7 +3111,7 @@
                 <a:ea typeface="Arial"/>
                 <a:cs typeface="Arial"/>
               </a:rPr>
-              <a:t>Twenty relationships × five products, approval-authoritative anchors, intervals and contestable gaps.</a:t>
+              <a:t>Twenty relationships × five products reveal where observed activity sits below a governed total-wallet interval.</a:t>
             </a:r>
           </a:p>
         </p:txBody>
@@ -3203,7 +3227,7 @@
         </p:spPr>
         <p:txBody>
           <a:bodyPr xmlns:a="http://schemas.openxmlformats.org/drawingml/2006/main" anchor="t">
-            <a:normAutofit fontScale="83711"/>
+            <a:normAutofit fontScale="100000"/>
           </a:bodyPr>
           <a:lstStyle xmlns:a="http://schemas.openxmlformats.org/drawingml/2006/main"/>
           <a:p xmlns:a="http://schemas.openxmlformats.org/drawingml/2006/main">
@@ -3227,7 +3251,7 @@
                 <a:ea typeface="Arial"/>
                 <a:cs typeface="Arial"/>
               </a:rPr>
-              <a:t>Run eight discovery conversations</a:t>
+              <a:t>Size the gap</a:t>
             </a:r>
           </a:p>
         </p:txBody>
@@ -3286,7 +3310,7 @@
                 <a:ea typeface="Arial"/>
                 <a:cs typeface="Arial"/>
               </a:rPr>
-              <a:t>Decision Twin adds stakeholder, business issue, bundle, timing, feasibility and the highest-VOI question.</a:t>
+              <a:t>Target-share scenarios convert the interval into contestable activity and transparent commercial value.</a:t>
             </a:r>
           </a:p>
         </p:txBody>
@@ -3426,7 +3450,7 @@
                 <a:ea typeface="Arial"/>
                 <a:cs typeface="Arial"/>
               </a:rPr>
-              <a:t>Earn the right to use it</a:t>
+              <a:t>Choose the conversation</a:t>
             </a:r>
           </a:p>
         </p:txBody>
@@ -3485,7 +3509,7 @@
                 <a:ea typeface="Arial"/>
                 <a:cs typeface="Arial"/>
               </a:rPr>
-              <a:t>Promotion Twin keeps signed rehearsal evidence separate from real bank authorization at every transition.</a:t>
+              <a:t>Stakeholder, issue, bundle, dated trigger, feasibility and the next-best question make the gap actionable.</a:t>
             </a:r>
           </a:p>
         </p:txBody>
@@ -3544,7 +3568,7 @@
                 <a:ea typeface="Arial"/>
                 <a:cs typeface="Arial"/>
               </a:rPr>
-              <a:t>Offline candidate validated; shadow promotion rehearsed. BANK_SHADOW_AUTHORIZED remains FALSE.</a:t>
+              <a:t>Hackathon ready. Real state OFFLINE_CANDIDATE; rehearsal SHADOW_READY; bank production NOT_PROMOTABLE.</a:t>
             </a:r>
           </a:p>
         </p:txBody>
@@ -7925,7 +7949,7 @@
         </p:xfrm>
         <a:graphic xmlns:a="http://schemas.openxmlformats.org/drawingml/2006/main">
           <a:graphicData uri="http://schemas.openxmlformats.org/drawingml/2006/chart">
-            <c:chart xmlns:r="http://schemas.openxmlformats.org/officeDocument/2006/relationships" xmlns:c="http://schemas.openxmlformats.org/drawingml/2006/chart" r:id="R78e6faa132074b5c"/>
+            <c:chart xmlns:r="http://schemas.openxmlformats.org/officeDocument/2006/relationships" xmlns:c="http://schemas.openxmlformats.org/drawingml/2006/chart" r:id="R2fe3bf8f71564999"/>
           </a:graphicData>
         </a:graphic>
       </p:graphicFrame>
@@ -8095,7 +8119,7 @@
                 <a:ea typeface="Arial"/>
                 <a:cs typeface="Arial"/>
               </a:rPr>
-              <a:t>THE 20 × 5 COMMERCIAL SURFACE</a:t>
+              <a:t>THE 20 × 5 COMMERCIAL SURFACE · TOP FIVE R 40,3M</a:t>
             </a:r>
           </a:p>
         </p:txBody>
@@ -8154,7 +8178,7 @@
                 <a:ea typeface="Arial"/>
                 <a:cs typeface="Arial"/>
               </a:rPr>
-              <a:t>One heatmap makes the latent opportunity actionable</a:t>
+              <a:t>Start with Glencore Trade Finance—then BHP</a:t>
             </a:r>
           </a:p>
         </p:txBody>
@@ -9400,7 +9424,7 @@
           <p:cNvPr id="69" name="">
             <a:extLst xmlns:a="http://schemas.openxmlformats.org/drawingml/2006/main">
               <a:ext uri="{FF2B5EF4-FFF2-40B4-BE49-F238E27FC236}">
-                <a16:creationId xmlns:a16="http://schemas.microsoft.com/office/drawing/2014/main" id="{75296C02-A961-4089-9C99-CEE3E99AC37E}"/>
+                <a16:creationId xmlns:a16="http://schemas.microsoft.com/office/drawing/2014/main" id="{784BDFD1-6AE5-494F-A70E-20CE160C823F}"/>
               </a:ext>
             </a:extLst>
           </p:cNvPr>
@@ -9437,13 +9461,13 @@
           <p:nvPr/>
         </p:nvPicPr>
         <p:blipFill>
-          <a:blip xmlns:r="http://schemas.openxmlformats.org/officeDocument/2006/relationships" xmlns:a="http://schemas.openxmlformats.org/drawingml/2006/main" r:embed="R9e8bcd9831fb4436"/>
+          <a:blip xmlns:r="http://schemas.openxmlformats.org/officeDocument/2006/relationships" xmlns:a="http://schemas.openxmlformats.org/drawingml/2006/main" r:embed="R5a16ed8695e64d63"/>
           <a:stretch xmlns:a="http://schemas.openxmlformats.org/drawingml/2006/main"/>
         </p:blipFill>
         <p:spPr>
           <a:xfrm xmlns:a="http://schemas.openxmlformats.org/drawingml/2006/main">
-            <a:off x="1991798" y="1524000"/>
-            <a:ext cx="8208404" cy="4762500"/>
+            <a:off x="2832472" y="1524000"/>
+            <a:ext cx="6527056" cy="4762500"/>
           </a:xfrm>
           <a:prstGeom xmlns:a="http://schemas.openxmlformats.org/drawingml/2006/main" prst="rect">
             <a:avLst/>
@@ -12972,7 +12996,7 @@
                 <a:ea typeface="Arial"/>
                 <a:cs typeface="Arial"/>
               </a:rPr>
-              <a:t>WHY NOW + WHAT TO ASK</a:t>
+              <a:t>WHY NOW: DATED EVENT + PREPARATION WINDOW</a:t>
             </a:r>
           </a:p>
         </p:txBody>
@@ -13053,7 +13077,7 @@
                 <a:ea typeface="Arial"/>
                 <a:cs typeface="Arial"/>
               </a:rPr>
-              <a:t>36.0%</a:t>
+              <a:t>14 AUG</a:t>
             </a:r>
           </a:p>
         </p:txBody>
@@ -13112,7 +13136,7 @@
                 <a:ea typeface="Arial"/>
                 <a:cs typeface="Arial"/>
               </a:rPr>
-              <a:t>90-day baseline</a:t>
+              <a:t>dated trade event</a:t>
             </a:r>
           </a:p>
         </p:txBody>
@@ -13171,7 +13195,7 @@
                 <a:ea typeface="Arial"/>
                 <a:cs typeface="Arial"/>
               </a:rPr>
-              <a:t>Transparent—not calibrated hazard</a:t>
+              <a:t>106 bank-observed trade events inside 90 days</a:t>
             </a:r>
           </a:p>
         </p:txBody>
@@ -13252,7 +13276,7 @@
                 <a:ea typeface="Arial"/>
                 <a:cs typeface="Arial"/>
               </a:rPr>
-              <a:t>1</a:t>
+              <a:t>45d</a:t>
             </a:r>
           </a:p>
         </p:txBody>
@@ -13311,7 +13335,7 @@
                 <a:ea typeface="Arial"/>
                 <a:cs typeface="Arial"/>
               </a:rPr>
-              <a:t>primary VOI question</a:t>
+              <a:t>preparation lead</a:t>
             </a:r>
           </a:p>
         </p:txBody>
@@ -13370,7 +13394,7 @@
                 <a:ea typeface="Arial"/>
                 <a:cs typeface="Arial"/>
               </a:rPr>
-              <a:t>Only if it can change the decision</a:t>
+              <a:t>Engagement window opens 30 June</a:t>
             </a:r>
           </a:p>
         </p:txBody>
@@ -14247,7 +14271,7 @@
                 <a:ea typeface="Arial"/>
                 <a:cs typeface="Arial"/>
               </a:rPr>
-              <a:t>3 / 3</a:t>
+              <a:t>8</a:t>
             </a:r>
           </a:p>
         </p:txBody>
@@ -14306,7 +14330,7 @@
                 <a:ea typeface="Arial"/>
                 <a:cs typeface="Arial"/>
               </a:rPr>
-              <a:t>showcase fallback briefs</a:t>
+              <a:t>accepted outputs</a:t>
             </a:r>
           </a:p>
         </p:txBody>
@@ -14365,7 +14389,7 @@
                 <a:ea typeface="Arial"/>
                 <a:cs typeface="Arial"/>
               </a:rPr>
-              <a:t>BHP · Glencore · Shoprite; deterministic and validated</a:t>
+              <a:t>9 targets · all three showcase clients covered</a:t>
             </a:r>
           </a:p>
         </p:txBody>
@@ -14446,7 +14470,7 @@
                 <a:ea typeface="Arial"/>
                 <a:cs typeface="Arial"/>
               </a:rPr>
-              <a:t>9</a:t>
+              <a:t>3</a:t>
             </a:r>
           </a:p>
         </p:txBody>
@@ -14505,7 +14529,7 @@
                 <a:ea typeface="Arial"/>
                 <a:cs typeface="Arial"/>
               </a:rPr>
-              <a:t>comparative target runs</a:t>
+              <a:t>providers accepted</a:t>
             </a:r>
           </a:p>
         </p:txBody>
@@ -14564,7 +14588,7 @@
                 <a:ea typeface="Arial"/>
                 <a:cs typeface="Arial"/>
               </a:rPr>
-              <a:t>OpenAI · Anthropic · Google × three clients</a:t>
+              <a:t>OpenAI · Anthropic · Google; exact pinned models</a:t>
             </a:r>
           </a:p>
         </p:txBody>
@@ -14645,7 +14669,7 @@
                 <a:ea typeface="Arial"/>
                 <a:cs typeface="Arial"/>
               </a:rPr>
-              <a:t>0</a:t>
+              <a:t>1</a:t>
             </a:r>
           </a:p>
         </p:txBody>
@@ -14704,7 +14728,7 @@
                 <a:ea typeface="Arial"/>
                 <a:cs typeface="Arial"/>
               </a:rPr>
-              <a:t>live runs executed</a:t>
+              <a:t>unsafe output blocked</a:t>
             </a:r>
           </a:p>
         </p:txBody>
@@ -14763,7 +14787,7 @@
                 <a:ea typeface="Arial"/>
                 <a:cs typeface="Arial"/>
               </a:rPr>
-              <a:t>Fresh rotated credentials and acknowledgement absent</a:t>
+              <a:t>Claim compiler rejected before publication; fallback retained</a:t>
             </a:r>
           </a:p>
         </p:txBody>
@@ -14945,7 +14969,7 @@
                 <a:ea typeface="Arial"/>
                 <a:cs typeface="Arial"/>
               </a:rPr>
-              <a:t>Resolve exact provider model; no silent substitution</a:t>
+              <a:t>BHP · OpenAI gpt-5.6-sol · accepted</a:t>
             </a:r>
           </a:p>
         </p:txBody>
@@ -15037,7 +15061,7 @@
                 <a:ea typeface="Arial"/>
                 <a:cs typeface="Arial"/>
               </a:rPr>
-              <a:t>Send approved public evidence + minimal synthetic aggregates only</a:t>
+              <a:t>Glencore · Anthropic claude-sonnet-5 · accepted</a:t>
             </a:r>
           </a:p>
         </p:txBody>
@@ -15129,7 +15153,7 @@
                 <a:ea typeface="Arial"/>
                 <a:cs typeface="Arial"/>
               </a:rPr>
-              <a:t>Validate schema, every number, sign, currency and citation</a:t>
+              <a:t>Shoprite · Google gemini-3.6-flash · accepted</a:t>
             </a:r>
           </a:p>
         </p:txBody>
@@ -15221,7 +15245,7 @@
                 <a:ea typeface="Arial"/>
                 <a:cs typeface="Arial"/>
               </a:rPr>
-              <a:t>Provider failure returns the deterministic brief</a:t>
+              <a:t>One Anthropic/BHP output blocked; deterministic fallback retained</a:t>
             </a:r>
           </a:p>
         </p:txBody>
@@ -15346,55 +15370,55 @@
         </p:spPr>
         <p:txBody>
           <a:bodyPr xmlns:a="http://schemas.openxmlformats.org/drawingml/2006/main" anchor="t">
-            <a:normAutofit fontScale="90112"/>
-          </a:bodyPr>
-          <a:lstStyle xmlns:a="http://schemas.openxmlformats.org/drawingml/2006/main"/>
-          <a:p xmlns:a="http://schemas.openxmlformats.org/drawingml/2006/main">
-            <a:pPr algn="l">
-              <a:buNone/>
-              <a:defRPr sz="2100" b="1">
-                <a:solidFill>
-                  <a:srgbClr val="0C1728"/>
-                </a:solidFill>
-                <a:latin typeface="Arial"/>
-                <a:ea typeface="Arial"/>
-                <a:cs typeface="Arial"/>
-              </a:defRPr>
-            </a:pPr>
-            <a:r>
-              <a:rPr sz="2100" b="1">
-                <a:solidFill>
-                  <a:srgbClr val="0C1728"/>
-                </a:solidFill>
-                <a:latin typeface="Arial"/>
-                <a:ea typeface="Arial"/>
-                <a:cs typeface="Arial"/>
-              </a:rPr>
-              <a:t>Strong mechanics,</a:t>
-            </a:r>
-          </a:p>
-          <a:p xmlns:a="http://schemas.openxmlformats.org/drawingml/2006/main">
-            <a:pPr algn="l">
-              <a:buNone/>
-              <a:defRPr sz="2100" b="1">
-                <a:solidFill>
-                  <a:srgbClr val="0C1728"/>
-                </a:solidFill>
-                <a:latin typeface="Arial"/>
-                <a:ea typeface="Arial"/>
-                <a:cs typeface="Arial"/>
-              </a:defRPr>
-            </a:pPr>
-            <a:r>
-              <a:rPr sz="2100" b="1">
-                <a:solidFill>
-                  <a:srgbClr val="0C1728"/>
-                </a:solidFill>
-                <a:latin typeface="Arial"/>
-                <a:ea typeface="Arial"/>
-                <a:cs typeface="Arial"/>
-              </a:rPr>
-              <a:t>not empirical E3 accuracy</a:t>
+            <a:normAutofit fontScale="100000"/>
+          </a:bodyPr>
+          <a:lstStyle xmlns:a="http://schemas.openxmlformats.org/drawingml/2006/main"/>
+          <a:p xmlns:a="http://schemas.openxmlformats.org/drawingml/2006/main">
+            <a:pPr algn="l">
+              <a:buNone/>
+              <a:defRPr sz="1950" b="1">
+                <a:solidFill>
+                  <a:srgbClr val="0F1F33"/>
+                </a:solidFill>
+                <a:latin typeface="Arial"/>
+                <a:ea typeface="Arial"/>
+                <a:cs typeface="Arial"/>
+              </a:defRPr>
+            </a:pPr>
+            <a:r>
+              <a:rPr sz="1950" b="1">
+                <a:solidFill>
+                  <a:srgbClr val="0F1F33"/>
+                </a:solidFill>
+                <a:latin typeface="Arial"/>
+                <a:ea typeface="Arial"/>
+                <a:cs typeface="Arial"/>
+              </a:rPr>
+              <a:t>8 accepted;</a:t>
+            </a:r>
+          </a:p>
+          <a:p xmlns:a="http://schemas.openxmlformats.org/drawingml/2006/main">
+            <a:pPr algn="l">
+              <a:buNone/>
+              <a:defRPr sz="1950" b="1">
+                <a:solidFill>
+                  <a:srgbClr val="0F1F33"/>
+                </a:solidFill>
+                <a:latin typeface="Arial"/>
+                <a:ea typeface="Arial"/>
+                <a:cs typeface="Arial"/>
+              </a:defRPr>
+            </a:pPr>
+            <a:r>
+              <a:rPr sz="1950" b="1">
+                <a:solidFill>
+                  <a:srgbClr val="0F1F33"/>
+                </a:solidFill>
+                <a:latin typeface="Arial"/>
+                <a:ea typeface="Arial"/>
+                <a:cs typeface="Arial"/>
+              </a:rPr>
+              <a:t>one blocked safely</a:t>
             </a:r>
           </a:p>
         </p:txBody>
@@ -15429,7 +15453,7 @@
         </p:spPr>
         <p:txBody>
           <a:bodyPr xmlns:a="http://schemas.openxmlformats.org/drawingml/2006/main" anchor="t">
-            <a:normAutofit fontScale="88889"/>
+            <a:normAutofit fontScale="66667"/>
           </a:bodyPr>
           <a:lstStyle xmlns:a="http://schemas.openxmlformats.org/drawingml/2006/main"/>
           <a:p xmlns:a="http://schemas.openxmlformats.org/drawingml/2006/main">
@@ -15453,7 +15477,7 @@
                 <a:ea typeface="Arial"/>
                 <a:cs typeface="Arial"/>
               </a:rPr>
-              <a:t>The report records all nine runs as NOT_EXECUTED. It will not present provider access failure as successful evaluation.</a:t>
+              <a:t>Every accepted output passed schema, number, sign, currency, citation, abstention and unsupported-claim checks. This is hackathon external-provider evaluation—not bank-authorized LIVE_GENAI.</a:t>
             </a:r>
           </a:p>
         </p:txBody>
@@ -15534,7 +15558,7 @@
                 <a:ea typeface="Arial"/>
                 <a:cs typeface="Arial"/>
               </a:rPr>
-              <a:t>PROMOTION READINESS TWIN</a:t>
+              <a:t>ANALYTICAL TRUST + PROMOTION BOUNDARY</a:t>
             </a:r>
           </a:p>
         </p:txBody>
@@ -15593,7 +15617,7 @@
                 <a:ea typeface="Arial"/>
                 <a:cs typeface="Arial"/>
               </a:rPr>
-              <a:t>The machinery is ready; bank authority is not</a:t>
+              <a:t>Trade Finance stays first; the portfolio mix still moves</a:t>
             </a:r>
           </a:p>
         </p:txBody>
@@ -16033,7 +16057,7 @@
                 <a:ea typeface="Arial"/>
                 <a:cs typeface="Arial"/>
               </a:rPr>
-              <a:t>Offline</a:t>
+              <a:t>Stress</a:t>
             </a:r>
           </a:p>
         </p:txBody>
@@ -16068,7 +16092,7 @@
         </p:spPr>
         <p:txBody>
           <a:bodyPr xmlns:a="http://schemas.openxmlformats.org/drawingml/2006/main" anchor="t">
-            <a:normAutofit fontScale="81391"/>
+            <a:normAutofit fontScale="100000"/>
           </a:bodyPr>
           <a:lstStyle xmlns:a="http://schemas.openxmlformats.org/drawingml/2006/main"/>
           <a:p xmlns:a="http://schemas.openxmlformats.org/drawingml/2006/main">
@@ -16092,7 +16116,7 @@
                 <a:ea typeface="Arial"/>
                 <a:cs typeface="Arial"/>
               </a:rPr>
-              <a:t>Reproducible candidate and claim boundaries</a:t>
+              <a:t>10,000 correlated scenario draws</a:t>
             </a:r>
           </a:p>
         </p:txBody>
@@ -16245,7 +16269,7 @@
                 <a:ea typeface="Arial"/>
                 <a:cs typeface="Arial"/>
               </a:rPr>
-              <a:t>Shadow</a:t>
+              <a:t>Prior</a:t>
             </a:r>
           </a:p>
         </p:txBody>
@@ -16280,7 +16304,7 @@
         </p:spPr>
         <p:txBody>
           <a:bodyPr xmlns:a="http://schemas.openxmlformats.org/drawingml/2006/main" anchor="t">
-            <a:normAutofit fontScale="75772"/>
+            <a:normAutofit fontScale="100000"/>
           </a:bodyPr>
           <a:lstStyle xmlns:a="http://schemas.openxmlformats.org/drawingml/2006/main"/>
           <a:p xmlns:a="http://schemas.openxmlformats.org/drawingml/2006/main">
@@ -16304,7 +16328,7 @@
                 <a:ea typeface="Arial"/>
                 <a:cs typeface="Arial"/>
               </a:rPr>
-              <a:t>Hidden bank run; missing capabilities fail closed</a:t>
+              <a:t>E1 weight 0.20 / 0.35 / 0.50</a:t>
             </a:r>
           </a:p>
         </p:txBody>
@@ -16457,7 +16481,7 @@
                 <a:ea typeface="Arial"/>
                 <a:cs typeface="Arial"/>
               </a:rPr>
-              <a:t>Pilot</a:t>
+              <a:t>Coverage</a:t>
             </a:r>
           </a:p>
         </p:txBody>
@@ -16492,7 +16516,7 @@
         </p:spPr>
         <p:txBody>
           <a:bodyPr xmlns:a="http://schemas.openxmlformats.org/drawingml/2006/main" anchor="t">
-            <a:normAutofit fontScale="73611"/>
+            <a:normAutofit fontScale="100000"/>
           </a:bodyPr>
           <a:lstStyle xmlns:a="http://schemas.openxmlformats.org/drawingml/2006/main"/>
           <a:p xmlns:a="http://schemas.openxmlformats.org/drawingml/2006/main">
@@ -16516,7 +16540,7 @@
                 <a:ea typeface="Arial"/>
                 <a:cs typeface="Arial"/>
               </a:rPr>
-              <a:t>Thirty real days + approved evidence and cohort</a:t>
+              <a:t>Known-truth only; no E3 claim</a:t>
             </a:r>
           </a:p>
         </p:txBody>
@@ -16669,7 +16693,7 @@
                 <a:ea typeface="Arial"/>
                 <a:cs typeface="Arial"/>
               </a:rPr>
-              <a:t>Scale</a:t>
+              <a:t>Selection</a:t>
             </a:r>
           </a:p>
         </p:txBody>
@@ -16704,7 +16728,7 @@
         </p:spPr>
         <p:txBody>
           <a:bodyPr xmlns:a="http://schemas.openxmlformats.org/drawingml/2006/main" anchor="t">
-            <a:normAutofit fontScale="75828"/>
+            <a:normAutofit fontScale="88072"/>
           </a:bodyPr>
           <a:lstStyle xmlns:a="http://schemas.openxmlformats.org/drawingml/2006/main"/>
           <a:p xmlns:a="http://schemas.openxmlformats.org/drawingml/2006/main">
@@ -16728,7 +16752,7 @@
                 <a:ea typeface="Arial"/>
                 <a:cs typeface="Arial"/>
               </a:rPr>
-              <a:t>Bank-attested pilot, operations and approvals</a:t>
+              <a:t>Top-eight composition is not invariant</a:t>
             </a:r>
           </a:p>
         </p:txBody>
@@ -16881,7 +16905,7 @@
                 <a:ea typeface="Arial"/>
                 <a:cs typeface="Arial"/>
               </a:rPr>
-              <a:t>Causal</a:t>
+              <a:t>Permission</a:t>
             </a:r>
           </a:p>
         </p:txBody>
@@ -16916,7 +16940,7 @@
         </p:spPr>
         <p:txBody>
           <a:bodyPr xmlns:a="http://schemas.openxmlformats.org/drawingml/2006/main" anchor="t">
-            <a:normAutofit fontScale="73611"/>
+            <a:normAutofit fontScale="88916"/>
           </a:bodyPr>
           <a:lstStyle xmlns:a="http://schemas.openxmlformats.org/drawingml/2006/main"/>
           <a:p xmlns:a="http://schemas.openxmlformats.org/drawingml/2006/main">
@@ -16940,7 +16964,8 @@
                 <a:ea typeface="Arial"/>
                 <a:cs typeface="Arial"/>
               </a:rPr>
-              <a:t>Positive independently validated randomized evidence</a:t>
+              <a:t>Real: OFFLINE
+Rehearsal: SHADOW</a:t>
             </a:r>
           </a:p>
         </p:txBody>
@@ -17021,7 +17046,7 @@
                 <a:ea typeface="Arial"/>
                 <a:cs typeface="Arial"/>
               </a:rPr>
-              <a:t>30</a:t>
+              <a:t>10k</a:t>
             </a:r>
           </a:p>
         </p:txBody>
@@ -17080,7 +17105,7 @@
                 <a:ea typeface="Arial"/>
                 <a:cs typeface="Arial"/>
               </a:rPr>
-              <a:t>governed gates</a:t>
+              <a:t>scenario draws</a:t>
             </a:r>
           </a:p>
         </p:txBody>
@@ -17139,7 +17164,7 @@
                 <a:ea typeface="Arial"/>
                 <a:cs typeface="Arial"/>
               </a:rPr>
-              <a:t>Every gate has REAL + REHEARSAL outcomes</a:t>
+              <a:t>Rates, wallet, share and commercial inputs</a:t>
             </a:r>
           </a:p>
         </p:txBody>
@@ -17279,7 +17304,7 @@
                 <a:ea typeface="Arial"/>
                 <a:cs typeface="Arial"/>
               </a:rPr>
-              <a:t>PMR</a:t>
+              <a:t>TF first-ranked</a:t>
             </a:r>
           </a:p>
         </p:txBody>
@@ -17338,7 +17363,7 @@
                 <a:ea typeface="Arial"/>
                 <a:cs typeface="Arial"/>
               </a:rPr>
-              <a:t>Signed positive and failure-path rehearsal</a:t>
+              <a:t>Global sensitivity—not a hard-coded winner</a:t>
             </a:r>
           </a:p>
         </p:txBody>
@@ -17419,7 +17444,7 @@
                 <a:ea typeface="Arial"/>
                 <a:cs typeface="Arial"/>
               </a:rPr>
-              <a:t>0%</a:t>
+              <a:t>87.8%</a:t>
             </a:r>
           </a:p>
         </p:txBody>
@@ -17478,7 +17503,7 @@
                 <a:ea typeface="Arial"/>
                 <a:cs typeface="Arial"/>
               </a:rPr>
-              <a:t>BER</a:t>
+              <a:t>TF majority dominance</a:t>
             </a:r>
           </a:p>
         </p:txBody>
@@ -17537,7 +17562,7 @@
                 <a:ea typeface="Arial"/>
                 <a:cs typeface="Arial"/>
               </a:rPr>
-              <a:t>Synthetic evidence contributes zero</a:t>
+              <a:t>Absolute economics still varies materially</a:t>
             </a:r>
           </a:p>
         </p:txBody>
@@ -17736,7 +17761,7 @@
                 <a:ea typeface="Arial"/>
                 <a:cs typeface="Arial"/>
               </a:rPr>
-              <a:t>30 clean virtual days are kept separate</a:t>
+              <a:t>PMR 100% · BER 0% · rehearsed only to SHADOW_READY</a:t>
             </a:r>
           </a:p>
         </p:txBody>

</xml_diff>